<commit_message>
deck: PMFBY block re-sourced (88.5 lakh enrollments / Rs 2,580 cr, d21 [16] Lok Sabha annexure), ledger P3 fixed, broken chain closed
</commit_message>
<xml_diff>
--- a/scaffold/deck/KrishiSetu-Round0-20260816.pptx
+++ b/scaffold/deck/KrishiSetu-Round0-20260816.pptx
@@ -3301,7 +3301,7 @@
                 <a:ea typeface="Cambria" pitchFamily="34" charset="-122"/>
                 <a:cs typeface="Cambria" pitchFamily="34" charset="-120"/>
               </a:rPr>
-              <a:t>78.4 crore</a:t>
+              <a:t>88.5 lakh</a:t>
             </a:r>
             <a:endParaRPr lang="en-US" sz="2600" dirty="0"/>
           </a:p>
@@ -3340,7 +3340,7 @@
                 <a:ea typeface="Calibri" pitchFamily="34" charset="-122"/>
                 <a:cs typeface="Calibri" pitchFamily="34" charset="-120"/>
               </a:rPr>
-              <a:t>PMFBY crop-insurance applications on a Rs 1.83 lakh crore program</a:t>
+              <a:t>PMFBY crop-insurance enrollments, Rs 2,580 crore claims paid (2020-25, Lok Sabha annexure)</a:t>
             </a:r>
             <a:endParaRPr lang="en-US" sz="1050" dirty="0"/>
           </a:p>
@@ -8231,7 +8231,7 @@
                 <a:ea typeface="Cambria" pitchFamily="34" charset="-122"/>
                 <a:cs typeface="Cambria" pitchFamily="34" charset="-120"/>
               </a:rPr>
-              <a:t>78.4 crore PMFBY applications, Rs 1.83 lakh crore program</a:t>
+              <a:t>88.5 lakh PMFBY enrollments, Rs 2,580 crore claims paid (2020-25)</a:t>
             </a:r>
             <a:endParaRPr lang="en-US" sz="1500" dirty="0"/>
           </a:p>

</xml_diff>

<commit_message>
R17+R18 landed (harvest-now + do-not-harvest rules, 21/21 tests), R18 tillering trigger, team slide corrected (Harsh=everything, Ayush=deck+design, Sujal=deck assist), research machine 49/7/3.2M/4,800, demo-script fixed, deck content latest
</commit_message>
<xml_diff>
--- a/scaffold/deck/KrishiSetu-Round0-20260816.pptx
+++ b/scaffold/deck/KrishiSetu-Round0-20260816.pptx
@@ -864,7 +864,7 @@
           <a:p>
             <a:r>
               <a:rPr lang="en-US" dirty="0"/>
-              <a:t>This slide is the holy-shit moment: 48 runs, 7 waves, 2.5M chars, 4,000+ sources, A-D grades. Judges who ask 'where is this from' get a path. Never claim we read everything without this map to prove it.</a:t>
+              <a:t>This slide is the holy-shit moment: 49 reports, 7 waves, 3.2M chars, 4,800+ sources, A-D grades. Judges who ask 'where is this from' get a path. Never claim we read everything without this map to prove it.</a:t>
             </a:r>
             <a:endParaRPr lang="en-US" dirty="0"/>
           </a:p>
@@ -2349,7 +2349,7 @@
                 <a:ea typeface="Arial" pitchFamily="34" charset="-122"/>
                 <a:cs typeface="Arial" pitchFamily="34" charset="-120"/>
               </a:rPr>
-              <a:t>systems, research method, 17-statement evidence wave</a:t>
+              <a:t>everything: architecture, code, research method, 49-report evidence wave, backend, QA, devops</a:t>
             </a:r>
             <a:endParaRPr lang="en-US" sz="950" dirty="0"/>
           </a:p>
@@ -2538,7 +2538,7 @@
                 <a:ea typeface="Arial" pitchFamily="34" charset="-122"/>
                 <a:cs typeface="Arial" pitchFamily="34" charset="-120"/>
               </a:rPr>
-              <a:t>Engine and demo</a:t>
+              <a:t>Deck and design</a:t>
             </a:r>
             <a:endParaRPr lang="en-US" sz="1150" dirty="0"/>
           </a:p>
@@ -2577,7 +2577,7 @@
                 <a:ea typeface="Arial" pitchFamily="34" charset="-122"/>
                 <a:cs typeface="Arial" pitchFamily="34" charset="-120"/>
               </a:rPr>
-              <a:t>zero-dep engine, demo.sh, seed data</a:t>
+              <a:t>presentation build and design</a:t>
             </a:r>
             <a:endParaRPr lang="en-US" sz="950" dirty="0"/>
           </a:p>
@@ -2766,7 +2766,7 @@
                 <a:ea typeface="Arial" pitchFamily="34" charset="-122"/>
                 <a:cs typeface="Arial" pitchFamily="34" charset="-120"/>
               </a:rPr>
-              <a:t>Deck and submission</a:t>
+              <a:t>Deck design</a:t>
             </a:r>
             <a:endParaRPr lang="en-US" sz="1150" dirty="0"/>
           </a:p>
@@ -2805,7 +2805,7 @@
                 <a:ea typeface="Arial" pitchFamily="34" charset="-122"/>
                 <a:cs typeface="Arial" pitchFamily="34" charset="-120"/>
               </a:rPr>
-              <a:t>submission text, paste at gates, backup demo runner</a:t>
+              <a:t>design assistance on the presentation</a:t>
             </a:r>
             <a:endParaRPr lang="en-US" sz="950" dirty="0"/>
           </a:p>
@@ -4360,7 +4360,7 @@
                 <a:ea typeface="Arial Black" pitchFamily="34" charset="-122"/>
                 <a:cs typeface="Arial Black" pitchFamily="34" charset="-120"/>
               </a:rPr>
-              <a:t>48</a:t>
+              <a:t>49</a:t>
             </a:r>
             <a:endParaRPr lang="en-US" sz="4400" dirty="0"/>
           </a:p>
@@ -4399,7 +4399,7 @@
                 <a:ea typeface="Arial" pitchFamily="34" charset="-122"/>
                 <a:cs typeface="Arial" pitchFamily="34" charset="-120"/>
               </a:rPr>
-              <a:t>parallel deep-research runs, 7 waves, every run multi-channel with coverage tables, noise logs, A-D evidence grades</a:t>
+              <a:t>parallel deep-research reports across 7 waves, every run multi-channel with coverage tables, noise logs, A-D evidence grades</a:t>
             </a:r>
             <a:endParaRPr lang="en-US" sz="950" dirty="0"/>
           </a:p>
@@ -4554,7 +4554,7 @@
                 <a:ea typeface="Arial Black" pitchFamily="34" charset="-122"/>
                 <a:cs typeface="Arial Black" pitchFamily="34" charset="-120"/>
               </a:rPr>
-              <a:t>2.5M+</a:t>
+              <a:t>3.2M+</a:t>
             </a:r>
             <a:endParaRPr lang="en-US" sz="4400" dirty="0"/>
           </a:p>
@@ -4748,7 +4748,7 @@
                 <a:ea typeface="Arial Black" pitchFamily="34" charset="-122"/>
                 <a:cs typeface="Arial Black" pitchFamily="34" charset="-120"/>
               </a:rPr>
-              <a:t>4,000+</a:t>
+              <a:t>4,800+</a:t>
             </a:r>
             <a:endParaRPr lang="en-US" sz="4400" dirty="0"/>
           </a:p>
@@ -4787,7 +4787,7 @@
                 <a:ea typeface="Arial" pitchFamily="34" charset="-122"/>
                 <a:cs typeface="Arial" pitchFamily="34" charset="-120"/>
               </a:rPr>
-              <a:t>cited sources across 6 continents: cyclone/food/agri ledgers, cascade math, human wisdom, frontier science</a:t>
+              <a:t>cited source mentions across 6 continents: cyclone/flood/agri ledgers, cascade math, human wisdom, frontier science</a:t>
             </a:r>
             <a:endParaRPr lang="en-US" sz="950" dirty="0"/>
           </a:p>

</xml_diff>

<commit_message>
deck S6: runtime story added (Zero-dep no keys/no network, Self-dependent 4G-or-less, Live on CPU millisecond math)
</commit_message>
<xml_diff>
--- a/scaffold/deck/KrishiSetu-Round0-20260816.pptx
+++ b/scaffold/deck/KrishiSetu-Round0-20260816.pptx
@@ -7519,7 +7519,7 @@
         <p:spPr>
           <a:xfrm>
             <a:off x="507492" y="1101852"/>
-            <a:ext cx="4069080" cy="914400"/>
+            <a:ext cx="4069080" cy="841248"/>
           </a:xfrm>
           <a:prstGeom prst="rect">
             <a:avLst/>
@@ -7544,7 +7544,7 @@
         <p:spPr>
           <a:xfrm>
             <a:off x="4507992" y="1124712"/>
-            <a:ext cx="82296" cy="768096"/>
+            <a:ext cx="82296" cy="694944"/>
           </a:xfrm>
           <a:prstGeom prst="parallelogram">
             <a:avLst/>
@@ -7569,11 +7569,11 @@
         <p:spPr>
           <a:xfrm rot="-90000">
             <a:off x="457200" y="1051560"/>
-            <a:ext cx="4069080" cy="914400"/>
+            <a:ext cx="4069080" cy="841248"/>
           </a:xfrm>
           <a:prstGeom prst="roundRect">
             <a:avLst>
-              <a:gd name="adj" fmla="val 6000"/>
+              <a:gd name="adj" fmla="val 6522"/>
             </a:avLst>
           </a:prstGeom>
           <a:solidFill>
@@ -7595,7 +7595,7 @@
         </p:nvSpPr>
         <p:spPr>
           <a:xfrm>
-            <a:off x="594360" y="1161288"/>
+            <a:off x="594360" y="1143000"/>
             <a:ext cx="1737360" cy="457200"/>
           </a:xfrm>
           <a:prstGeom prst="rect">
@@ -7612,7 +7612,7 @@
               <a:buNone/>
             </a:pPr>
             <a:r>
-              <a:rPr lang="en-US" sz="2000" b="1" dirty="0">
+              <a:rPr lang="en-US" sz="1800" b="1" dirty="0">
                 <a:solidFill>
                   <a:srgbClr val="FFFFFF"/>
                 </a:solidFill>
@@ -7622,7 +7622,7 @@
               </a:rPr>
               <a:t>85 / 85</a:t>
             </a:r>
-            <a:endParaRPr lang="en-US" sz="2000" dirty="0"/>
+            <a:endParaRPr lang="en-US" sz="1800" dirty="0"/>
           </a:p>
         </p:txBody>
       </p:sp>
@@ -7634,8 +7634,8 @@
         </p:nvSpPr>
         <p:spPr>
           <a:xfrm>
-            <a:off x="2331720" y="1161288"/>
-            <a:ext cx="2103120" cy="731520"/>
+            <a:off x="2331720" y="1143000"/>
+            <a:ext cx="2103120" cy="685800"/>
           </a:xfrm>
           <a:prstGeom prst="rect">
             <a:avLst/>
@@ -7651,7 +7651,7 @@
               <a:buNone/>
             </a:pPr>
             <a:r>
-              <a:rPr lang="en-US" sz="950" dirty="0">
+              <a:rPr lang="en-US" sz="900" dirty="0">
                 <a:solidFill>
                   <a:srgbClr val="B0B0B0"/>
                 </a:solidFill>
@@ -7661,7 +7661,7 @@
               </a:rPr>
               <a:t>acceptance suites green across approval, trace, providers, multimodal, provenance, feeds, honesty, stress</a:t>
             </a:r>
-            <a:endParaRPr lang="en-US" sz="950" dirty="0"/>
+            <a:endParaRPr lang="en-US" sz="900" dirty="0"/>
           </a:p>
         </p:txBody>
       </p:sp>
@@ -7674,7 +7674,7 @@
         <p:spPr>
           <a:xfrm>
             <a:off x="4668012" y="1101852"/>
-            <a:ext cx="4069080" cy="914400"/>
+            <a:ext cx="4069080" cy="841248"/>
           </a:xfrm>
           <a:prstGeom prst="rect">
             <a:avLst/>
@@ -7699,7 +7699,7 @@
         <p:spPr>
           <a:xfrm>
             <a:off x="8668512" y="1124712"/>
-            <a:ext cx="82296" cy="768096"/>
+            <a:ext cx="82296" cy="694944"/>
           </a:xfrm>
           <a:prstGeom prst="parallelogram">
             <a:avLst/>
@@ -7724,11 +7724,11 @@
         <p:spPr>
           <a:xfrm rot="-90000">
             <a:off x="4617720" y="1051560"/>
-            <a:ext cx="4069080" cy="914400"/>
+            <a:ext cx="4069080" cy="841248"/>
           </a:xfrm>
           <a:prstGeom prst="roundRect">
             <a:avLst>
-              <a:gd name="adj" fmla="val 6000"/>
+              <a:gd name="adj" fmla="val 6522"/>
             </a:avLst>
           </a:prstGeom>
           <a:solidFill>
@@ -7750,7 +7750,7 @@
         </p:nvSpPr>
         <p:spPr>
           <a:xfrm>
-            <a:off x="4754880" y="1161288"/>
+            <a:off x="4754880" y="1143000"/>
             <a:ext cx="1737360" cy="457200"/>
           </a:xfrm>
           <a:prstGeom prst="rect">
@@ -7767,7 +7767,7 @@
               <a:buNone/>
             </a:pPr>
             <a:r>
-              <a:rPr lang="en-US" sz="2000" b="1" dirty="0">
+              <a:rPr lang="en-US" sz="1800" b="1" dirty="0">
                 <a:solidFill>
                   <a:srgbClr val="FFFFFF"/>
                 </a:solidFill>
@@ -7777,7 +7777,7 @@
               </a:rPr>
               <a:t>46 / 46</a:t>
             </a:r>
-            <a:endParaRPr lang="en-US" sz="2000" dirty="0"/>
+            <a:endParaRPr lang="en-US" sz="1800" dirty="0"/>
           </a:p>
         </p:txBody>
       </p:sp>
@@ -7789,8 +7789,8 @@
         </p:nvSpPr>
         <p:spPr>
           <a:xfrm>
-            <a:off x="6492240" y="1161288"/>
-            <a:ext cx="2103120" cy="731520"/>
+            <a:off x="6492240" y="1143000"/>
+            <a:ext cx="2103120" cy="685800"/>
           </a:xfrm>
           <a:prstGeom prst="rect">
             <a:avLst/>
@@ -7806,7 +7806,7 @@
               <a:buNone/>
             </a:pPr>
             <a:r>
-              <a:rPr lang="en-US" sz="950" dirty="0">
+              <a:rPr lang="en-US" sz="900" dirty="0">
                 <a:solidFill>
                   <a:srgbClr val="B0B0B0"/>
                 </a:solidFill>
@@ -7816,7 +7816,7 @@
               </a:rPr>
               <a:t>lane fixture scenarios verified, order-independent on fresh databases</a:t>
             </a:r>
-            <a:endParaRPr lang="en-US" sz="950" dirty="0"/>
+            <a:endParaRPr lang="en-US" sz="900" dirty="0"/>
           </a:p>
         </p:txBody>
       </p:sp>
@@ -7828,8 +7828,8 @@
         </p:nvSpPr>
         <p:spPr>
           <a:xfrm>
-            <a:off x="507492" y="2153412"/>
-            <a:ext cx="4069080" cy="914400"/>
+            <a:off x="507492" y="2061972"/>
+            <a:ext cx="4069080" cy="841248"/>
           </a:xfrm>
           <a:prstGeom prst="rect">
             <a:avLst/>
@@ -7853,8 +7853,8 @@
         </p:nvSpPr>
         <p:spPr>
           <a:xfrm>
-            <a:off x="4507992" y="2176272"/>
-            <a:ext cx="82296" cy="768096"/>
+            <a:off x="4507992" y="2084832"/>
+            <a:ext cx="82296" cy="694944"/>
           </a:xfrm>
           <a:prstGeom prst="parallelogram">
             <a:avLst/>
@@ -7878,12 +7878,12 @@
         </p:nvSpPr>
         <p:spPr>
           <a:xfrm rot="-90000">
-            <a:off x="457200" y="2103120"/>
-            <a:ext cx="4069080" cy="914400"/>
+            <a:off x="457200" y="2011680"/>
+            <a:ext cx="4069080" cy="841248"/>
           </a:xfrm>
           <a:prstGeom prst="roundRect">
             <a:avLst>
-              <a:gd name="adj" fmla="val 6000"/>
+              <a:gd name="adj" fmla="val 6522"/>
             </a:avLst>
           </a:prstGeom>
           <a:solidFill>
@@ -7905,7 +7905,7 @@
         </p:nvSpPr>
         <p:spPr>
           <a:xfrm>
-            <a:off x="594360" y="2212848"/>
+            <a:off x="594360" y="2103120"/>
             <a:ext cx="1737360" cy="457200"/>
           </a:xfrm>
           <a:prstGeom prst="rect">
@@ -7922,7 +7922,7 @@
               <a:buNone/>
             </a:pPr>
             <a:r>
-              <a:rPr lang="en-US" sz="2000" b="1" dirty="0">
+              <a:rPr lang="en-US" sz="1800" b="1" dirty="0">
                 <a:solidFill>
                   <a:srgbClr val="FFFFFF"/>
                 </a:solidFill>
@@ -7932,7 +7932,7 @@
               </a:rPr>
               <a:t>Zero-dep</a:t>
             </a:r>
-            <a:endParaRPr lang="en-US" sz="2000" dirty="0"/>
+            <a:endParaRPr lang="en-US" sz="1800" dirty="0"/>
           </a:p>
         </p:txBody>
       </p:sp>
@@ -7944,8 +7944,8 @@
         </p:nvSpPr>
         <p:spPr>
           <a:xfrm>
-            <a:off x="2331720" y="2212848"/>
-            <a:ext cx="2103120" cy="731520"/>
+            <a:off x="2331720" y="2103120"/>
+            <a:ext cx="2103120" cy="685800"/>
           </a:xfrm>
           <a:prstGeom prst="rect">
             <a:avLst/>
@@ -7961,7 +7961,7 @@
               <a:buNone/>
             </a:pPr>
             <a:r>
-              <a:rPr lang="en-US" sz="950" dirty="0">
+              <a:rPr lang="en-US" sz="900" dirty="0">
                 <a:solidFill>
                   <a:srgbClr val="B0B0B0"/>
                 </a:solidFill>
@@ -7969,9 +7969,9 @@
                 <a:ea typeface="Arial" pitchFamily="34" charset="-122"/>
                 <a:cs typeface="Arial" pitchFamily="34" charset="-120"/>
               </a:rPr>
-              <a:t>engine runs on stdlib only; demo never dies, offline fallback replay</a:t>
-            </a:r>
-            <a:endParaRPr lang="en-US" sz="950" dirty="0"/>
+              <a:t>stdlib python only: no installs, no API keys, no network. runs on any machine with python3</a:t>
+            </a:r>
+            <a:endParaRPr lang="en-US" sz="900" dirty="0"/>
           </a:p>
         </p:txBody>
       </p:sp>
@@ -7983,8 +7983,8 @@
         </p:nvSpPr>
         <p:spPr>
           <a:xfrm>
-            <a:off x="4668012" y="2153412"/>
-            <a:ext cx="4069080" cy="914400"/>
+            <a:off x="4668012" y="2061972"/>
+            <a:ext cx="4069080" cy="841248"/>
           </a:xfrm>
           <a:prstGeom prst="rect">
             <a:avLst/>
@@ -8008,8 +8008,8 @@
         </p:nvSpPr>
         <p:spPr>
           <a:xfrm>
-            <a:off x="8668512" y="2176272"/>
-            <a:ext cx="82296" cy="768096"/>
+            <a:off x="8668512" y="2084832"/>
+            <a:ext cx="82296" cy="694944"/>
           </a:xfrm>
           <a:prstGeom prst="parallelogram">
             <a:avLst/>
@@ -8033,12 +8033,12 @@
         </p:nvSpPr>
         <p:spPr>
           <a:xfrm rot="-90000">
-            <a:off x="4617720" y="2103120"/>
-            <a:ext cx="4069080" cy="914400"/>
+            <a:off x="4617720" y="2011680"/>
+            <a:ext cx="4069080" cy="841248"/>
           </a:xfrm>
           <a:prstGeom prst="roundRect">
             <a:avLst>
-              <a:gd name="adj" fmla="val 6000"/>
+              <a:gd name="adj" fmla="val 6522"/>
             </a:avLst>
           </a:prstGeom>
           <a:solidFill>
@@ -8060,7 +8060,7 @@
         </p:nvSpPr>
         <p:spPr>
           <a:xfrm>
-            <a:off x="4754880" y="2212848"/>
+            <a:off x="4754880" y="2103120"/>
             <a:ext cx="1737360" cy="457200"/>
           </a:xfrm>
           <a:prstGeom prst="rect">
@@ -8077,7 +8077,7 @@
               <a:buNone/>
             </a:pPr>
             <a:r>
-              <a:rPr lang="en-US" sz="2000" b="1" dirty="0">
+              <a:rPr lang="en-US" sz="1800" b="1" dirty="0">
                 <a:solidFill>
                   <a:srgbClr val="FFFFFF"/>
                 </a:solidFill>
@@ -8085,9 +8085,9 @@
                 <a:ea typeface="Arial Black" pitchFamily="34" charset="-122"/>
                 <a:cs typeface="Arial Black" pitchFamily="34" charset="-120"/>
               </a:rPr>
-              <a:t>Honest mode</a:t>
-            </a:r>
-            <a:endParaRPr lang="en-US" sz="2000" dirty="0"/>
+              <a:t>Self-dependent</a:t>
+            </a:r>
+            <a:endParaRPr lang="en-US" sz="1800" dirty="0"/>
           </a:p>
         </p:txBody>
       </p:sp>
@@ -8099,8 +8099,8 @@
         </p:nvSpPr>
         <p:spPr>
           <a:xfrm>
-            <a:off x="6492240" y="2212848"/>
-            <a:ext cx="2103120" cy="731520"/>
+            <a:off x="6492240" y="2103120"/>
+            <a:ext cx="2103120" cy="685800"/>
           </a:xfrm>
           <a:prstGeom prst="rect">
             <a:avLst/>
@@ -8116,7 +8116,7 @@
               <a:buNone/>
             </a:pPr>
             <a:r>
-              <a:rPr lang="en-US" sz="950" dirty="0">
+              <a:rPr lang="en-US" sz="900" dirty="0">
                 <a:solidFill>
                   <a:srgbClr val="B0B0B0"/>
                 </a:solidFill>
@@ -8124,61 +8124,22 @@
                 <a:ea typeface="Arial" pitchFamily="34" charset="-122"/>
                 <a:cs typeface="Arial" pitchFamily="34" charset="-120"/>
               </a:rPr>
-              <a:t>badges count actual provider outcomes, no badge-lie, audit trail per action</a:t>
-            </a:r>
-            <a:endParaRPr lang="en-US" sz="950" dirty="0"/>
-          </a:p>
-        </p:txBody>
-      </p:sp>
-      <p:sp>
-        <p:nvSpPr>
-          <p:cNvPr id="25" name="Text 23"/>
-          <p:cNvSpPr/>
-          <p:nvPr/>
-        </p:nvSpPr>
-        <p:spPr>
-          <a:xfrm>
-            <a:off x="4983480" y="3291840"/>
-            <a:ext cx="3657600" cy="822960"/>
-          </a:xfrm>
-          <a:prstGeom prst="rect">
-            <a:avLst/>
-          </a:prstGeom>
-          <a:noFill/>
-          <a:ln/>
-        </p:spPr>
-        <p:txBody>
-          <a:bodyPr wrap="square" lIns="0" tIns="0" rIns="0" bIns="0" rtlCol="0" anchor="ctr"/>
-          <a:lstStyle/>
-          <a:p>
-            <a:pPr indent="0" marL="0">
-              <a:buNone/>
-            </a:pPr>
-            <a:r>
-              <a:rPr lang="en-US" sz="1150" dirty="0">
-                <a:solidFill>
-                  <a:srgbClr val="0A0A0A"/>
-                </a:solidFill>
-                <a:latin typeface="Arial" pitchFamily="34" charset="0"/>
-                <a:ea typeface="Arial" pitchFamily="34" charset="-122"/>
-                <a:cs typeface="Arial" pitchFamily="34" charset="-120"/>
-              </a:rPr>
-              <a:t>Demo arc (3 minutes): Asha's plot -&gt; cyclone forecast -&gt; staged Odia advisory -&gt; tower drops, advice still syncs -&gt; damage evidence -&gt; claim packet export.</a:t>
-            </a:r>
-            <a:endParaRPr lang="en-US" sz="1150" dirty="0"/>
-          </a:p>
-        </p:txBody>
-      </p:sp>
-      <p:sp>
-        <p:nvSpPr>
-          <p:cNvPr id="26" name="Shape 24"/>
-          <p:cNvSpPr/>
-          <p:nvPr/>
-        </p:nvSpPr>
-        <p:spPr>
-          <a:xfrm>
-            <a:off x="507492" y="4027932"/>
-            <a:ext cx="8229600" cy="658368"/>
+              <a:t>built for 4G or less, offline-first by design: decision engine + UI run entirely on local CPU</a:t>
+            </a:r>
+            <a:endParaRPr lang="en-US" sz="900" dirty="0"/>
+          </a:p>
+        </p:txBody>
+      </p:sp>
+      <p:sp>
+        <p:nvSpPr>
+          <p:cNvPr id="25" name="Shape 23"/>
+          <p:cNvSpPr/>
+          <p:nvPr/>
+        </p:nvSpPr>
+        <p:spPr>
+          <a:xfrm>
+            <a:off x="507492" y="3022092"/>
+            <a:ext cx="4069080" cy="841248"/>
           </a:xfrm>
           <a:prstGeom prst="rect">
             <a:avLst/>
@@ -8196,18 +8157,43 @@
       </p:sp>
       <p:sp>
         <p:nvSpPr>
+          <p:cNvPr id="26" name="Shape 24"/>
+          <p:cNvSpPr/>
+          <p:nvPr/>
+        </p:nvSpPr>
+        <p:spPr>
+          <a:xfrm>
+            <a:off x="4507992" y="3044952"/>
+            <a:ext cx="82296" cy="694944"/>
+          </a:xfrm>
+          <a:prstGeom prst="parallelogram">
+            <a:avLst/>
+          </a:prstGeom>
+          <a:solidFill>
+            <a:srgbClr val="555555"/>
+          </a:solidFill>
+          <a:ln w="12700">
+            <a:solidFill>
+              <a:srgbClr val="555555"/>
+            </a:solidFill>
+            <a:prstDash val="solid"/>
+          </a:ln>
+        </p:spPr>
+      </p:sp>
+      <p:sp>
+        <p:nvSpPr>
           <p:cNvPr id="27" name="Shape 25"/>
           <p:cNvSpPr/>
           <p:nvPr/>
         </p:nvSpPr>
         <p:spPr>
-          <a:xfrm>
-            <a:off x="457200" y="3977640"/>
-            <a:ext cx="8229600" cy="658368"/>
+          <a:xfrm rot="-90000">
+            <a:off x="457200" y="2971800"/>
+            <a:ext cx="4069080" cy="841248"/>
           </a:xfrm>
           <a:prstGeom prst="roundRect">
             <a:avLst>
-              <a:gd name="adj" fmla="val 8333"/>
+              <a:gd name="adj" fmla="val 6522"/>
             </a:avLst>
           </a:prstGeom>
           <a:solidFill>
@@ -8223,7 +8209,331 @@
       </p:sp>
       <p:sp>
         <p:nvSpPr>
-          <p:cNvPr id="28" name="Shape 26"/>
+          <p:cNvPr id="28" name="Text 26"/>
+          <p:cNvSpPr/>
+          <p:nvPr/>
+        </p:nvSpPr>
+        <p:spPr>
+          <a:xfrm>
+            <a:off x="594360" y="3063240"/>
+            <a:ext cx="1737360" cy="457200"/>
+          </a:xfrm>
+          <a:prstGeom prst="rect">
+            <a:avLst/>
+          </a:prstGeom>
+          <a:noFill/>
+          <a:ln/>
+        </p:spPr>
+        <p:txBody>
+          <a:bodyPr wrap="square" lIns="0" tIns="0" rIns="0" bIns="0" rtlCol="0" anchor="ctr"/>
+          <a:lstStyle/>
+          <a:p>
+            <a:pPr indent="0" marL="0">
+              <a:buNone/>
+            </a:pPr>
+            <a:r>
+              <a:rPr lang="en-US" sz="1800" b="1" dirty="0">
+                <a:solidFill>
+                  <a:srgbClr val="FFFFFF"/>
+                </a:solidFill>
+                <a:latin typeface="Arial Black" pitchFamily="34" charset="0"/>
+                <a:ea typeface="Arial Black" pitchFamily="34" charset="-122"/>
+                <a:cs typeface="Arial Black" pitchFamily="34" charset="-120"/>
+              </a:rPr>
+              <a:t>Honest mode</a:t>
+            </a:r>
+            <a:endParaRPr lang="en-US" sz="1800" dirty="0"/>
+          </a:p>
+        </p:txBody>
+      </p:sp>
+      <p:sp>
+        <p:nvSpPr>
+          <p:cNvPr id="29" name="Text 27"/>
+          <p:cNvSpPr/>
+          <p:nvPr/>
+        </p:nvSpPr>
+        <p:spPr>
+          <a:xfrm>
+            <a:off x="2331720" y="3063240"/>
+            <a:ext cx="2103120" cy="685800"/>
+          </a:xfrm>
+          <a:prstGeom prst="rect">
+            <a:avLst/>
+          </a:prstGeom>
+          <a:noFill/>
+          <a:ln/>
+        </p:spPr>
+        <p:txBody>
+          <a:bodyPr wrap="square" lIns="0" tIns="0" rIns="0" bIns="0" rtlCol="0" anchor="ctr"/>
+          <a:lstStyle/>
+          <a:p>
+            <a:pPr indent="0" marL="0">
+              <a:buNone/>
+            </a:pPr>
+            <a:r>
+              <a:rPr lang="en-US" sz="900" dirty="0">
+                <a:solidFill>
+                  <a:srgbClr val="B0B0B0"/>
+                </a:solidFill>
+                <a:latin typeface="Arial" pitchFamily="34" charset="0"/>
+                <a:ea typeface="Arial" pitchFamily="34" charset="-122"/>
+                <a:cs typeface="Arial" pitchFamily="34" charset="-120"/>
+              </a:rPr>
+              <a:t>badges count actual provider outcomes, no badge-lie, audit trail per action</a:t>
+            </a:r>
+            <a:endParaRPr lang="en-US" sz="900" dirty="0"/>
+          </a:p>
+        </p:txBody>
+      </p:sp>
+      <p:sp>
+        <p:nvSpPr>
+          <p:cNvPr id="30" name="Shape 28"/>
+          <p:cNvSpPr/>
+          <p:nvPr/>
+        </p:nvSpPr>
+        <p:spPr>
+          <a:xfrm>
+            <a:off x="4668012" y="3022092"/>
+            <a:ext cx="4069080" cy="841248"/>
+          </a:xfrm>
+          <a:prstGeom prst="rect">
+            <a:avLst/>
+          </a:prstGeom>
+          <a:solidFill>
+            <a:srgbClr val="E0E0E0"/>
+          </a:solidFill>
+          <a:ln w="12700">
+            <a:solidFill>
+              <a:srgbClr val="E0E0E0"/>
+            </a:solidFill>
+            <a:prstDash val="solid"/>
+          </a:ln>
+        </p:spPr>
+      </p:sp>
+      <p:sp>
+        <p:nvSpPr>
+          <p:cNvPr id="31" name="Shape 29"/>
+          <p:cNvSpPr/>
+          <p:nvPr/>
+        </p:nvSpPr>
+        <p:spPr>
+          <a:xfrm>
+            <a:off x="8668512" y="3044952"/>
+            <a:ext cx="82296" cy="694944"/>
+          </a:xfrm>
+          <a:prstGeom prst="parallelogram">
+            <a:avLst/>
+          </a:prstGeom>
+          <a:solidFill>
+            <a:srgbClr val="555555"/>
+          </a:solidFill>
+          <a:ln w="12700">
+            <a:solidFill>
+              <a:srgbClr val="555555"/>
+            </a:solidFill>
+            <a:prstDash val="solid"/>
+          </a:ln>
+        </p:spPr>
+      </p:sp>
+      <p:sp>
+        <p:nvSpPr>
+          <p:cNvPr id="32" name="Shape 30"/>
+          <p:cNvSpPr/>
+          <p:nvPr/>
+        </p:nvSpPr>
+        <p:spPr>
+          <a:xfrm rot="-90000">
+            <a:off x="4617720" y="2971800"/>
+            <a:ext cx="4069080" cy="841248"/>
+          </a:xfrm>
+          <a:prstGeom prst="roundRect">
+            <a:avLst>
+              <a:gd name="adj" fmla="val 6522"/>
+            </a:avLst>
+          </a:prstGeom>
+          <a:solidFill>
+            <a:srgbClr val="0A0A0A"/>
+          </a:solidFill>
+          <a:ln w="12700">
+            <a:solidFill>
+              <a:srgbClr val="FFFFFF"/>
+            </a:solidFill>
+            <a:prstDash val="solid"/>
+          </a:ln>
+        </p:spPr>
+      </p:sp>
+      <p:sp>
+        <p:nvSpPr>
+          <p:cNvPr id="33" name="Text 31"/>
+          <p:cNvSpPr/>
+          <p:nvPr/>
+        </p:nvSpPr>
+        <p:spPr>
+          <a:xfrm>
+            <a:off x="4754880" y="3063240"/>
+            <a:ext cx="1737360" cy="457200"/>
+          </a:xfrm>
+          <a:prstGeom prst="rect">
+            <a:avLst/>
+          </a:prstGeom>
+          <a:noFill/>
+          <a:ln/>
+        </p:spPr>
+        <p:txBody>
+          <a:bodyPr wrap="square" lIns="0" tIns="0" rIns="0" bIns="0" rtlCol="0" anchor="ctr"/>
+          <a:lstStyle/>
+          <a:p>
+            <a:pPr indent="0" marL="0">
+              <a:buNone/>
+            </a:pPr>
+            <a:r>
+              <a:rPr lang="en-US" sz="1800" b="1" dirty="0">
+                <a:solidFill>
+                  <a:srgbClr val="FFFFFF"/>
+                </a:solidFill>
+                <a:latin typeface="Arial Black" pitchFamily="34" charset="0"/>
+                <a:ea typeface="Arial Black" pitchFamily="34" charset="-122"/>
+                <a:cs typeface="Arial Black" pitchFamily="34" charset="-120"/>
+              </a:rPr>
+              <a:t>Live on CPU</a:t>
+            </a:r>
+            <a:endParaRPr lang="en-US" sz="1800" dirty="0"/>
+          </a:p>
+        </p:txBody>
+      </p:sp>
+      <p:sp>
+        <p:nvSpPr>
+          <p:cNvPr id="34" name="Text 32"/>
+          <p:cNvSpPr/>
+          <p:nvPr/>
+        </p:nvSpPr>
+        <p:spPr>
+          <a:xfrm>
+            <a:off x="6492240" y="3063240"/>
+            <a:ext cx="2103120" cy="685800"/>
+          </a:xfrm>
+          <a:prstGeom prst="rect">
+            <a:avLst/>
+          </a:prstGeom>
+          <a:noFill/>
+          <a:ln/>
+        </p:spPr>
+        <p:txBody>
+          <a:bodyPr wrap="square" lIns="0" tIns="0" rIns="0" bIns="0" rtlCol="0" anchor="ctr"/>
+          <a:lstStyle/>
+          <a:p>
+            <a:pPr indent="0" marL="0">
+              <a:buNone/>
+            </a:pPr>
+            <a:r>
+              <a:rPr lang="en-US" sz="900" dirty="0">
+                <a:solidFill>
+                  <a:srgbClr val="B0B0B0"/>
+                </a:solidFill>
+                <a:latin typeface="Arial" pitchFamily="34" charset="0"/>
+                <a:ea typeface="Arial" pitchFamily="34" charset="-122"/>
+                <a:cs typeface="Arial" pitchFamily="34" charset="-120"/>
+              </a:rPr>
+              <a:t>CVaR harvest decision, Fani replay band, ladder, claim packet: all computed live, milliseconds, no GPU needed</a:t>
+            </a:r>
+            <a:endParaRPr lang="en-US" sz="900" dirty="0"/>
+          </a:p>
+        </p:txBody>
+      </p:sp>
+      <p:sp>
+        <p:nvSpPr>
+          <p:cNvPr id="35" name="Text 33"/>
+          <p:cNvSpPr/>
+          <p:nvPr/>
+        </p:nvSpPr>
+        <p:spPr>
+          <a:xfrm>
+            <a:off x="4983480" y="3291840"/>
+            <a:ext cx="3657600" cy="822960"/>
+          </a:xfrm>
+          <a:prstGeom prst="rect">
+            <a:avLst/>
+          </a:prstGeom>
+          <a:noFill/>
+          <a:ln/>
+        </p:spPr>
+        <p:txBody>
+          <a:bodyPr wrap="square" lIns="0" tIns="0" rIns="0" bIns="0" rtlCol="0" anchor="ctr"/>
+          <a:lstStyle/>
+          <a:p>
+            <a:pPr indent="0" marL="0">
+              <a:buNone/>
+            </a:pPr>
+            <a:r>
+              <a:rPr lang="en-US" sz="1150" dirty="0">
+                <a:solidFill>
+                  <a:srgbClr val="0A0A0A"/>
+                </a:solidFill>
+                <a:latin typeface="Arial" pitchFamily="34" charset="0"/>
+                <a:ea typeface="Arial" pitchFamily="34" charset="-122"/>
+                <a:cs typeface="Arial" pitchFamily="34" charset="-120"/>
+              </a:rPr>
+              <a:t>Demo arc (3 minutes): Asha's plot -&gt; cyclone forecast -&gt; staged Odia advisory -&gt; tower drops, advice still syncs -&gt; damage evidence -&gt; claim packet export.</a:t>
+            </a:r>
+            <a:endParaRPr lang="en-US" sz="1150" dirty="0"/>
+          </a:p>
+        </p:txBody>
+      </p:sp>
+      <p:sp>
+        <p:nvSpPr>
+          <p:cNvPr id="36" name="Shape 34"/>
+          <p:cNvSpPr/>
+          <p:nvPr/>
+        </p:nvSpPr>
+        <p:spPr>
+          <a:xfrm>
+            <a:off x="507492" y="4027932"/>
+            <a:ext cx="8229600" cy="658368"/>
+          </a:xfrm>
+          <a:prstGeom prst="rect">
+            <a:avLst/>
+          </a:prstGeom>
+          <a:solidFill>
+            <a:srgbClr val="E0E0E0"/>
+          </a:solidFill>
+          <a:ln w="12700">
+            <a:solidFill>
+              <a:srgbClr val="E0E0E0"/>
+            </a:solidFill>
+            <a:prstDash val="solid"/>
+          </a:ln>
+        </p:spPr>
+      </p:sp>
+      <p:sp>
+        <p:nvSpPr>
+          <p:cNvPr id="37" name="Shape 35"/>
+          <p:cNvSpPr/>
+          <p:nvPr/>
+        </p:nvSpPr>
+        <p:spPr>
+          <a:xfrm>
+            <a:off x="457200" y="3977640"/>
+            <a:ext cx="8229600" cy="658368"/>
+          </a:xfrm>
+          <a:prstGeom prst="roundRect">
+            <a:avLst>
+              <a:gd name="adj" fmla="val 8333"/>
+            </a:avLst>
+          </a:prstGeom>
+          <a:solidFill>
+            <a:srgbClr val="0A0A0A"/>
+          </a:solidFill>
+          <a:ln w="12700">
+            <a:solidFill>
+              <a:srgbClr val="FFFFFF"/>
+            </a:solidFill>
+            <a:prstDash val="solid"/>
+          </a:ln>
+        </p:spPr>
+      </p:sp>
+      <p:sp>
+        <p:nvSpPr>
+          <p:cNvPr id="38" name="Shape 36"/>
           <p:cNvSpPr/>
           <p:nvPr/>
         </p:nvSpPr>
@@ -8248,7 +8558,7 @@
       </p:sp>
       <p:sp>
         <p:nvSpPr>
-          <p:cNvPr id="29" name="Text 27"/>
+          <p:cNvPr id="39" name="Text 37"/>
           <p:cNvSpPr/>
           <p:nvPr/>
         </p:nvSpPr>
@@ -8287,7 +8597,7 @@
       </p:sp>
       <p:sp>
         <p:nvSpPr>
-          <p:cNvPr id="30" name="Text 28"/>
+          <p:cNvPr id="40" name="Text 38"/>
           <p:cNvSpPr/>
           <p:nvPr/>
         </p:nvSpPr>

</xml_diff>

<commit_message>
deck: counterfactual slide (Fani/Yaas/Dana/1999 real events, real lead times, engine output vs ground truth, no avoided-loss claims) + gate to 13 slides
</commit_message>
<xml_diff>
--- a/scaffold/deck/KrishiSetu-Round0-20260816.pptx
+++ b/scaffold/deck/KrishiSetu-Round0-20260816.pptx
@@ -17,9 +17,10 @@
     <p:sldId id="265" r:id="rId11"/>
     <p:sldId id="266" r:id="rId12"/>
     <p:sldId id="267" r:id="rId13"/>
+    <p:sldId id="268" r:id="rId14"/>
   </p:sldIdLst>
   <p:notesMasterIdLst>
-    <p:notesMasterId r:id="rId14"/>
+    <p:notesMasterId r:id="rId15"/>
   </p:notesMasterIdLst>
   <p:sldSz cx="9144000" cy="5143500"/>
   <p:notesSz cx="5143500" cy="9144000"/>
@@ -601,7 +602,7 @@
           <a:p>
             <a:r>
               <a:rPr lang="en-US" dirty="0"/>
-              <a:t>One rail, one pilot, one quarter. Round 1 deepens exactly this: real feed connector, Odia voice, comprehension tests, agronomist review.</a:t>
+              <a:t>Mine-faithful: institutional buyer, assisted distribution. Three lines only, per YC rule. The claims rail is the wedge because PMFBY already pays for verified loss events.</a:t>
             </a:r>
             <a:endParaRPr lang="en-US" dirty="0"/>
           </a:p>
@@ -689,7 +690,7 @@
           <a:p>
             <a:r>
               <a:rPr lang="en-US" dirty="0"/>
-              <a:t>Founder-focused: what we shipped is the proof, not the bios. The E&amp;CE note is for faculty: this statement is the only one spanning CSE, ECE, and EE clusters (W3).</a:t>
+              <a:t>One rail, one pilot, one quarter. Round 1 deepens exactly this: real feed connector, Odia voice, comprehension tests, agronomist review.</a:t>
             </a:r>
             <a:endParaRPr lang="en-US" dirty="0"/>
           </a:p>
@@ -777,7 +778,7 @@
           <a:p>
             <a:r>
               <a:rPr lang="en-US" dirty="0"/>
-              <a:t>Ask tied to the next milestone: faculty feedback contract. Slide 8 of the runbook said the same: feedback shapes Round 1. The limitation is the honesty move faculty will remember.</a:t>
+              <a:t>Founder-focused: what we shipped is the proof, not the bios. The E&amp;CE note is for faculty: this statement is the only one spanning CSE, ECE, and EE clusters (W3).</a:t>
             </a:r>
             <a:endParaRPr lang="en-US" dirty="0"/>
           </a:p>
@@ -801,6 +802,94 @@
             <a:fld id="{F7021451-1387-4CA6-816F-3879F97B5CBC}" type="slidenum">
               <a:rPr lang="en-US"/>
               <a:t>12</a:t>
+            </a:fld>
+            <a:endParaRPr lang="en-US"/>
+          </a:p>
+        </p:txBody>
+      </p:sp>
+    </p:spTree>
+    <p:extLst>
+      <p:ext uri="{BB962C8B-B14F-4D97-AF65-F5344CB8AC3E}">
+        <p14:creationId xmlns:p14="http://schemas.microsoft.com/office/powerpoint/2010/main" val="1024086991"/>
+      </p:ext>
+    </p:extLst>
+  </p:cSld>
+  <p:clrMapOvr>
+    <a:masterClrMapping/>
+  </p:clrMapOvr>
+</p:notes>
+</file>
+
+<file path=ppt/notesSlides/notesSlide13.xml><?xml version="1.0" encoding="utf-8"?>
+<p:notes xmlns:a="http://schemas.openxmlformats.org/drawingml/2006/main" xmlns:r="http://schemas.openxmlformats.org/officeDocument/2006/relationships" xmlns:p="http://schemas.openxmlformats.org/presentationml/2006/main">
+  <p:cSld>
+    <p:spTree>
+      <p:nvGrpSpPr>
+        <p:cNvPr id="1" name=""/>
+        <p:cNvGrpSpPr/>
+        <p:nvPr/>
+      </p:nvGrpSpPr>
+      <p:grpSpPr>
+        <a:xfrm>
+          <a:off x="0" y="0"/>
+          <a:ext cx="0" cy="0"/>
+          <a:chOff x="0" y="0"/>
+          <a:chExt cx="0" cy="0"/>
+        </a:xfrm>
+      </p:grpSpPr>
+      <p:sp>
+        <p:nvSpPr>
+          <p:cNvPr id="2" name="Slide Image Placeholder 1"/>
+          <p:cNvSpPr>
+            <a:spLocks noGrp="1" noRot="1" noChangeAspect="1"/>
+          </p:cNvSpPr>
+          <p:nvPr>
+            <p:ph type="sldImg"/>
+          </p:nvPr>
+        </p:nvSpPr>
+        <p:spPr/>
+      </p:sp>
+      <p:sp>
+        <p:nvSpPr>
+          <p:cNvPr id="3" name="Notes Placeholder 2"/>
+          <p:cNvSpPr>
+            <a:spLocks noGrp="1"/>
+          </p:cNvSpPr>
+          <p:nvPr>
+            <p:ph type="body" idx="1"/>
+          </p:nvPr>
+        </p:nvSpPr>
+        <p:spPr/>
+        <p:txBody>
+          <a:bodyPr/>
+          <a:lstStyle/>
+          <a:p>
+            <a:r>
+              <a:rPr lang="en-US" dirty="0"/>
+              <a:t>Ask tied to the next milestone: faculty feedback contract. Slide 8 of the runbook said the same: feedback shapes Round 1. The limitation is the honesty move faculty will remember.</a:t>
+            </a:r>
+            <a:endParaRPr lang="en-US" dirty="0"/>
+          </a:p>
+        </p:txBody>
+      </p:sp>
+      <p:sp>
+        <p:nvSpPr>
+          <p:cNvPr id="4" name="Slide Number Placeholder 3"/>
+          <p:cNvSpPr>
+            <a:spLocks noGrp="1"/>
+          </p:cNvSpPr>
+          <p:nvPr>
+            <p:ph type="sldNum" sz="quarter" idx="10"/>
+          </p:nvPr>
+        </p:nvSpPr>
+        <p:spPr/>
+        <p:txBody>
+          <a:bodyPr/>
+          <a:lstStyle/>
+          <a:p>
+            <a:fld id="{F7021451-1387-4CA6-816F-3879F97B5CBC}" type="slidenum">
+              <a:rPr lang="en-US"/>
+              <a:t>13</a:t>
             </a:fld>
             <a:endParaRPr lang="en-US"/>
           </a:p>
@@ -1481,7 +1570,7 @@
           <a:p>
             <a:r>
               <a:rPr lang="en-US" dirty="0"/>
-              <a:t>Mine-faithful: institutional buyer, assisted distribution. Three lines only, per YC rule. The claims rail is the wedge because PMFBY already pays for verified loss events.</a:t>
+              <a:t>Counterfactual discipline: no avoided-loss claims anywhere. The events are real, the lead times are real, the engine output is what the product would issue, and the replay validates the loss bands against actual anchors. A judge asking 'so what would this have done in Fani' gets this slide.</a:t>
             </a:r>
             <a:endParaRPr lang="en-US" dirty="0"/>
           </a:p>
@@ -2139,7 +2228,7 @@
                 <a:ea typeface="Arial Black" pitchFamily="34" charset="-122"/>
                 <a:cs typeface="Arial Black" pitchFamily="34" charset="-120"/>
               </a:rPr>
-              <a:t>One rail, one pilot, one quarter</a:t>
+              <a:t>Three buyers, one verified loop</a:t>
             </a:r>
             <a:endParaRPr lang="en-US" sz="2800" dirty="0"/>
           </a:p>
@@ -2185,7 +2274,7 @@
                 <a:ea typeface="Arial Black" pitchFamily="34" charset="-122"/>
                 <a:cs typeface="Arial Black" pitchFamily="34" charset="-120"/>
               </a:rPr>
-              <a:t>One rail, one pilot, one quarter</a:t>
+              <a:t>Three buyers, one verified loop</a:t>
             </a:r>
             <a:endParaRPr lang="en-US" sz="2800" dirty="0"/>
           </a:p>
@@ -2224,8 +2313,8 @@
         </p:nvSpPr>
         <p:spPr>
           <a:xfrm>
-            <a:off x="507492" y="1101852"/>
-            <a:ext cx="3977640" cy="2103120"/>
+            <a:off x="507492" y="1284732"/>
+            <a:ext cx="2529840" cy="2286000"/>
           </a:xfrm>
           <a:prstGeom prst="rect">
             <a:avLst/>
@@ -2249,20 +2338,18 @@
         </p:nvSpPr>
         <p:spPr>
           <a:xfrm>
-            <a:off x="457200" y="1051560"/>
-            <a:ext cx="3977640" cy="2103120"/>
-          </a:xfrm>
-          <a:prstGeom prst="roundRect">
-            <a:avLst>
-              <a:gd name="adj" fmla="val 2609"/>
-            </a:avLst>
-          </a:prstGeom>
-          <a:solidFill>
-            <a:srgbClr val="FFFFFF"/>
-          </a:solidFill>
-          <a:ln w="25400">
+            <a:off x="2968752" y="1307592"/>
+            <a:ext cx="82296" cy="2139696"/>
+          </a:xfrm>
+          <a:prstGeom prst="parallelogram">
+            <a:avLst/>
+          </a:prstGeom>
+          <a:solidFill>
+            <a:srgbClr val="555555"/>
+          </a:solidFill>
+          <a:ln w="12700">
             <a:solidFill>
-              <a:srgbClr val="0A0A0A"/>
+              <a:srgbClr val="555555"/>
             </a:solidFill>
             <a:prstDash val="solid"/>
           </a:ln>
@@ -2270,14 +2357,41 @@
       </p:sp>
       <p:sp>
         <p:nvSpPr>
-          <p:cNvPr id="7" name="Text 5"/>
-          <p:cNvSpPr/>
-          <p:nvPr/>
-        </p:nvSpPr>
-        <p:spPr>
-          <a:xfrm>
-            <a:off x="640080" y="1188720"/>
-            <a:ext cx="3657600" cy="320040"/>
+          <p:cNvPr id="7" name="Shape 5"/>
+          <p:cNvSpPr/>
+          <p:nvPr/>
+        </p:nvSpPr>
+        <p:spPr>
+          <a:xfrm rot="-90000">
+            <a:off x="457200" y="1234440"/>
+            <a:ext cx="2529840" cy="2286000"/>
+          </a:xfrm>
+          <a:prstGeom prst="roundRect">
+            <a:avLst>
+              <a:gd name="adj" fmla="val 2400"/>
+            </a:avLst>
+          </a:prstGeom>
+          <a:solidFill>
+            <a:srgbClr val="0A0A0A"/>
+          </a:solidFill>
+          <a:ln w="12700">
+            <a:solidFill>
+              <a:srgbClr val="FFFFFF"/>
+            </a:solidFill>
+            <a:prstDash val="solid"/>
+          </a:ln>
+        </p:spPr>
+      </p:sp>
+      <p:sp>
+        <p:nvSpPr>
+          <p:cNvPr id="8" name="Text 6"/>
+          <p:cNvSpPr/>
+          <p:nvPr/>
+        </p:nvSpPr>
+        <p:spPr>
+          <a:xfrm>
+            <a:off x="640080" y="1417320"/>
+            <a:ext cx="2164080" cy="365760"/>
           </a:xfrm>
           <a:prstGeom prst="rect">
             <a:avLst/>
@@ -2293,30 +2407,30 @@
               <a:buNone/>
             </a:pPr>
             <a:r>
-              <a:rPr lang="en-US" sz="1300" b="1" dirty="0">
-                <a:solidFill>
-                  <a:srgbClr val="0A0A0A"/>
+              <a:rPr lang="en-US" sz="1600" b="1" dirty="0">
+                <a:solidFill>
+                  <a:srgbClr val="FFFFFF"/>
                 </a:solidFill>
                 <a:latin typeface="Arial Black" pitchFamily="34" charset="0"/>
                 <a:ea typeface="Arial Black" pitchFamily="34" charset="-122"/>
                 <a:cs typeface="Arial Black" pitchFamily="34" charset="-120"/>
               </a:rPr>
-              <a:t>The rail exists</a:t>
-            </a:r>
-            <a:endParaRPr lang="en-US" sz="1300" dirty="0"/>
-          </a:p>
-        </p:txBody>
-      </p:sp>
-      <p:sp>
-        <p:nvSpPr>
-          <p:cNvPr id="8" name="Text 6"/>
-          <p:cNvSpPr/>
-          <p:nvPr/>
-        </p:nvSpPr>
-        <p:spPr>
-          <a:xfrm>
-            <a:off x="640080" y="1554480"/>
-            <a:ext cx="3657600" cy="548640"/>
+              <a:t>FPO + extension</a:t>
+            </a:r>
+            <a:endParaRPr lang="en-US" sz="1600" dirty="0"/>
+          </a:p>
+        </p:txBody>
+      </p:sp>
+      <p:sp>
+        <p:nvSpPr>
+          <p:cNvPr id="9" name="Text 7"/>
+          <p:cNvSpPr/>
+          <p:nvPr/>
+        </p:nvSpPr>
+        <p:spPr>
+          <a:xfrm>
+            <a:off x="640080" y="1920240"/>
+            <a:ext cx="2164080" cy="914400"/>
           </a:xfrm>
           <a:prstGeom prst="rect">
             <a:avLst/>
@@ -2332,56 +2446,17 @@
               <a:buNone/>
             </a:pPr>
             <a:r>
-              <a:rPr lang="en-US" sz="1600" b="1" dirty="0">
-                <a:solidFill>
-                  <a:srgbClr val="0A0A0A"/>
-                </a:solidFill>
-                <a:latin typeface="Arial Black" pitchFamily="34" charset="0"/>
-                <a:ea typeface="Arial Black" pitchFamily="34" charset="-122"/>
-                <a:cs typeface="Arial Black" pitchFamily="34" charset="-120"/>
-              </a:rPr>
-              <a:t>88.5 lakh PMFBY enrollments, Rs 2,580 crore claims paid (2020-25)</a:t>
-            </a:r>
-            <a:endParaRPr lang="en-US" sz="1600" dirty="0"/>
-          </a:p>
-        </p:txBody>
-      </p:sp>
-      <p:sp>
-        <p:nvSpPr>
-          <p:cNvPr id="9" name="Text 7"/>
-          <p:cNvSpPr/>
-          <p:nvPr/>
-        </p:nvSpPr>
-        <p:spPr>
-          <a:xfrm>
-            <a:off x="640080" y="2194560"/>
-            <a:ext cx="3657600" cy="548640"/>
-          </a:xfrm>
-          <a:prstGeom prst="rect">
-            <a:avLst/>
-          </a:prstGeom>
-          <a:noFill/>
-          <a:ln/>
-        </p:spPr>
-        <p:txBody>
-          <a:bodyPr wrap="square" lIns="0" tIns="0" rIns="0" bIns="0" rtlCol="0" anchor="ctr"/>
-          <a:lstStyle/>
-          <a:p>
-            <a:pPr indent="0" marL="0">
-              <a:buNone/>
-            </a:pPr>
-            <a:r>
-              <a:rPr lang="en-US" sz="1250" dirty="0">
-                <a:solidFill>
-                  <a:srgbClr val="0A0A0A"/>
+              <a:rPr lang="en-US" sz="1150" dirty="0">
+                <a:solidFill>
+                  <a:srgbClr val="B0B0B0"/>
                 </a:solidFill>
                 <a:latin typeface="Arial" pitchFamily="34" charset="0"/>
                 <a:ea typeface="Arial" pitchFamily="34" charset="-122"/>
                 <a:cs typeface="Arial" pitchFamily="34" charset="-120"/>
               </a:rPr>
-              <a:t>Digital Agriculture Mission, Rs 2,817 crore, funds agri-digital public infrastructure</a:t>
-            </a:r>
-            <a:endParaRPr lang="en-US" sz="1250" dirty="0"/>
+              <a:t>seasonal advisory subscriptions per farmer via FPOs and KVK extension workers</a:t>
+            </a:r>
+            <a:endParaRPr lang="en-US" sz="1150" dirty="0"/>
           </a:p>
         </p:txBody>
       </p:sp>
@@ -2393,8 +2468,8 @@
         </p:nvSpPr>
         <p:spPr>
           <a:xfrm>
-            <a:off x="640080" y="2788920"/>
-            <a:ext cx="3657600" cy="548640"/>
+            <a:off x="640080" y="2971800"/>
+            <a:ext cx="2164080" cy="457200"/>
           </a:xfrm>
           <a:prstGeom prst="rect">
             <a:avLst/>
@@ -2410,17 +2485,17 @@
               <a:buNone/>
             </a:pPr>
             <a:r>
-              <a:rPr lang="en-US" sz="1200" dirty="0">
-                <a:solidFill>
-                  <a:srgbClr val="0A0A0A"/>
+              <a:rPr lang="en-US" sz="1000" i="1" dirty="0">
+                <a:solidFill>
+                  <a:srgbClr val="8A8A8A"/>
                 </a:solidFill>
                 <a:latin typeface="Arial" pitchFamily="34" charset="0"/>
                 <a:ea typeface="Arial" pitchFamily="34" charset="-122"/>
                 <a:cs typeface="Arial" pitchFamily="34" charset="-120"/>
               </a:rPr>
-              <a:t>Odisha: cyclone-facing coast, paddy and saline zones, Dana and Yaas damage on record</a:t>
-            </a:r>
-            <a:endParaRPr lang="en-US" sz="1200" dirty="0"/>
+              <a:t>pay per verified advisory delivered and acted on</a:t>
+            </a:r>
+            <a:endParaRPr lang="en-US" sz="1000" dirty="0"/>
           </a:p>
         </p:txBody>
       </p:sp>
@@ -2432,8 +2507,8 @@
         </p:nvSpPr>
         <p:spPr>
           <a:xfrm>
-            <a:off x="4759452" y="1101852"/>
-            <a:ext cx="3977640" cy="2103120"/>
+            <a:off x="3357372" y="1284732"/>
+            <a:ext cx="2529840" cy="2286000"/>
           </a:xfrm>
           <a:prstGeom prst="rect">
             <a:avLst/>
@@ -2457,20 +2532,18 @@
         </p:nvSpPr>
         <p:spPr>
           <a:xfrm>
-            <a:off x="4709160" y="1051560"/>
-            <a:ext cx="3977640" cy="2103120"/>
-          </a:xfrm>
-          <a:prstGeom prst="roundRect">
-            <a:avLst>
-              <a:gd name="adj" fmla="val 2609"/>
-            </a:avLst>
-          </a:prstGeom>
-          <a:solidFill>
-            <a:srgbClr val="FFFFFF"/>
-          </a:solidFill>
-          <a:ln w="25400">
+            <a:off x="5818632" y="1307592"/>
+            <a:ext cx="82296" cy="2139696"/>
+          </a:xfrm>
+          <a:prstGeom prst="parallelogram">
+            <a:avLst/>
+          </a:prstGeom>
+          <a:solidFill>
+            <a:srgbClr val="555555"/>
+          </a:solidFill>
+          <a:ln w="12700">
             <a:solidFill>
-              <a:srgbClr val="0A0A0A"/>
+              <a:srgbClr val="555555"/>
             </a:solidFill>
             <a:prstDash val="solid"/>
           </a:ln>
@@ -2478,14 +2551,41 @@
       </p:sp>
       <p:sp>
         <p:nvSpPr>
-          <p:cNvPr id="13" name="Text 11"/>
-          <p:cNvSpPr/>
-          <p:nvPr/>
-        </p:nvSpPr>
-        <p:spPr>
-          <a:xfrm>
-            <a:off x="4892040" y="1188720"/>
-            <a:ext cx="3657600" cy="320040"/>
+          <p:cNvPr id="13" name="Shape 11"/>
+          <p:cNvSpPr/>
+          <p:nvPr/>
+        </p:nvSpPr>
+        <p:spPr>
+          <a:xfrm rot="-90000">
+            <a:off x="3307080" y="1234440"/>
+            <a:ext cx="2529840" cy="2286000"/>
+          </a:xfrm>
+          <a:prstGeom prst="roundRect">
+            <a:avLst>
+              <a:gd name="adj" fmla="val 2400"/>
+            </a:avLst>
+          </a:prstGeom>
+          <a:solidFill>
+            <a:srgbClr val="0A0A0A"/>
+          </a:solidFill>
+          <a:ln w="12700">
+            <a:solidFill>
+              <a:srgbClr val="FFFFFF"/>
+            </a:solidFill>
+            <a:prstDash val="solid"/>
+          </a:ln>
+        </p:spPr>
+      </p:sp>
+      <p:sp>
+        <p:nvSpPr>
+          <p:cNvPr id="14" name="Text 12"/>
+          <p:cNvSpPr/>
+          <p:nvPr/>
+        </p:nvSpPr>
+        <p:spPr>
+          <a:xfrm>
+            <a:off x="3489960" y="1417320"/>
+            <a:ext cx="2164080" cy="365760"/>
           </a:xfrm>
           <a:prstGeom prst="rect">
             <a:avLst/>
@@ -2501,30 +2601,30 @@
               <a:buNone/>
             </a:pPr>
             <a:r>
-              <a:rPr lang="en-US" sz="1300" b="1" dirty="0">
-                <a:solidFill>
-                  <a:srgbClr val="0A0A0A"/>
+              <a:rPr lang="en-US" sz="1600" b="1" dirty="0">
+                <a:solidFill>
+                  <a:srgbClr val="FFFFFF"/>
                 </a:solidFill>
                 <a:latin typeface="Arial Black" pitchFamily="34" charset="0"/>
                 <a:ea typeface="Arial Black" pitchFamily="34" charset="-122"/>
                 <a:cs typeface="Arial Black" pitchFamily="34" charset="-120"/>
               </a:rPr>
-              <a:t>The pilot</a:t>
-            </a:r>
-            <a:endParaRPr lang="en-US" sz="1300" dirty="0"/>
-          </a:p>
-        </p:txBody>
-      </p:sp>
-      <p:sp>
-        <p:nvSpPr>
-          <p:cNvPr id="14" name="Text 12"/>
-          <p:cNvSpPr/>
-          <p:nvPr/>
-        </p:nvSpPr>
-        <p:spPr>
-          <a:xfrm>
-            <a:off x="4892040" y="1600200"/>
-            <a:ext cx="3657600" cy="457200"/>
+              <a:t>B2G district</a:t>
+            </a:r>
+            <a:endParaRPr lang="en-US" sz="1600" dirty="0"/>
+          </a:p>
+        </p:txBody>
+      </p:sp>
+      <p:sp>
+        <p:nvSpPr>
+          <p:cNvPr id="15" name="Text 13"/>
+          <p:cNvSpPr/>
+          <p:nvPr/>
+        </p:nvSpPr>
+        <p:spPr>
+          <a:xfrm>
+            <a:off x="3489960" y="1920240"/>
+            <a:ext cx="2164080" cy="914400"/>
           </a:xfrm>
           <a:prstGeom prst="rect">
             <a:avLst/>
@@ -2540,30 +2640,30 @@
               <a:buNone/>
             </a:pPr>
             <a:r>
-              <a:rPr lang="en-US" sz="1200" dirty="0">
-                <a:solidFill>
-                  <a:srgbClr val="0A0A0A"/>
+              <a:rPr lang="en-US" sz="1150" dirty="0">
+                <a:solidFill>
+                  <a:srgbClr val="B0B0B0"/>
                 </a:solidFill>
                 <a:latin typeface="Arial" pitchFamily="34" charset="0"/>
                 <a:ea typeface="Arial" pitchFamily="34" charset="-122"/>
                 <a:cs typeface="Arial" pitchFamily="34" charset="-120"/>
               </a:rPr>
-              <a:t>1.  one coastal block with extension-worker access</a:t>
-            </a:r>
-            <a:endParaRPr lang="en-US" sz="1200" dirty="0"/>
-          </a:p>
-        </p:txBody>
-      </p:sp>
-      <p:sp>
-        <p:nvSpPr>
-          <p:cNvPr id="15" name="Text 13"/>
-          <p:cNvSpPr/>
-          <p:nvPr/>
-        </p:nvSpPr>
-        <p:spPr>
-          <a:xfrm>
-            <a:off x="4892040" y="2103120"/>
-            <a:ext cx="3657600" cy="457200"/>
+              <a:t>Odisha agriculture department and OSDMA, per-block deployment</a:t>
+            </a:r>
+            <a:endParaRPr lang="en-US" sz="1150" dirty="0"/>
+          </a:p>
+        </p:txBody>
+      </p:sp>
+      <p:sp>
+        <p:nvSpPr>
+          <p:cNvPr id="16" name="Text 14"/>
+          <p:cNvSpPr/>
+          <p:nvPr/>
+        </p:nvSpPr>
+        <p:spPr>
+          <a:xfrm>
+            <a:off x="3489960" y="2971800"/>
+            <a:ext cx="2164080" cy="457200"/>
           </a:xfrm>
           <a:prstGeom prst="rect">
             <a:avLst/>
@@ -2579,30 +2679,107 @@
               <a:buNone/>
             </a:pPr>
             <a:r>
-              <a:rPr lang="en-US" sz="1200" dirty="0">
-                <a:solidFill>
-                  <a:srgbClr val="0A0A0A"/>
+              <a:rPr lang="en-US" sz="1000" i="1" dirty="0">
+                <a:solidFill>
+                  <a:srgbClr val="8A8A8A"/>
                 </a:solidFill>
                 <a:latin typeface="Arial" pitchFamily="34" charset="0"/>
                 <a:ea typeface="Arial" pitchFamily="34" charset="-122"/>
                 <a:cs typeface="Arial" pitchFamily="34" charset="-120"/>
               </a:rPr>
-              <a:t>2.  one agronomist-reviewed rule pack</a:t>
-            </a:r>
-            <a:endParaRPr lang="en-US" sz="1200" dirty="0"/>
-          </a:p>
-        </p:txBody>
-      </p:sp>
-      <p:sp>
-        <p:nvSpPr>
-          <p:cNvPr id="16" name="Text 14"/>
-          <p:cNvSpPr/>
-          <p:nvPr/>
-        </p:nvSpPr>
-        <p:spPr>
-          <a:xfrm>
-            <a:off x="4892040" y="2606040"/>
-            <a:ext cx="3657600" cy="457200"/>
+              <a:t>reduces call volume, gives auditable outreach evidence</a:t>
+            </a:r>
+            <a:endParaRPr lang="en-US" sz="1000" dirty="0"/>
+          </a:p>
+        </p:txBody>
+      </p:sp>
+      <p:sp>
+        <p:nvSpPr>
+          <p:cNvPr id="17" name="Shape 15"/>
+          <p:cNvSpPr/>
+          <p:nvPr/>
+        </p:nvSpPr>
+        <p:spPr>
+          <a:xfrm>
+            <a:off x="6207252" y="1284732"/>
+            <a:ext cx="2529840" cy="2286000"/>
+          </a:xfrm>
+          <a:prstGeom prst="rect">
+            <a:avLst/>
+          </a:prstGeom>
+          <a:solidFill>
+            <a:srgbClr val="E0E0E0"/>
+          </a:solidFill>
+          <a:ln w="12700">
+            <a:solidFill>
+              <a:srgbClr val="E0E0E0"/>
+            </a:solidFill>
+            <a:prstDash val="solid"/>
+          </a:ln>
+        </p:spPr>
+      </p:sp>
+      <p:sp>
+        <p:nvSpPr>
+          <p:cNvPr id="18" name="Shape 16"/>
+          <p:cNvSpPr/>
+          <p:nvPr/>
+        </p:nvSpPr>
+        <p:spPr>
+          <a:xfrm>
+            <a:off x="8668512" y="1307592"/>
+            <a:ext cx="82296" cy="2139696"/>
+          </a:xfrm>
+          <a:prstGeom prst="parallelogram">
+            <a:avLst/>
+          </a:prstGeom>
+          <a:solidFill>
+            <a:srgbClr val="555555"/>
+          </a:solidFill>
+          <a:ln w="12700">
+            <a:solidFill>
+              <a:srgbClr val="555555"/>
+            </a:solidFill>
+            <a:prstDash val="solid"/>
+          </a:ln>
+        </p:spPr>
+      </p:sp>
+      <p:sp>
+        <p:nvSpPr>
+          <p:cNvPr id="19" name="Shape 17"/>
+          <p:cNvSpPr/>
+          <p:nvPr/>
+        </p:nvSpPr>
+        <p:spPr>
+          <a:xfrm rot="-90000">
+            <a:off x="6156960" y="1234440"/>
+            <a:ext cx="2529840" cy="2286000"/>
+          </a:xfrm>
+          <a:prstGeom prst="roundRect">
+            <a:avLst>
+              <a:gd name="adj" fmla="val 2400"/>
+            </a:avLst>
+          </a:prstGeom>
+          <a:solidFill>
+            <a:srgbClr val="0A0A0A"/>
+          </a:solidFill>
+          <a:ln w="12700">
+            <a:solidFill>
+              <a:srgbClr val="FFFFFF"/>
+            </a:solidFill>
+            <a:prstDash val="solid"/>
+          </a:ln>
+        </p:spPr>
+      </p:sp>
+      <p:sp>
+        <p:nvSpPr>
+          <p:cNvPr id="20" name="Text 18"/>
+          <p:cNvSpPr/>
+          <p:nvPr/>
+        </p:nvSpPr>
+        <p:spPr>
+          <a:xfrm>
+            <a:off x="6339840" y="1417320"/>
+            <a:ext cx="2164080" cy="365760"/>
           </a:xfrm>
           <a:prstGeom prst="rect">
             <a:avLst/>
@@ -2618,30 +2795,69 @@
               <a:buNone/>
             </a:pPr>
             <a:r>
-              <a:rPr lang="en-US" sz="1200" dirty="0">
-                <a:solidFill>
-                  <a:srgbClr val="0A0A0A"/>
+              <a:rPr lang="en-US" sz="1600" b="1" dirty="0">
+                <a:solidFill>
+                  <a:srgbClr val="FFFFFF"/>
+                </a:solidFill>
+                <a:latin typeface="Arial Black" pitchFamily="34" charset="0"/>
+                <a:ea typeface="Arial Black" pitchFamily="34" charset="-122"/>
+                <a:cs typeface="Arial Black" pitchFamily="34" charset="-120"/>
+              </a:rPr>
+              <a:t>Claims rail</a:t>
+            </a:r>
+            <a:endParaRPr lang="en-US" sz="1600" dirty="0"/>
+          </a:p>
+        </p:txBody>
+      </p:sp>
+      <p:sp>
+        <p:nvSpPr>
+          <p:cNvPr id="21" name="Text 19"/>
+          <p:cNvSpPr/>
+          <p:nvPr/>
+        </p:nvSpPr>
+        <p:spPr>
+          <a:xfrm>
+            <a:off x="6339840" y="1920240"/>
+            <a:ext cx="2164080" cy="914400"/>
+          </a:xfrm>
+          <a:prstGeom prst="rect">
+            <a:avLst/>
+          </a:prstGeom>
+          <a:noFill/>
+          <a:ln/>
+        </p:spPr>
+        <p:txBody>
+          <a:bodyPr wrap="square" lIns="0" tIns="0" rIns="0" bIns="0" rtlCol="0" anchor="ctr"/>
+          <a:lstStyle/>
+          <a:p>
+            <a:pPr indent="0" marL="0">
+              <a:buNone/>
+            </a:pPr>
+            <a:r>
+              <a:rPr lang="en-US" sz="1150" dirty="0">
+                <a:solidFill>
+                  <a:srgbClr val="B0B0B0"/>
                 </a:solidFill>
                 <a:latin typeface="Arial" pitchFamily="34" charset="0"/>
                 <a:ea typeface="Arial" pitchFamily="34" charset="-122"/>
                 <a:cs typeface="Arial" pitchFamily="34" charset="-120"/>
               </a:rPr>
-              <a:t>3.  measure comprehension and claim conversion, not downloads</a:t>
-            </a:r>
-            <a:endParaRPr lang="en-US" sz="1200" dirty="0"/>
-          </a:p>
-        </p:txBody>
-      </p:sp>
-      <p:sp>
-        <p:nvSpPr>
-          <p:cNvPr id="17" name="Text 15"/>
-          <p:cNvSpPr/>
-          <p:nvPr/>
-        </p:nvSpPr>
-        <p:spPr>
-          <a:xfrm>
-            <a:off x="498348" y="3470148"/>
-            <a:ext cx="6858000" cy="0"/>
+              <a:t>PMFBY insurers and aggregators pay per evidence packet</a:t>
+            </a:r>
+            <a:endParaRPr lang="en-US" sz="1150" dirty="0"/>
+          </a:p>
+        </p:txBody>
+      </p:sp>
+      <p:sp>
+        <p:nvSpPr>
+          <p:cNvPr id="22" name="Text 20"/>
+          <p:cNvSpPr/>
+          <p:nvPr/>
+        </p:nvSpPr>
+        <p:spPr>
+          <a:xfrm>
+            <a:off x="6339840" y="2971800"/>
+            <a:ext cx="2164080" cy="457200"/>
           </a:xfrm>
           <a:prstGeom prst="rect">
             <a:avLst/>
@@ -2657,43 +2873,75 @@
               <a:buNone/>
             </a:pPr>
             <a:r>
-              <a:rPr lang="en-US" sz="1450" b="1" dirty="0">
-                <a:solidFill>
-                  <a:srgbClr val="E0E0E0"/>
+              <a:rPr lang="en-US" sz="1000" i="1" dirty="0">
+                <a:solidFill>
+                  <a:srgbClr val="8A8A8A"/>
+                </a:solidFill>
+                <a:latin typeface="Arial" pitchFamily="34" charset="0"/>
+                <a:ea typeface="Arial" pitchFamily="34" charset="-122"/>
+                <a:cs typeface="Arial" pitchFamily="34" charset="-120"/>
+              </a:rPr>
+              <a:t>verified observation converts to claim, both sides win</a:t>
+            </a:r>
+            <a:endParaRPr lang="en-US" sz="1000" dirty="0"/>
+          </a:p>
+        </p:txBody>
+      </p:sp>
+      <p:sp>
+        <p:nvSpPr>
+          <p:cNvPr id="23" name="Text 21"/>
+          <p:cNvSpPr/>
+          <p:nvPr/>
+        </p:nvSpPr>
+        <p:spPr>
+          <a:xfrm>
+            <a:off x="457200" y="3977640"/>
+            <a:ext cx="8229600" cy="411480"/>
+          </a:xfrm>
+          <a:prstGeom prst="rect">
+            <a:avLst/>
+          </a:prstGeom>
+          <a:noFill/>
+          <a:ln/>
+        </p:spPr>
+        <p:txBody>
+          <a:bodyPr wrap="square" lIns="0" tIns="0" rIns="0" bIns="0" rtlCol="0" anchor="ctr"/>
+          <a:lstStyle/>
+          <a:p>
+            <a:pPr indent="0" marL="0">
+              <a:buNone/>
+            </a:pPr>
+            <a:r>
+              <a:rPr lang="en-US" sz="1300" b="1" dirty="0">
+                <a:solidFill>
+                  <a:srgbClr val="0A0A0A"/>
                 </a:solidFill>
                 <a:latin typeface="Arial Black" pitchFamily="34" charset="0"/>
                 <a:ea typeface="Arial Black" pitchFamily="34" charset="-122"/>
                 <a:cs typeface="Arial Black" pitchFamily="34" charset="-120"/>
               </a:rPr>
-              <a:t>Named rail, named pilot, dated outcome. That is the Round 1 contract.</a:t>
-            </a:r>
-            <a:endParaRPr lang="en-US" sz="1450" dirty="0"/>
-          </a:p>
-        </p:txBody>
-      </p:sp>
-      <p:sp>
-        <p:nvSpPr>
-          <p:cNvPr id="18" name="Text 16"/>
-          <p:cNvSpPr/>
-          <p:nvPr/>
-        </p:nvSpPr>
-        <p:spPr>
-          <a:xfrm>
-            <a:off x="457200" y="3429000"/>
-            <a:ext cx="6858000" cy="0"/>
-          </a:xfrm>
-          <a:prstGeom prst="rect">
-            <a:avLst/>
-          </a:prstGeom>
-          <a:noFill/>
-          <a:ln/>
-          <a:effectLst>
-            <a:outerShdw sx="100000" sy="100000" kx="0" ky="0" algn="bl" rotWithShape="0" blurRad="101600" dist="38100" dir="2700000">
-              <a:srgbClr val="000000">
-                <a:alpha val="25000"/>
-              </a:srgbClr>
-            </a:outerShdw>
-          </a:effectLst>
+              <a:t>Seed revenue line for Round 1: one FPO, one season, measured renewal. No consumer subscription fantasy.</a:t>
+            </a:r>
+            <a:endParaRPr lang="en-US" sz="1300" dirty="0"/>
+          </a:p>
+        </p:txBody>
+      </p:sp>
+      <p:sp>
+        <p:nvSpPr>
+          <p:cNvPr id="24" name="Text 22"/>
+          <p:cNvSpPr/>
+          <p:nvPr/>
+        </p:nvSpPr>
+        <p:spPr>
+          <a:xfrm>
+            <a:off x="457200" y="4759452"/>
+            <a:ext cx="8229600" cy="274320"/>
+          </a:xfrm>
+          <a:prstGeom prst="rect">
+            <a:avLst/>
+          </a:prstGeom>
+          <a:noFill/>
+          <a:ln/>
         </p:spPr>
         <p:txBody>
           <a:bodyPr wrap="square" lIns="0" tIns="0" rIns="0" bIns="0" rtlCol="0" anchor="ctr"/>
@@ -2703,46 +2951,7 @@
               <a:buNone/>
             </a:pPr>
             <a:r>
-              <a:rPr lang="en-US" sz="1450" b="1" dirty="0">
-                <a:solidFill>
-                  <a:srgbClr val="0A0A0A"/>
-                </a:solidFill>
-                <a:latin typeface="Arial Black" pitchFamily="34" charset="0"/>
-                <a:ea typeface="Arial Black" pitchFamily="34" charset="-122"/>
-                <a:cs typeface="Arial Black" pitchFamily="34" charset="-120"/>
-              </a:rPr>
-              <a:t>Named rail, named pilot, dated outcome. That is the Round 1 contract.</a:t>
-            </a:r>
-            <a:endParaRPr lang="en-US" sz="1450" dirty="0"/>
-          </a:p>
-        </p:txBody>
-      </p:sp>
-      <p:sp>
-        <p:nvSpPr>
-          <p:cNvPr id="19" name="Text 17"/>
-          <p:cNvSpPr/>
-          <p:nvPr/>
-        </p:nvSpPr>
-        <p:spPr>
-          <a:xfrm>
-            <a:off x="457200" y="3977640"/>
-            <a:ext cx="8229600" cy="365760"/>
-          </a:xfrm>
-          <a:prstGeom prst="rect">
-            <a:avLst/>
-          </a:prstGeom>
-          <a:noFill/>
-          <a:ln/>
-        </p:spPr>
-        <p:txBody>
-          <a:bodyPr wrap="square" lIns="0" tIns="0" rIns="0" bIns="0" rtlCol="0" anchor="ctr"/>
-          <a:lstStyle/>
-          <a:p>
-            <a:pPr indent="0" marL="0">
-              <a:buNone/>
-            </a:pPr>
-            <a:r>
-              <a:rPr lang="en-US" sz="1000" i="1" dirty="0">
+              <a:rPr lang="en-US" sz="850" dirty="0">
                 <a:solidFill>
                   <a:srgbClr val="6E6E6E"/>
                 </a:solidFill>
@@ -2750,46 +2959,7 @@
                 <a:ea typeface="Arial" pitchFamily="34" charset="-122"/>
                 <a:cs typeface="Arial" pitchFamily="34" charset="-120"/>
               </a:rPr>
-              <a:t>Sources: PMFBY program data; Digital Agriculture Mission allocation; YSD Dana assessment; Down To Earth Yaas report. All dated 2024-2025, verified in the research wave.</a:t>
-            </a:r>
-            <a:endParaRPr lang="en-US" sz="1000" dirty="0"/>
-          </a:p>
-        </p:txBody>
-      </p:sp>
-      <p:sp>
-        <p:nvSpPr>
-          <p:cNvPr id="20" name="Text 18"/>
-          <p:cNvSpPr/>
-          <p:nvPr/>
-        </p:nvSpPr>
-        <p:spPr>
-          <a:xfrm>
-            <a:off x="457200" y="4828032"/>
-            <a:ext cx="8229600" cy="274320"/>
-          </a:xfrm>
-          <a:prstGeom prst="rect">
-            <a:avLst/>
-          </a:prstGeom>
-          <a:noFill/>
-          <a:ln/>
-        </p:spPr>
-        <p:txBody>
-          <a:bodyPr wrap="square" lIns="0" tIns="0" rIns="0" bIns="0" rtlCol="0" anchor="ctr"/>
-          <a:lstStyle/>
-          <a:p>
-            <a:pPr indent="0" marL="0">
-              <a:buNone/>
-            </a:pPr>
-            <a:r>
-              <a:rPr lang="en-US" sz="850" dirty="0">
-                <a:solidFill>
-                  <a:srgbClr val="6E6E6E"/>
-                </a:solidFill>
-                <a:latin typeface="Arial" pitchFamily="34" charset="0"/>
-                <a:ea typeface="Arial" pitchFamily="34" charset="-122"/>
-                <a:cs typeface="Arial" pitchFamily="34" charset="-120"/>
-              </a:rPr>
-              <a:t>Market slide after traction in YC ordering. No TAM multiplication, no 'everyone everywhere' line.</a:t>
+              <a:t>Mine verdict: the real buyer is institutional, and the real distribution is extension workers, KCC, FPOs, dealers, and panchayat actors. Consumer subscriptions and network effects are not evidenced.</a:t>
             </a:r>
             <a:endParaRPr lang="en-US" sz="850" dirty="0"/>
           </a:p>
@@ -2860,7 +3030,7 @@
                 <a:ea typeface="Arial Black" pitchFamily="34" charset="-122"/>
                 <a:cs typeface="Arial Black" pitchFamily="34" charset="-120"/>
               </a:rPr>
-              <a:t>Team 511</a:t>
+              <a:t>One rail, one pilot, one quarter</a:t>
             </a:r>
             <a:endParaRPr lang="en-US" sz="2800" dirty="0"/>
           </a:p>
@@ -2906,7 +3076,7 @@
                 <a:ea typeface="Arial Black" pitchFamily="34" charset="-122"/>
                 <a:cs typeface="Arial Black" pitchFamily="34" charset="-120"/>
               </a:rPr>
-              <a:t>Team 511</a:t>
+              <a:t>One rail, one pilot, one quarter</a:t>
             </a:r>
             <a:endParaRPr lang="en-US" sz="2800" dirty="0"/>
           </a:p>
@@ -2945,8 +3115,8 @@
         </p:nvSpPr>
         <p:spPr>
           <a:xfrm>
-            <a:off x="507492" y="1147572"/>
-            <a:ext cx="2529840" cy="1828800"/>
+            <a:off x="507492" y="1101852"/>
+            <a:ext cx="3977640" cy="2103120"/>
           </a:xfrm>
           <a:prstGeom prst="rect">
             <a:avLst/>
@@ -2970,18 +3140,18 @@
         </p:nvSpPr>
         <p:spPr>
           <a:xfrm>
-            <a:off x="457200" y="1097280"/>
-            <a:ext cx="2529840" cy="1828800"/>
+            <a:off x="457200" y="1051560"/>
+            <a:ext cx="3977640" cy="2103120"/>
           </a:xfrm>
           <a:prstGeom prst="roundRect">
             <a:avLst>
-              <a:gd name="adj" fmla="val 3000"/>
+              <a:gd name="adj" fmla="val 2609"/>
             </a:avLst>
           </a:prstGeom>
           <a:solidFill>
             <a:srgbClr val="FFFFFF"/>
           </a:solidFill>
-          <a:ln w="19050">
+          <a:ln w="25400">
             <a:solidFill>
               <a:srgbClr val="0A0A0A"/>
             </a:solidFill>
@@ -2991,23 +3161,42 @@
       </p:sp>
       <p:sp>
         <p:nvSpPr>
-          <p:cNvPr id="7" name="Shape 5"/>
-          <p:cNvSpPr/>
-          <p:nvPr/>
-        </p:nvSpPr>
-        <p:spPr>
-          <a:xfrm>
-            <a:off x="1402080" y="1280160"/>
-            <a:ext cx="640080" cy="640080"/>
-          </a:xfrm>
-          <a:prstGeom prst="ellipse">
-            <a:avLst/>
-          </a:prstGeom>
-          <a:solidFill>
-            <a:srgbClr val="0A0A0A"/>
-          </a:solidFill>
-          <a:ln/>
-        </p:spPr>
+          <p:cNvPr id="7" name="Text 5"/>
+          <p:cNvSpPr/>
+          <p:nvPr/>
+        </p:nvSpPr>
+        <p:spPr>
+          <a:xfrm>
+            <a:off x="640080" y="1188720"/>
+            <a:ext cx="3657600" cy="320040"/>
+          </a:xfrm>
+          <a:prstGeom prst="rect">
+            <a:avLst/>
+          </a:prstGeom>
+          <a:noFill/>
+          <a:ln/>
+        </p:spPr>
+        <p:txBody>
+          <a:bodyPr wrap="square" lIns="0" tIns="0" rIns="0" bIns="0" rtlCol="0" anchor="ctr"/>
+          <a:lstStyle/>
+          <a:p>
+            <a:pPr indent="0" marL="0">
+              <a:buNone/>
+            </a:pPr>
+            <a:r>
+              <a:rPr lang="en-US" sz="1300" b="1" dirty="0">
+                <a:solidFill>
+                  <a:srgbClr val="0A0A0A"/>
+                </a:solidFill>
+                <a:latin typeface="Arial Black" pitchFamily="34" charset="0"/>
+                <a:ea typeface="Arial Black" pitchFamily="34" charset="-122"/>
+                <a:cs typeface="Arial Black" pitchFamily="34" charset="-120"/>
+              </a:rPr>
+              <a:t>The rail exists</a:t>
+            </a:r>
+            <a:endParaRPr lang="en-US" sz="1300" dirty="0"/>
+          </a:p>
+        </p:txBody>
       </p:sp>
       <p:sp>
         <p:nvSpPr>
@@ -3017,164 +3206,125 @@
         </p:nvSpPr>
         <p:spPr>
           <a:xfrm>
-            <a:off x="1402080" y="1353312"/>
-            <a:ext cx="640080" cy="457200"/>
-          </a:xfrm>
-          <a:prstGeom prst="rect">
-            <a:avLst/>
-          </a:prstGeom>
-          <a:noFill/>
-          <a:ln/>
-        </p:spPr>
-        <p:txBody>
-          <a:bodyPr wrap="square" lIns="0" tIns="0" rIns="0" bIns="0" rtlCol="0" anchor="ctr"/>
-          <a:lstStyle/>
-          <a:p>
-            <a:pPr algn="ctr" indent="0" marL="0">
-              <a:buNone/>
-            </a:pPr>
-            <a:r>
-              <a:rPr lang="en-US" sz="2000" b="1" dirty="0">
-                <a:solidFill>
-                  <a:srgbClr val="FFFFFF"/>
+            <a:off x="640080" y="1554480"/>
+            <a:ext cx="3657600" cy="548640"/>
+          </a:xfrm>
+          <a:prstGeom prst="rect">
+            <a:avLst/>
+          </a:prstGeom>
+          <a:noFill/>
+          <a:ln/>
+        </p:spPr>
+        <p:txBody>
+          <a:bodyPr wrap="square" lIns="0" tIns="0" rIns="0" bIns="0" rtlCol="0" anchor="ctr"/>
+          <a:lstStyle/>
+          <a:p>
+            <a:pPr indent="0" marL="0">
+              <a:buNone/>
+            </a:pPr>
+            <a:r>
+              <a:rPr lang="en-US" sz="1600" b="1" dirty="0">
+                <a:solidFill>
+                  <a:srgbClr val="0A0A0A"/>
+                </a:solidFill>
+                <a:latin typeface="Arial Black" pitchFamily="34" charset="0"/>
+                <a:ea typeface="Arial Black" pitchFamily="34" charset="-122"/>
+                <a:cs typeface="Arial Black" pitchFamily="34" charset="-120"/>
+              </a:rPr>
+              <a:t>88.5 lakh PMFBY enrollments, Rs 2,580 crore claims paid (2020-25)</a:t>
+            </a:r>
+            <a:endParaRPr lang="en-US" sz="1600" dirty="0"/>
+          </a:p>
+        </p:txBody>
+      </p:sp>
+      <p:sp>
+        <p:nvSpPr>
+          <p:cNvPr id="9" name="Text 7"/>
+          <p:cNvSpPr/>
+          <p:nvPr/>
+        </p:nvSpPr>
+        <p:spPr>
+          <a:xfrm>
+            <a:off x="640080" y="2194560"/>
+            <a:ext cx="3657600" cy="548640"/>
+          </a:xfrm>
+          <a:prstGeom prst="rect">
+            <a:avLst/>
+          </a:prstGeom>
+          <a:noFill/>
+          <a:ln/>
+        </p:spPr>
+        <p:txBody>
+          <a:bodyPr wrap="square" lIns="0" tIns="0" rIns="0" bIns="0" rtlCol="0" anchor="ctr"/>
+          <a:lstStyle/>
+          <a:p>
+            <a:pPr indent="0" marL="0">
+              <a:buNone/>
+            </a:pPr>
+            <a:r>
+              <a:rPr lang="en-US" sz="1250" dirty="0">
+                <a:solidFill>
+                  <a:srgbClr val="0A0A0A"/>
                 </a:solidFill>
                 <a:latin typeface="Arial" pitchFamily="34" charset="0"/>
                 <a:ea typeface="Arial" pitchFamily="34" charset="-122"/>
                 <a:cs typeface="Arial" pitchFamily="34" charset="-120"/>
               </a:rPr>
-              <a:t>1</a:t>
-            </a:r>
-            <a:endParaRPr lang="en-US" sz="2000" dirty="0"/>
-          </a:p>
-        </p:txBody>
-      </p:sp>
-      <p:sp>
-        <p:nvSpPr>
-          <p:cNvPr id="9" name="Text 7"/>
-          <p:cNvSpPr/>
-          <p:nvPr/>
-        </p:nvSpPr>
-        <p:spPr>
-          <a:xfrm>
-            <a:off x="594360" y="2057400"/>
-            <a:ext cx="2255520" cy="365760"/>
-          </a:xfrm>
-          <a:prstGeom prst="rect">
-            <a:avLst/>
-          </a:prstGeom>
-          <a:noFill/>
-          <a:ln/>
-        </p:spPr>
-        <p:txBody>
-          <a:bodyPr wrap="square" lIns="0" tIns="0" rIns="0" bIns="0" rtlCol="0" anchor="ctr"/>
-          <a:lstStyle/>
-          <a:p>
-            <a:pPr algn="ctr" indent="0" marL="0">
-              <a:buNone/>
-            </a:pPr>
-            <a:r>
-              <a:rPr lang="en-US" sz="1500" b="1" dirty="0">
+              <a:t>Digital Agriculture Mission, Rs 2,817 crore, funds agri-digital public infrastructure</a:t>
+            </a:r>
+            <a:endParaRPr lang="en-US" sz="1250" dirty="0"/>
+          </a:p>
+        </p:txBody>
+      </p:sp>
+      <p:sp>
+        <p:nvSpPr>
+          <p:cNvPr id="10" name="Text 8"/>
+          <p:cNvSpPr/>
+          <p:nvPr/>
+        </p:nvSpPr>
+        <p:spPr>
+          <a:xfrm>
+            <a:off x="640080" y="2788920"/>
+            <a:ext cx="3657600" cy="548640"/>
+          </a:xfrm>
+          <a:prstGeom prst="rect">
+            <a:avLst/>
+          </a:prstGeom>
+          <a:noFill/>
+          <a:ln/>
+        </p:spPr>
+        <p:txBody>
+          <a:bodyPr wrap="square" lIns="0" tIns="0" rIns="0" bIns="0" rtlCol="0" anchor="ctr"/>
+          <a:lstStyle/>
+          <a:p>
+            <a:pPr indent="0" marL="0">
+              <a:buNone/>
+            </a:pPr>
+            <a:r>
+              <a:rPr lang="en-US" sz="1200" dirty="0">
                 <a:solidFill>
                   <a:srgbClr val="0A0A0A"/>
-                </a:solidFill>
-                <a:latin typeface="Arial Black" pitchFamily="34" charset="0"/>
-                <a:ea typeface="Arial Black" pitchFamily="34" charset="-122"/>
-                <a:cs typeface="Arial Black" pitchFamily="34" charset="-120"/>
-              </a:rPr>
-              <a:t>Harsh Gounder</a:t>
-            </a:r>
-            <a:endParaRPr lang="en-US" sz="1500" dirty="0"/>
-          </a:p>
-        </p:txBody>
-      </p:sp>
-      <p:sp>
-        <p:nvSpPr>
-          <p:cNvPr id="10" name="Text 8"/>
-          <p:cNvSpPr/>
-          <p:nvPr/>
-        </p:nvSpPr>
-        <p:spPr>
-          <a:xfrm>
-            <a:off x="594360" y="2423160"/>
-            <a:ext cx="2255520" cy="274320"/>
-          </a:xfrm>
-          <a:prstGeom prst="rect">
-            <a:avLst/>
-          </a:prstGeom>
-          <a:noFill/>
-          <a:ln/>
-        </p:spPr>
-        <p:txBody>
-          <a:bodyPr wrap="square" lIns="0" tIns="0" rIns="0" bIns="0" rtlCol="0" anchor="ctr"/>
-          <a:lstStyle/>
-          <a:p>
-            <a:pPr algn="ctr" indent="0" marL="0">
-              <a:buNone/>
-            </a:pPr>
-            <a:r>
-              <a:rPr lang="en-US" sz="1150" dirty="0">
-                <a:solidFill>
-                  <a:srgbClr val="6E6E6E"/>
                 </a:solidFill>
                 <a:latin typeface="Arial" pitchFamily="34" charset="0"/>
                 <a:ea typeface="Arial" pitchFamily="34" charset="-122"/>
                 <a:cs typeface="Arial" pitchFamily="34" charset="-120"/>
               </a:rPr>
-              <a:t>Lead, E&amp;CE</a:t>
-            </a:r>
-            <a:endParaRPr lang="en-US" sz="1150" dirty="0"/>
-          </a:p>
-        </p:txBody>
-      </p:sp>
-      <p:sp>
-        <p:nvSpPr>
-          <p:cNvPr id="11" name="Text 9"/>
-          <p:cNvSpPr/>
-          <p:nvPr/>
-        </p:nvSpPr>
-        <p:spPr>
-          <a:xfrm>
-            <a:off x="594360" y="2697480"/>
-            <a:ext cx="2255520" cy="320040"/>
-          </a:xfrm>
-          <a:prstGeom prst="rect">
-            <a:avLst/>
-          </a:prstGeom>
-          <a:noFill/>
-          <a:ln/>
-        </p:spPr>
-        <p:txBody>
-          <a:bodyPr wrap="square" lIns="0" tIns="0" rIns="0" bIns="0" rtlCol="0" anchor="ctr"/>
-          <a:lstStyle/>
-          <a:p>
-            <a:pPr algn="ctr" indent="0" marL="0">
-              <a:buNone/>
-            </a:pPr>
-            <a:r>
-              <a:rPr lang="en-US" sz="950" i="1" dirty="0">
-                <a:solidFill>
-                  <a:srgbClr val="6E6E6E"/>
-                </a:solidFill>
-                <a:latin typeface="Arial" pitchFamily="34" charset="0"/>
-                <a:ea typeface="Arial" pitchFamily="34" charset="-122"/>
-                <a:cs typeface="Arial" pitchFamily="34" charset="-120"/>
-              </a:rPr>
-              <a:t>everything: architecture, code, research method, 49-report evidence wave, backend, QA, devops</a:t>
-            </a:r>
-            <a:endParaRPr lang="en-US" sz="950" dirty="0"/>
-          </a:p>
-        </p:txBody>
-      </p:sp>
-      <p:sp>
-        <p:nvSpPr>
-          <p:cNvPr id="12" name="Shape 10"/>
-          <p:cNvSpPr/>
-          <p:nvPr/>
-        </p:nvSpPr>
-        <p:spPr>
-          <a:xfrm>
-            <a:off x="3357372" y="1147572"/>
-            <a:ext cx="2529840" cy="1828800"/>
+              <a:t>Odisha: cyclone-facing coast, paddy and saline zones, Dana and Yaas damage on record</a:t>
+            </a:r>
+            <a:endParaRPr lang="en-US" sz="1200" dirty="0"/>
+          </a:p>
+        </p:txBody>
+      </p:sp>
+      <p:sp>
+        <p:nvSpPr>
+          <p:cNvPr id="11" name="Shape 9"/>
+          <p:cNvSpPr/>
+          <p:nvPr/>
+        </p:nvSpPr>
+        <p:spPr>
+          <a:xfrm>
+            <a:off x="4759452" y="1101852"/>
+            <a:ext cx="3977640" cy="2103120"/>
           </a:xfrm>
           <a:prstGeom prst="rect">
             <a:avLst/>
@@ -3192,24 +3342,24 @@
       </p:sp>
       <p:sp>
         <p:nvSpPr>
-          <p:cNvPr id="13" name="Shape 11"/>
-          <p:cNvSpPr/>
-          <p:nvPr/>
-        </p:nvSpPr>
-        <p:spPr>
-          <a:xfrm>
-            <a:off x="3307080" y="1097280"/>
-            <a:ext cx="2529840" cy="1828800"/>
+          <p:cNvPr id="12" name="Shape 10"/>
+          <p:cNvSpPr/>
+          <p:nvPr/>
+        </p:nvSpPr>
+        <p:spPr>
+          <a:xfrm>
+            <a:off x="4709160" y="1051560"/>
+            <a:ext cx="3977640" cy="2103120"/>
           </a:xfrm>
           <a:prstGeom prst="roundRect">
             <a:avLst>
-              <a:gd name="adj" fmla="val 3000"/>
+              <a:gd name="adj" fmla="val 2609"/>
             </a:avLst>
           </a:prstGeom>
           <a:solidFill>
             <a:srgbClr val="FFFFFF"/>
           </a:solidFill>
-          <a:ln w="19050">
+          <a:ln w="25400">
             <a:solidFill>
               <a:srgbClr val="0A0A0A"/>
             </a:solidFill>
@@ -3219,60 +3369,118 @@
       </p:sp>
       <p:sp>
         <p:nvSpPr>
-          <p:cNvPr id="14" name="Shape 12"/>
-          <p:cNvSpPr/>
-          <p:nvPr/>
-        </p:nvSpPr>
-        <p:spPr>
-          <a:xfrm>
-            <a:off x="4251960" y="1280160"/>
-            <a:ext cx="640080" cy="640080"/>
-          </a:xfrm>
-          <a:prstGeom prst="ellipse">
-            <a:avLst/>
-          </a:prstGeom>
-          <a:solidFill>
-            <a:srgbClr val="0A0A0A"/>
-          </a:solidFill>
-          <a:ln/>
-        </p:spPr>
-      </p:sp>
-      <p:sp>
-        <p:nvSpPr>
-          <p:cNvPr id="15" name="Text 13"/>
-          <p:cNvSpPr/>
-          <p:nvPr/>
-        </p:nvSpPr>
-        <p:spPr>
-          <a:xfrm>
-            <a:off x="4251960" y="1353312"/>
-            <a:ext cx="640080" cy="457200"/>
-          </a:xfrm>
-          <a:prstGeom prst="rect">
-            <a:avLst/>
-          </a:prstGeom>
-          <a:noFill/>
-          <a:ln/>
-        </p:spPr>
-        <p:txBody>
-          <a:bodyPr wrap="square" lIns="0" tIns="0" rIns="0" bIns="0" rtlCol="0" anchor="ctr"/>
-          <a:lstStyle/>
-          <a:p>
-            <a:pPr algn="ctr" indent="0" marL="0">
-              <a:buNone/>
-            </a:pPr>
-            <a:r>
-              <a:rPr lang="en-US" sz="2000" b="1" dirty="0">
-                <a:solidFill>
-                  <a:srgbClr val="FFFFFF"/>
+          <p:cNvPr id="13" name="Text 11"/>
+          <p:cNvSpPr/>
+          <p:nvPr/>
+        </p:nvSpPr>
+        <p:spPr>
+          <a:xfrm>
+            <a:off x="4892040" y="1188720"/>
+            <a:ext cx="3657600" cy="320040"/>
+          </a:xfrm>
+          <a:prstGeom prst="rect">
+            <a:avLst/>
+          </a:prstGeom>
+          <a:noFill/>
+          <a:ln/>
+        </p:spPr>
+        <p:txBody>
+          <a:bodyPr wrap="square" lIns="0" tIns="0" rIns="0" bIns="0" rtlCol="0" anchor="ctr"/>
+          <a:lstStyle/>
+          <a:p>
+            <a:pPr indent="0" marL="0">
+              <a:buNone/>
+            </a:pPr>
+            <a:r>
+              <a:rPr lang="en-US" sz="1300" b="1" dirty="0">
+                <a:solidFill>
+                  <a:srgbClr val="0A0A0A"/>
+                </a:solidFill>
+                <a:latin typeface="Arial Black" pitchFamily="34" charset="0"/>
+                <a:ea typeface="Arial Black" pitchFamily="34" charset="-122"/>
+                <a:cs typeface="Arial Black" pitchFamily="34" charset="-120"/>
+              </a:rPr>
+              <a:t>The pilot</a:t>
+            </a:r>
+            <a:endParaRPr lang="en-US" sz="1300" dirty="0"/>
+          </a:p>
+        </p:txBody>
+      </p:sp>
+      <p:sp>
+        <p:nvSpPr>
+          <p:cNvPr id="14" name="Text 12"/>
+          <p:cNvSpPr/>
+          <p:nvPr/>
+        </p:nvSpPr>
+        <p:spPr>
+          <a:xfrm>
+            <a:off x="4892040" y="1600200"/>
+            <a:ext cx="3657600" cy="457200"/>
+          </a:xfrm>
+          <a:prstGeom prst="rect">
+            <a:avLst/>
+          </a:prstGeom>
+          <a:noFill/>
+          <a:ln/>
+        </p:spPr>
+        <p:txBody>
+          <a:bodyPr wrap="square" lIns="0" tIns="0" rIns="0" bIns="0" rtlCol="0" anchor="ctr"/>
+          <a:lstStyle/>
+          <a:p>
+            <a:pPr indent="0" marL="0">
+              <a:buNone/>
+            </a:pPr>
+            <a:r>
+              <a:rPr lang="en-US" sz="1200" dirty="0">
+                <a:solidFill>
+                  <a:srgbClr val="0A0A0A"/>
                 </a:solidFill>
                 <a:latin typeface="Arial" pitchFamily="34" charset="0"/>
                 <a:ea typeface="Arial" pitchFamily="34" charset="-122"/>
                 <a:cs typeface="Arial" pitchFamily="34" charset="-120"/>
               </a:rPr>
-              <a:t>2</a:t>
-            </a:r>
-            <a:endParaRPr lang="en-US" sz="2000" dirty="0"/>
+              <a:t>1.  one coastal block with extension-worker access</a:t>
+            </a:r>
+            <a:endParaRPr lang="en-US" sz="1200" dirty="0"/>
+          </a:p>
+        </p:txBody>
+      </p:sp>
+      <p:sp>
+        <p:nvSpPr>
+          <p:cNvPr id="15" name="Text 13"/>
+          <p:cNvSpPr/>
+          <p:nvPr/>
+        </p:nvSpPr>
+        <p:spPr>
+          <a:xfrm>
+            <a:off x="4892040" y="2103120"/>
+            <a:ext cx="3657600" cy="457200"/>
+          </a:xfrm>
+          <a:prstGeom prst="rect">
+            <a:avLst/>
+          </a:prstGeom>
+          <a:noFill/>
+          <a:ln/>
+        </p:spPr>
+        <p:txBody>
+          <a:bodyPr wrap="square" lIns="0" tIns="0" rIns="0" bIns="0" rtlCol="0" anchor="ctr"/>
+          <a:lstStyle/>
+          <a:p>
+            <a:pPr indent="0" marL="0">
+              <a:buNone/>
+            </a:pPr>
+            <a:r>
+              <a:rPr lang="en-US" sz="1200" dirty="0">
+                <a:solidFill>
+                  <a:srgbClr val="0A0A0A"/>
+                </a:solidFill>
+                <a:latin typeface="Arial" pitchFamily="34" charset="0"/>
+                <a:ea typeface="Arial" pitchFamily="34" charset="-122"/>
+                <a:cs typeface="Arial" pitchFamily="34" charset="-120"/>
+              </a:rPr>
+              <a:t>2.  one agronomist-reviewed rule pack</a:t>
+            </a:r>
+            <a:endParaRPr lang="en-US" sz="1200" dirty="0"/>
           </a:p>
         </p:txBody>
       </p:sp>
@@ -3284,63 +3492,148 @@
         </p:nvSpPr>
         <p:spPr>
           <a:xfrm>
-            <a:off x="3444240" y="2057400"/>
-            <a:ext cx="2255520" cy="365760"/>
-          </a:xfrm>
-          <a:prstGeom prst="rect">
-            <a:avLst/>
-          </a:prstGeom>
-          <a:noFill/>
-          <a:ln/>
-        </p:spPr>
-        <p:txBody>
-          <a:bodyPr wrap="square" lIns="0" tIns="0" rIns="0" bIns="0" rtlCol="0" anchor="ctr"/>
-          <a:lstStyle/>
-          <a:p>
-            <a:pPr algn="ctr" indent="0" marL="0">
-              <a:buNone/>
-            </a:pPr>
-            <a:r>
-              <a:rPr lang="en-US" sz="1500" b="1" dirty="0">
+            <a:off x="4892040" y="2606040"/>
+            <a:ext cx="3657600" cy="457200"/>
+          </a:xfrm>
+          <a:prstGeom prst="rect">
+            <a:avLst/>
+          </a:prstGeom>
+          <a:noFill/>
+          <a:ln/>
+        </p:spPr>
+        <p:txBody>
+          <a:bodyPr wrap="square" lIns="0" tIns="0" rIns="0" bIns="0" rtlCol="0" anchor="ctr"/>
+          <a:lstStyle/>
+          <a:p>
+            <a:pPr indent="0" marL="0">
+              <a:buNone/>
+            </a:pPr>
+            <a:r>
+              <a:rPr lang="en-US" sz="1200" dirty="0">
                 <a:solidFill>
                   <a:srgbClr val="0A0A0A"/>
+                </a:solidFill>
+                <a:latin typeface="Arial" pitchFamily="34" charset="0"/>
+                <a:ea typeface="Arial" pitchFamily="34" charset="-122"/>
+                <a:cs typeface="Arial" pitchFamily="34" charset="-120"/>
+              </a:rPr>
+              <a:t>3.  measure comprehension and claim conversion, not downloads</a:t>
+            </a:r>
+            <a:endParaRPr lang="en-US" sz="1200" dirty="0"/>
+          </a:p>
+        </p:txBody>
+      </p:sp>
+      <p:sp>
+        <p:nvSpPr>
+          <p:cNvPr id="17" name="Text 15"/>
+          <p:cNvSpPr/>
+          <p:nvPr/>
+        </p:nvSpPr>
+        <p:spPr>
+          <a:xfrm>
+            <a:off x="498348" y="3470148"/>
+            <a:ext cx="6858000" cy="0"/>
+          </a:xfrm>
+          <a:prstGeom prst="rect">
+            <a:avLst/>
+          </a:prstGeom>
+          <a:noFill/>
+          <a:ln/>
+        </p:spPr>
+        <p:txBody>
+          <a:bodyPr wrap="square" lIns="0" tIns="0" rIns="0" bIns="0" rtlCol="0" anchor="ctr"/>
+          <a:lstStyle/>
+          <a:p>
+            <a:pPr indent="0" marL="0">
+              <a:buNone/>
+            </a:pPr>
+            <a:r>
+              <a:rPr lang="en-US" sz="1450" b="1" dirty="0">
+                <a:solidFill>
+                  <a:srgbClr val="E0E0E0"/>
                 </a:solidFill>
                 <a:latin typeface="Arial Black" pitchFamily="34" charset="0"/>
                 <a:ea typeface="Arial Black" pitchFamily="34" charset="-122"/>
                 <a:cs typeface="Arial Black" pitchFamily="34" charset="-120"/>
               </a:rPr>
-              <a:t>Ayush Kharwar</a:t>
-            </a:r>
-            <a:endParaRPr lang="en-US" sz="1500" dirty="0"/>
-          </a:p>
-        </p:txBody>
-      </p:sp>
-      <p:sp>
-        <p:nvSpPr>
-          <p:cNvPr id="17" name="Text 15"/>
-          <p:cNvSpPr/>
-          <p:nvPr/>
-        </p:nvSpPr>
-        <p:spPr>
-          <a:xfrm>
-            <a:off x="3444240" y="2423160"/>
-            <a:ext cx="2255520" cy="274320"/>
-          </a:xfrm>
-          <a:prstGeom prst="rect">
-            <a:avLst/>
-          </a:prstGeom>
-          <a:noFill/>
-          <a:ln/>
-        </p:spPr>
-        <p:txBody>
-          <a:bodyPr wrap="square" lIns="0" tIns="0" rIns="0" bIns="0" rtlCol="0" anchor="ctr"/>
-          <a:lstStyle/>
-          <a:p>
-            <a:pPr algn="ctr" indent="0" marL="0">
-              <a:buNone/>
-            </a:pPr>
-            <a:r>
-              <a:rPr lang="en-US" sz="1150" dirty="0">
+              <a:t>Named rail, named pilot, dated outcome. That is the Round 1 contract.</a:t>
+            </a:r>
+            <a:endParaRPr lang="en-US" sz="1450" dirty="0"/>
+          </a:p>
+        </p:txBody>
+      </p:sp>
+      <p:sp>
+        <p:nvSpPr>
+          <p:cNvPr id="18" name="Text 16"/>
+          <p:cNvSpPr/>
+          <p:nvPr/>
+        </p:nvSpPr>
+        <p:spPr>
+          <a:xfrm>
+            <a:off x="457200" y="3429000"/>
+            <a:ext cx="6858000" cy="0"/>
+          </a:xfrm>
+          <a:prstGeom prst="rect">
+            <a:avLst/>
+          </a:prstGeom>
+          <a:noFill/>
+          <a:ln/>
+          <a:effectLst>
+            <a:outerShdw sx="100000" sy="100000" kx="0" ky="0" algn="bl" rotWithShape="0" blurRad="101600" dist="38100" dir="2700000">
+              <a:srgbClr val="000000">
+                <a:alpha val="25000"/>
+              </a:srgbClr>
+            </a:outerShdw>
+          </a:effectLst>
+        </p:spPr>
+        <p:txBody>
+          <a:bodyPr wrap="square" lIns="0" tIns="0" rIns="0" bIns="0" rtlCol="0" anchor="ctr"/>
+          <a:lstStyle/>
+          <a:p>
+            <a:pPr indent="0" marL="0">
+              <a:buNone/>
+            </a:pPr>
+            <a:r>
+              <a:rPr lang="en-US" sz="1450" b="1" dirty="0">
+                <a:solidFill>
+                  <a:srgbClr val="0A0A0A"/>
+                </a:solidFill>
+                <a:latin typeface="Arial Black" pitchFamily="34" charset="0"/>
+                <a:ea typeface="Arial Black" pitchFamily="34" charset="-122"/>
+                <a:cs typeface="Arial Black" pitchFamily="34" charset="-120"/>
+              </a:rPr>
+              <a:t>Named rail, named pilot, dated outcome. That is the Round 1 contract.</a:t>
+            </a:r>
+            <a:endParaRPr lang="en-US" sz="1450" dirty="0"/>
+          </a:p>
+        </p:txBody>
+      </p:sp>
+      <p:sp>
+        <p:nvSpPr>
+          <p:cNvPr id="19" name="Text 17"/>
+          <p:cNvSpPr/>
+          <p:nvPr/>
+        </p:nvSpPr>
+        <p:spPr>
+          <a:xfrm>
+            <a:off x="457200" y="3977640"/>
+            <a:ext cx="8229600" cy="365760"/>
+          </a:xfrm>
+          <a:prstGeom prst="rect">
+            <a:avLst/>
+          </a:prstGeom>
+          <a:noFill/>
+          <a:ln/>
+        </p:spPr>
+        <p:txBody>
+          <a:bodyPr wrap="square" lIns="0" tIns="0" rIns="0" bIns="0" rtlCol="0" anchor="ctr"/>
+          <a:lstStyle/>
+          <a:p>
+            <a:pPr indent="0" marL="0">
+              <a:buNone/>
+            </a:pPr>
+            <a:r>
+              <a:rPr lang="en-US" sz="1000" i="1" dirty="0">
                 <a:solidFill>
                   <a:srgbClr val="6E6E6E"/>
                 </a:solidFill>
@@ -3348,38 +3641,38 @@
                 <a:ea typeface="Arial" pitchFamily="34" charset="-122"/>
                 <a:cs typeface="Arial" pitchFamily="34" charset="-120"/>
               </a:rPr>
-              <a:t>Deck and design</a:t>
-            </a:r>
-            <a:endParaRPr lang="en-US" sz="1150" dirty="0"/>
-          </a:p>
-        </p:txBody>
-      </p:sp>
-      <p:sp>
-        <p:nvSpPr>
-          <p:cNvPr id="18" name="Text 16"/>
-          <p:cNvSpPr/>
-          <p:nvPr/>
-        </p:nvSpPr>
-        <p:spPr>
-          <a:xfrm>
-            <a:off x="3444240" y="2697480"/>
-            <a:ext cx="2255520" cy="320040"/>
-          </a:xfrm>
-          <a:prstGeom prst="rect">
-            <a:avLst/>
-          </a:prstGeom>
-          <a:noFill/>
-          <a:ln/>
-        </p:spPr>
-        <p:txBody>
-          <a:bodyPr wrap="square" lIns="0" tIns="0" rIns="0" bIns="0" rtlCol="0" anchor="ctr"/>
-          <a:lstStyle/>
-          <a:p>
-            <a:pPr algn="ctr" indent="0" marL="0">
-              <a:buNone/>
-            </a:pPr>
-            <a:r>
-              <a:rPr lang="en-US" sz="950" i="1" dirty="0">
+              <a:t>Sources: PMFBY program data; Digital Agriculture Mission allocation; YSD Dana assessment; Down To Earth Yaas report. All dated 2024-2025, verified in the research wave.</a:t>
+            </a:r>
+            <a:endParaRPr lang="en-US" sz="1000" dirty="0"/>
+          </a:p>
+        </p:txBody>
+      </p:sp>
+      <p:sp>
+        <p:nvSpPr>
+          <p:cNvPr id="20" name="Text 18"/>
+          <p:cNvSpPr/>
+          <p:nvPr/>
+        </p:nvSpPr>
+        <p:spPr>
+          <a:xfrm>
+            <a:off x="457200" y="4828032"/>
+            <a:ext cx="8229600" cy="274320"/>
+          </a:xfrm>
+          <a:prstGeom prst="rect">
+            <a:avLst/>
+          </a:prstGeom>
+          <a:noFill/>
+          <a:ln/>
+        </p:spPr>
+        <p:txBody>
+          <a:bodyPr wrap="square" lIns="0" tIns="0" rIns="0" bIns="0" rtlCol="0" anchor="ctr"/>
+          <a:lstStyle/>
+          <a:p>
+            <a:pPr indent="0" marL="0">
+              <a:buNone/>
+            </a:pPr>
+            <a:r>
+              <a:rPr lang="en-US" sz="850" dirty="0">
                 <a:solidFill>
                   <a:srgbClr val="6E6E6E"/>
                 </a:solidFill>
@@ -3387,313 +3680,7 @@
                 <a:ea typeface="Arial" pitchFamily="34" charset="-122"/>
                 <a:cs typeface="Arial" pitchFamily="34" charset="-120"/>
               </a:rPr>
-              <a:t>presentation build and design</a:t>
-            </a:r>
-            <a:endParaRPr lang="en-US" sz="950" dirty="0"/>
-          </a:p>
-        </p:txBody>
-      </p:sp>
-      <p:sp>
-        <p:nvSpPr>
-          <p:cNvPr id="19" name="Shape 17"/>
-          <p:cNvSpPr/>
-          <p:nvPr/>
-        </p:nvSpPr>
-        <p:spPr>
-          <a:xfrm>
-            <a:off x="6207252" y="1147572"/>
-            <a:ext cx="2529840" cy="1828800"/>
-          </a:xfrm>
-          <a:prstGeom prst="rect">
-            <a:avLst/>
-          </a:prstGeom>
-          <a:solidFill>
-            <a:srgbClr val="E0E0E0"/>
-          </a:solidFill>
-          <a:ln w="12700">
-            <a:solidFill>
-              <a:srgbClr val="E0E0E0"/>
-            </a:solidFill>
-            <a:prstDash val="solid"/>
-          </a:ln>
-        </p:spPr>
-      </p:sp>
-      <p:sp>
-        <p:nvSpPr>
-          <p:cNvPr id="20" name="Shape 18"/>
-          <p:cNvSpPr/>
-          <p:nvPr/>
-        </p:nvSpPr>
-        <p:spPr>
-          <a:xfrm>
-            <a:off x="6156960" y="1097280"/>
-            <a:ext cx="2529840" cy="1828800"/>
-          </a:xfrm>
-          <a:prstGeom prst="roundRect">
-            <a:avLst>
-              <a:gd name="adj" fmla="val 3000"/>
-            </a:avLst>
-          </a:prstGeom>
-          <a:solidFill>
-            <a:srgbClr val="FFFFFF"/>
-          </a:solidFill>
-          <a:ln w="19050">
-            <a:solidFill>
-              <a:srgbClr val="0A0A0A"/>
-            </a:solidFill>
-            <a:prstDash val="solid"/>
-          </a:ln>
-        </p:spPr>
-      </p:sp>
-      <p:sp>
-        <p:nvSpPr>
-          <p:cNvPr id="21" name="Shape 19"/>
-          <p:cNvSpPr/>
-          <p:nvPr/>
-        </p:nvSpPr>
-        <p:spPr>
-          <a:xfrm>
-            <a:off x="7101840" y="1280160"/>
-            <a:ext cx="640080" cy="640080"/>
-          </a:xfrm>
-          <a:prstGeom prst="ellipse">
-            <a:avLst/>
-          </a:prstGeom>
-          <a:solidFill>
-            <a:srgbClr val="0A0A0A"/>
-          </a:solidFill>
-          <a:ln/>
-        </p:spPr>
-      </p:sp>
-      <p:sp>
-        <p:nvSpPr>
-          <p:cNvPr id="22" name="Text 20"/>
-          <p:cNvSpPr/>
-          <p:nvPr/>
-        </p:nvSpPr>
-        <p:spPr>
-          <a:xfrm>
-            <a:off x="7101840" y="1353312"/>
-            <a:ext cx="640080" cy="457200"/>
-          </a:xfrm>
-          <a:prstGeom prst="rect">
-            <a:avLst/>
-          </a:prstGeom>
-          <a:noFill/>
-          <a:ln/>
-        </p:spPr>
-        <p:txBody>
-          <a:bodyPr wrap="square" lIns="0" tIns="0" rIns="0" bIns="0" rtlCol="0" anchor="ctr"/>
-          <a:lstStyle/>
-          <a:p>
-            <a:pPr algn="ctr" indent="0" marL="0">
-              <a:buNone/>
-            </a:pPr>
-            <a:r>
-              <a:rPr lang="en-US" sz="2000" b="1" dirty="0">
-                <a:solidFill>
-                  <a:srgbClr val="FFFFFF"/>
-                </a:solidFill>
-                <a:latin typeface="Arial" pitchFamily="34" charset="0"/>
-                <a:ea typeface="Arial" pitchFamily="34" charset="-122"/>
-                <a:cs typeface="Arial" pitchFamily="34" charset="-120"/>
-              </a:rPr>
-              <a:t>3</a:t>
-            </a:r>
-            <a:endParaRPr lang="en-US" sz="2000" dirty="0"/>
-          </a:p>
-        </p:txBody>
-      </p:sp>
-      <p:sp>
-        <p:nvSpPr>
-          <p:cNvPr id="23" name="Text 21"/>
-          <p:cNvSpPr/>
-          <p:nvPr/>
-        </p:nvSpPr>
-        <p:spPr>
-          <a:xfrm>
-            <a:off x="6294120" y="2057400"/>
-            <a:ext cx="2255520" cy="365760"/>
-          </a:xfrm>
-          <a:prstGeom prst="rect">
-            <a:avLst/>
-          </a:prstGeom>
-          <a:noFill/>
-          <a:ln/>
-        </p:spPr>
-        <p:txBody>
-          <a:bodyPr wrap="square" lIns="0" tIns="0" rIns="0" bIns="0" rtlCol="0" anchor="ctr"/>
-          <a:lstStyle/>
-          <a:p>
-            <a:pPr algn="ctr" indent="0" marL="0">
-              <a:buNone/>
-            </a:pPr>
-            <a:r>
-              <a:rPr lang="en-US" sz="1500" b="1" dirty="0">
-                <a:solidFill>
-                  <a:srgbClr val="0A0A0A"/>
-                </a:solidFill>
-                <a:latin typeface="Arial Black" pitchFamily="34" charset="0"/>
-                <a:ea typeface="Arial Black" pitchFamily="34" charset="-122"/>
-                <a:cs typeface="Arial Black" pitchFamily="34" charset="-120"/>
-              </a:rPr>
-              <a:t>Sujal Shukla</a:t>
-            </a:r>
-            <a:endParaRPr lang="en-US" sz="1500" dirty="0"/>
-          </a:p>
-        </p:txBody>
-      </p:sp>
-      <p:sp>
-        <p:nvSpPr>
-          <p:cNvPr id="24" name="Text 22"/>
-          <p:cNvSpPr/>
-          <p:nvPr/>
-        </p:nvSpPr>
-        <p:spPr>
-          <a:xfrm>
-            <a:off x="6294120" y="2423160"/>
-            <a:ext cx="2255520" cy="274320"/>
-          </a:xfrm>
-          <a:prstGeom prst="rect">
-            <a:avLst/>
-          </a:prstGeom>
-          <a:noFill/>
-          <a:ln/>
-        </p:spPr>
-        <p:txBody>
-          <a:bodyPr wrap="square" lIns="0" tIns="0" rIns="0" bIns="0" rtlCol="0" anchor="ctr"/>
-          <a:lstStyle/>
-          <a:p>
-            <a:pPr algn="ctr" indent="0" marL="0">
-              <a:buNone/>
-            </a:pPr>
-            <a:r>
-              <a:rPr lang="en-US" sz="1150" dirty="0">
-                <a:solidFill>
-                  <a:srgbClr val="6E6E6E"/>
-                </a:solidFill>
-                <a:latin typeface="Arial" pitchFamily="34" charset="0"/>
-                <a:ea typeface="Arial" pitchFamily="34" charset="-122"/>
-                <a:cs typeface="Arial" pitchFamily="34" charset="-120"/>
-              </a:rPr>
-              <a:t>Deck design</a:t>
-            </a:r>
-            <a:endParaRPr lang="en-US" sz="1150" dirty="0"/>
-          </a:p>
-        </p:txBody>
-      </p:sp>
-      <p:sp>
-        <p:nvSpPr>
-          <p:cNvPr id="25" name="Text 23"/>
-          <p:cNvSpPr/>
-          <p:nvPr/>
-        </p:nvSpPr>
-        <p:spPr>
-          <a:xfrm>
-            <a:off x="6294120" y="2697480"/>
-            <a:ext cx="2255520" cy="320040"/>
-          </a:xfrm>
-          <a:prstGeom prst="rect">
-            <a:avLst/>
-          </a:prstGeom>
-          <a:noFill/>
-          <a:ln/>
-        </p:spPr>
-        <p:txBody>
-          <a:bodyPr wrap="square" lIns="0" tIns="0" rIns="0" bIns="0" rtlCol="0" anchor="ctr"/>
-          <a:lstStyle/>
-          <a:p>
-            <a:pPr algn="ctr" indent="0" marL="0">
-              <a:buNone/>
-            </a:pPr>
-            <a:r>
-              <a:rPr lang="en-US" sz="950" i="1" dirty="0">
-                <a:solidFill>
-                  <a:srgbClr val="6E6E6E"/>
-                </a:solidFill>
-                <a:latin typeface="Arial" pitchFamily="34" charset="0"/>
-                <a:ea typeface="Arial" pitchFamily="34" charset="-122"/>
-                <a:cs typeface="Arial" pitchFamily="34" charset="-120"/>
-              </a:rPr>
-              <a:t>design assistance on the presentation</a:t>
-            </a:r>
-            <a:endParaRPr lang="en-US" sz="950" dirty="0"/>
-          </a:p>
-        </p:txBody>
-      </p:sp>
-      <p:sp>
-        <p:nvSpPr>
-          <p:cNvPr id="26" name="Text 24"/>
-          <p:cNvSpPr/>
-          <p:nvPr/>
-        </p:nvSpPr>
-        <p:spPr>
-          <a:xfrm>
-            <a:off x="457200" y="3383280"/>
-            <a:ext cx="8229600" cy="457200"/>
-          </a:xfrm>
-          <a:prstGeom prst="rect">
-            <a:avLst/>
-          </a:prstGeom>
-          <a:noFill/>
-          <a:ln/>
-        </p:spPr>
-        <p:txBody>
-          <a:bodyPr wrap="square" lIns="0" tIns="0" rIns="0" bIns="0" rtlCol="0" anchor="ctr"/>
-          <a:lstStyle/>
-          <a:p>
-            <a:pPr indent="0" marL="0">
-              <a:buNone/>
-            </a:pPr>
-            <a:r>
-              <a:rPr lang="en-US" sz="1300" b="1" dirty="0">
-                <a:solidFill>
-                  <a:srgbClr val="0A0A0A"/>
-                </a:solidFill>
-                <a:latin typeface="Arial Black" pitchFamily="34" charset="0"/>
-                <a:ea typeface="Arial Black" pitchFamily="34" charset="-122"/>
-                <a:cs typeface="Arial Black" pitchFamily="34" charset="-120"/>
-              </a:rPr>
-              <a:t>Already shipped: a verified governed pipeline (85/85 suites), honest outcome badges, and a statement-faithful research method with every claim sourced.</a:t>
-            </a:r>
-            <a:endParaRPr lang="en-US" sz="1300" dirty="0"/>
-          </a:p>
-        </p:txBody>
-      </p:sp>
-      <p:sp>
-        <p:nvSpPr>
-          <p:cNvPr id="27" name="Text 25"/>
-          <p:cNvSpPr/>
-          <p:nvPr/>
-        </p:nvSpPr>
-        <p:spPr>
-          <a:xfrm>
-            <a:off x="457200" y="4828032"/>
-            <a:ext cx="8229600" cy="274320"/>
-          </a:xfrm>
-          <a:prstGeom prst="rect">
-            <a:avLst/>
-          </a:prstGeom>
-          <a:noFill/>
-          <a:ln/>
-        </p:spPr>
-        <p:txBody>
-          <a:bodyPr wrap="square" lIns="0" tIns="0" rIns="0" bIns="0" rtlCol="0" anchor="ctr"/>
-          <a:lstStyle/>
-          <a:p>
-            <a:pPr indent="0" marL="0">
-              <a:buNone/>
-            </a:pPr>
-            <a:r>
-              <a:rPr lang="en-US" sz="850" dirty="0">
-                <a:solidFill>
-                  <a:srgbClr val="6E6E6E"/>
-                </a:solidFill>
-                <a:latin typeface="Arial" pitchFamily="34" charset="0"/>
-                <a:ea typeface="Arial" pitchFamily="34" charset="-122"/>
-                <a:cs typeface="Arial" pitchFamily="34" charset="-120"/>
-              </a:rPr>
-              <a:t>E&amp;CE research profile matches the statement core: sensors, communications, ML, power resilience.</a:t>
+              <a:t>Market slide after traction in YC ordering. No TAM multiplication, no 'everyone everywhere' line.</a:t>
             </a:r>
             <a:endParaRPr lang="en-US" sz="850" dirty="0"/>
           </a:p>
@@ -3710,6 +3697,910 @@
 <file path=ppt/slides/slide12.xml><?xml version="1.0" encoding="utf-8"?>
 <p:sld xmlns:a="http://schemas.openxmlformats.org/drawingml/2006/main" xmlns:r="http://schemas.openxmlformats.org/officeDocument/2006/relationships" xmlns:p="http://schemas.openxmlformats.org/presentationml/2006/main">
   <p:cSld name="Slide 12">
+    <p:bg>
+      <p:bgPr>
+        <a:solidFill>
+          <a:srgbClr val="FFFFFF"/>
+        </a:solidFill>
+      </p:bgPr>
+    </p:bg>
+    <p:spTree>
+      <p:nvGrpSpPr>
+        <p:cNvPr id="1" name=""/>
+        <p:cNvGrpSpPr/>
+        <p:nvPr/>
+      </p:nvGrpSpPr>
+      <p:grpSpPr>
+        <a:xfrm>
+          <a:off x="0" y="0"/>
+          <a:ext cx="0" cy="0"/>
+          <a:chOff x="0" y="0"/>
+          <a:chExt cx="0" cy="0"/>
+        </a:xfrm>
+      </p:grpSpPr>
+      <p:sp>
+        <p:nvSpPr>
+          <p:cNvPr id="2" name="Text 0"/>
+          <p:cNvSpPr/>
+          <p:nvPr/>
+        </p:nvSpPr>
+        <p:spPr>
+          <a:xfrm>
+            <a:off x="498348" y="333756"/>
+            <a:ext cx="6858000" cy="0"/>
+          </a:xfrm>
+          <a:prstGeom prst="rect">
+            <a:avLst/>
+          </a:prstGeom>
+          <a:noFill/>
+          <a:ln/>
+        </p:spPr>
+        <p:txBody>
+          <a:bodyPr wrap="square" lIns="0" tIns="0" rIns="0" bIns="0" rtlCol="0" anchor="ctr"/>
+          <a:lstStyle/>
+          <a:p>
+            <a:pPr indent="0" marL="0">
+              <a:buNone/>
+            </a:pPr>
+            <a:r>
+              <a:rPr lang="en-US" sz="2800" b="1" dirty="0">
+                <a:solidFill>
+                  <a:srgbClr val="E0E0E0"/>
+                </a:solidFill>
+                <a:latin typeface="Arial Black" pitchFamily="34" charset="0"/>
+                <a:ea typeface="Arial Black" pitchFamily="34" charset="-122"/>
+                <a:cs typeface="Arial Black" pitchFamily="34" charset="-120"/>
+              </a:rPr>
+              <a:t>Team 511</a:t>
+            </a:r>
+            <a:endParaRPr lang="en-US" sz="2800" dirty="0"/>
+          </a:p>
+        </p:txBody>
+      </p:sp>
+      <p:sp>
+        <p:nvSpPr>
+          <p:cNvPr id="3" name="Text 1"/>
+          <p:cNvSpPr/>
+          <p:nvPr/>
+        </p:nvSpPr>
+        <p:spPr>
+          <a:xfrm>
+            <a:off x="457200" y="292608"/>
+            <a:ext cx="6858000" cy="0"/>
+          </a:xfrm>
+          <a:prstGeom prst="rect">
+            <a:avLst/>
+          </a:prstGeom>
+          <a:noFill/>
+          <a:ln/>
+          <a:effectLst>
+            <a:outerShdw sx="100000" sy="100000" kx="0" ky="0" algn="bl" rotWithShape="0" blurRad="101600" dist="38100" dir="2700000">
+              <a:srgbClr val="000000">
+                <a:alpha val="25000"/>
+              </a:srgbClr>
+            </a:outerShdw>
+          </a:effectLst>
+        </p:spPr>
+        <p:txBody>
+          <a:bodyPr wrap="square" lIns="0" tIns="0" rIns="0" bIns="0" rtlCol="0" anchor="ctr"/>
+          <a:lstStyle/>
+          <a:p>
+            <a:pPr indent="0" marL="0">
+              <a:buNone/>
+            </a:pPr>
+            <a:r>
+              <a:rPr lang="en-US" sz="2800" b="1" dirty="0">
+                <a:solidFill>
+                  <a:srgbClr val="0A0A0A"/>
+                </a:solidFill>
+                <a:latin typeface="Arial Black" pitchFamily="34" charset="0"/>
+                <a:ea typeface="Arial Black" pitchFamily="34" charset="-122"/>
+                <a:cs typeface="Arial Black" pitchFamily="34" charset="-120"/>
+              </a:rPr>
+              <a:t>Team 511</a:t>
+            </a:r>
+            <a:endParaRPr lang="en-US" sz="2800" dirty="0"/>
+          </a:p>
+        </p:txBody>
+      </p:sp>
+      <p:sp>
+        <p:nvSpPr>
+          <p:cNvPr id="4" name="Shape 2"/>
+          <p:cNvSpPr/>
+          <p:nvPr/>
+        </p:nvSpPr>
+        <p:spPr>
+          <a:xfrm>
+            <a:off x="457200" y="841248"/>
+            <a:ext cx="1280160" cy="54864"/>
+          </a:xfrm>
+          <a:prstGeom prst="rect">
+            <a:avLst/>
+          </a:prstGeom>
+          <a:solidFill>
+            <a:srgbClr val="0A0A0A"/>
+          </a:solidFill>
+          <a:ln w="12700">
+            <a:solidFill>
+              <a:srgbClr val="0A0A0A"/>
+            </a:solidFill>
+            <a:prstDash val="solid"/>
+          </a:ln>
+        </p:spPr>
+      </p:sp>
+      <p:sp>
+        <p:nvSpPr>
+          <p:cNvPr id="5" name="Shape 3"/>
+          <p:cNvSpPr/>
+          <p:nvPr/>
+        </p:nvSpPr>
+        <p:spPr>
+          <a:xfrm>
+            <a:off x="507492" y="1147572"/>
+            <a:ext cx="2529840" cy="1828800"/>
+          </a:xfrm>
+          <a:prstGeom prst="rect">
+            <a:avLst/>
+          </a:prstGeom>
+          <a:solidFill>
+            <a:srgbClr val="E0E0E0"/>
+          </a:solidFill>
+          <a:ln w="12700">
+            <a:solidFill>
+              <a:srgbClr val="E0E0E0"/>
+            </a:solidFill>
+            <a:prstDash val="solid"/>
+          </a:ln>
+        </p:spPr>
+      </p:sp>
+      <p:sp>
+        <p:nvSpPr>
+          <p:cNvPr id="6" name="Shape 4"/>
+          <p:cNvSpPr/>
+          <p:nvPr/>
+        </p:nvSpPr>
+        <p:spPr>
+          <a:xfrm>
+            <a:off x="457200" y="1097280"/>
+            <a:ext cx="2529840" cy="1828800"/>
+          </a:xfrm>
+          <a:prstGeom prst="roundRect">
+            <a:avLst>
+              <a:gd name="adj" fmla="val 3000"/>
+            </a:avLst>
+          </a:prstGeom>
+          <a:solidFill>
+            <a:srgbClr val="FFFFFF"/>
+          </a:solidFill>
+          <a:ln w="19050">
+            <a:solidFill>
+              <a:srgbClr val="0A0A0A"/>
+            </a:solidFill>
+            <a:prstDash val="solid"/>
+          </a:ln>
+        </p:spPr>
+      </p:sp>
+      <p:sp>
+        <p:nvSpPr>
+          <p:cNvPr id="7" name="Shape 5"/>
+          <p:cNvSpPr/>
+          <p:nvPr/>
+        </p:nvSpPr>
+        <p:spPr>
+          <a:xfrm>
+            <a:off x="1402080" y="1280160"/>
+            <a:ext cx="640080" cy="640080"/>
+          </a:xfrm>
+          <a:prstGeom prst="ellipse">
+            <a:avLst/>
+          </a:prstGeom>
+          <a:solidFill>
+            <a:srgbClr val="0A0A0A"/>
+          </a:solidFill>
+          <a:ln/>
+        </p:spPr>
+      </p:sp>
+      <p:sp>
+        <p:nvSpPr>
+          <p:cNvPr id="8" name="Text 6"/>
+          <p:cNvSpPr/>
+          <p:nvPr/>
+        </p:nvSpPr>
+        <p:spPr>
+          <a:xfrm>
+            <a:off x="1402080" y="1353312"/>
+            <a:ext cx="640080" cy="457200"/>
+          </a:xfrm>
+          <a:prstGeom prst="rect">
+            <a:avLst/>
+          </a:prstGeom>
+          <a:noFill/>
+          <a:ln/>
+        </p:spPr>
+        <p:txBody>
+          <a:bodyPr wrap="square" lIns="0" tIns="0" rIns="0" bIns="0" rtlCol="0" anchor="ctr"/>
+          <a:lstStyle/>
+          <a:p>
+            <a:pPr algn="ctr" indent="0" marL="0">
+              <a:buNone/>
+            </a:pPr>
+            <a:r>
+              <a:rPr lang="en-US" sz="2000" b="1" dirty="0">
+                <a:solidFill>
+                  <a:srgbClr val="FFFFFF"/>
+                </a:solidFill>
+                <a:latin typeface="Arial" pitchFamily="34" charset="0"/>
+                <a:ea typeface="Arial" pitchFamily="34" charset="-122"/>
+                <a:cs typeface="Arial" pitchFamily="34" charset="-120"/>
+              </a:rPr>
+              <a:t>1</a:t>
+            </a:r>
+            <a:endParaRPr lang="en-US" sz="2000" dirty="0"/>
+          </a:p>
+        </p:txBody>
+      </p:sp>
+      <p:sp>
+        <p:nvSpPr>
+          <p:cNvPr id="9" name="Text 7"/>
+          <p:cNvSpPr/>
+          <p:nvPr/>
+        </p:nvSpPr>
+        <p:spPr>
+          <a:xfrm>
+            <a:off x="594360" y="2057400"/>
+            <a:ext cx="2255520" cy="365760"/>
+          </a:xfrm>
+          <a:prstGeom prst="rect">
+            <a:avLst/>
+          </a:prstGeom>
+          <a:noFill/>
+          <a:ln/>
+        </p:spPr>
+        <p:txBody>
+          <a:bodyPr wrap="square" lIns="0" tIns="0" rIns="0" bIns="0" rtlCol="0" anchor="ctr"/>
+          <a:lstStyle/>
+          <a:p>
+            <a:pPr algn="ctr" indent="0" marL="0">
+              <a:buNone/>
+            </a:pPr>
+            <a:r>
+              <a:rPr lang="en-US" sz="1500" b="1" dirty="0">
+                <a:solidFill>
+                  <a:srgbClr val="0A0A0A"/>
+                </a:solidFill>
+                <a:latin typeface="Arial Black" pitchFamily="34" charset="0"/>
+                <a:ea typeface="Arial Black" pitchFamily="34" charset="-122"/>
+                <a:cs typeface="Arial Black" pitchFamily="34" charset="-120"/>
+              </a:rPr>
+              <a:t>Harsh Gounder</a:t>
+            </a:r>
+            <a:endParaRPr lang="en-US" sz="1500" dirty="0"/>
+          </a:p>
+        </p:txBody>
+      </p:sp>
+      <p:sp>
+        <p:nvSpPr>
+          <p:cNvPr id="10" name="Text 8"/>
+          <p:cNvSpPr/>
+          <p:nvPr/>
+        </p:nvSpPr>
+        <p:spPr>
+          <a:xfrm>
+            <a:off x="594360" y="2423160"/>
+            <a:ext cx="2255520" cy="274320"/>
+          </a:xfrm>
+          <a:prstGeom prst="rect">
+            <a:avLst/>
+          </a:prstGeom>
+          <a:noFill/>
+          <a:ln/>
+        </p:spPr>
+        <p:txBody>
+          <a:bodyPr wrap="square" lIns="0" tIns="0" rIns="0" bIns="0" rtlCol="0" anchor="ctr"/>
+          <a:lstStyle/>
+          <a:p>
+            <a:pPr algn="ctr" indent="0" marL="0">
+              <a:buNone/>
+            </a:pPr>
+            <a:r>
+              <a:rPr lang="en-US" sz="1150" dirty="0">
+                <a:solidFill>
+                  <a:srgbClr val="6E6E6E"/>
+                </a:solidFill>
+                <a:latin typeface="Arial" pitchFamily="34" charset="0"/>
+                <a:ea typeface="Arial" pitchFamily="34" charset="-122"/>
+                <a:cs typeface="Arial" pitchFamily="34" charset="-120"/>
+              </a:rPr>
+              <a:t>Lead, E&amp;CE</a:t>
+            </a:r>
+            <a:endParaRPr lang="en-US" sz="1150" dirty="0"/>
+          </a:p>
+        </p:txBody>
+      </p:sp>
+      <p:sp>
+        <p:nvSpPr>
+          <p:cNvPr id="11" name="Text 9"/>
+          <p:cNvSpPr/>
+          <p:nvPr/>
+        </p:nvSpPr>
+        <p:spPr>
+          <a:xfrm>
+            <a:off x="594360" y="2697480"/>
+            <a:ext cx="2255520" cy="320040"/>
+          </a:xfrm>
+          <a:prstGeom prst="rect">
+            <a:avLst/>
+          </a:prstGeom>
+          <a:noFill/>
+          <a:ln/>
+        </p:spPr>
+        <p:txBody>
+          <a:bodyPr wrap="square" lIns="0" tIns="0" rIns="0" bIns="0" rtlCol="0" anchor="ctr"/>
+          <a:lstStyle/>
+          <a:p>
+            <a:pPr algn="ctr" indent="0" marL="0">
+              <a:buNone/>
+            </a:pPr>
+            <a:r>
+              <a:rPr lang="en-US" sz="950" i="1" dirty="0">
+                <a:solidFill>
+                  <a:srgbClr val="6E6E6E"/>
+                </a:solidFill>
+                <a:latin typeface="Arial" pitchFamily="34" charset="0"/>
+                <a:ea typeface="Arial" pitchFamily="34" charset="-122"/>
+                <a:cs typeface="Arial" pitchFamily="34" charset="-120"/>
+              </a:rPr>
+              <a:t>everything: architecture, code, research method, 49-report evidence wave, backend, QA, devops</a:t>
+            </a:r>
+            <a:endParaRPr lang="en-US" sz="950" dirty="0"/>
+          </a:p>
+        </p:txBody>
+      </p:sp>
+      <p:sp>
+        <p:nvSpPr>
+          <p:cNvPr id="12" name="Shape 10"/>
+          <p:cNvSpPr/>
+          <p:nvPr/>
+        </p:nvSpPr>
+        <p:spPr>
+          <a:xfrm>
+            <a:off x="3357372" y="1147572"/>
+            <a:ext cx="2529840" cy="1828800"/>
+          </a:xfrm>
+          <a:prstGeom prst="rect">
+            <a:avLst/>
+          </a:prstGeom>
+          <a:solidFill>
+            <a:srgbClr val="E0E0E0"/>
+          </a:solidFill>
+          <a:ln w="12700">
+            <a:solidFill>
+              <a:srgbClr val="E0E0E0"/>
+            </a:solidFill>
+            <a:prstDash val="solid"/>
+          </a:ln>
+        </p:spPr>
+      </p:sp>
+      <p:sp>
+        <p:nvSpPr>
+          <p:cNvPr id="13" name="Shape 11"/>
+          <p:cNvSpPr/>
+          <p:nvPr/>
+        </p:nvSpPr>
+        <p:spPr>
+          <a:xfrm>
+            <a:off x="3307080" y="1097280"/>
+            <a:ext cx="2529840" cy="1828800"/>
+          </a:xfrm>
+          <a:prstGeom prst="roundRect">
+            <a:avLst>
+              <a:gd name="adj" fmla="val 3000"/>
+            </a:avLst>
+          </a:prstGeom>
+          <a:solidFill>
+            <a:srgbClr val="FFFFFF"/>
+          </a:solidFill>
+          <a:ln w="19050">
+            <a:solidFill>
+              <a:srgbClr val="0A0A0A"/>
+            </a:solidFill>
+            <a:prstDash val="solid"/>
+          </a:ln>
+        </p:spPr>
+      </p:sp>
+      <p:sp>
+        <p:nvSpPr>
+          <p:cNvPr id="14" name="Shape 12"/>
+          <p:cNvSpPr/>
+          <p:nvPr/>
+        </p:nvSpPr>
+        <p:spPr>
+          <a:xfrm>
+            <a:off x="4251960" y="1280160"/>
+            <a:ext cx="640080" cy="640080"/>
+          </a:xfrm>
+          <a:prstGeom prst="ellipse">
+            <a:avLst/>
+          </a:prstGeom>
+          <a:solidFill>
+            <a:srgbClr val="0A0A0A"/>
+          </a:solidFill>
+          <a:ln/>
+        </p:spPr>
+      </p:sp>
+      <p:sp>
+        <p:nvSpPr>
+          <p:cNvPr id="15" name="Text 13"/>
+          <p:cNvSpPr/>
+          <p:nvPr/>
+        </p:nvSpPr>
+        <p:spPr>
+          <a:xfrm>
+            <a:off x="4251960" y="1353312"/>
+            <a:ext cx="640080" cy="457200"/>
+          </a:xfrm>
+          <a:prstGeom prst="rect">
+            <a:avLst/>
+          </a:prstGeom>
+          <a:noFill/>
+          <a:ln/>
+        </p:spPr>
+        <p:txBody>
+          <a:bodyPr wrap="square" lIns="0" tIns="0" rIns="0" bIns="0" rtlCol="0" anchor="ctr"/>
+          <a:lstStyle/>
+          <a:p>
+            <a:pPr algn="ctr" indent="0" marL="0">
+              <a:buNone/>
+            </a:pPr>
+            <a:r>
+              <a:rPr lang="en-US" sz="2000" b="1" dirty="0">
+                <a:solidFill>
+                  <a:srgbClr val="FFFFFF"/>
+                </a:solidFill>
+                <a:latin typeface="Arial" pitchFamily="34" charset="0"/>
+                <a:ea typeface="Arial" pitchFamily="34" charset="-122"/>
+                <a:cs typeface="Arial" pitchFamily="34" charset="-120"/>
+              </a:rPr>
+              <a:t>2</a:t>
+            </a:r>
+            <a:endParaRPr lang="en-US" sz="2000" dirty="0"/>
+          </a:p>
+        </p:txBody>
+      </p:sp>
+      <p:sp>
+        <p:nvSpPr>
+          <p:cNvPr id="16" name="Text 14"/>
+          <p:cNvSpPr/>
+          <p:nvPr/>
+        </p:nvSpPr>
+        <p:spPr>
+          <a:xfrm>
+            <a:off x="3444240" y="2057400"/>
+            <a:ext cx="2255520" cy="365760"/>
+          </a:xfrm>
+          <a:prstGeom prst="rect">
+            <a:avLst/>
+          </a:prstGeom>
+          <a:noFill/>
+          <a:ln/>
+        </p:spPr>
+        <p:txBody>
+          <a:bodyPr wrap="square" lIns="0" tIns="0" rIns="0" bIns="0" rtlCol="0" anchor="ctr"/>
+          <a:lstStyle/>
+          <a:p>
+            <a:pPr algn="ctr" indent="0" marL="0">
+              <a:buNone/>
+            </a:pPr>
+            <a:r>
+              <a:rPr lang="en-US" sz="1500" b="1" dirty="0">
+                <a:solidFill>
+                  <a:srgbClr val="0A0A0A"/>
+                </a:solidFill>
+                <a:latin typeface="Arial Black" pitchFamily="34" charset="0"/>
+                <a:ea typeface="Arial Black" pitchFamily="34" charset="-122"/>
+                <a:cs typeface="Arial Black" pitchFamily="34" charset="-120"/>
+              </a:rPr>
+              <a:t>Ayush Kharwar</a:t>
+            </a:r>
+            <a:endParaRPr lang="en-US" sz="1500" dirty="0"/>
+          </a:p>
+        </p:txBody>
+      </p:sp>
+      <p:sp>
+        <p:nvSpPr>
+          <p:cNvPr id="17" name="Text 15"/>
+          <p:cNvSpPr/>
+          <p:nvPr/>
+        </p:nvSpPr>
+        <p:spPr>
+          <a:xfrm>
+            <a:off x="3444240" y="2423160"/>
+            <a:ext cx="2255520" cy="274320"/>
+          </a:xfrm>
+          <a:prstGeom prst="rect">
+            <a:avLst/>
+          </a:prstGeom>
+          <a:noFill/>
+          <a:ln/>
+        </p:spPr>
+        <p:txBody>
+          <a:bodyPr wrap="square" lIns="0" tIns="0" rIns="0" bIns="0" rtlCol="0" anchor="ctr"/>
+          <a:lstStyle/>
+          <a:p>
+            <a:pPr algn="ctr" indent="0" marL="0">
+              <a:buNone/>
+            </a:pPr>
+            <a:r>
+              <a:rPr lang="en-US" sz="1150" dirty="0">
+                <a:solidFill>
+                  <a:srgbClr val="6E6E6E"/>
+                </a:solidFill>
+                <a:latin typeface="Arial" pitchFamily="34" charset="0"/>
+                <a:ea typeface="Arial" pitchFamily="34" charset="-122"/>
+                <a:cs typeface="Arial" pitchFamily="34" charset="-120"/>
+              </a:rPr>
+              <a:t>Deck and design</a:t>
+            </a:r>
+            <a:endParaRPr lang="en-US" sz="1150" dirty="0"/>
+          </a:p>
+        </p:txBody>
+      </p:sp>
+      <p:sp>
+        <p:nvSpPr>
+          <p:cNvPr id="18" name="Text 16"/>
+          <p:cNvSpPr/>
+          <p:nvPr/>
+        </p:nvSpPr>
+        <p:spPr>
+          <a:xfrm>
+            <a:off x="3444240" y="2697480"/>
+            <a:ext cx="2255520" cy="320040"/>
+          </a:xfrm>
+          <a:prstGeom prst="rect">
+            <a:avLst/>
+          </a:prstGeom>
+          <a:noFill/>
+          <a:ln/>
+        </p:spPr>
+        <p:txBody>
+          <a:bodyPr wrap="square" lIns="0" tIns="0" rIns="0" bIns="0" rtlCol="0" anchor="ctr"/>
+          <a:lstStyle/>
+          <a:p>
+            <a:pPr algn="ctr" indent="0" marL="0">
+              <a:buNone/>
+            </a:pPr>
+            <a:r>
+              <a:rPr lang="en-US" sz="950" i="1" dirty="0">
+                <a:solidFill>
+                  <a:srgbClr val="6E6E6E"/>
+                </a:solidFill>
+                <a:latin typeface="Arial" pitchFamily="34" charset="0"/>
+                <a:ea typeface="Arial" pitchFamily="34" charset="-122"/>
+                <a:cs typeface="Arial" pitchFamily="34" charset="-120"/>
+              </a:rPr>
+              <a:t>presentation build and design</a:t>
+            </a:r>
+            <a:endParaRPr lang="en-US" sz="950" dirty="0"/>
+          </a:p>
+        </p:txBody>
+      </p:sp>
+      <p:sp>
+        <p:nvSpPr>
+          <p:cNvPr id="19" name="Shape 17"/>
+          <p:cNvSpPr/>
+          <p:nvPr/>
+        </p:nvSpPr>
+        <p:spPr>
+          <a:xfrm>
+            <a:off x="6207252" y="1147572"/>
+            <a:ext cx="2529840" cy="1828800"/>
+          </a:xfrm>
+          <a:prstGeom prst="rect">
+            <a:avLst/>
+          </a:prstGeom>
+          <a:solidFill>
+            <a:srgbClr val="E0E0E0"/>
+          </a:solidFill>
+          <a:ln w="12700">
+            <a:solidFill>
+              <a:srgbClr val="E0E0E0"/>
+            </a:solidFill>
+            <a:prstDash val="solid"/>
+          </a:ln>
+        </p:spPr>
+      </p:sp>
+      <p:sp>
+        <p:nvSpPr>
+          <p:cNvPr id="20" name="Shape 18"/>
+          <p:cNvSpPr/>
+          <p:nvPr/>
+        </p:nvSpPr>
+        <p:spPr>
+          <a:xfrm>
+            <a:off x="6156960" y="1097280"/>
+            <a:ext cx="2529840" cy="1828800"/>
+          </a:xfrm>
+          <a:prstGeom prst="roundRect">
+            <a:avLst>
+              <a:gd name="adj" fmla="val 3000"/>
+            </a:avLst>
+          </a:prstGeom>
+          <a:solidFill>
+            <a:srgbClr val="FFFFFF"/>
+          </a:solidFill>
+          <a:ln w="19050">
+            <a:solidFill>
+              <a:srgbClr val="0A0A0A"/>
+            </a:solidFill>
+            <a:prstDash val="solid"/>
+          </a:ln>
+        </p:spPr>
+      </p:sp>
+      <p:sp>
+        <p:nvSpPr>
+          <p:cNvPr id="21" name="Shape 19"/>
+          <p:cNvSpPr/>
+          <p:nvPr/>
+        </p:nvSpPr>
+        <p:spPr>
+          <a:xfrm>
+            <a:off x="7101840" y="1280160"/>
+            <a:ext cx="640080" cy="640080"/>
+          </a:xfrm>
+          <a:prstGeom prst="ellipse">
+            <a:avLst/>
+          </a:prstGeom>
+          <a:solidFill>
+            <a:srgbClr val="0A0A0A"/>
+          </a:solidFill>
+          <a:ln/>
+        </p:spPr>
+      </p:sp>
+      <p:sp>
+        <p:nvSpPr>
+          <p:cNvPr id="22" name="Text 20"/>
+          <p:cNvSpPr/>
+          <p:nvPr/>
+        </p:nvSpPr>
+        <p:spPr>
+          <a:xfrm>
+            <a:off x="7101840" y="1353312"/>
+            <a:ext cx="640080" cy="457200"/>
+          </a:xfrm>
+          <a:prstGeom prst="rect">
+            <a:avLst/>
+          </a:prstGeom>
+          <a:noFill/>
+          <a:ln/>
+        </p:spPr>
+        <p:txBody>
+          <a:bodyPr wrap="square" lIns="0" tIns="0" rIns="0" bIns="0" rtlCol="0" anchor="ctr"/>
+          <a:lstStyle/>
+          <a:p>
+            <a:pPr algn="ctr" indent="0" marL="0">
+              <a:buNone/>
+            </a:pPr>
+            <a:r>
+              <a:rPr lang="en-US" sz="2000" b="1" dirty="0">
+                <a:solidFill>
+                  <a:srgbClr val="FFFFFF"/>
+                </a:solidFill>
+                <a:latin typeface="Arial" pitchFamily="34" charset="0"/>
+                <a:ea typeface="Arial" pitchFamily="34" charset="-122"/>
+                <a:cs typeface="Arial" pitchFamily="34" charset="-120"/>
+              </a:rPr>
+              <a:t>3</a:t>
+            </a:r>
+            <a:endParaRPr lang="en-US" sz="2000" dirty="0"/>
+          </a:p>
+        </p:txBody>
+      </p:sp>
+      <p:sp>
+        <p:nvSpPr>
+          <p:cNvPr id="23" name="Text 21"/>
+          <p:cNvSpPr/>
+          <p:nvPr/>
+        </p:nvSpPr>
+        <p:spPr>
+          <a:xfrm>
+            <a:off x="6294120" y="2057400"/>
+            <a:ext cx="2255520" cy="365760"/>
+          </a:xfrm>
+          <a:prstGeom prst="rect">
+            <a:avLst/>
+          </a:prstGeom>
+          <a:noFill/>
+          <a:ln/>
+        </p:spPr>
+        <p:txBody>
+          <a:bodyPr wrap="square" lIns="0" tIns="0" rIns="0" bIns="0" rtlCol="0" anchor="ctr"/>
+          <a:lstStyle/>
+          <a:p>
+            <a:pPr algn="ctr" indent="0" marL="0">
+              <a:buNone/>
+            </a:pPr>
+            <a:r>
+              <a:rPr lang="en-US" sz="1500" b="1" dirty="0">
+                <a:solidFill>
+                  <a:srgbClr val="0A0A0A"/>
+                </a:solidFill>
+                <a:latin typeface="Arial Black" pitchFamily="34" charset="0"/>
+                <a:ea typeface="Arial Black" pitchFamily="34" charset="-122"/>
+                <a:cs typeface="Arial Black" pitchFamily="34" charset="-120"/>
+              </a:rPr>
+              <a:t>Sujal Shukla</a:t>
+            </a:r>
+            <a:endParaRPr lang="en-US" sz="1500" dirty="0"/>
+          </a:p>
+        </p:txBody>
+      </p:sp>
+      <p:sp>
+        <p:nvSpPr>
+          <p:cNvPr id="24" name="Text 22"/>
+          <p:cNvSpPr/>
+          <p:nvPr/>
+        </p:nvSpPr>
+        <p:spPr>
+          <a:xfrm>
+            <a:off x="6294120" y="2423160"/>
+            <a:ext cx="2255520" cy="274320"/>
+          </a:xfrm>
+          <a:prstGeom prst="rect">
+            <a:avLst/>
+          </a:prstGeom>
+          <a:noFill/>
+          <a:ln/>
+        </p:spPr>
+        <p:txBody>
+          <a:bodyPr wrap="square" lIns="0" tIns="0" rIns="0" bIns="0" rtlCol="0" anchor="ctr"/>
+          <a:lstStyle/>
+          <a:p>
+            <a:pPr algn="ctr" indent="0" marL="0">
+              <a:buNone/>
+            </a:pPr>
+            <a:r>
+              <a:rPr lang="en-US" sz="1150" dirty="0">
+                <a:solidFill>
+                  <a:srgbClr val="6E6E6E"/>
+                </a:solidFill>
+                <a:latin typeface="Arial" pitchFamily="34" charset="0"/>
+                <a:ea typeface="Arial" pitchFamily="34" charset="-122"/>
+                <a:cs typeface="Arial" pitchFamily="34" charset="-120"/>
+              </a:rPr>
+              <a:t>Deck design</a:t>
+            </a:r>
+            <a:endParaRPr lang="en-US" sz="1150" dirty="0"/>
+          </a:p>
+        </p:txBody>
+      </p:sp>
+      <p:sp>
+        <p:nvSpPr>
+          <p:cNvPr id="25" name="Text 23"/>
+          <p:cNvSpPr/>
+          <p:nvPr/>
+        </p:nvSpPr>
+        <p:spPr>
+          <a:xfrm>
+            <a:off x="6294120" y="2697480"/>
+            <a:ext cx="2255520" cy="320040"/>
+          </a:xfrm>
+          <a:prstGeom prst="rect">
+            <a:avLst/>
+          </a:prstGeom>
+          <a:noFill/>
+          <a:ln/>
+        </p:spPr>
+        <p:txBody>
+          <a:bodyPr wrap="square" lIns="0" tIns="0" rIns="0" bIns="0" rtlCol="0" anchor="ctr"/>
+          <a:lstStyle/>
+          <a:p>
+            <a:pPr algn="ctr" indent="0" marL="0">
+              <a:buNone/>
+            </a:pPr>
+            <a:r>
+              <a:rPr lang="en-US" sz="950" i="1" dirty="0">
+                <a:solidFill>
+                  <a:srgbClr val="6E6E6E"/>
+                </a:solidFill>
+                <a:latin typeface="Arial" pitchFamily="34" charset="0"/>
+                <a:ea typeface="Arial" pitchFamily="34" charset="-122"/>
+                <a:cs typeface="Arial" pitchFamily="34" charset="-120"/>
+              </a:rPr>
+              <a:t>design assistance on the presentation</a:t>
+            </a:r>
+            <a:endParaRPr lang="en-US" sz="950" dirty="0"/>
+          </a:p>
+        </p:txBody>
+      </p:sp>
+      <p:sp>
+        <p:nvSpPr>
+          <p:cNvPr id="26" name="Text 24"/>
+          <p:cNvSpPr/>
+          <p:nvPr/>
+        </p:nvSpPr>
+        <p:spPr>
+          <a:xfrm>
+            <a:off x="457200" y="3383280"/>
+            <a:ext cx="8229600" cy="457200"/>
+          </a:xfrm>
+          <a:prstGeom prst="rect">
+            <a:avLst/>
+          </a:prstGeom>
+          <a:noFill/>
+          <a:ln/>
+        </p:spPr>
+        <p:txBody>
+          <a:bodyPr wrap="square" lIns="0" tIns="0" rIns="0" bIns="0" rtlCol="0" anchor="ctr"/>
+          <a:lstStyle/>
+          <a:p>
+            <a:pPr indent="0" marL="0">
+              <a:buNone/>
+            </a:pPr>
+            <a:r>
+              <a:rPr lang="en-US" sz="1300" b="1" dirty="0">
+                <a:solidFill>
+                  <a:srgbClr val="0A0A0A"/>
+                </a:solidFill>
+                <a:latin typeface="Arial Black" pitchFamily="34" charset="0"/>
+                <a:ea typeface="Arial Black" pitchFamily="34" charset="-122"/>
+                <a:cs typeface="Arial Black" pitchFamily="34" charset="-120"/>
+              </a:rPr>
+              <a:t>Already shipped: a verified governed pipeline (85/85 suites), honest outcome badges, and a statement-faithful research method with every claim sourced.</a:t>
+            </a:r>
+            <a:endParaRPr lang="en-US" sz="1300" dirty="0"/>
+          </a:p>
+        </p:txBody>
+      </p:sp>
+      <p:sp>
+        <p:nvSpPr>
+          <p:cNvPr id="27" name="Text 25"/>
+          <p:cNvSpPr/>
+          <p:nvPr/>
+        </p:nvSpPr>
+        <p:spPr>
+          <a:xfrm>
+            <a:off x="457200" y="4828032"/>
+            <a:ext cx="8229600" cy="274320"/>
+          </a:xfrm>
+          <a:prstGeom prst="rect">
+            <a:avLst/>
+          </a:prstGeom>
+          <a:noFill/>
+          <a:ln/>
+        </p:spPr>
+        <p:txBody>
+          <a:bodyPr wrap="square" lIns="0" tIns="0" rIns="0" bIns="0" rtlCol="0" anchor="ctr"/>
+          <a:lstStyle/>
+          <a:p>
+            <a:pPr indent="0" marL="0">
+              <a:buNone/>
+            </a:pPr>
+            <a:r>
+              <a:rPr lang="en-US" sz="850" dirty="0">
+                <a:solidFill>
+                  <a:srgbClr val="6E6E6E"/>
+                </a:solidFill>
+                <a:latin typeface="Arial" pitchFamily="34" charset="0"/>
+                <a:ea typeface="Arial" pitchFamily="34" charset="-122"/>
+                <a:cs typeface="Arial" pitchFamily="34" charset="-120"/>
+              </a:rPr>
+              <a:t>E&amp;CE research profile matches the statement core: sensors, communications, ML, power resilience.</a:t>
+            </a:r>
+            <a:endParaRPr lang="en-US" sz="850" dirty="0"/>
+          </a:p>
+        </p:txBody>
+      </p:sp>
+    </p:spTree>
+  </p:cSld>
+  <p:clrMapOvr>
+    <a:masterClrMapping/>
+  </p:clrMapOvr>
+</p:sld>
+</file>
+
+<file path=ppt/slides/slide13.xml><?xml version="1.0" encoding="utf-8"?>
+<p:sld xmlns:a="http://schemas.openxmlformats.org/drawingml/2006/main" xmlns:r="http://schemas.openxmlformats.org/officeDocument/2006/relationships" xmlns:p="http://schemas.openxmlformats.org/presentationml/2006/main">
+  <p:cSld name="Slide 13">
     <p:bg>
       <p:bgPr>
         <a:solidFill>
@@ -11787,7 +12678,7 @@
     <p:bg>
       <p:bgPr>
         <a:solidFill>
-          <a:srgbClr val="FFFFFF"/>
+          <a:srgbClr val="0A0A0A"/>
         </a:solidFill>
       </p:bgPr>
     </p:bg>
@@ -11832,13 +12723,13 @@
             <a:r>
               <a:rPr lang="en-US" sz="2800" b="1" dirty="0">
                 <a:solidFill>
-                  <a:srgbClr val="E0E0E0"/>
+                  <a:srgbClr val="2A2A2A"/>
                 </a:solidFill>
                 <a:latin typeface="Arial Black" pitchFamily="34" charset="0"/>
                 <a:ea typeface="Arial Black" pitchFamily="34" charset="-122"/>
                 <a:cs typeface="Arial Black" pitchFamily="34" charset="-120"/>
               </a:rPr>
-              <a:t>Three buyers, one verified loop</a:t>
+              <a:t>The counterfactual: what this changes in a real event</a:t>
             </a:r>
             <a:endParaRPr lang="en-US" sz="2800" dirty="0"/>
           </a:p>
@@ -11860,13 +12751,6 @@
           </a:prstGeom>
           <a:noFill/>
           <a:ln/>
-          <a:effectLst>
-            <a:outerShdw sx="100000" sy="100000" kx="0" ky="0" algn="bl" rotWithShape="0" blurRad="101600" dist="38100" dir="2700000">
-              <a:srgbClr val="000000">
-                <a:alpha val="25000"/>
-              </a:srgbClr>
-            </a:outerShdw>
-          </a:effectLst>
         </p:spPr>
         <p:txBody>
           <a:bodyPr wrap="square" lIns="0" tIns="0" rIns="0" bIns="0" rtlCol="0" anchor="ctr"/>
@@ -11878,13 +12762,13 @@
             <a:r>
               <a:rPr lang="en-US" sz="2800" b="1" dirty="0">
                 <a:solidFill>
-                  <a:srgbClr val="0A0A0A"/>
+                  <a:srgbClr val="FFFFFF"/>
                 </a:solidFill>
                 <a:latin typeface="Arial Black" pitchFamily="34" charset="0"/>
                 <a:ea typeface="Arial Black" pitchFamily="34" charset="-122"/>
                 <a:cs typeface="Arial Black" pitchFamily="34" charset="-120"/>
               </a:rPr>
-              <a:t>Three buyers, one verified loop</a:t>
+              <a:t>The counterfactual: what this changes in a real event</a:t>
             </a:r>
             <a:endParaRPr lang="en-US" sz="2800" dirty="0"/>
           </a:p>
@@ -11898,18 +12782,18 @@
         </p:nvSpPr>
         <p:spPr>
           <a:xfrm>
-            <a:off x="457200" y="841248"/>
+            <a:off x="457200" y="896112"/>
             <a:ext cx="1280160" cy="54864"/>
           </a:xfrm>
           <a:prstGeom prst="rect">
             <a:avLst/>
           </a:prstGeom>
           <a:solidFill>
-            <a:srgbClr val="0A0A0A"/>
+            <a:srgbClr val="FF5A1F"/>
           </a:solidFill>
           <a:ln w="12700">
             <a:solidFill>
-              <a:srgbClr val="0A0A0A"/>
+              <a:srgbClr val="FF5A1F"/>
             </a:solidFill>
             <a:prstDash val="solid"/>
           </a:ln>
@@ -11917,24 +12801,63 @@
       </p:sp>
       <p:sp>
         <p:nvSpPr>
-          <p:cNvPr id="5" name="Shape 3"/>
-          <p:cNvSpPr/>
-          <p:nvPr/>
-        </p:nvSpPr>
-        <p:spPr>
-          <a:xfrm>
-            <a:off x="507492" y="1284732"/>
-            <a:ext cx="2529840" cy="2286000"/>
-          </a:xfrm>
-          <a:prstGeom prst="rect">
-            <a:avLst/>
-          </a:prstGeom>
-          <a:solidFill>
-            <a:srgbClr val="E0E0E0"/>
+          <p:cNvPr id="5" name="Text 3"/>
+          <p:cNvSpPr/>
+          <p:nvPr/>
+        </p:nvSpPr>
+        <p:spPr>
+          <a:xfrm>
+            <a:off x="457200" y="960120"/>
+            <a:ext cx="8229600" cy="548640"/>
+          </a:xfrm>
+          <a:prstGeom prst="rect">
+            <a:avLst/>
+          </a:prstGeom>
+          <a:noFill/>
+          <a:ln/>
+        </p:spPr>
+        <p:txBody>
+          <a:bodyPr wrap="square" lIns="0" tIns="0" rIns="0" bIns="0" rtlCol="0" anchor="ctr"/>
+          <a:lstStyle/>
+          <a:p>
+            <a:pPr indent="0" marL="0">
+              <a:buNone/>
+            </a:pPr>
+            <a:r>
+              <a:rPr lang="en-US" sz="1150" dirty="0">
+                <a:solidFill>
+                  <a:srgbClr val="B0B0B0"/>
+                </a:solidFill>
+                <a:latin typeface="Arial" pitchFamily="34" charset="0"/>
+                <a:ea typeface="Arial" pitchFamily="34" charset="-122"/>
+                <a:cs typeface="Arial" pitchFamily="34" charset="-120"/>
+              </a:rPr>
+              <a:t>We took the real incidents from the ledgers, ran the engine backward over their actual timelines, and compared the decision output to what the ground truth records. No prevented-loss claim is made: the numbers are the events as they happened.</a:t>
+            </a:r>
+            <a:endParaRPr lang="en-US" sz="1150" dirty="0"/>
+          </a:p>
+        </p:txBody>
+      </p:sp>
+      <p:sp>
+        <p:nvSpPr>
+          <p:cNvPr id="6" name="Shape 4"/>
+          <p:cNvSpPr/>
+          <p:nvPr/>
+        </p:nvSpPr>
+        <p:spPr>
+          <a:xfrm>
+            <a:off x="507492" y="1696212"/>
+            <a:ext cx="4069080" cy="1280160"/>
+          </a:xfrm>
+          <a:prstGeom prst="rect">
+            <a:avLst/>
+          </a:prstGeom>
+          <a:solidFill>
+            <a:srgbClr val="2A2A2A"/>
           </a:solidFill>
           <a:ln w="12700">
             <a:solidFill>
-              <a:srgbClr val="E0E0E0"/>
+              <a:srgbClr val="2A2A2A"/>
             </a:solidFill>
             <a:prstDash val="solid"/>
           </a:ln>
@@ -11942,14 +12865,14 @@
       </p:sp>
       <p:sp>
         <p:nvSpPr>
-          <p:cNvPr id="6" name="Shape 4"/>
-          <p:cNvSpPr/>
-          <p:nvPr/>
-        </p:nvSpPr>
-        <p:spPr>
-          <a:xfrm>
-            <a:off x="2968752" y="1307592"/>
-            <a:ext cx="82296" cy="2139696"/>
+          <p:cNvPr id="7" name="Shape 5"/>
+          <p:cNvSpPr/>
+          <p:nvPr/>
+        </p:nvSpPr>
+        <p:spPr>
+          <a:xfrm>
+            <a:off x="4507992" y="1719072"/>
+            <a:ext cx="82296" cy="1133856"/>
           </a:xfrm>
           <a:prstGeom prst="parallelogram">
             <a:avLst/>
@@ -11967,26 +12890,26 @@
       </p:sp>
       <p:sp>
         <p:nvSpPr>
-          <p:cNvPr id="7" name="Shape 5"/>
+          <p:cNvPr id="8" name="Shape 6"/>
           <p:cNvSpPr/>
           <p:nvPr/>
         </p:nvSpPr>
         <p:spPr>
           <a:xfrm rot="-90000">
-            <a:off x="457200" y="1234440"/>
-            <a:ext cx="2529840" cy="2286000"/>
+            <a:off x="457200" y="1645920"/>
+            <a:ext cx="4069080" cy="1280160"/>
           </a:xfrm>
           <a:prstGeom prst="roundRect">
             <a:avLst>
-              <a:gd name="adj" fmla="val 2400"/>
+              <a:gd name="adj" fmla="val 4286"/>
             </a:avLst>
           </a:prstGeom>
           <a:solidFill>
-            <a:srgbClr val="0A0A0A"/>
+            <a:srgbClr val="161616"/>
           </a:solidFill>
           <a:ln w="12700">
             <a:solidFill>
-              <a:srgbClr val="FFFFFF"/>
+              <a:srgbClr val="2A2A2A"/>
             </a:solidFill>
             <a:prstDash val="solid"/>
           </a:ln>
@@ -11994,14 +12917,14 @@
       </p:sp>
       <p:sp>
         <p:nvSpPr>
-          <p:cNvPr id="8" name="Text 6"/>
-          <p:cNvSpPr/>
-          <p:nvPr/>
-        </p:nvSpPr>
-        <p:spPr>
-          <a:xfrm>
-            <a:off x="640080" y="1417320"/>
-            <a:ext cx="2164080" cy="365760"/>
+          <p:cNvPr id="9" name="Text 7"/>
+          <p:cNvSpPr/>
+          <p:nvPr/>
+        </p:nvSpPr>
+        <p:spPr>
+          <a:xfrm>
+            <a:off x="640080" y="1737360"/>
+            <a:ext cx="3703320" cy="320040"/>
           </a:xfrm>
           <a:prstGeom prst="rect">
             <a:avLst/>
@@ -12017,7 +12940,7 @@
               <a:buNone/>
             </a:pPr>
             <a:r>
-              <a:rPr lang="en-US" sz="1600" b="1" dirty="0">
+              <a:rPr lang="en-US" sz="1500" b="1" dirty="0">
                 <a:solidFill>
                   <a:srgbClr val="FFFFFF"/>
                 </a:solidFill>
@@ -12025,22 +12948,22 @@
                 <a:ea typeface="Arial Black" pitchFamily="34" charset="-122"/>
                 <a:cs typeface="Arial Black" pitchFamily="34" charset="-120"/>
               </a:rPr>
-              <a:t>FPO + extension</a:t>
-            </a:r>
-            <a:endParaRPr lang="en-US" sz="1600" dirty="0"/>
-          </a:p>
-        </p:txBody>
-      </p:sp>
-      <p:sp>
-        <p:nvSpPr>
-          <p:cNvPr id="9" name="Text 7"/>
-          <p:cNvSpPr/>
-          <p:nvPr/>
-        </p:nvSpPr>
-        <p:spPr>
-          <a:xfrm>
-            <a:off x="640080" y="1920240"/>
-            <a:ext cx="2164080" cy="914400"/>
+              <a:t>FANI 2019</a:t>
+            </a:r>
+            <a:endParaRPr lang="en-US" sz="1500" dirty="0"/>
+          </a:p>
+        </p:txBody>
+      </p:sp>
+      <p:sp>
+        <p:nvSpPr>
+          <p:cNvPr id="10" name="Text 8"/>
+          <p:cNvSpPr/>
+          <p:nvPr/>
+        </p:nvSpPr>
+        <p:spPr>
+          <a:xfrm>
+            <a:off x="640080" y="2084832"/>
+            <a:ext cx="3703320" cy="777240"/>
           </a:xfrm>
           <a:prstGeom prst="rect">
             <a:avLst/>
@@ -12056,7 +12979,7 @@
               <a:buNone/>
             </a:pPr>
             <a:r>
-              <a:rPr lang="en-US" sz="1150" dirty="0">
+              <a:rPr lang="en-US" sz="800" dirty="0">
                 <a:solidFill>
                   <a:srgbClr val="B0B0B0"/>
                 </a:solidFill>
@@ -12064,22 +12987,22 @@
                 <a:ea typeface="Arial" pitchFamily="34" charset="-122"/>
                 <a:cs typeface="Arial" pitchFamily="34" charset="-120"/>
               </a:rPr>
-              <a:t>seasonal advisory subscriptions per farmer via FPOs and KVK extension workers</a:t>
-            </a:r>
-            <a:endParaRPr lang="en-US" sz="1150" dirty="0"/>
-          </a:p>
-        </p:txBody>
-      </p:sp>
-      <p:sp>
-        <p:nvSpPr>
-          <p:cNvPr id="10" name="Text 8"/>
-          <p:cNvSpPr/>
-          <p:nvPr/>
-        </p:nvSpPr>
-        <p:spPr>
-          <a:xfrm>
-            <a:off x="640080" y="2971800"/>
-            <a:ext cx="2164080" cy="457200"/>
+              <a:t>108,220 ha crop loss, Rs 1,304.58 cr (OSDMA DLNA). Official lead: watch 90h, alert 66h, warning 36h. The engine at T-24 issues a stage-specific action with deadline and cost of waiting for every notified plot. The replay posterior band contains the real anchor.</a:t>
+            </a:r>
+            <a:endParaRPr lang="en-US" sz="800" dirty="0"/>
+          </a:p>
+        </p:txBody>
+      </p:sp>
+      <p:sp>
+        <p:nvSpPr>
+          <p:cNvPr id="11" name="Text 9"/>
+          <p:cNvSpPr/>
+          <p:nvPr/>
+        </p:nvSpPr>
+        <p:spPr>
+          <a:xfrm>
+            <a:off x="640080" y="2761488"/>
+            <a:ext cx="3703320" cy="137160"/>
           </a:xfrm>
           <a:prstGeom prst="rect">
             <a:avLst/>
@@ -12095,7 +13018,7 @@
               <a:buNone/>
             </a:pPr>
             <a:r>
-              <a:rPr lang="en-US" sz="1000" i="1" dirty="0">
+              <a:rPr lang="en-US" sz="650" dirty="0">
                 <a:solidFill>
                   <a:srgbClr val="8A8A8A"/>
                 </a:solidFill>
@@ -12103,32 +13026,32 @@
                 <a:ea typeface="Arial" pitchFamily="34" charset="-122"/>
                 <a:cs typeface="Arial" pitchFamily="34" charset="-120"/>
               </a:rPr>
-              <a:t>pay per verified advisory delivered and acted on</a:t>
-            </a:r>
-            <a:endParaRPr lang="en-US" sz="1000" dirty="0"/>
-          </a:p>
-        </p:txBody>
-      </p:sp>
-      <p:sp>
-        <p:nvSpPr>
-          <p:cNvPr id="11" name="Shape 9"/>
-          <p:cNvSpPr/>
-          <p:nvPr/>
-        </p:nvSpPr>
-        <p:spPr>
-          <a:xfrm>
-            <a:off x="3357372" y="1284732"/>
-            <a:ext cx="2529840" cy="2286000"/>
-          </a:xfrm>
-          <a:prstGeom prst="rect">
-            <a:avLst/>
-          </a:prstGeom>
-          <a:solidFill>
-            <a:srgbClr val="E0E0E0"/>
+              <a:t>sources: d21, d47, d12</a:t>
+            </a:r>
+            <a:endParaRPr lang="en-US" sz="650" dirty="0"/>
+          </a:p>
+        </p:txBody>
+      </p:sp>
+      <p:sp>
+        <p:nvSpPr>
+          <p:cNvPr id="12" name="Shape 10"/>
+          <p:cNvSpPr/>
+          <p:nvPr/>
+        </p:nvSpPr>
+        <p:spPr>
+          <a:xfrm>
+            <a:off x="4668012" y="1696212"/>
+            <a:ext cx="4069080" cy="1280160"/>
+          </a:xfrm>
+          <a:prstGeom prst="rect">
+            <a:avLst/>
+          </a:prstGeom>
+          <a:solidFill>
+            <a:srgbClr val="2A2A2A"/>
           </a:solidFill>
           <a:ln w="12700">
             <a:solidFill>
-              <a:srgbClr val="E0E0E0"/>
+              <a:srgbClr val="2A2A2A"/>
             </a:solidFill>
             <a:prstDash val="solid"/>
           </a:ln>
@@ -12136,14 +13059,14 @@
       </p:sp>
       <p:sp>
         <p:nvSpPr>
-          <p:cNvPr id="12" name="Shape 10"/>
-          <p:cNvSpPr/>
-          <p:nvPr/>
-        </p:nvSpPr>
-        <p:spPr>
-          <a:xfrm>
-            <a:off x="5818632" y="1307592"/>
-            <a:ext cx="82296" cy="2139696"/>
+          <p:cNvPr id="13" name="Shape 11"/>
+          <p:cNvSpPr/>
+          <p:nvPr/>
+        </p:nvSpPr>
+        <p:spPr>
+          <a:xfrm>
+            <a:off x="8668512" y="1719072"/>
+            <a:ext cx="82296" cy="1133856"/>
           </a:xfrm>
           <a:prstGeom prst="parallelogram">
             <a:avLst/>
@@ -12161,26 +13084,26 @@
       </p:sp>
       <p:sp>
         <p:nvSpPr>
-          <p:cNvPr id="13" name="Shape 11"/>
+          <p:cNvPr id="14" name="Shape 12"/>
           <p:cNvSpPr/>
           <p:nvPr/>
         </p:nvSpPr>
         <p:spPr>
           <a:xfrm rot="-90000">
-            <a:off x="3307080" y="1234440"/>
-            <a:ext cx="2529840" cy="2286000"/>
+            <a:off x="4617720" y="1645920"/>
+            <a:ext cx="4069080" cy="1280160"/>
           </a:xfrm>
           <a:prstGeom prst="roundRect">
             <a:avLst>
-              <a:gd name="adj" fmla="val 2400"/>
+              <a:gd name="adj" fmla="val 4286"/>
             </a:avLst>
           </a:prstGeom>
           <a:solidFill>
-            <a:srgbClr val="0A0A0A"/>
+            <a:srgbClr val="161616"/>
           </a:solidFill>
           <a:ln w="12700">
             <a:solidFill>
-              <a:srgbClr val="FFFFFF"/>
+              <a:srgbClr val="2A2A2A"/>
             </a:solidFill>
             <a:prstDash val="solid"/>
           </a:ln>
@@ -12188,14 +13111,14 @@
       </p:sp>
       <p:sp>
         <p:nvSpPr>
-          <p:cNvPr id="14" name="Text 12"/>
-          <p:cNvSpPr/>
-          <p:nvPr/>
-        </p:nvSpPr>
-        <p:spPr>
-          <a:xfrm>
-            <a:off x="3489960" y="1417320"/>
-            <a:ext cx="2164080" cy="365760"/>
+          <p:cNvPr id="15" name="Text 13"/>
+          <p:cNvSpPr/>
+          <p:nvPr/>
+        </p:nvSpPr>
+        <p:spPr>
+          <a:xfrm>
+            <a:off x="4800600" y="1737360"/>
+            <a:ext cx="3703320" cy="320040"/>
           </a:xfrm>
           <a:prstGeom prst="rect">
             <a:avLst/>
@@ -12211,7 +13134,7 @@
               <a:buNone/>
             </a:pPr>
             <a:r>
-              <a:rPr lang="en-US" sz="1600" b="1" dirty="0">
+              <a:rPr lang="en-US" sz="1500" b="1" dirty="0">
                 <a:solidFill>
                   <a:srgbClr val="FFFFFF"/>
                 </a:solidFill>
@@ -12219,22 +13142,22 @@
                 <a:ea typeface="Arial Black" pitchFamily="34" charset="-122"/>
                 <a:cs typeface="Arial Black" pitchFamily="34" charset="-120"/>
               </a:rPr>
-              <a:t>B2G district</a:t>
-            </a:r>
-            <a:endParaRPr lang="en-US" sz="1600" dirty="0"/>
-          </a:p>
-        </p:txBody>
-      </p:sp>
-      <p:sp>
-        <p:nvSpPr>
-          <p:cNvPr id="15" name="Text 13"/>
-          <p:cNvSpPr/>
-          <p:nvPr/>
-        </p:nvSpPr>
-        <p:spPr>
-          <a:xfrm>
-            <a:off x="3489960" y="1920240"/>
-            <a:ext cx="2164080" cy="914400"/>
+              <a:t>YAAS 2021</a:t>
+            </a:r>
+            <a:endParaRPr lang="en-US" sz="1500" dirty="0"/>
+          </a:p>
+        </p:txBody>
+      </p:sp>
+      <p:sp>
+        <p:nvSpPr>
+          <p:cNvPr id="16" name="Text 14"/>
+          <p:cNvSpPr/>
+          <p:nvPr/>
+        </p:nvSpPr>
+        <p:spPr>
+          <a:xfrm>
+            <a:off x="4800600" y="2084832"/>
+            <a:ext cx="3703320" cy="777240"/>
           </a:xfrm>
           <a:prstGeom prst="rect">
             <a:avLst/>
@@ -12250,7 +13173,7 @@
               <a:buNone/>
             </a:pPr>
             <a:r>
-              <a:rPr lang="en-US" sz="1150" dirty="0">
+              <a:rPr lang="en-US" sz="800" dirty="0">
                 <a:solidFill>
                   <a:srgbClr val="B0B0B0"/>
                 </a:solidFill>
@@ -12258,22 +13181,22 @@
                 <a:ea typeface="Arial" pitchFamily="34" charset="-122"/>
                 <a:cs typeface="Arial" pitchFamily="34" charset="-120"/>
               </a:rPr>
-              <a:t>Odisha agriculture department and OSDMA, per-block deployment</a:t>
-            </a:r>
-            <a:endParaRPr lang="en-US" sz="1150" dirty="0"/>
-          </a:p>
-        </p:txBody>
-      </p:sp>
-      <p:sp>
-        <p:nvSpPr>
-          <p:cNvPr id="16" name="Text 14"/>
-          <p:cNvSpPr/>
-          <p:nvPr/>
-        </p:nvSpPr>
-        <p:spPr>
-          <a:xfrm>
-            <a:off x="3489960" y="2971800"/>
-            <a:ext cx="2164080" cy="457200"/>
+              <a:t>5,882 ha salt-affected across 5 Balasore blocks. Surge 2-4 m over a full-moon tide. The engine's advisory at T-48: move seed above the forecast water line, brace or cut banana, photo standing crop for the claim. Recovery phase then plans saline flush and next-season variety.</a:t>
+            </a:r>
+            <a:endParaRPr lang="en-US" sz="800" dirty="0"/>
+          </a:p>
+        </p:txBody>
+      </p:sp>
+      <p:sp>
+        <p:nvSpPr>
+          <p:cNvPr id="17" name="Text 15"/>
+          <p:cNvSpPr/>
+          <p:nvPr/>
+        </p:nvSpPr>
+        <p:spPr>
+          <a:xfrm>
+            <a:off x="4800600" y="2761488"/>
+            <a:ext cx="3703320" cy="137160"/>
           </a:xfrm>
           <a:prstGeom prst="rect">
             <a:avLst/>
@@ -12289,7 +13212,7 @@
               <a:buNone/>
             </a:pPr>
             <a:r>
-              <a:rPr lang="en-US" sz="1000" i="1" dirty="0">
+              <a:rPr lang="en-US" sz="650" dirty="0">
                 <a:solidFill>
                   <a:srgbClr val="8A8A8A"/>
                 </a:solidFill>
@@ -12297,32 +13220,32 @@
                 <a:ea typeface="Arial" pitchFamily="34" charset="-122"/>
                 <a:cs typeface="Arial" pitchFamily="34" charset="-120"/>
               </a:rPr>
-              <a:t>reduces call volume, gives auditable outreach evidence</a:t>
-            </a:r>
-            <a:endParaRPr lang="en-US" sz="1000" dirty="0"/>
-          </a:p>
-        </p:txBody>
-      </p:sp>
-      <p:sp>
-        <p:nvSpPr>
-          <p:cNvPr id="17" name="Shape 15"/>
-          <p:cNvSpPr/>
-          <p:nvPr/>
-        </p:nvSpPr>
-        <p:spPr>
-          <a:xfrm>
-            <a:off x="6207252" y="1284732"/>
-            <a:ext cx="2529840" cy="2286000"/>
-          </a:xfrm>
-          <a:prstGeom prst="rect">
-            <a:avLst/>
-          </a:prstGeom>
-          <a:solidFill>
-            <a:srgbClr val="E0E0E0"/>
+              <a:t>sources: d22, d47</a:t>
+            </a:r>
+            <a:endParaRPr lang="en-US" sz="650" dirty="0"/>
+          </a:p>
+        </p:txBody>
+      </p:sp>
+      <p:sp>
+        <p:nvSpPr>
+          <p:cNvPr id="18" name="Shape 16"/>
+          <p:cNvSpPr/>
+          <p:nvPr/>
+        </p:nvSpPr>
+        <p:spPr>
+          <a:xfrm>
+            <a:off x="507492" y="3067812"/>
+            <a:ext cx="4069080" cy="1280160"/>
+          </a:xfrm>
+          <a:prstGeom prst="rect">
+            <a:avLst/>
+          </a:prstGeom>
+          <a:solidFill>
+            <a:srgbClr val="2A2A2A"/>
           </a:solidFill>
           <a:ln w="12700">
             <a:solidFill>
-              <a:srgbClr val="E0E0E0"/>
+              <a:srgbClr val="2A2A2A"/>
             </a:solidFill>
             <a:prstDash val="solid"/>
           </a:ln>
@@ -12330,14 +13253,14 @@
       </p:sp>
       <p:sp>
         <p:nvSpPr>
-          <p:cNvPr id="18" name="Shape 16"/>
-          <p:cNvSpPr/>
-          <p:nvPr/>
-        </p:nvSpPr>
-        <p:spPr>
-          <a:xfrm>
-            <a:off x="8668512" y="1307592"/>
-            <a:ext cx="82296" cy="2139696"/>
+          <p:cNvPr id="19" name="Shape 17"/>
+          <p:cNvSpPr/>
+          <p:nvPr/>
+        </p:nvSpPr>
+        <p:spPr>
+          <a:xfrm>
+            <a:off x="4507992" y="3090672"/>
+            <a:ext cx="82296" cy="1133856"/>
           </a:xfrm>
           <a:prstGeom prst="parallelogram">
             <a:avLst/>
@@ -12355,26 +13278,26 @@
       </p:sp>
       <p:sp>
         <p:nvSpPr>
-          <p:cNvPr id="19" name="Shape 17"/>
+          <p:cNvPr id="20" name="Shape 18"/>
           <p:cNvSpPr/>
           <p:nvPr/>
         </p:nvSpPr>
         <p:spPr>
           <a:xfrm rot="-90000">
-            <a:off x="6156960" y="1234440"/>
-            <a:ext cx="2529840" cy="2286000"/>
+            <a:off x="457200" y="3017520"/>
+            <a:ext cx="4069080" cy="1280160"/>
           </a:xfrm>
           <a:prstGeom prst="roundRect">
             <a:avLst>
-              <a:gd name="adj" fmla="val 2400"/>
+              <a:gd name="adj" fmla="val 4286"/>
             </a:avLst>
           </a:prstGeom>
           <a:solidFill>
-            <a:srgbClr val="0A0A0A"/>
+            <a:srgbClr val="161616"/>
           </a:solidFill>
           <a:ln w="12700">
             <a:solidFill>
-              <a:srgbClr val="FFFFFF"/>
+              <a:srgbClr val="2A2A2A"/>
             </a:solidFill>
             <a:prstDash val="solid"/>
           </a:ln>
@@ -12382,14 +13305,14 @@
       </p:sp>
       <p:sp>
         <p:nvSpPr>
-          <p:cNvPr id="20" name="Text 18"/>
-          <p:cNvSpPr/>
-          <p:nvPr/>
-        </p:nvSpPr>
-        <p:spPr>
-          <a:xfrm>
-            <a:off x="6339840" y="1417320"/>
-            <a:ext cx="2164080" cy="365760"/>
+          <p:cNvPr id="21" name="Text 19"/>
+          <p:cNvSpPr/>
+          <p:nvPr/>
+        </p:nvSpPr>
+        <p:spPr>
+          <a:xfrm>
+            <a:off x="640080" y="3108960"/>
+            <a:ext cx="3703320" cy="320040"/>
           </a:xfrm>
           <a:prstGeom prst="rect">
             <a:avLst/>
@@ -12405,7 +13328,7 @@
               <a:buNone/>
             </a:pPr>
             <a:r>
-              <a:rPr lang="en-US" sz="1600" b="1" dirty="0">
+              <a:rPr lang="en-US" sz="1500" b="1" dirty="0">
                 <a:solidFill>
                   <a:srgbClr val="FFFFFF"/>
                 </a:solidFill>
@@ -12413,22 +13336,22 @@
                 <a:ea typeface="Arial Black" pitchFamily="34" charset="-122"/>
                 <a:cs typeface="Arial Black" pitchFamily="34" charset="-120"/>
               </a:rPr>
-              <a:t>Claims rail</a:t>
-            </a:r>
-            <a:endParaRPr lang="en-US" sz="1600" dirty="0"/>
-          </a:p>
-        </p:txBody>
-      </p:sp>
-      <p:sp>
-        <p:nvSpPr>
-          <p:cNvPr id="21" name="Text 19"/>
-          <p:cNvSpPr/>
-          <p:nvPr/>
-        </p:nvSpPr>
-        <p:spPr>
-          <a:xfrm>
-            <a:off x="6339840" y="1920240"/>
-            <a:ext cx="2164080" cy="914400"/>
+              <a:t>DANA 2024</a:t>
+            </a:r>
+            <a:endParaRPr lang="en-US" sz="1500" dirty="0"/>
+          </a:p>
+        </p:txBody>
+      </p:sp>
+      <p:sp>
+        <p:nvSpPr>
+          <p:cNvPr id="22" name="Text 20"/>
+          <p:cNvSpPr/>
+          <p:nvPr/>
+        </p:nvSpPr>
+        <p:spPr>
+          <a:xfrm>
+            <a:off x="640080" y="3456432"/>
+            <a:ext cx="3703320" cy="777240"/>
           </a:xfrm>
           <a:prstGeom prst="rect">
             <a:avLst/>
@@ -12444,7 +13367,7 @@
               <a:buNone/>
             </a:pPr>
             <a:r>
-              <a:rPr lang="en-US" sz="1150" dirty="0">
+              <a:rPr lang="en-US" sz="800" dirty="0">
                 <a:solidFill>
                   <a:srgbClr val="B0B0B0"/>
                 </a:solidFill>
@@ -12452,22 +13375,22 @@
                 <a:ea typeface="Arial" pitchFamily="34" charset="-122"/>
                 <a:cs typeface="Arial" pitchFamily="34" charset="-120"/>
               </a:rPr>
-              <a:t>PMFBY insurers and aggregators pay per evidence packet</a:t>
-            </a:r>
-            <a:endParaRPr lang="en-US" sz="1150" dirty="0"/>
-          </a:p>
-        </p:txBody>
-      </p:sp>
-      <p:sp>
-        <p:nvSpPr>
-          <p:cNvPr id="22" name="Text 20"/>
-          <p:cNvSpPr/>
-          <p:nvPr/>
-        </p:nvSpPr>
-        <p:spPr>
-          <a:xfrm>
-            <a:off x="6339840" y="2971800"/>
-            <a:ext cx="2164080" cy="457200"/>
+              <a:t>5,428 acres across 4 blocks of Kendrapada + Bhadrak (rapid assessment). The engine's T-72 watch triggers R17 harvest-now for mature owned plots with labor, R18 protect-in-place for immature paddy. Same warning, two different governed decisions.</a:t>
+            </a:r>
+            <a:endParaRPr lang="en-US" sz="800" dirty="0"/>
+          </a:p>
+        </p:txBody>
+      </p:sp>
+      <p:sp>
+        <p:nvSpPr>
+          <p:cNvPr id="23" name="Text 21"/>
+          <p:cNvSpPr/>
+          <p:nvPr/>
+        </p:nvSpPr>
+        <p:spPr>
+          <a:xfrm>
+            <a:off x="640080" y="4133088"/>
+            <a:ext cx="3703320" cy="137160"/>
           </a:xfrm>
           <a:prstGeom prst="rect">
             <a:avLst/>
@@ -12483,7 +13406,7 @@
               <a:buNone/>
             </a:pPr>
             <a:r>
-              <a:rPr lang="en-US" sz="1000" i="1" dirty="0">
+              <a:rPr lang="en-US" sz="650" dirty="0">
                 <a:solidFill>
                   <a:srgbClr val="8A8A8A"/>
                 </a:solidFill>
@@ -12491,22 +13414,99 @@
                 <a:ea typeface="Arial" pitchFamily="34" charset="-122"/>
                 <a:cs typeface="Arial" pitchFamily="34" charset="-120"/>
               </a:rPr>
-              <a:t>verified observation converts to claim, both sides win</a:t>
-            </a:r>
-            <a:endParaRPr lang="en-US" sz="1000" dirty="0"/>
-          </a:p>
-        </p:txBody>
-      </p:sp>
-      <p:sp>
-        <p:nvSpPr>
-          <p:cNvPr id="23" name="Text 21"/>
-          <p:cNvSpPr/>
-          <p:nvPr/>
-        </p:nvSpPr>
-        <p:spPr>
-          <a:xfrm>
-            <a:off x="457200" y="3977640"/>
-            <a:ext cx="8229600" cy="411480"/>
+              <a:t>sources: d6, d20</a:t>
+            </a:r>
+            <a:endParaRPr lang="en-US" sz="650" dirty="0"/>
+          </a:p>
+        </p:txBody>
+      </p:sp>
+      <p:sp>
+        <p:nvSpPr>
+          <p:cNvPr id="24" name="Shape 22"/>
+          <p:cNvSpPr/>
+          <p:nvPr/>
+        </p:nvSpPr>
+        <p:spPr>
+          <a:xfrm>
+            <a:off x="4668012" y="3067812"/>
+            <a:ext cx="4069080" cy="1280160"/>
+          </a:xfrm>
+          <a:prstGeom prst="rect">
+            <a:avLst/>
+          </a:prstGeom>
+          <a:solidFill>
+            <a:srgbClr val="2A2A2A"/>
+          </a:solidFill>
+          <a:ln w="12700">
+            <a:solidFill>
+              <a:srgbClr val="2A2A2A"/>
+            </a:solidFill>
+            <a:prstDash val="solid"/>
+          </a:ln>
+        </p:spPr>
+      </p:sp>
+      <p:sp>
+        <p:nvSpPr>
+          <p:cNvPr id="25" name="Shape 23"/>
+          <p:cNvSpPr/>
+          <p:nvPr/>
+        </p:nvSpPr>
+        <p:spPr>
+          <a:xfrm>
+            <a:off x="8668512" y="3090672"/>
+            <a:ext cx="82296" cy="1133856"/>
+          </a:xfrm>
+          <a:prstGeom prst="parallelogram">
+            <a:avLst/>
+          </a:prstGeom>
+          <a:solidFill>
+            <a:srgbClr val="555555"/>
+          </a:solidFill>
+          <a:ln w="12700">
+            <a:solidFill>
+              <a:srgbClr val="555555"/>
+            </a:solidFill>
+            <a:prstDash val="solid"/>
+          </a:ln>
+        </p:spPr>
+      </p:sp>
+      <p:sp>
+        <p:nvSpPr>
+          <p:cNvPr id="26" name="Shape 24"/>
+          <p:cNvSpPr/>
+          <p:nvPr/>
+        </p:nvSpPr>
+        <p:spPr>
+          <a:xfrm rot="-90000">
+            <a:off x="4617720" y="3017520"/>
+            <a:ext cx="4069080" cy="1280160"/>
+          </a:xfrm>
+          <a:prstGeom prst="roundRect">
+            <a:avLst>
+              <a:gd name="adj" fmla="val 4286"/>
+            </a:avLst>
+          </a:prstGeom>
+          <a:solidFill>
+            <a:srgbClr val="161616"/>
+          </a:solidFill>
+          <a:ln w="12700">
+            <a:solidFill>
+              <a:srgbClr val="2A2A2A"/>
+            </a:solidFill>
+            <a:prstDash val="solid"/>
+          </a:ln>
+        </p:spPr>
+      </p:sp>
+      <p:sp>
+        <p:nvSpPr>
+          <p:cNvPr id="27" name="Text 25"/>
+          <p:cNvSpPr/>
+          <p:nvPr/>
+        </p:nvSpPr>
+        <p:spPr>
+          <a:xfrm>
+            <a:off x="4800600" y="3108960"/>
+            <a:ext cx="3703320" cy="320040"/>
           </a:xfrm>
           <a:prstGeom prst="rect">
             <a:avLst/>
@@ -12522,30 +13522,30 @@
               <a:buNone/>
             </a:pPr>
             <a:r>
-              <a:rPr lang="en-US" sz="1300" b="1" dirty="0">
-                <a:solidFill>
-                  <a:srgbClr val="0A0A0A"/>
+              <a:rPr lang="en-US" sz="1500" b="1" dirty="0">
+                <a:solidFill>
+                  <a:srgbClr val="FFFFFF"/>
                 </a:solidFill>
                 <a:latin typeface="Arial Black" pitchFamily="34" charset="0"/>
                 <a:ea typeface="Arial Black" pitchFamily="34" charset="-122"/>
                 <a:cs typeface="Arial Black" pitchFamily="34" charset="-120"/>
               </a:rPr>
-              <a:t>Seed revenue line for Round 1: one FPO, one season, measured renewal. No consumer subscription fantasy.</a:t>
-            </a:r>
-            <a:endParaRPr lang="en-US" sz="1300" dirty="0"/>
-          </a:p>
-        </p:txBody>
-      </p:sp>
-      <p:sp>
-        <p:nvSpPr>
-          <p:cNvPr id="24" name="Text 22"/>
-          <p:cNvSpPr/>
-          <p:nvPr/>
-        </p:nvSpPr>
-        <p:spPr>
-          <a:xfrm>
-            <a:off x="457200" y="4759452"/>
-            <a:ext cx="8229600" cy="274320"/>
+              <a:t>1999 SUPER CYCLONE</a:t>
+            </a:r>
+            <a:endParaRPr lang="en-US" sz="1500" dirty="0"/>
+          </a:p>
+        </p:txBody>
+      </p:sp>
+      <p:sp>
+        <p:nvSpPr>
+          <p:cNvPr id="28" name="Text 26"/>
+          <p:cNvSpPr/>
+          <p:nvPr/>
+        </p:nvSpPr>
+        <p:spPr>
+          <a:xfrm>
+            <a:off x="4800600" y="3456432"/>
+            <a:ext cx="3703320" cy="777240"/>
           </a:xfrm>
           <a:prstGeom prst="rect">
             <a:avLst/>
@@ -12561,15 +13561,93 @@
               <a:buNone/>
             </a:pPr>
             <a:r>
-              <a:rPr lang="en-US" sz="850" dirty="0">
-                <a:solidFill>
-                  <a:srgbClr val="6E6E6E"/>
+              <a:rPr lang="en-US" sz="800" dirty="0">
+                <a:solidFill>
+                  <a:srgbClr val="B0B0B0"/>
                 </a:solidFill>
                 <a:latin typeface="Arial" pitchFamily="34" charset="0"/>
                 <a:ea typeface="Arial" pitchFamily="34" charset="-122"/>
                 <a:cs typeface="Arial" pitchFamily="34" charset="-120"/>
               </a:rPr>
-              <a:t>Mine verdict: the real buyer is institutional, and the real distribution is extension workers, KCC, FPOs, dealers, and panchayat actors. Consumer subscriptions and network effects are not evidenced.</a:t>
+              <a:t>9,893 deaths with a 48h+ official warning. The warning existed; the decision did not. This is the entire thesis: warnings are infrastructure, decisions are the product. Every subsequent event is measured against that failure.</a:t>
+            </a:r>
+            <a:endParaRPr lang="en-US" sz="800" dirty="0"/>
+          </a:p>
+        </p:txBody>
+      </p:sp>
+      <p:sp>
+        <p:nvSpPr>
+          <p:cNvPr id="29" name="Text 27"/>
+          <p:cNvSpPr/>
+          <p:nvPr/>
+        </p:nvSpPr>
+        <p:spPr>
+          <a:xfrm>
+            <a:off x="4800600" y="4133088"/>
+            <a:ext cx="3703320" cy="137160"/>
+          </a:xfrm>
+          <a:prstGeom prst="rect">
+            <a:avLst/>
+          </a:prstGeom>
+          <a:noFill/>
+          <a:ln/>
+        </p:spPr>
+        <p:txBody>
+          <a:bodyPr wrap="square" lIns="0" tIns="0" rIns="0" bIns="0" rtlCol="0" anchor="ctr"/>
+          <a:lstStyle/>
+          <a:p>
+            <a:pPr indent="0" marL="0">
+              <a:buNone/>
+            </a:pPr>
+            <a:r>
+              <a:rPr lang="en-US" sz="650" dirty="0">
+                <a:solidFill>
+                  <a:srgbClr val="8A8A8A"/>
+                </a:solidFill>
+                <a:latin typeface="Arial" pitchFamily="34" charset="0"/>
+                <a:ea typeface="Arial" pitchFamily="34" charset="-122"/>
+                <a:cs typeface="Arial" pitchFamily="34" charset="-120"/>
+              </a:rPr>
+              <a:t>sources: d1, d35</a:t>
+            </a:r>
+            <a:endParaRPr lang="en-US" sz="650" dirty="0"/>
+          </a:p>
+        </p:txBody>
+      </p:sp>
+      <p:sp>
+        <p:nvSpPr>
+          <p:cNvPr id="30" name="Text 28"/>
+          <p:cNvSpPr/>
+          <p:nvPr/>
+        </p:nvSpPr>
+        <p:spPr>
+          <a:xfrm>
+            <a:off x="457200" y="4663440"/>
+            <a:ext cx="8229600" cy="274320"/>
+          </a:xfrm>
+          <a:prstGeom prst="rect">
+            <a:avLst/>
+          </a:prstGeom>
+          <a:noFill/>
+          <a:ln/>
+        </p:spPr>
+        <p:txBody>
+          <a:bodyPr wrap="square" lIns="0" tIns="0" rIns="0" bIns="0" rtlCol="0" anchor="ctr"/>
+          <a:lstStyle/>
+          <a:p>
+            <a:pPr indent="0" marL="0">
+              <a:buNone/>
+            </a:pPr>
+            <a:r>
+              <a:rPr lang="en-US" sz="850" dirty="0">
+                <a:solidFill>
+                  <a:srgbClr val="B0B0B0"/>
+                </a:solidFill>
+                <a:latin typeface="Arial" pitchFamily="34" charset="0"/>
+                <a:ea typeface="Arial" pitchFamily="34" charset="-122"/>
+                <a:cs typeface="Arial" pitchFamily="34" charset="-120"/>
+              </a:rPr>
+              <a:t>The replay harness froze each event's best track before running, so the engine never sees the outcome. Honesty: what the engine WOULD have issued, validated against what happened.</a:t>
             </a:r>
             <a:endParaRPr lang="en-US" sz="850" dirty="0"/>
           </a:p>

</xml_diff>

<commit_message>
deck: fix 5 layout bugs + add fade slide transitions
Layout fixes (no wording/numbers touched, pure geometry + contrast):
- S2: remove -2deg rotate on the 3 stat cards so orange bars line up in a straight row
- S3 (research machine): nudge title down 0.07in so it no longer hugs the top edge; brighten card footer (8A8A8A -> B0B0B0) so source/freshness is readable
- S3 (solution): drop bullet font 11->10.5 + lineSpacing 22->20 to kill dangling-word widows
- S6 (moat): shrink advisory quote 13.5->12.5pt so it fits its box (was cut off)
- S8 (market): pull last rail line up + shrink 12->11pt so 'record' no longer clips the box

Animations: inject_transitions.py adds a medium fade transition to all 13 slides post-build (pptxgenjs cannot author transitions natively). Run it after node build-krishi-setu.js.

Verified: rebuilt, 13 slides, gate tokens intact (FF5A1F/0A0A0A/Arial Black), 0 em dash, 13 transitions injected, all 5 fixes confirmed by render.
</commit_message>
<xml_diff>
--- a/scaffold/deck/KrishiSetu-Round0-20260816.pptx
+++ b/scaffold/deck/KrishiSetu-Round0-20260816.pptx
@@ -2168,6 +2168,9 @@
   <p:clrMapOvr>
     <a:masterClrMapping/>
   </p:clrMapOvr>
+  <p:transition spd="med">
+    <p:fade/>
+  </p:transition>
 </p:sld>
 </file>
 
@@ -2970,6 +2973,9 @@
   <p:clrMapOvr>
     <a:masterClrMapping/>
   </p:clrMapOvr>
+  <p:transition spd="med">
+    <p:fade/>
+  </p:transition>
 </p:sld>
 </file>
 
@@ -3284,8 +3290,8 @@
         </p:nvSpPr>
         <p:spPr>
           <a:xfrm>
-            <a:off x="640080" y="2788920"/>
-            <a:ext cx="3657600" cy="548640"/>
+            <a:off x="640080" y="2724912"/>
+            <a:ext cx="3657600" cy="411480"/>
           </a:xfrm>
           <a:prstGeom prst="rect">
             <a:avLst/>
@@ -3301,7 +3307,7 @@
               <a:buNone/>
             </a:pPr>
             <a:r>
-              <a:rPr lang="en-US" sz="1200" dirty="0">
+              <a:rPr lang="en-US" sz="1100" dirty="0">
                 <a:solidFill>
                   <a:srgbClr val="0A0A0A"/>
                 </a:solidFill>
@@ -3311,7 +3317,7 @@
               </a:rPr>
               <a:t>Odisha: cyclone-facing coast, paddy and saline zones, Dana and Yaas damage on record</a:t>
             </a:r>
-            <a:endParaRPr lang="en-US" sz="1200" dirty="0"/>
+            <a:endParaRPr lang="en-US" sz="1100" dirty="0"/>
           </a:p>
         </p:txBody>
       </p:sp>
@@ -3691,6 +3697,9 @@
   <p:clrMapOvr>
     <a:masterClrMapping/>
   </p:clrMapOvr>
+  <p:transition spd="med">
+    <p:fade/>
+  </p:transition>
 </p:sld>
 </file>
 
@@ -4595,6 +4604,9 @@
   <p:clrMapOvr>
     <a:masterClrMapping/>
   </p:clrMapOvr>
+  <p:transition spd="med">
+    <p:fade/>
+  </p:transition>
 </p:sld>
 </file>
 
@@ -4899,6 +4911,9 @@
   <p:clrMapOvr>
     <a:masterClrMapping/>
   </p:clrMapOvr>
+  <p:transition spd="med">
+    <p:fade/>
+  </p:transition>
 </p:sld>
 </file>
 
@@ -5209,7 +5224,7 @@
           <p:nvPr/>
         </p:nvSpPr>
         <p:spPr>
-          <a:xfrm rot="-120000">
+          <a:xfrm>
             <a:off x="457200" y="2240280"/>
             <a:ext cx="2529840" cy="1463040"/>
           </a:xfrm>
@@ -5389,7 +5404,7 @@
           <p:nvPr/>
         </p:nvSpPr>
         <p:spPr>
-          <a:xfrm rot="-120000">
+          <a:xfrm>
             <a:off x="3307080" y="2240280"/>
             <a:ext cx="2529840" cy="1463040"/>
           </a:xfrm>
@@ -5569,7 +5584,7 @@
           <p:nvPr/>
         </p:nvSpPr>
         <p:spPr>
-          <a:xfrm rot="-120000">
+          <a:xfrm>
             <a:off x="6156960" y="2240280"/>
             <a:ext cx="2529840" cy="1463040"/>
           </a:xfrm>
@@ -5821,6 +5836,9 @@
   <p:clrMapOvr>
     <a:masterClrMapping/>
   </p:clrMapOvr>
+  <p:transition spd="med">
+    <p:fade/>
+  </p:transition>
 </p:sld>
 </file>
 
@@ -5856,7 +5874,7 @@
         </p:nvSpPr>
         <p:spPr>
           <a:xfrm>
-            <a:off x="498348" y="361188"/>
+            <a:off x="498348" y="425196"/>
             <a:ext cx="6858000" cy="0"/>
           </a:xfrm>
           <a:prstGeom prst="rect">
@@ -5873,7 +5891,7 @@
               <a:buNone/>
             </a:pPr>
             <a:r>
-              <a:rPr lang="en-US" sz="3200" b="1" dirty="0">
+              <a:rPr lang="en-US" sz="3000" b="1" dirty="0">
                 <a:solidFill>
                   <a:srgbClr val="2A2A2A"/>
                 </a:solidFill>
@@ -5883,7 +5901,7 @@
               </a:rPr>
               <a:t>The research machine behind this deck</a:t>
             </a:r>
-            <a:endParaRPr lang="en-US" sz="3200" dirty="0"/>
+            <a:endParaRPr lang="en-US" sz="3000" dirty="0"/>
           </a:p>
         </p:txBody>
       </p:sp>
@@ -5895,7 +5913,7 @@
         </p:nvSpPr>
         <p:spPr>
           <a:xfrm>
-            <a:off x="457200" y="320040"/>
+            <a:off x="457200" y="384048"/>
             <a:ext cx="6858000" cy="0"/>
           </a:xfrm>
           <a:prstGeom prst="rect">
@@ -5912,7 +5930,7 @@
               <a:buNone/>
             </a:pPr>
             <a:r>
-              <a:rPr lang="en-US" sz="3200" b="1" dirty="0">
+              <a:rPr lang="en-US" sz="3000" b="1" dirty="0">
                 <a:solidFill>
                   <a:srgbClr val="FFFFFF"/>
                 </a:solidFill>
@@ -5922,7 +5940,7 @@
               </a:rPr>
               <a:t>The research machine behind this deck</a:t>
             </a:r>
-            <a:endParaRPr lang="en-US" sz="3200" dirty="0"/>
+            <a:endParaRPr lang="en-US" sz="3000" dirty="0"/>
           </a:p>
         </p:txBody>
       </p:sp>
@@ -5934,7 +5952,7 @@
         </p:nvSpPr>
         <p:spPr>
           <a:xfrm>
-            <a:off x="457200" y="896112"/>
+            <a:off x="457200" y="950976"/>
             <a:ext cx="1280160" cy="54864"/>
           </a:xfrm>
           <a:prstGeom prst="rect">
@@ -6133,7 +6151,7 @@
             <a:r>
               <a:rPr lang="en-US" sz="750" dirty="0">
                 <a:solidFill>
-                  <a:srgbClr val="8A8A8A"/>
+                  <a:srgbClr val="B0B0B0"/>
                 </a:solidFill>
                 <a:latin typeface="Arial" pitchFamily="34" charset="0"/>
                 <a:ea typeface="Arial" pitchFamily="34" charset="-122"/>
@@ -6327,7 +6345,7 @@
             <a:r>
               <a:rPr lang="en-US" sz="750" dirty="0">
                 <a:solidFill>
-                  <a:srgbClr val="8A8A8A"/>
+                  <a:srgbClr val="B0B0B0"/>
                 </a:solidFill>
                 <a:latin typeface="Arial" pitchFamily="34" charset="0"/>
                 <a:ea typeface="Arial" pitchFamily="34" charset="-122"/>
@@ -6521,7 +6539,7 @@
             <a:r>
               <a:rPr lang="en-US" sz="750" dirty="0">
                 <a:solidFill>
-                  <a:srgbClr val="8A8A8A"/>
+                  <a:srgbClr val="B0B0B0"/>
                 </a:solidFill>
                 <a:latin typeface="Arial" pitchFamily="34" charset="0"/>
                 <a:ea typeface="Arial" pitchFamily="34" charset="-122"/>
@@ -6715,7 +6733,7 @@
             <a:r>
               <a:rPr lang="en-US" sz="750" dirty="0">
                 <a:solidFill>
-                  <a:srgbClr val="8A8A8A"/>
+                  <a:srgbClr val="B0B0B0"/>
                 </a:solidFill>
                 <a:latin typeface="Arial" pitchFamily="34" charset="0"/>
                 <a:ea typeface="Arial" pitchFamily="34" charset="-122"/>
@@ -6810,6 +6828,9 @@
   <p:clrMapOvr>
     <a:masterClrMapping/>
   </p:clrMapOvr>
+  <p:transition spd="med">
+    <p:fade/>
+  </p:transition>
 </p:sld>
 </file>
 
@@ -7643,6 +7664,9 @@
   <p:clrMapOvr>
     <a:masterClrMapping/>
   </p:clrMapOvr>
+  <p:transition spd="med">
+    <p:fade/>
+  </p:transition>
 </p:sld>
 </file>
 
@@ -7992,12 +8016,12 @@
           <a:p>
             <a:pPr indent="0" marL="0">
               <a:lnSpc>
-                <a:spcPts val="2200"/>
+                <a:spcPts val="2000"/>
               </a:lnSpc>
               <a:buNone/>
             </a:pPr>
             <a:r>
-              <a:rPr lang="en-US" sz="1100" dirty="0">
+              <a:rPr lang="en-US" sz="1050" dirty="0">
                 <a:solidFill>
                   <a:srgbClr val="0A0A0A"/>
                 </a:solidFill>
@@ -8007,17 +8031,17 @@
               </a:rPr>
               <a:t>STAGE THE CROP</a:t>
             </a:r>
-            <a:endParaRPr lang="en-US" sz="1100" dirty="0"/>
+            <a:endParaRPr lang="en-US" sz="1050" dirty="0"/>
           </a:p>
           <a:p>
             <a:pPr indent="0" marL="0">
               <a:lnSpc>
-                <a:spcPts val="2200"/>
+                <a:spcPts val="2000"/>
               </a:lnSpc>
               <a:buNone/>
             </a:pPr>
             <a:r>
-              <a:rPr lang="en-US" sz="1100" dirty="0">
+              <a:rPr lang="en-US" sz="1050" dirty="0">
                 <a:solidFill>
                   <a:srgbClr val="0A0A0A"/>
                 </a:solidFill>
@@ -8027,17 +8051,17 @@
               </a:rPr>
               <a:t>harvest or move to raised platform on a deadline</a:t>
             </a:r>
-            <a:endParaRPr lang="en-US" sz="1100" dirty="0"/>
+            <a:endParaRPr lang="en-US" sz="1050" dirty="0"/>
           </a:p>
           <a:p>
             <a:pPr indent="0" marL="0">
               <a:lnSpc>
-                <a:spcPts val="2200"/>
+                <a:spcPts val="2000"/>
               </a:lnSpc>
               <a:buNone/>
             </a:pPr>
             <a:r>
-              <a:rPr lang="en-US" sz="1100" dirty="0">
+              <a:rPr lang="en-US" sz="1050" dirty="0">
                 <a:solidFill>
                   <a:srgbClr val="0A0A0A"/>
                 </a:solidFill>
@@ -8047,17 +8071,17 @@
               </a:rPr>
               <a:t>protect seed, livestock, equipment</a:t>
             </a:r>
-            <a:endParaRPr lang="en-US" sz="1100" dirty="0"/>
+            <a:endParaRPr lang="en-US" sz="1050" dirty="0"/>
           </a:p>
           <a:p>
             <a:pPr indent="0" marL="0">
               <a:lnSpc>
-                <a:spcPts val="2200"/>
+                <a:spcPts val="2000"/>
               </a:lnSpc>
               <a:buNone/>
             </a:pPr>
             <a:r>
-              <a:rPr lang="en-US" sz="1100" dirty="0">
+              <a:rPr lang="en-US" sz="1050" dirty="0">
                 <a:solidFill>
                   <a:srgbClr val="0A0A0A"/>
                 </a:solidFill>
@@ -8067,7 +8091,7 @@
               </a:rPr>
               <a:t>evacuate people, secure the house</a:t>
             </a:r>
-            <a:endParaRPr lang="en-US" sz="1100" dirty="0"/>
+            <a:endParaRPr lang="en-US" sz="1050" dirty="0"/>
           </a:p>
         </p:txBody>
       </p:sp>
@@ -8244,12 +8268,12 @@
           <a:p>
             <a:pPr indent="0" marL="0">
               <a:lnSpc>
-                <a:spcPts val="2200"/>
+                <a:spcPts val="2000"/>
               </a:lnSpc>
               <a:buNone/>
             </a:pPr>
             <a:r>
-              <a:rPr lang="en-US" sz="1100" dirty="0">
+              <a:rPr lang="en-US" sz="1050" dirty="0">
                 <a:solidFill>
                   <a:srgbClr val="0A0A0A"/>
                 </a:solidFill>
@@ -8259,17 +8283,17 @@
               </a:rPr>
               <a:t>SHELTER AND SAFETY</a:t>
             </a:r>
-            <a:endParaRPr lang="en-US" sz="1100" dirty="0"/>
+            <a:endParaRPr lang="en-US" sz="1050" dirty="0"/>
           </a:p>
           <a:p>
             <a:pPr indent="0" marL="0">
               <a:lnSpc>
-                <a:spcPts val="2200"/>
+                <a:spcPts val="2000"/>
               </a:lnSpc>
               <a:buNone/>
             </a:pPr>
             <a:r>
-              <a:rPr lang="en-US" sz="1100" dirty="0">
+              <a:rPr lang="en-US" sz="1050" dirty="0">
                 <a:solidFill>
                   <a:srgbClr val="0A0A0A"/>
                 </a:solidFill>
@@ -8279,17 +8303,17 @@
               </a:rPr>
               <a:t>Odia guidance for the household</a:t>
             </a:r>
-            <a:endParaRPr lang="en-US" sz="1100" dirty="0"/>
+            <a:endParaRPr lang="en-US" sz="1050" dirty="0"/>
           </a:p>
           <a:p>
             <a:pPr indent="0" marL="0">
               <a:lnSpc>
-                <a:spcPts val="2200"/>
+                <a:spcPts val="2000"/>
               </a:lnSpc>
               <a:buNone/>
             </a:pPr>
             <a:r>
-              <a:rPr lang="en-US" sz="1100" dirty="0">
+              <a:rPr lang="en-US" sz="1050" dirty="0">
                 <a:solidFill>
                   <a:srgbClr val="0A0A0A"/>
                 </a:solidFill>
@@ -8299,17 +8323,17 @@
               </a:rPr>
               <a:t>livestock and fodder checklist</a:t>
             </a:r>
-            <a:endParaRPr lang="en-US" sz="1100" dirty="0"/>
+            <a:endParaRPr lang="en-US" sz="1050" dirty="0"/>
           </a:p>
           <a:p>
             <a:pPr indent="0" marL="0">
               <a:lnSpc>
-                <a:spcPts val="2200"/>
+                <a:spcPts val="2000"/>
               </a:lnSpc>
               <a:buNone/>
             </a:pPr>
             <a:r>
-              <a:rPr lang="en-US" sz="1100" dirty="0">
+              <a:rPr lang="en-US" sz="1050" dirty="0">
                 <a:solidFill>
                   <a:srgbClr val="0A0A0A"/>
                 </a:solidFill>
@@ -8319,7 +8343,7 @@
               </a:rPr>
               <a:t>keep the advisory reachable offline</a:t>
             </a:r>
-            <a:endParaRPr lang="en-US" sz="1100" dirty="0"/>
+            <a:endParaRPr lang="en-US" sz="1050" dirty="0"/>
           </a:p>
         </p:txBody>
       </p:sp>
@@ -8496,12 +8520,12 @@
           <a:p>
             <a:pPr indent="0" marL="0">
               <a:lnSpc>
-                <a:spcPts val="2200"/>
+                <a:spcPts val="2000"/>
               </a:lnSpc>
               <a:buNone/>
             </a:pPr>
             <a:r>
-              <a:rPr lang="en-US" sz="1100" dirty="0">
+              <a:rPr lang="en-US" sz="1050" dirty="0">
                 <a:solidFill>
                   <a:srgbClr val="0A0A0A"/>
                 </a:solidFill>
@@ -8511,17 +8535,17 @@
               </a:rPr>
               <a:t>RECOVERY AND CLAIMS</a:t>
             </a:r>
-            <a:endParaRPr lang="en-US" sz="1100" dirty="0"/>
+            <a:endParaRPr lang="en-US" sz="1050" dirty="0"/>
           </a:p>
           <a:p>
             <a:pPr indent="0" marL="0">
               <a:lnSpc>
-                <a:spcPts val="2200"/>
+                <a:spcPts val="2000"/>
               </a:lnSpc>
               <a:buNone/>
             </a:pPr>
             <a:r>
-              <a:rPr lang="en-US" sz="1100" dirty="0">
+              <a:rPr lang="en-US" sz="1050" dirty="0">
                 <a:solidFill>
                   <a:srgbClr val="0A0A0A"/>
                 </a:solidFill>
@@ -8531,17 +8555,17 @@
               </a:rPr>
               <a:t>saline flush and re-sowing plan per plot</a:t>
             </a:r>
-            <a:endParaRPr lang="en-US" sz="1100" dirty="0"/>
+            <a:endParaRPr lang="en-US" sz="1050" dirty="0"/>
           </a:p>
           <a:p>
             <a:pPr indent="0" marL="0">
               <a:lnSpc>
-                <a:spcPts val="2200"/>
+                <a:spcPts val="2000"/>
               </a:lnSpc>
               <a:buNone/>
             </a:pPr>
             <a:r>
-              <a:rPr lang="en-US" sz="1100" dirty="0">
+              <a:rPr lang="en-US" sz="1050" dirty="0">
                 <a:solidFill>
                   <a:srgbClr val="0A0A0A"/>
                 </a:solidFill>
@@ -8551,17 +8575,17 @@
               </a:rPr>
               <a:t>damage evidence capture on a basic phone</a:t>
             </a:r>
-            <a:endParaRPr lang="en-US" sz="1100" dirty="0"/>
+            <a:endParaRPr lang="en-US" sz="1050" dirty="0"/>
           </a:p>
           <a:p>
             <a:pPr indent="0" marL="0">
               <a:lnSpc>
-                <a:spcPts val="2200"/>
+                <a:spcPts val="2000"/>
               </a:lnSpc>
               <a:buNone/>
             </a:pPr>
             <a:r>
-              <a:rPr lang="en-US" sz="1100" dirty="0">
+              <a:rPr lang="en-US" sz="1050" dirty="0">
                 <a:solidFill>
                   <a:srgbClr val="0A0A0A"/>
                 </a:solidFill>
@@ -8571,7 +8595,7 @@
               </a:rPr>
               <a:t>PMFBY claim packet export</a:t>
             </a:r>
-            <a:endParaRPr lang="en-US" sz="1100" dirty="0"/>
+            <a:endParaRPr lang="en-US" sz="1050" dirty="0"/>
           </a:p>
         </p:txBody>
       </p:sp>
@@ -8658,6 +8682,9 @@
   <p:clrMapOvr>
     <a:masterClrMapping/>
   </p:clrMapOvr>
+  <p:transition spd="med">
+    <p:fade/>
+  </p:transition>
 </p:sld>
 </file>
 
@@ -9907,6 +9934,9 @@
   <p:clrMapOvr>
     <a:masterClrMapping/>
   </p:clrMapOvr>
+  <p:transition spd="med">
+    <p:fade/>
+  </p:transition>
 </p:sld>
 </file>
 
@@ -11173,6 +11203,9 @@
   <p:clrMapOvr>
     <a:masterClrMapping/>
   </p:clrMapOvr>
+  <p:transition spd="med">
+    <p:fade/>
+  </p:transition>
 </p:sld>
 </file>
 
@@ -11595,7 +11628,7 @@
               <a:buNone/>
             </a:pPr>
             <a:r>
-              <a:rPr lang="en-US" sz="1350" dirty="0">
+              <a:rPr lang="en-US" sz="1250" dirty="0">
                 <a:solidFill>
                   <a:srgbClr val="FFFFFF"/>
                 </a:solidFill>
@@ -11605,7 +11638,7 @@
               </a:rPr>
               <a:t>"Plot 12B, flowering paddy: harvest by 18:00 tomorrow, or move to the raised platform. Source: IMD + rule R17. Cost of waiting: est. yield loss."</a:t>
             </a:r>
-            <a:endParaRPr lang="en-US" sz="1350" dirty="0"/>
+            <a:endParaRPr lang="en-US" sz="1250" dirty="0"/>
           </a:p>
         </p:txBody>
       </p:sp>
@@ -12669,6 +12702,9 @@
   <p:clrMapOvr>
     <a:masterClrMapping/>
   </p:clrMapOvr>
+  <p:transition spd="med">
+    <p:fade/>
+  </p:transition>
 </p:sld>
 </file>
 
@@ -13658,6 +13694,9 @@
   <p:clrMapOvr>
     <a:masterClrMapping/>
   </p:clrMapOvr>
+  <p:transition spd="med">
+    <p:fade/>
+  </p:transition>
 </p:sld>
 </file>
 

</xml_diff>

<commit_message>
deck P0 fixes from stress run D: hero quote mature paddy (R17 engine-truth), frontier math relabeled shipped-vs-designed
</commit_message>
<xml_diff>
--- a/scaffold/deck/KrishiSetu-Round0-20260816.pptx
+++ b/scaffold/deck/KrishiSetu-Round0-20260816.pptx
@@ -7438,7 +7438,7 @@
                 <a:ea typeface="Arial" pitchFamily="34" charset="-122"/>
                 <a:cs typeface="Arial" pitchFamily="34" charset="-120"/>
               </a:rPr>
-              <a:t>Monte Carlo with convergence gates, CVaR at every decision node, copulas for compound events (cyclone + surge + river flood, fitted not borrowed), BOCPD regime detection, fragility curves per crop and stage, self-excitation for disaster clustering.</a:t>
+              <a:t>shipped in the prototype: Monte Carlo with convergence gates, CVaR at every decision node, fragility curves per crop and stage. designed for the live system: fitted copulas for compound events (cyclone + surge + river flood), BOCPD regime detection, self-excitation for disaster clustering.</a:t>
             </a:r>
             <a:endParaRPr lang="en-US" sz="850" dirty="0"/>
           </a:p>
@@ -11603,7 +11603,7 @@
                 <a:ea typeface="Arial" pitchFamily="34" charset="-122"/>
                 <a:cs typeface="Arial" pitchFamily="34" charset="-120"/>
               </a:rPr>
-              <a:t>"Plot 12B, flowering paddy: harvest by 18:00 tomorrow, or move to the raised platform. Source: IMD + rule R17. Cost of waiting: est. yield loss."</a:t>
+              <a:t>"Plot 12B, mature paddy: harvest by 18:00 tomorrow, or move to the raised platform. Source: IMD + rule R17. Cost of waiting: est. yield loss."</a:t>
             </a:r>
             <a:endParaRPr lang="en-US" sz="1350" dirty="0"/>
           </a:p>

</xml_diff>

<commit_message>
deck P0 fixes from stress B: Dana out of stats (Fani verified in), Dana rapid-assessment caveat, agronomist-curated not reviewed, Kendrapara spelling
</commit_message>
<xml_diff>
--- a/scaffold/deck/KrishiSetu-Round0-20260816.pptx
+++ b/scaffold/deck/KrishiSetu-Round0-20260816.pptx
@@ -3478,7 +3478,7 @@
                 <a:ea typeface="Arial" pitchFamily="34" charset="-122"/>
                 <a:cs typeface="Arial" pitchFamily="34" charset="-120"/>
               </a:rPr>
-              <a:t>2.  one agronomist-reviewed rule pack</a:t>
+              <a:t>2.  one agronomist-curated rule pack</a:t>
             </a:r>
             <a:endParaRPr lang="en-US" sz="1200" dirty="0"/>
           </a:p>
@@ -5287,7 +5287,7 @@
                 <a:ea typeface="Arial Black" pitchFamily="34" charset="-122"/>
                 <a:cs typeface="Arial Black" pitchFamily="34" charset="-120"/>
               </a:rPr>
-              <a:t>5,428 acres</a:t>
+              <a:t>108,220 ha</a:t>
             </a:r>
             <a:endParaRPr lang="en-US" sz="3200" dirty="0"/>
           </a:p>
@@ -5326,7 +5326,7 @@
                 <a:ea typeface="Arial" pitchFamily="34" charset="-122"/>
                 <a:cs typeface="Arial" pitchFamily="34" charset="-120"/>
               </a:rPr>
-              <a:t>crop loss across 4 blocks of Kendrapada and Bhadrak, Cyclone Dana 2024 (rapid assessment)</a:t>
+              <a:t>crop loss in Odisha, Cyclone Fani 2019, Rs 1,304.58 cr (OSDMA damage assessment)</a:t>
             </a:r>
             <a:endParaRPr lang="en-US" sz="1000" dirty="0"/>
           </a:p>
@@ -9245,7 +9245,7 @@
                 <a:ea typeface="Arial" pitchFamily="34" charset="-122"/>
                 <a:cs typeface="Arial" pitchFamily="34" charset="-120"/>
               </a:rPr>
-              <a:t>agronomist-reviewed rule engine: pre/during/post x crop x stage x hazard</a:t>
+              <a:t>agronomist-curated rule engine: pre/during/post x crop x stage x hazard</a:t>
             </a:r>
             <a:endParaRPr lang="en-US" sz="1050" dirty="0"/>
           </a:p>
@@ -13375,7 +13375,7 @@
                 <a:ea typeface="Arial" pitchFamily="34" charset="-122"/>
                 <a:cs typeface="Arial" pitchFamily="34" charset="-120"/>
               </a:rPr>
-              <a:t>5,428 acres across 4 blocks of Kendrapada + Bhadrak (rapid assessment). The engine's T-72 watch triggers R17 harvest-now for mature owned plots with labor, R18 protect-in-place for immature paddy. Same warning, two different governed decisions.</a:t>
+              <a:t>rapid assessment: 5,428 acres across 4 selected blocks of Kendrapara + Bhadrak (nonrepresentative, d6). The engine's T-72 watch triggers R17 harvest-now for mature owned plots with labor, R18 protect-in-place for immature paddy. Same warning, two different governed decisions.</a:t>
             </a:r>
             <a:endParaRPr lang="en-US" sz="800" dirty="0"/>
           </a:p>

</xml_diff>

<commit_message>
repo polish: fresh judge-facing README, de-AI language (research reports, no orchestrated machinery), deck slide 3 reframed to evidence chain
</commit_message>
<xml_diff>
--- a/scaffold/deck/KrishiSetu-Round0-20260816.pptx
+++ b/scaffold/deck/KrishiSetu-Round0-20260816.pptx
@@ -6100,7 +6100,7 @@
                 <a:ea typeface="Arial" pitchFamily="34" charset="-122"/>
                 <a:cs typeface="Arial" pitchFamily="34" charset="-120"/>
               </a:rPr>
-              <a:t>parallel deep-research reports across 7 waves, every run multi-channel with coverage tables, noise logs, A-D evidence grades</a:t>
+              <a:t>research reports across 7 waves, every one multi-channel with coverage tables, noise logs, A-D evidence grades</a:t>
             </a:r>
             <a:endParaRPr lang="en-US" sz="950" dirty="0"/>
           </a:p>
@@ -6760,7 +6760,7 @@
                 <a:ea typeface="Arial Black" pitchFamily="34" charset="-122"/>
                 <a:cs typeface="Arial Black" pitchFamily="34" charset="-120"/>
               </a:rPr>
-              <a:t>single-pass AI summarizes. this is an orchestrated parallel research machine with verification gates: every number in this deck traces to a source you can open.</a:t>
+              <a:t>every number in this deck traces to a source you can open: slide, proof ledger, index, raw report. nothing ships without the chain.</a:t>
             </a:r>
             <a:endParaRPr lang="en-US" sz="1300" dirty="0"/>
           </a:p>

</xml_diff>

<commit_message>
deck: revert theme to forest & moss green (data unchanged)
User directive: revert the black/white/orange theme back to green. Content,
numbers, 13 slides, layout fixes, and transitions all preserved.

Palette swap (all hardcoded tones recolored, no text/number touched):
- near-black 0A0A0A -> forest green 1F3D26 (dark backgrounds + cards)
- hazard orange FF5A1F -> moss green 97BC62 (accent bars, quote, circles)
- gray/edge tones -> muted sage greens; card fills -> pale greens
- extrusion shadows 2A2A2A -> deep green 142B1A; strips 555555 -> 3E5C42

Gate updated: check-deck.sh now asserts 97BC62 + 1F3D26 instead of
FF5A1F + 0A0A0A. Verified: gate PASSES (13 slides, 0 em dash, 0 banned
words), 13 fade transitions re-injected after gate rebuild.
</commit_message>
<xml_diff>
--- a/scaffold/deck/KrishiSetu-Round0-20260816.pptx
+++ b/scaffold/deck/KrishiSetu-Round0-20260816.pptx
@@ -1925,7 +1925,7 @@
     <p:bg>
       <p:bgPr>
         <a:solidFill>
-          <a:srgbClr val="0A0A0A"/>
+          <a:srgbClr val="1F3D26"/>
         </a:solidFill>
       </p:bgPr>
     </p:bg>
@@ -1970,7 +1970,7 @@
             <a:r>
               <a:rPr lang="en-US" sz="5800" b="1" dirty="0">
                 <a:solidFill>
-                  <a:srgbClr val="2A2A2A"/>
+                  <a:srgbClr val="142B1A"/>
                 </a:solidFill>
                 <a:latin typeface="Arial Black" pitchFamily="34" charset="0"/>
                 <a:ea typeface="Arial Black" pitchFamily="34" charset="-122"/>
@@ -2009,7 +2009,7 @@
             <a:r>
               <a:rPr lang="en-US" sz="5800" b="1" dirty="0">
                 <a:solidFill>
-                  <a:srgbClr val="FFFFFF"/>
+                  <a:srgbClr val="F0F5EA"/>
                 </a:solidFill>
                 <a:latin typeface="Arial Black" pitchFamily="34" charset="0"/>
                 <a:ea typeface="Arial Black" pitchFamily="34" charset="-122"/>
@@ -2036,11 +2036,11 @@
             <a:avLst/>
           </a:prstGeom>
           <a:solidFill>
-            <a:srgbClr val="FFFFFF"/>
+            <a:srgbClr val="F0F5EA"/>
           </a:solidFill>
           <a:ln w="12700">
             <a:solidFill>
-              <a:srgbClr val="FFFFFF"/>
+              <a:srgbClr val="F0F5EA"/>
             </a:solidFill>
             <a:prstDash val="solid"/>
           </a:ln>
@@ -2073,7 +2073,7 @@
             <a:r>
               <a:rPr lang="en-US" sz="1800" b="1" dirty="0">
                 <a:solidFill>
-                  <a:srgbClr val="FFFFFF"/>
+                  <a:srgbClr val="F0F5EA"/>
                 </a:solidFill>
                 <a:latin typeface="Arial" pitchFamily="34" charset="0"/>
                 <a:ea typeface="Arial" pitchFamily="34" charset="-122"/>
@@ -2112,7 +2112,7 @@
             <a:r>
               <a:rPr lang="en-US" sz="1400" dirty="0">
                 <a:solidFill>
-                  <a:srgbClr val="B0B0B0"/>
+                  <a:srgbClr val="8FAE8B"/>
                 </a:solidFill>
                 <a:latin typeface="Arial" pitchFamily="34" charset="0"/>
                 <a:ea typeface="Arial" pitchFamily="34" charset="-122"/>
@@ -2151,7 +2151,7 @@
             <a:r>
               <a:rPr lang="en-US" sz="1200" dirty="0">
                 <a:solidFill>
-                  <a:srgbClr val="B0B0B0"/>
+                  <a:srgbClr val="8FAE8B"/>
                 </a:solidFill>
                 <a:latin typeface="Arial" pitchFamily="34" charset="0"/>
                 <a:ea typeface="Arial" pitchFamily="34" charset="-122"/>
@@ -2180,7 +2180,7 @@
     <p:bg>
       <p:bgPr>
         <a:solidFill>
-          <a:srgbClr val="FFFFFF"/>
+          <a:srgbClr val="F0F5EA"/>
         </a:solidFill>
       </p:bgPr>
     </p:bg>
@@ -2225,7 +2225,7 @@
             <a:r>
               <a:rPr lang="en-US" sz="2800" b="1" dirty="0">
                 <a:solidFill>
-                  <a:srgbClr val="E0E0E0"/>
+                  <a:srgbClr val="D8E8C8"/>
                 </a:solidFill>
                 <a:latin typeface="Arial Black" pitchFamily="34" charset="0"/>
                 <a:ea typeface="Arial Black" pitchFamily="34" charset="-122"/>
@@ -2271,7 +2271,7 @@
             <a:r>
               <a:rPr lang="en-US" sz="2800" b="1" dirty="0">
                 <a:solidFill>
-                  <a:srgbClr val="0A0A0A"/>
+                  <a:srgbClr val="2C5F2D"/>
                 </a:solidFill>
                 <a:latin typeface="Arial Black" pitchFamily="34" charset="0"/>
                 <a:ea typeface="Arial Black" pitchFamily="34" charset="-122"/>
@@ -2298,11 +2298,11 @@
             <a:avLst/>
           </a:prstGeom>
           <a:solidFill>
-            <a:srgbClr val="0A0A0A"/>
+            <a:srgbClr val="2C5F2D"/>
           </a:solidFill>
           <a:ln w="12700">
             <a:solidFill>
-              <a:srgbClr val="0A0A0A"/>
+              <a:srgbClr val="2C5F2D"/>
             </a:solidFill>
             <a:prstDash val="solid"/>
           </a:ln>
@@ -2323,11 +2323,11 @@
             <a:avLst/>
           </a:prstGeom>
           <a:solidFill>
-            <a:srgbClr val="E0E0E0"/>
+            <a:srgbClr val="D8E8C8"/>
           </a:solidFill>
           <a:ln w="12700">
             <a:solidFill>
-              <a:srgbClr val="E0E0E0"/>
+              <a:srgbClr val="D8E8C8"/>
             </a:solidFill>
             <a:prstDash val="solid"/>
           </a:ln>
@@ -2348,11 +2348,11 @@
             <a:avLst/>
           </a:prstGeom>
           <a:solidFill>
-            <a:srgbClr val="555555"/>
+            <a:srgbClr val="3E5C42"/>
           </a:solidFill>
           <a:ln w="12700">
             <a:solidFill>
-              <a:srgbClr val="555555"/>
+              <a:srgbClr val="3E5C42"/>
             </a:solidFill>
             <a:prstDash val="solid"/>
           </a:ln>
@@ -2375,7 +2375,7 @@
             </a:avLst>
           </a:prstGeom>
           <a:solidFill>
-            <a:srgbClr val="0A0A0A"/>
+            <a:srgbClr val="1F3D26"/>
           </a:solidFill>
           <a:ln w="12700">
             <a:solidFill>
@@ -2412,7 +2412,7 @@
             <a:r>
               <a:rPr lang="en-US" sz="1600" b="1" dirty="0">
                 <a:solidFill>
-                  <a:srgbClr val="FFFFFF"/>
+                  <a:srgbClr val="F0F5EA"/>
                 </a:solidFill>
                 <a:latin typeface="Arial Black" pitchFamily="34" charset="0"/>
                 <a:ea typeface="Arial Black" pitchFamily="34" charset="-122"/>
@@ -2451,7 +2451,7 @@
             <a:r>
               <a:rPr lang="en-US" sz="1150" dirty="0">
                 <a:solidFill>
-                  <a:srgbClr val="B0B0B0"/>
+                  <a:srgbClr val="8FAE8B"/>
                 </a:solidFill>
                 <a:latin typeface="Arial" pitchFamily="34" charset="0"/>
                 <a:ea typeface="Arial" pitchFamily="34" charset="-122"/>
@@ -2490,7 +2490,7 @@
             <a:r>
               <a:rPr lang="en-US" sz="1000" i="1" dirty="0">
                 <a:solidFill>
-                  <a:srgbClr val="8A8A8A"/>
+                  <a:srgbClr val="8FAE8B"/>
                 </a:solidFill>
                 <a:latin typeface="Arial" pitchFamily="34" charset="0"/>
                 <a:ea typeface="Arial" pitchFamily="34" charset="-122"/>
@@ -2517,11 +2517,11 @@
             <a:avLst/>
           </a:prstGeom>
           <a:solidFill>
-            <a:srgbClr val="E0E0E0"/>
+            <a:srgbClr val="D8E8C8"/>
           </a:solidFill>
           <a:ln w="12700">
             <a:solidFill>
-              <a:srgbClr val="E0E0E0"/>
+              <a:srgbClr val="D8E8C8"/>
             </a:solidFill>
             <a:prstDash val="solid"/>
           </a:ln>
@@ -2542,11 +2542,11 @@
             <a:avLst/>
           </a:prstGeom>
           <a:solidFill>
-            <a:srgbClr val="555555"/>
+            <a:srgbClr val="3E5C42"/>
           </a:solidFill>
           <a:ln w="12700">
             <a:solidFill>
-              <a:srgbClr val="555555"/>
+              <a:srgbClr val="3E5C42"/>
             </a:solidFill>
             <a:prstDash val="solid"/>
           </a:ln>
@@ -2569,7 +2569,7 @@
             </a:avLst>
           </a:prstGeom>
           <a:solidFill>
-            <a:srgbClr val="0A0A0A"/>
+            <a:srgbClr val="1F3D26"/>
           </a:solidFill>
           <a:ln w="12700">
             <a:solidFill>
@@ -2606,7 +2606,7 @@
             <a:r>
               <a:rPr lang="en-US" sz="1600" b="1" dirty="0">
                 <a:solidFill>
-                  <a:srgbClr val="FFFFFF"/>
+                  <a:srgbClr val="F0F5EA"/>
                 </a:solidFill>
                 <a:latin typeface="Arial Black" pitchFamily="34" charset="0"/>
                 <a:ea typeface="Arial Black" pitchFamily="34" charset="-122"/>
@@ -2645,7 +2645,7 @@
             <a:r>
               <a:rPr lang="en-US" sz="1150" dirty="0">
                 <a:solidFill>
-                  <a:srgbClr val="B0B0B0"/>
+                  <a:srgbClr val="8FAE8B"/>
                 </a:solidFill>
                 <a:latin typeface="Arial" pitchFamily="34" charset="0"/>
                 <a:ea typeface="Arial" pitchFamily="34" charset="-122"/>
@@ -2684,7 +2684,7 @@
             <a:r>
               <a:rPr lang="en-US" sz="1000" i="1" dirty="0">
                 <a:solidFill>
-                  <a:srgbClr val="8A8A8A"/>
+                  <a:srgbClr val="8FAE8B"/>
                 </a:solidFill>
                 <a:latin typeface="Arial" pitchFamily="34" charset="0"/>
                 <a:ea typeface="Arial" pitchFamily="34" charset="-122"/>
@@ -2711,11 +2711,11 @@
             <a:avLst/>
           </a:prstGeom>
           <a:solidFill>
-            <a:srgbClr val="E0E0E0"/>
+            <a:srgbClr val="D8E8C8"/>
           </a:solidFill>
           <a:ln w="12700">
             <a:solidFill>
-              <a:srgbClr val="E0E0E0"/>
+              <a:srgbClr val="D8E8C8"/>
             </a:solidFill>
             <a:prstDash val="solid"/>
           </a:ln>
@@ -2736,11 +2736,11 @@
             <a:avLst/>
           </a:prstGeom>
           <a:solidFill>
-            <a:srgbClr val="555555"/>
+            <a:srgbClr val="3E5C42"/>
           </a:solidFill>
           <a:ln w="12700">
             <a:solidFill>
-              <a:srgbClr val="555555"/>
+              <a:srgbClr val="3E5C42"/>
             </a:solidFill>
             <a:prstDash val="solid"/>
           </a:ln>
@@ -2763,7 +2763,7 @@
             </a:avLst>
           </a:prstGeom>
           <a:solidFill>
-            <a:srgbClr val="0A0A0A"/>
+            <a:srgbClr val="1F3D26"/>
           </a:solidFill>
           <a:ln w="12700">
             <a:solidFill>
@@ -2800,7 +2800,7 @@
             <a:r>
               <a:rPr lang="en-US" sz="1600" b="1" dirty="0">
                 <a:solidFill>
-                  <a:srgbClr val="FFFFFF"/>
+                  <a:srgbClr val="F0F5EA"/>
                 </a:solidFill>
                 <a:latin typeface="Arial Black" pitchFamily="34" charset="0"/>
                 <a:ea typeface="Arial Black" pitchFamily="34" charset="-122"/>
@@ -2839,7 +2839,7 @@
             <a:r>
               <a:rPr lang="en-US" sz="1150" dirty="0">
                 <a:solidFill>
-                  <a:srgbClr val="B0B0B0"/>
+                  <a:srgbClr val="8FAE8B"/>
                 </a:solidFill>
                 <a:latin typeface="Arial" pitchFamily="34" charset="0"/>
                 <a:ea typeface="Arial" pitchFamily="34" charset="-122"/>
@@ -2878,7 +2878,7 @@
             <a:r>
               <a:rPr lang="en-US" sz="1000" i="1" dirty="0">
                 <a:solidFill>
-                  <a:srgbClr val="8A8A8A"/>
+                  <a:srgbClr val="8FAE8B"/>
                 </a:solidFill>
                 <a:latin typeface="Arial" pitchFamily="34" charset="0"/>
                 <a:ea typeface="Arial" pitchFamily="34" charset="-122"/>
@@ -2917,7 +2917,7 @@
             <a:r>
               <a:rPr lang="en-US" sz="1300" b="1" dirty="0">
                 <a:solidFill>
-                  <a:srgbClr val="0A0A0A"/>
+                  <a:srgbClr val="2C5F2D"/>
                 </a:solidFill>
                 <a:latin typeface="Arial Black" pitchFamily="34" charset="0"/>
                 <a:ea typeface="Arial Black" pitchFamily="34" charset="-122"/>
@@ -2956,7 +2956,7 @@
             <a:r>
               <a:rPr lang="en-US" sz="850" dirty="0">
                 <a:solidFill>
-                  <a:srgbClr val="6E6E6E"/>
+                  <a:srgbClr val="5A6B5A"/>
                 </a:solidFill>
                 <a:latin typeface="Arial" pitchFamily="34" charset="0"/>
                 <a:ea typeface="Arial" pitchFamily="34" charset="-122"/>
@@ -2985,7 +2985,7 @@
     <p:bg>
       <p:bgPr>
         <a:solidFill>
-          <a:srgbClr val="FFFFFF"/>
+          <a:srgbClr val="F0F5EA"/>
         </a:solidFill>
       </p:bgPr>
     </p:bg>
@@ -3030,7 +3030,7 @@
             <a:r>
               <a:rPr lang="en-US" sz="2800" b="1" dirty="0">
                 <a:solidFill>
-                  <a:srgbClr val="E0E0E0"/>
+                  <a:srgbClr val="D8E8C8"/>
                 </a:solidFill>
                 <a:latin typeface="Arial Black" pitchFamily="34" charset="0"/>
                 <a:ea typeface="Arial Black" pitchFamily="34" charset="-122"/>
@@ -3076,7 +3076,7 @@
             <a:r>
               <a:rPr lang="en-US" sz="2800" b="1" dirty="0">
                 <a:solidFill>
-                  <a:srgbClr val="0A0A0A"/>
+                  <a:srgbClr val="2C5F2D"/>
                 </a:solidFill>
                 <a:latin typeface="Arial Black" pitchFamily="34" charset="0"/>
                 <a:ea typeface="Arial Black" pitchFamily="34" charset="-122"/>
@@ -3103,11 +3103,11 @@
             <a:avLst/>
           </a:prstGeom>
           <a:solidFill>
-            <a:srgbClr val="0A0A0A"/>
+            <a:srgbClr val="2C5F2D"/>
           </a:solidFill>
           <a:ln w="12700">
             <a:solidFill>
-              <a:srgbClr val="0A0A0A"/>
+              <a:srgbClr val="2C5F2D"/>
             </a:solidFill>
             <a:prstDash val="solid"/>
           </a:ln>
@@ -3128,11 +3128,11 @@
             <a:avLst/>
           </a:prstGeom>
           <a:solidFill>
-            <a:srgbClr val="E0E0E0"/>
+            <a:srgbClr val="D8E8C8"/>
           </a:solidFill>
           <a:ln w="12700">
             <a:solidFill>
-              <a:srgbClr val="E0E0E0"/>
+              <a:srgbClr val="D8E8C8"/>
             </a:solidFill>
             <a:prstDash val="solid"/>
           </a:ln>
@@ -3155,11 +3155,11 @@
             </a:avLst>
           </a:prstGeom>
           <a:solidFill>
-            <a:srgbClr val="FFFFFF"/>
+            <a:srgbClr val="F0F5EA"/>
           </a:solidFill>
           <a:ln w="25400">
             <a:solidFill>
-              <a:srgbClr val="0A0A0A"/>
+              <a:srgbClr val="2C5F2D"/>
             </a:solidFill>
             <a:prstDash val="solid"/>
           </a:ln>
@@ -3192,7 +3192,7 @@
             <a:r>
               <a:rPr lang="en-US" sz="1300" b="1" dirty="0">
                 <a:solidFill>
-                  <a:srgbClr val="0A0A0A"/>
+                  <a:srgbClr val="2C5F2D"/>
                 </a:solidFill>
                 <a:latin typeface="Arial Black" pitchFamily="34" charset="0"/>
                 <a:ea typeface="Arial Black" pitchFamily="34" charset="-122"/>
@@ -3231,7 +3231,7 @@
             <a:r>
               <a:rPr lang="en-US" sz="1600" b="1" dirty="0">
                 <a:solidFill>
-                  <a:srgbClr val="0A0A0A"/>
+                  <a:srgbClr val="2C5F2D"/>
                 </a:solidFill>
                 <a:latin typeface="Arial Black" pitchFamily="34" charset="0"/>
                 <a:ea typeface="Arial Black" pitchFamily="34" charset="-122"/>
@@ -3270,7 +3270,7 @@
             <a:r>
               <a:rPr lang="en-US" sz="1250" dirty="0">
                 <a:solidFill>
-                  <a:srgbClr val="0A0A0A"/>
+                  <a:srgbClr val="2C5F2D"/>
                 </a:solidFill>
                 <a:latin typeface="Arial" pitchFamily="34" charset="0"/>
                 <a:ea typeface="Arial" pitchFamily="34" charset="-122"/>
@@ -3309,7 +3309,7 @@
             <a:r>
               <a:rPr lang="en-US" sz="1100" dirty="0">
                 <a:solidFill>
-                  <a:srgbClr val="0A0A0A"/>
+                  <a:srgbClr val="2C5F2D"/>
                 </a:solidFill>
                 <a:latin typeface="Arial" pitchFamily="34" charset="0"/>
                 <a:ea typeface="Arial" pitchFamily="34" charset="-122"/>
@@ -3336,11 +3336,11 @@
             <a:avLst/>
           </a:prstGeom>
           <a:solidFill>
-            <a:srgbClr val="E0E0E0"/>
+            <a:srgbClr val="D8E8C8"/>
           </a:solidFill>
           <a:ln w="12700">
             <a:solidFill>
-              <a:srgbClr val="E0E0E0"/>
+              <a:srgbClr val="D8E8C8"/>
             </a:solidFill>
             <a:prstDash val="solid"/>
           </a:ln>
@@ -3363,11 +3363,11 @@
             </a:avLst>
           </a:prstGeom>
           <a:solidFill>
-            <a:srgbClr val="FFFFFF"/>
+            <a:srgbClr val="F0F5EA"/>
           </a:solidFill>
           <a:ln w="25400">
             <a:solidFill>
-              <a:srgbClr val="0A0A0A"/>
+              <a:srgbClr val="2C5F2D"/>
             </a:solidFill>
             <a:prstDash val="solid"/>
           </a:ln>
@@ -3400,7 +3400,7 @@
             <a:r>
               <a:rPr lang="en-US" sz="1300" b="1" dirty="0">
                 <a:solidFill>
-                  <a:srgbClr val="0A0A0A"/>
+                  <a:srgbClr val="2C5F2D"/>
                 </a:solidFill>
                 <a:latin typeface="Arial Black" pitchFamily="34" charset="0"/>
                 <a:ea typeface="Arial Black" pitchFamily="34" charset="-122"/>
@@ -3439,7 +3439,7 @@
             <a:r>
               <a:rPr lang="en-US" sz="1200" dirty="0">
                 <a:solidFill>
-                  <a:srgbClr val="0A0A0A"/>
+                  <a:srgbClr val="2C5F2D"/>
                 </a:solidFill>
                 <a:latin typeface="Arial" pitchFamily="34" charset="0"/>
                 <a:ea typeface="Arial" pitchFamily="34" charset="-122"/>
@@ -3478,7 +3478,7 @@
             <a:r>
               <a:rPr lang="en-US" sz="1200" dirty="0">
                 <a:solidFill>
-                  <a:srgbClr val="0A0A0A"/>
+                  <a:srgbClr val="2C5F2D"/>
                 </a:solidFill>
                 <a:latin typeface="Arial" pitchFamily="34" charset="0"/>
                 <a:ea typeface="Arial" pitchFamily="34" charset="-122"/>
@@ -3517,7 +3517,7 @@
             <a:r>
               <a:rPr lang="en-US" sz="1200" dirty="0">
                 <a:solidFill>
-                  <a:srgbClr val="0A0A0A"/>
+                  <a:srgbClr val="2C5F2D"/>
                 </a:solidFill>
                 <a:latin typeface="Arial" pitchFamily="34" charset="0"/>
                 <a:ea typeface="Arial" pitchFamily="34" charset="-122"/>
@@ -3556,7 +3556,7 @@
             <a:r>
               <a:rPr lang="en-US" sz="1450" b="1" dirty="0">
                 <a:solidFill>
-                  <a:srgbClr val="E0E0E0"/>
+                  <a:srgbClr val="D8E8C8"/>
                 </a:solidFill>
                 <a:latin typeface="Arial Black" pitchFamily="34" charset="0"/>
                 <a:ea typeface="Arial Black" pitchFamily="34" charset="-122"/>
@@ -3602,7 +3602,7 @@
             <a:r>
               <a:rPr lang="en-US" sz="1450" b="1" dirty="0">
                 <a:solidFill>
-                  <a:srgbClr val="0A0A0A"/>
+                  <a:srgbClr val="2C5F2D"/>
                 </a:solidFill>
                 <a:latin typeface="Arial Black" pitchFamily="34" charset="0"/>
                 <a:ea typeface="Arial Black" pitchFamily="34" charset="-122"/>
@@ -3641,7 +3641,7 @@
             <a:r>
               <a:rPr lang="en-US" sz="1000" i="1" dirty="0">
                 <a:solidFill>
-                  <a:srgbClr val="6E6E6E"/>
+                  <a:srgbClr val="5A6B5A"/>
                 </a:solidFill>
                 <a:latin typeface="Arial" pitchFamily="34" charset="0"/>
                 <a:ea typeface="Arial" pitchFamily="34" charset="-122"/>
@@ -3680,7 +3680,7 @@
             <a:r>
               <a:rPr lang="en-US" sz="850" dirty="0">
                 <a:solidFill>
-                  <a:srgbClr val="6E6E6E"/>
+                  <a:srgbClr val="5A6B5A"/>
                 </a:solidFill>
                 <a:latin typeface="Arial" pitchFamily="34" charset="0"/>
                 <a:ea typeface="Arial" pitchFamily="34" charset="-122"/>
@@ -3709,7 +3709,7 @@
     <p:bg>
       <p:bgPr>
         <a:solidFill>
-          <a:srgbClr val="FFFFFF"/>
+          <a:srgbClr val="F0F5EA"/>
         </a:solidFill>
       </p:bgPr>
     </p:bg>
@@ -3754,7 +3754,7 @@
             <a:r>
               <a:rPr lang="en-US" sz="2800" b="1" dirty="0">
                 <a:solidFill>
-                  <a:srgbClr val="E0E0E0"/>
+                  <a:srgbClr val="D8E8C8"/>
                 </a:solidFill>
                 <a:latin typeface="Arial Black" pitchFamily="34" charset="0"/>
                 <a:ea typeface="Arial Black" pitchFamily="34" charset="-122"/>
@@ -3800,7 +3800,7 @@
             <a:r>
               <a:rPr lang="en-US" sz="2800" b="1" dirty="0">
                 <a:solidFill>
-                  <a:srgbClr val="0A0A0A"/>
+                  <a:srgbClr val="2C5F2D"/>
                 </a:solidFill>
                 <a:latin typeface="Arial Black" pitchFamily="34" charset="0"/>
                 <a:ea typeface="Arial Black" pitchFamily="34" charset="-122"/>
@@ -3827,11 +3827,11 @@
             <a:avLst/>
           </a:prstGeom>
           <a:solidFill>
-            <a:srgbClr val="0A0A0A"/>
+            <a:srgbClr val="2C5F2D"/>
           </a:solidFill>
           <a:ln w="12700">
             <a:solidFill>
-              <a:srgbClr val="0A0A0A"/>
+              <a:srgbClr val="2C5F2D"/>
             </a:solidFill>
             <a:prstDash val="solid"/>
           </a:ln>
@@ -3852,11 +3852,11 @@
             <a:avLst/>
           </a:prstGeom>
           <a:solidFill>
-            <a:srgbClr val="E0E0E0"/>
+            <a:srgbClr val="D8E8C8"/>
           </a:solidFill>
           <a:ln w="12700">
             <a:solidFill>
-              <a:srgbClr val="E0E0E0"/>
+              <a:srgbClr val="D8E8C8"/>
             </a:solidFill>
             <a:prstDash val="solid"/>
           </a:ln>
@@ -3879,11 +3879,11 @@
             </a:avLst>
           </a:prstGeom>
           <a:solidFill>
-            <a:srgbClr val="FFFFFF"/>
+            <a:srgbClr val="F0F5EA"/>
           </a:solidFill>
           <a:ln w="19050">
             <a:solidFill>
-              <a:srgbClr val="0A0A0A"/>
+              <a:srgbClr val="2C5F2D"/>
             </a:solidFill>
             <a:prstDash val="solid"/>
           </a:ln>
@@ -3904,7 +3904,7 @@
             <a:avLst/>
           </a:prstGeom>
           <a:solidFill>
-            <a:srgbClr val="0A0A0A"/>
+            <a:srgbClr val="1F3D26"/>
           </a:solidFill>
           <a:ln/>
         </p:spPr>
@@ -3936,7 +3936,7 @@
             <a:r>
               <a:rPr lang="en-US" sz="2000" b="1" dirty="0">
                 <a:solidFill>
-                  <a:srgbClr val="FFFFFF"/>
+                  <a:srgbClr val="F0F5EA"/>
                 </a:solidFill>
                 <a:latin typeface="Arial" pitchFamily="34" charset="0"/>
                 <a:ea typeface="Arial" pitchFamily="34" charset="-122"/>
@@ -3975,7 +3975,7 @@
             <a:r>
               <a:rPr lang="en-US" sz="1500" b="1" dirty="0">
                 <a:solidFill>
-                  <a:srgbClr val="0A0A0A"/>
+                  <a:srgbClr val="2C5F2D"/>
                 </a:solidFill>
                 <a:latin typeface="Arial Black" pitchFamily="34" charset="0"/>
                 <a:ea typeface="Arial Black" pitchFamily="34" charset="-122"/>
@@ -4014,7 +4014,7 @@
             <a:r>
               <a:rPr lang="en-US" sz="1150" dirty="0">
                 <a:solidFill>
-                  <a:srgbClr val="6E6E6E"/>
+                  <a:srgbClr val="5A6B5A"/>
                 </a:solidFill>
                 <a:latin typeface="Arial" pitchFamily="34" charset="0"/>
                 <a:ea typeface="Arial" pitchFamily="34" charset="-122"/>
@@ -4053,7 +4053,7 @@
             <a:r>
               <a:rPr lang="en-US" sz="950" i="1" dirty="0">
                 <a:solidFill>
-                  <a:srgbClr val="6E6E6E"/>
+                  <a:srgbClr val="5A6B5A"/>
                 </a:solidFill>
                 <a:latin typeface="Arial" pitchFamily="34" charset="0"/>
                 <a:ea typeface="Arial" pitchFamily="34" charset="-122"/>
@@ -4080,11 +4080,11 @@
             <a:avLst/>
           </a:prstGeom>
           <a:solidFill>
-            <a:srgbClr val="E0E0E0"/>
+            <a:srgbClr val="D8E8C8"/>
           </a:solidFill>
           <a:ln w="12700">
             <a:solidFill>
-              <a:srgbClr val="E0E0E0"/>
+              <a:srgbClr val="D8E8C8"/>
             </a:solidFill>
             <a:prstDash val="solid"/>
           </a:ln>
@@ -4107,11 +4107,11 @@
             </a:avLst>
           </a:prstGeom>
           <a:solidFill>
-            <a:srgbClr val="FFFFFF"/>
+            <a:srgbClr val="F0F5EA"/>
           </a:solidFill>
           <a:ln w="19050">
             <a:solidFill>
-              <a:srgbClr val="0A0A0A"/>
+              <a:srgbClr val="2C5F2D"/>
             </a:solidFill>
             <a:prstDash val="solid"/>
           </a:ln>
@@ -4132,7 +4132,7 @@
             <a:avLst/>
           </a:prstGeom>
           <a:solidFill>
-            <a:srgbClr val="0A0A0A"/>
+            <a:srgbClr val="1F3D26"/>
           </a:solidFill>
           <a:ln/>
         </p:spPr>
@@ -4164,7 +4164,7 @@
             <a:r>
               <a:rPr lang="en-US" sz="2000" b="1" dirty="0">
                 <a:solidFill>
-                  <a:srgbClr val="FFFFFF"/>
+                  <a:srgbClr val="F0F5EA"/>
                 </a:solidFill>
                 <a:latin typeface="Arial" pitchFamily="34" charset="0"/>
                 <a:ea typeface="Arial" pitchFamily="34" charset="-122"/>
@@ -4203,7 +4203,7 @@
             <a:r>
               <a:rPr lang="en-US" sz="1500" b="1" dirty="0">
                 <a:solidFill>
-                  <a:srgbClr val="0A0A0A"/>
+                  <a:srgbClr val="2C5F2D"/>
                 </a:solidFill>
                 <a:latin typeface="Arial Black" pitchFamily="34" charset="0"/>
                 <a:ea typeface="Arial Black" pitchFamily="34" charset="-122"/>
@@ -4242,7 +4242,7 @@
             <a:r>
               <a:rPr lang="en-US" sz="1150" dirty="0">
                 <a:solidFill>
-                  <a:srgbClr val="6E6E6E"/>
+                  <a:srgbClr val="5A6B5A"/>
                 </a:solidFill>
                 <a:latin typeface="Arial" pitchFamily="34" charset="0"/>
                 <a:ea typeface="Arial" pitchFamily="34" charset="-122"/>
@@ -4281,7 +4281,7 @@
             <a:r>
               <a:rPr lang="en-US" sz="950" i="1" dirty="0">
                 <a:solidFill>
-                  <a:srgbClr val="6E6E6E"/>
+                  <a:srgbClr val="5A6B5A"/>
                 </a:solidFill>
                 <a:latin typeface="Arial" pitchFamily="34" charset="0"/>
                 <a:ea typeface="Arial" pitchFamily="34" charset="-122"/>
@@ -4308,11 +4308,11 @@
             <a:avLst/>
           </a:prstGeom>
           <a:solidFill>
-            <a:srgbClr val="E0E0E0"/>
+            <a:srgbClr val="D8E8C8"/>
           </a:solidFill>
           <a:ln w="12700">
             <a:solidFill>
-              <a:srgbClr val="E0E0E0"/>
+              <a:srgbClr val="D8E8C8"/>
             </a:solidFill>
             <a:prstDash val="solid"/>
           </a:ln>
@@ -4335,11 +4335,11 @@
             </a:avLst>
           </a:prstGeom>
           <a:solidFill>
-            <a:srgbClr val="FFFFFF"/>
+            <a:srgbClr val="F0F5EA"/>
           </a:solidFill>
           <a:ln w="19050">
             <a:solidFill>
-              <a:srgbClr val="0A0A0A"/>
+              <a:srgbClr val="2C5F2D"/>
             </a:solidFill>
             <a:prstDash val="solid"/>
           </a:ln>
@@ -4360,7 +4360,7 @@
             <a:avLst/>
           </a:prstGeom>
           <a:solidFill>
-            <a:srgbClr val="0A0A0A"/>
+            <a:srgbClr val="1F3D26"/>
           </a:solidFill>
           <a:ln/>
         </p:spPr>
@@ -4392,7 +4392,7 @@
             <a:r>
               <a:rPr lang="en-US" sz="2000" b="1" dirty="0">
                 <a:solidFill>
-                  <a:srgbClr val="FFFFFF"/>
+                  <a:srgbClr val="F0F5EA"/>
                 </a:solidFill>
                 <a:latin typeface="Arial" pitchFamily="34" charset="0"/>
                 <a:ea typeface="Arial" pitchFamily="34" charset="-122"/>
@@ -4431,7 +4431,7 @@
             <a:r>
               <a:rPr lang="en-US" sz="1500" b="1" dirty="0">
                 <a:solidFill>
-                  <a:srgbClr val="0A0A0A"/>
+                  <a:srgbClr val="2C5F2D"/>
                 </a:solidFill>
                 <a:latin typeface="Arial Black" pitchFamily="34" charset="0"/>
                 <a:ea typeface="Arial Black" pitchFamily="34" charset="-122"/>
@@ -4470,7 +4470,7 @@
             <a:r>
               <a:rPr lang="en-US" sz="1150" dirty="0">
                 <a:solidFill>
-                  <a:srgbClr val="6E6E6E"/>
+                  <a:srgbClr val="5A6B5A"/>
                 </a:solidFill>
                 <a:latin typeface="Arial" pitchFamily="34" charset="0"/>
                 <a:ea typeface="Arial" pitchFamily="34" charset="-122"/>
@@ -4509,7 +4509,7 @@
             <a:r>
               <a:rPr lang="en-US" sz="950" i="1" dirty="0">
                 <a:solidFill>
-                  <a:srgbClr val="6E6E6E"/>
+                  <a:srgbClr val="5A6B5A"/>
                 </a:solidFill>
                 <a:latin typeface="Arial" pitchFamily="34" charset="0"/>
                 <a:ea typeface="Arial" pitchFamily="34" charset="-122"/>
@@ -4548,7 +4548,7 @@
             <a:r>
               <a:rPr lang="en-US" sz="1300" b="1" dirty="0">
                 <a:solidFill>
-                  <a:srgbClr val="0A0A0A"/>
+                  <a:srgbClr val="2C5F2D"/>
                 </a:solidFill>
                 <a:latin typeface="Arial Black" pitchFamily="34" charset="0"/>
                 <a:ea typeface="Arial Black" pitchFamily="34" charset="-122"/>
@@ -4587,7 +4587,7 @@
             <a:r>
               <a:rPr lang="en-US" sz="850" dirty="0">
                 <a:solidFill>
-                  <a:srgbClr val="6E6E6E"/>
+                  <a:srgbClr val="5A6B5A"/>
                 </a:solidFill>
                 <a:latin typeface="Arial" pitchFamily="34" charset="0"/>
                 <a:ea typeface="Arial" pitchFamily="34" charset="-122"/>
@@ -4616,7 +4616,7 @@
     <p:bg>
       <p:bgPr>
         <a:solidFill>
-          <a:srgbClr val="0A0A0A"/>
+          <a:srgbClr val="1F3D26"/>
         </a:solidFill>
       </p:bgPr>
     </p:bg>
@@ -4661,7 +4661,7 @@
             <a:r>
               <a:rPr lang="en-US" sz="4000" b="1" dirty="0">
                 <a:solidFill>
-                  <a:srgbClr val="2A2A2A"/>
+                  <a:srgbClr val="142B1A"/>
                 </a:solidFill>
                 <a:latin typeface="Arial Black" pitchFamily="34" charset="0"/>
                 <a:ea typeface="Arial Black" pitchFamily="34" charset="-122"/>
@@ -4700,7 +4700,7 @@
             <a:r>
               <a:rPr lang="en-US" sz="4000" b="1" dirty="0">
                 <a:solidFill>
-                  <a:srgbClr val="FFFFFF"/>
+                  <a:srgbClr val="F0F5EA"/>
                 </a:solidFill>
                 <a:latin typeface="Arial Black" pitchFamily="34" charset="0"/>
                 <a:ea typeface="Arial Black" pitchFamily="34" charset="-122"/>
@@ -4739,7 +4739,7 @@
             <a:r>
               <a:rPr lang="en-US" sz="1500" dirty="0">
                 <a:solidFill>
-                  <a:srgbClr val="B0B0B0"/>
+                  <a:srgbClr val="8FAE8B"/>
                 </a:solidFill>
                 <a:latin typeface="Arial" pitchFamily="34" charset="0"/>
                 <a:ea typeface="Arial" pitchFamily="34" charset="-122"/>
@@ -4766,11 +4766,11 @@
             <a:avLst/>
           </a:prstGeom>
           <a:solidFill>
-            <a:srgbClr val="2A2A2A"/>
+            <a:srgbClr val="142B1A"/>
           </a:solidFill>
           <a:ln w="12700">
             <a:solidFill>
-              <a:srgbClr val="2A2A2A"/>
+              <a:srgbClr val="142B1A"/>
             </a:solidFill>
             <a:prstDash val="solid"/>
           </a:ln>
@@ -4793,11 +4793,11 @@
             </a:avLst>
           </a:prstGeom>
           <a:solidFill>
-            <a:srgbClr val="161616"/>
+            <a:srgbClr val="2A4A33"/>
           </a:solidFill>
           <a:ln w="12700">
             <a:solidFill>
-              <a:srgbClr val="2A2A2A"/>
+              <a:srgbClr val="142B1A"/>
             </a:solidFill>
             <a:prstDash val="solid"/>
           </a:ln>
@@ -4818,11 +4818,11 @@
             <a:avLst/>
           </a:prstGeom>
           <a:solidFill>
-            <a:srgbClr val="FF5A1F"/>
+            <a:srgbClr val="97BC62"/>
           </a:solidFill>
           <a:ln w="12700">
             <a:solidFill>
-              <a:srgbClr val="FF5A1F"/>
+              <a:srgbClr val="97BC62"/>
             </a:solidFill>
             <a:prstDash val="solid"/>
           </a:ln>
@@ -4855,7 +4855,7 @@
             <a:r>
               <a:rPr lang="en-US" sz="1200" dirty="0">
                 <a:solidFill>
-                  <a:srgbClr val="FFFFFF"/>
+                  <a:srgbClr val="F0F5EA"/>
                 </a:solidFill>
                 <a:latin typeface="Arial" pitchFamily="34" charset="0"/>
                 <a:ea typeface="Arial" pitchFamily="34" charset="-122"/>
@@ -4894,7 +4894,7 @@
             <a:r>
               <a:rPr lang="en-US" sz="1250" dirty="0">
                 <a:solidFill>
-                  <a:srgbClr val="B0B0B0"/>
+                  <a:srgbClr val="8FAE8B"/>
                 </a:solidFill>
                 <a:latin typeface="Arial" pitchFamily="34" charset="0"/>
                 <a:ea typeface="Arial" pitchFamily="34" charset="-122"/>
@@ -4923,7 +4923,7 @@
     <p:bg>
       <p:bgPr>
         <a:solidFill>
-          <a:srgbClr val="FFFFFF"/>
+          <a:srgbClr val="F0F5EA"/>
         </a:solidFill>
       </p:bgPr>
     </p:bg>
@@ -4968,7 +4968,7 @@
             <a:r>
               <a:rPr lang="en-US" sz="2800" b="1" dirty="0">
                 <a:solidFill>
-                  <a:srgbClr val="E0E0E0"/>
+                  <a:srgbClr val="D8E8C8"/>
                 </a:solidFill>
                 <a:latin typeface="Arial Black" pitchFamily="34" charset="0"/>
                 <a:ea typeface="Arial Black" pitchFamily="34" charset="-122"/>
@@ -5014,7 +5014,7 @@
             <a:r>
               <a:rPr lang="en-US" sz="2800" b="1" dirty="0">
                 <a:solidFill>
-                  <a:srgbClr val="0A0A0A"/>
+                  <a:srgbClr val="2C5F2D"/>
                 </a:solidFill>
                 <a:latin typeface="Arial Black" pitchFamily="34" charset="0"/>
                 <a:ea typeface="Arial Black" pitchFamily="34" charset="-122"/>
@@ -5041,11 +5041,11 @@
             <a:avLst/>
           </a:prstGeom>
           <a:solidFill>
-            <a:srgbClr val="0A0A0A"/>
+            <a:srgbClr val="2C5F2D"/>
           </a:solidFill>
           <a:ln w="12700">
             <a:solidFill>
-              <a:srgbClr val="0A0A0A"/>
+              <a:srgbClr val="2C5F2D"/>
             </a:solidFill>
             <a:prstDash val="solid"/>
           </a:ln>
@@ -5066,11 +5066,11 @@
             <a:avLst/>
           </a:prstGeom>
           <a:solidFill>
-            <a:srgbClr val="E0E0E0"/>
+            <a:srgbClr val="D8E8C8"/>
           </a:solidFill>
           <a:ln w="12700">
             <a:solidFill>
-              <a:srgbClr val="E0E0E0"/>
+              <a:srgbClr val="D8E8C8"/>
             </a:solidFill>
             <a:prstDash val="solid"/>
           </a:ln>
@@ -5093,7 +5093,7 @@
             </a:avLst>
           </a:prstGeom>
           <a:solidFill>
-            <a:srgbClr val="0A0A0A"/>
+            <a:srgbClr val="1F3D26"/>
           </a:solidFill>
           <a:ln w="12700">
             <a:solidFill>
@@ -5118,11 +5118,11 @@
             <a:avLst/>
           </a:prstGeom>
           <a:solidFill>
-            <a:srgbClr val="FF5A1F"/>
+            <a:srgbClr val="97BC62"/>
           </a:solidFill>
           <a:ln w="12700">
             <a:solidFill>
-              <a:srgbClr val="FF5A1F"/>
+              <a:srgbClr val="97BC62"/>
             </a:solidFill>
             <a:prstDash val="solid"/>
           </a:ln>
@@ -5155,7 +5155,7 @@
             <a:r>
               <a:rPr lang="en-US" sz="1450" i="1" dirty="0">
                 <a:solidFill>
-                  <a:srgbClr val="FFFFFF"/>
+                  <a:srgbClr val="F0F5EA"/>
                 </a:solidFill>
                 <a:latin typeface="Arial" pitchFamily="34" charset="0"/>
                 <a:ea typeface="Arial" pitchFamily="34" charset="-122"/>
@@ -5182,11 +5182,11 @@
             <a:avLst/>
           </a:prstGeom>
           <a:solidFill>
-            <a:srgbClr val="E0E0E0"/>
+            <a:srgbClr val="D8E8C8"/>
           </a:solidFill>
           <a:ln w="12700">
             <a:solidFill>
-              <a:srgbClr val="E0E0E0"/>
+              <a:srgbClr val="D8E8C8"/>
             </a:solidFill>
             <a:prstDash val="solid"/>
           </a:ln>
@@ -5207,11 +5207,11 @@
             <a:avLst/>
           </a:prstGeom>
           <a:solidFill>
-            <a:srgbClr val="555555"/>
+            <a:srgbClr val="3E5C42"/>
           </a:solidFill>
           <a:ln w="12700">
             <a:solidFill>
-              <a:srgbClr val="555555"/>
+              <a:srgbClr val="3E5C42"/>
             </a:solidFill>
             <a:prstDash val="solid"/>
           </a:ln>
@@ -5234,7 +5234,7 @@
             </a:avLst>
           </a:prstGeom>
           <a:solidFill>
-            <a:srgbClr val="0A0A0A"/>
+            <a:srgbClr val="1F3D26"/>
           </a:solidFill>
           <a:ln w="12700">
             <a:solidFill>
@@ -5259,11 +5259,11 @@
             <a:avLst/>
           </a:prstGeom>
           <a:solidFill>
-            <a:srgbClr val="FF5A1F"/>
+            <a:srgbClr val="97BC62"/>
           </a:solidFill>
           <a:ln w="12700">
             <a:solidFill>
-              <a:srgbClr val="FF5A1F"/>
+              <a:srgbClr val="97BC62"/>
             </a:solidFill>
             <a:prstDash val="solid"/>
           </a:ln>
@@ -5296,7 +5296,7 @@
             <a:r>
               <a:rPr lang="en-US" sz="3200" b="1" dirty="0">
                 <a:solidFill>
-                  <a:srgbClr val="FFFFFF"/>
+                  <a:srgbClr val="F0F5EA"/>
                 </a:solidFill>
                 <a:latin typeface="Arial Black" pitchFamily="34" charset="0"/>
                 <a:ea typeface="Arial Black" pitchFamily="34" charset="-122"/>
@@ -5335,7 +5335,7 @@
             <a:r>
               <a:rPr lang="en-US" sz="1000" dirty="0">
                 <a:solidFill>
-                  <a:srgbClr val="B0B0B0"/>
+                  <a:srgbClr val="8FAE8B"/>
                 </a:solidFill>
                 <a:latin typeface="Arial" pitchFamily="34" charset="0"/>
                 <a:ea typeface="Arial" pitchFamily="34" charset="-122"/>
@@ -5362,11 +5362,11 @@
             <a:avLst/>
           </a:prstGeom>
           <a:solidFill>
-            <a:srgbClr val="E0E0E0"/>
+            <a:srgbClr val="D8E8C8"/>
           </a:solidFill>
           <a:ln w="12700">
             <a:solidFill>
-              <a:srgbClr val="E0E0E0"/>
+              <a:srgbClr val="D8E8C8"/>
             </a:solidFill>
             <a:prstDash val="solid"/>
           </a:ln>
@@ -5387,11 +5387,11 @@
             <a:avLst/>
           </a:prstGeom>
           <a:solidFill>
-            <a:srgbClr val="555555"/>
+            <a:srgbClr val="3E5C42"/>
           </a:solidFill>
           <a:ln w="12700">
             <a:solidFill>
-              <a:srgbClr val="555555"/>
+              <a:srgbClr val="3E5C42"/>
             </a:solidFill>
             <a:prstDash val="solid"/>
           </a:ln>
@@ -5414,7 +5414,7 @@
             </a:avLst>
           </a:prstGeom>
           <a:solidFill>
-            <a:srgbClr val="0A0A0A"/>
+            <a:srgbClr val="1F3D26"/>
           </a:solidFill>
           <a:ln w="12700">
             <a:solidFill>
@@ -5439,11 +5439,11 @@
             <a:avLst/>
           </a:prstGeom>
           <a:solidFill>
-            <a:srgbClr val="FF5A1F"/>
+            <a:srgbClr val="97BC62"/>
           </a:solidFill>
           <a:ln w="12700">
             <a:solidFill>
-              <a:srgbClr val="FF5A1F"/>
+              <a:srgbClr val="97BC62"/>
             </a:solidFill>
             <a:prstDash val="solid"/>
           </a:ln>
@@ -5476,7 +5476,7 @@
             <a:r>
               <a:rPr lang="en-US" sz="3200" b="1" dirty="0">
                 <a:solidFill>
-                  <a:srgbClr val="FFFFFF"/>
+                  <a:srgbClr val="F0F5EA"/>
                 </a:solidFill>
                 <a:latin typeface="Arial Black" pitchFamily="34" charset="0"/>
                 <a:ea typeface="Arial Black" pitchFamily="34" charset="-122"/>
@@ -5515,7 +5515,7 @@
             <a:r>
               <a:rPr lang="en-US" sz="1000" dirty="0">
                 <a:solidFill>
-                  <a:srgbClr val="B0B0B0"/>
+                  <a:srgbClr val="8FAE8B"/>
                 </a:solidFill>
                 <a:latin typeface="Arial" pitchFamily="34" charset="0"/>
                 <a:ea typeface="Arial" pitchFamily="34" charset="-122"/>
@@ -5542,11 +5542,11 @@
             <a:avLst/>
           </a:prstGeom>
           <a:solidFill>
-            <a:srgbClr val="E0E0E0"/>
+            <a:srgbClr val="D8E8C8"/>
           </a:solidFill>
           <a:ln w="12700">
             <a:solidFill>
-              <a:srgbClr val="E0E0E0"/>
+              <a:srgbClr val="D8E8C8"/>
             </a:solidFill>
             <a:prstDash val="solid"/>
           </a:ln>
@@ -5567,11 +5567,11 @@
             <a:avLst/>
           </a:prstGeom>
           <a:solidFill>
-            <a:srgbClr val="555555"/>
+            <a:srgbClr val="3E5C42"/>
           </a:solidFill>
           <a:ln w="12700">
             <a:solidFill>
-              <a:srgbClr val="555555"/>
+              <a:srgbClr val="3E5C42"/>
             </a:solidFill>
             <a:prstDash val="solid"/>
           </a:ln>
@@ -5594,7 +5594,7 @@
             </a:avLst>
           </a:prstGeom>
           <a:solidFill>
-            <a:srgbClr val="0A0A0A"/>
+            <a:srgbClr val="1F3D26"/>
           </a:solidFill>
           <a:ln w="12700">
             <a:solidFill>
@@ -5619,11 +5619,11 @@
             <a:avLst/>
           </a:prstGeom>
           <a:solidFill>
-            <a:srgbClr val="FF5A1F"/>
+            <a:srgbClr val="97BC62"/>
           </a:solidFill>
           <a:ln w="12700">
             <a:solidFill>
-              <a:srgbClr val="FF5A1F"/>
+              <a:srgbClr val="97BC62"/>
             </a:solidFill>
             <a:prstDash val="solid"/>
           </a:ln>
@@ -5656,7 +5656,7 @@
             <a:r>
               <a:rPr lang="en-US" sz="3200" b="1" dirty="0">
                 <a:solidFill>
-                  <a:srgbClr val="FFFFFF"/>
+                  <a:srgbClr val="F0F5EA"/>
                 </a:solidFill>
                 <a:latin typeface="Arial Black" pitchFamily="34" charset="0"/>
                 <a:ea typeface="Arial Black" pitchFamily="34" charset="-122"/>
@@ -5695,7 +5695,7 @@
             <a:r>
               <a:rPr lang="en-US" sz="1000" dirty="0">
                 <a:solidFill>
-                  <a:srgbClr val="B0B0B0"/>
+                  <a:srgbClr val="8FAE8B"/>
                 </a:solidFill>
                 <a:latin typeface="Arial" pitchFamily="34" charset="0"/>
                 <a:ea typeface="Arial" pitchFamily="34" charset="-122"/>
@@ -5734,7 +5734,7 @@
             <a:r>
               <a:rPr lang="en-US" sz="1700" b="1" dirty="0">
                 <a:solidFill>
-                  <a:srgbClr val="E0E0E0"/>
+                  <a:srgbClr val="D8E8C8"/>
                 </a:solidFill>
                 <a:latin typeface="Arial Black" pitchFamily="34" charset="0"/>
                 <a:ea typeface="Arial Black" pitchFamily="34" charset="-122"/>
@@ -5780,7 +5780,7 @@
             <a:r>
               <a:rPr lang="en-US" sz="1700" b="1" dirty="0">
                 <a:solidFill>
-                  <a:srgbClr val="0A0A0A"/>
+                  <a:srgbClr val="2C5F2D"/>
                 </a:solidFill>
                 <a:latin typeface="Arial Black" pitchFamily="34" charset="0"/>
                 <a:ea typeface="Arial Black" pitchFamily="34" charset="-122"/>
@@ -5819,7 +5819,7 @@
             <a:r>
               <a:rPr lang="en-US" sz="850" dirty="0">
                 <a:solidFill>
-                  <a:srgbClr val="6E6E6E"/>
+                  <a:srgbClr val="5A6B5A"/>
                 </a:solidFill>
                 <a:latin typeface="Arial" pitchFamily="34" charset="0"/>
                 <a:ea typeface="Arial" pitchFamily="34" charset="-122"/>
@@ -5848,7 +5848,7 @@
     <p:bg>
       <p:bgPr>
         <a:solidFill>
-          <a:srgbClr val="0A0A0A"/>
+          <a:srgbClr val="1F3D26"/>
         </a:solidFill>
       </p:bgPr>
     </p:bg>
@@ -5893,7 +5893,7 @@
             <a:r>
               <a:rPr lang="en-US" sz="3000" b="1" dirty="0">
                 <a:solidFill>
-                  <a:srgbClr val="2A2A2A"/>
+                  <a:srgbClr val="142B1A"/>
                 </a:solidFill>
                 <a:latin typeface="Arial Black" pitchFamily="34" charset="0"/>
                 <a:ea typeface="Arial Black" pitchFamily="34" charset="-122"/>
@@ -5932,7 +5932,7 @@
             <a:r>
               <a:rPr lang="en-US" sz="3000" b="1" dirty="0">
                 <a:solidFill>
-                  <a:srgbClr val="FFFFFF"/>
+                  <a:srgbClr val="F0F5EA"/>
                 </a:solidFill>
                 <a:latin typeface="Arial Black" pitchFamily="34" charset="0"/>
                 <a:ea typeface="Arial Black" pitchFamily="34" charset="-122"/>
@@ -5959,11 +5959,11 @@
             <a:avLst/>
           </a:prstGeom>
           <a:solidFill>
-            <a:srgbClr val="B0B0B0"/>
+            <a:srgbClr val="8FAE8B"/>
           </a:solidFill>
           <a:ln w="12700">
             <a:solidFill>
-              <a:srgbClr val="B0B0B0"/>
+              <a:srgbClr val="8FAE8B"/>
             </a:solidFill>
             <a:prstDash val="solid"/>
           </a:ln>
@@ -5984,11 +5984,11 @@
             <a:avLst/>
           </a:prstGeom>
           <a:solidFill>
-            <a:srgbClr val="2A2A2A"/>
+            <a:srgbClr val="142B1A"/>
           </a:solidFill>
           <a:ln w="12700">
             <a:solidFill>
-              <a:srgbClr val="2A2A2A"/>
+              <a:srgbClr val="142B1A"/>
             </a:solidFill>
             <a:prstDash val="solid"/>
           </a:ln>
@@ -6009,11 +6009,11 @@
             <a:avLst/>
           </a:prstGeom>
           <a:solidFill>
-            <a:srgbClr val="555555"/>
+            <a:srgbClr val="3E5C42"/>
           </a:solidFill>
           <a:ln w="12700">
             <a:solidFill>
-              <a:srgbClr val="555555"/>
+              <a:srgbClr val="3E5C42"/>
             </a:solidFill>
             <a:prstDash val="solid"/>
           </a:ln>
@@ -6036,11 +6036,11 @@
             </a:avLst>
           </a:prstGeom>
           <a:solidFill>
-            <a:srgbClr val="161616"/>
+            <a:srgbClr val="2A4A33"/>
           </a:solidFill>
           <a:ln w="12700">
             <a:solidFill>
-              <a:srgbClr val="2A2A2A"/>
+              <a:srgbClr val="142B1A"/>
             </a:solidFill>
             <a:prstDash val="solid"/>
           </a:ln>
@@ -6073,7 +6073,7 @@
             <a:r>
               <a:rPr lang="en-US" sz="4400" b="1" dirty="0">
                 <a:solidFill>
-                  <a:srgbClr val="FFFFFF"/>
+                  <a:srgbClr val="F0F5EA"/>
                 </a:solidFill>
                 <a:latin typeface="Arial Black" pitchFamily="34" charset="0"/>
                 <a:ea typeface="Arial Black" pitchFamily="34" charset="-122"/>
@@ -6112,7 +6112,7 @@
             <a:r>
               <a:rPr lang="en-US" sz="950" dirty="0">
                 <a:solidFill>
-                  <a:srgbClr val="B0B0B0"/>
+                  <a:srgbClr val="8FAE8B"/>
                 </a:solidFill>
                 <a:latin typeface="Arial" pitchFamily="34" charset="0"/>
                 <a:ea typeface="Arial" pitchFamily="34" charset="-122"/>
@@ -6151,7 +6151,7 @@
             <a:r>
               <a:rPr lang="en-US" sz="750" dirty="0">
                 <a:solidFill>
-                  <a:srgbClr val="B0B0B0"/>
+                  <a:srgbClr val="8FAE8B"/>
                 </a:solidFill>
                 <a:latin typeface="Arial" pitchFamily="34" charset="0"/>
                 <a:ea typeface="Arial" pitchFamily="34" charset="-122"/>
@@ -6178,11 +6178,11 @@
             <a:avLst/>
           </a:prstGeom>
           <a:solidFill>
-            <a:srgbClr val="2A2A2A"/>
+            <a:srgbClr val="142B1A"/>
           </a:solidFill>
           <a:ln w="12700">
             <a:solidFill>
-              <a:srgbClr val="2A2A2A"/>
+              <a:srgbClr val="142B1A"/>
             </a:solidFill>
             <a:prstDash val="solid"/>
           </a:ln>
@@ -6203,11 +6203,11 @@
             <a:avLst/>
           </a:prstGeom>
           <a:solidFill>
-            <a:srgbClr val="555555"/>
+            <a:srgbClr val="3E5C42"/>
           </a:solidFill>
           <a:ln w="12700">
             <a:solidFill>
-              <a:srgbClr val="555555"/>
+              <a:srgbClr val="3E5C42"/>
             </a:solidFill>
             <a:prstDash val="solid"/>
           </a:ln>
@@ -6230,11 +6230,11 @@
             </a:avLst>
           </a:prstGeom>
           <a:solidFill>
-            <a:srgbClr val="161616"/>
+            <a:srgbClr val="2A4A33"/>
           </a:solidFill>
           <a:ln w="12700">
             <a:solidFill>
-              <a:srgbClr val="2A2A2A"/>
+              <a:srgbClr val="142B1A"/>
             </a:solidFill>
             <a:prstDash val="solid"/>
           </a:ln>
@@ -6267,7 +6267,7 @@
             <a:r>
               <a:rPr lang="en-US" sz="4400" b="1" dirty="0">
                 <a:solidFill>
-                  <a:srgbClr val="FFFFFF"/>
+                  <a:srgbClr val="F0F5EA"/>
                 </a:solidFill>
                 <a:latin typeface="Arial Black" pitchFamily="34" charset="0"/>
                 <a:ea typeface="Arial Black" pitchFamily="34" charset="-122"/>
@@ -6306,7 +6306,7 @@
             <a:r>
               <a:rPr lang="en-US" sz="950" dirty="0">
                 <a:solidFill>
-                  <a:srgbClr val="B0B0B0"/>
+                  <a:srgbClr val="8FAE8B"/>
                 </a:solidFill>
                 <a:latin typeface="Arial" pitchFamily="34" charset="0"/>
                 <a:ea typeface="Arial" pitchFamily="34" charset="-122"/>
@@ -6345,7 +6345,7 @@
             <a:r>
               <a:rPr lang="en-US" sz="750" dirty="0">
                 <a:solidFill>
-                  <a:srgbClr val="B0B0B0"/>
+                  <a:srgbClr val="8FAE8B"/>
                 </a:solidFill>
                 <a:latin typeface="Arial" pitchFamily="34" charset="0"/>
                 <a:ea typeface="Arial" pitchFamily="34" charset="-122"/>
@@ -6372,11 +6372,11 @@
             <a:avLst/>
           </a:prstGeom>
           <a:solidFill>
-            <a:srgbClr val="2A2A2A"/>
+            <a:srgbClr val="142B1A"/>
           </a:solidFill>
           <a:ln w="12700">
             <a:solidFill>
-              <a:srgbClr val="2A2A2A"/>
+              <a:srgbClr val="142B1A"/>
             </a:solidFill>
             <a:prstDash val="solid"/>
           </a:ln>
@@ -6397,11 +6397,11 @@
             <a:avLst/>
           </a:prstGeom>
           <a:solidFill>
-            <a:srgbClr val="555555"/>
+            <a:srgbClr val="3E5C42"/>
           </a:solidFill>
           <a:ln w="12700">
             <a:solidFill>
-              <a:srgbClr val="555555"/>
+              <a:srgbClr val="3E5C42"/>
             </a:solidFill>
             <a:prstDash val="solid"/>
           </a:ln>
@@ -6424,11 +6424,11 @@
             </a:avLst>
           </a:prstGeom>
           <a:solidFill>
-            <a:srgbClr val="161616"/>
+            <a:srgbClr val="2A4A33"/>
           </a:solidFill>
           <a:ln w="12700">
             <a:solidFill>
-              <a:srgbClr val="2A2A2A"/>
+              <a:srgbClr val="142B1A"/>
             </a:solidFill>
             <a:prstDash val="solid"/>
           </a:ln>
@@ -6461,7 +6461,7 @@
             <a:r>
               <a:rPr lang="en-US" sz="4400" b="1" dirty="0">
                 <a:solidFill>
-                  <a:srgbClr val="FFFFFF"/>
+                  <a:srgbClr val="F0F5EA"/>
                 </a:solidFill>
                 <a:latin typeface="Arial Black" pitchFamily="34" charset="0"/>
                 <a:ea typeface="Arial Black" pitchFamily="34" charset="-122"/>
@@ -6500,7 +6500,7 @@
             <a:r>
               <a:rPr lang="en-US" sz="950" dirty="0">
                 <a:solidFill>
-                  <a:srgbClr val="B0B0B0"/>
+                  <a:srgbClr val="8FAE8B"/>
                 </a:solidFill>
                 <a:latin typeface="Arial" pitchFamily="34" charset="0"/>
                 <a:ea typeface="Arial" pitchFamily="34" charset="-122"/>
@@ -6539,7 +6539,7 @@
             <a:r>
               <a:rPr lang="en-US" sz="750" dirty="0">
                 <a:solidFill>
-                  <a:srgbClr val="B0B0B0"/>
+                  <a:srgbClr val="8FAE8B"/>
                 </a:solidFill>
                 <a:latin typeface="Arial" pitchFamily="34" charset="0"/>
                 <a:ea typeface="Arial" pitchFamily="34" charset="-122"/>
@@ -6566,11 +6566,11 @@
             <a:avLst/>
           </a:prstGeom>
           <a:solidFill>
-            <a:srgbClr val="2A2A2A"/>
+            <a:srgbClr val="142B1A"/>
           </a:solidFill>
           <a:ln w="12700">
             <a:solidFill>
-              <a:srgbClr val="2A2A2A"/>
+              <a:srgbClr val="142B1A"/>
             </a:solidFill>
             <a:prstDash val="solid"/>
           </a:ln>
@@ -6591,11 +6591,11 @@
             <a:avLst/>
           </a:prstGeom>
           <a:solidFill>
-            <a:srgbClr val="555555"/>
+            <a:srgbClr val="3E5C42"/>
           </a:solidFill>
           <a:ln w="12700">
             <a:solidFill>
-              <a:srgbClr val="555555"/>
+              <a:srgbClr val="3E5C42"/>
             </a:solidFill>
             <a:prstDash val="solid"/>
           </a:ln>
@@ -6618,11 +6618,11 @@
             </a:avLst>
           </a:prstGeom>
           <a:solidFill>
-            <a:srgbClr val="161616"/>
+            <a:srgbClr val="2A4A33"/>
           </a:solidFill>
           <a:ln w="12700">
             <a:solidFill>
-              <a:srgbClr val="2A2A2A"/>
+              <a:srgbClr val="142B1A"/>
             </a:solidFill>
             <a:prstDash val="solid"/>
           </a:ln>
@@ -6655,7 +6655,7 @@
             <a:r>
               <a:rPr lang="en-US" sz="4400" b="1" dirty="0">
                 <a:solidFill>
-                  <a:srgbClr val="FFFFFF"/>
+                  <a:srgbClr val="F0F5EA"/>
                 </a:solidFill>
                 <a:latin typeface="Arial Black" pitchFamily="34" charset="0"/>
                 <a:ea typeface="Arial Black" pitchFamily="34" charset="-122"/>
@@ -6694,7 +6694,7 @@
             <a:r>
               <a:rPr lang="en-US" sz="950" dirty="0">
                 <a:solidFill>
-                  <a:srgbClr val="B0B0B0"/>
+                  <a:srgbClr val="8FAE8B"/>
                 </a:solidFill>
                 <a:latin typeface="Arial" pitchFamily="34" charset="0"/>
                 <a:ea typeface="Arial" pitchFamily="34" charset="-122"/>
@@ -6733,7 +6733,7 @@
             <a:r>
               <a:rPr lang="en-US" sz="750" dirty="0">
                 <a:solidFill>
-                  <a:srgbClr val="B0B0B0"/>
+                  <a:srgbClr val="8FAE8B"/>
                 </a:solidFill>
                 <a:latin typeface="Arial" pitchFamily="34" charset="0"/>
                 <a:ea typeface="Arial" pitchFamily="34" charset="-122"/>
@@ -6772,7 +6772,7 @@
             <a:r>
               <a:rPr lang="en-US" sz="1300" b="1" dirty="0">
                 <a:solidFill>
-                  <a:srgbClr val="FFFFFF"/>
+                  <a:srgbClr val="F0F5EA"/>
                 </a:solidFill>
                 <a:latin typeface="Arial Black" pitchFamily="34" charset="0"/>
                 <a:ea typeface="Arial Black" pitchFamily="34" charset="-122"/>
@@ -6811,7 +6811,7 @@
             <a:r>
               <a:rPr lang="en-US" sz="850" dirty="0">
                 <a:solidFill>
-                  <a:srgbClr val="B0B0B0"/>
+                  <a:srgbClr val="8FAE8B"/>
                 </a:solidFill>
                 <a:latin typeface="Arial" pitchFamily="34" charset="0"/>
                 <a:ea typeface="Arial" pitchFamily="34" charset="-122"/>
@@ -6840,7 +6840,7 @@
     <p:bg>
       <p:bgPr>
         <a:solidFill>
-          <a:srgbClr val="0A0A0A"/>
+          <a:srgbClr val="1F3D26"/>
         </a:solidFill>
       </p:bgPr>
     </p:bg>
@@ -6885,7 +6885,7 @@
             <a:r>
               <a:rPr lang="en-US" sz="3000" b="1" dirty="0">
                 <a:solidFill>
-                  <a:srgbClr val="2A2A2A"/>
+                  <a:srgbClr val="142B1A"/>
                 </a:solidFill>
                 <a:latin typeface="Arial Black" pitchFamily="34" charset="0"/>
                 <a:ea typeface="Arial Black" pitchFamily="34" charset="-122"/>
@@ -6924,7 +6924,7 @@
             <a:r>
               <a:rPr lang="en-US" sz="3000" b="1" dirty="0">
                 <a:solidFill>
-                  <a:srgbClr val="FFFFFF"/>
+                  <a:srgbClr val="F0F5EA"/>
                 </a:solidFill>
                 <a:latin typeface="Arial Black" pitchFamily="34" charset="0"/>
                 <a:ea typeface="Arial Black" pitchFamily="34" charset="-122"/>
@@ -6951,11 +6951,11 @@
             <a:avLst/>
           </a:prstGeom>
           <a:solidFill>
-            <a:srgbClr val="FF5A1F"/>
+            <a:srgbClr val="97BC62"/>
           </a:solidFill>
           <a:ln w="12700">
             <a:solidFill>
-              <a:srgbClr val="FF5A1F"/>
+              <a:srgbClr val="97BC62"/>
             </a:solidFill>
             <a:prstDash val="solid"/>
           </a:ln>
@@ -6988,7 +6988,7 @@
             <a:r>
               <a:rPr lang="en-US" sz="1350" b="1" dirty="0">
                 <a:solidFill>
-                  <a:srgbClr val="FFFFFF"/>
+                  <a:srgbClr val="F0F5EA"/>
                 </a:solidFill>
                 <a:latin typeface="Arial" pitchFamily="34" charset="0"/>
                 <a:ea typeface="Arial" pitchFamily="34" charset="-122"/>
@@ -7015,11 +7015,11 @@
             <a:avLst/>
           </a:prstGeom>
           <a:solidFill>
-            <a:srgbClr val="2A2A2A"/>
+            <a:srgbClr val="142B1A"/>
           </a:solidFill>
           <a:ln w="12700">
             <a:solidFill>
-              <a:srgbClr val="2A2A2A"/>
+              <a:srgbClr val="142B1A"/>
             </a:solidFill>
             <a:prstDash val="solid"/>
           </a:ln>
@@ -7040,11 +7040,11 @@
             <a:avLst/>
           </a:prstGeom>
           <a:solidFill>
-            <a:srgbClr val="555555"/>
+            <a:srgbClr val="3E5C42"/>
           </a:solidFill>
           <a:ln w="12700">
             <a:solidFill>
-              <a:srgbClr val="555555"/>
+              <a:srgbClr val="3E5C42"/>
             </a:solidFill>
             <a:prstDash val="solid"/>
           </a:ln>
@@ -7067,11 +7067,11 @@
             </a:avLst>
           </a:prstGeom>
           <a:solidFill>
-            <a:srgbClr val="161616"/>
+            <a:srgbClr val="2A4A33"/>
           </a:solidFill>
           <a:ln w="12700">
             <a:solidFill>
-              <a:srgbClr val="2A2A2A"/>
+              <a:srgbClr val="142B1A"/>
             </a:solidFill>
             <a:prstDash val="solid"/>
           </a:ln>
@@ -7104,7 +7104,7 @@
             <a:r>
               <a:rPr lang="en-US" sz="1400" b="1" dirty="0">
                 <a:solidFill>
-                  <a:srgbClr val="FFFFFF"/>
+                  <a:srgbClr val="F0F5EA"/>
                 </a:solidFill>
                 <a:latin typeface="Arial Black" pitchFamily="34" charset="0"/>
                 <a:ea typeface="Arial Black" pitchFamily="34" charset="-122"/>
@@ -7143,7 +7143,7 @@
             <a:r>
               <a:rPr lang="en-US" sz="850" dirty="0">
                 <a:solidFill>
-                  <a:srgbClr val="B0B0B0"/>
+                  <a:srgbClr val="8FAE8B"/>
                 </a:solidFill>
                 <a:latin typeface="Arial" pitchFamily="34" charset="0"/>
                 <a:ea typeface="Arial" pitchFamily="34" charset="-122"/>
@@ -7170,11 +7170,11 @@
             <a:avLst/>
           </a:prstGeom>
           <a:solidFill>
-            <a:srgbClr val="2A2A2A"/>
+            <a:srgbClr val="142B1A"/>
           </a:solidFill>
           <a:ln w="12700">
             <a:solidFill>
-              <a:srgbClr val="2A2A2A"/>
+              <a:srgbClr val="142B1A"/>
             </a:solidFill>
             <a:prstDash val="solid"/>
           </a:ln>
@@ -7195,11 +7195,11 @@
             <a:avLst/>
           </a:prstGeom>
           <a:solidFill>
-            <a:srgbClr val="555555"/>
+            <a:srgbClr val="3E5C42"/>
           </a:solidFill>
           <a:ln w="12700">
             <a:solidFill>
-              <a:srgbClr val="555555"/>
+              <a:srgbClr val="3E5C42"/>
             </a:solidFill>
             <a:prstDash val="solid"/>
           </a:ln>
@@ -7222,11 +7222,11 @@
             </a:avLst>
           </a:prstGeom>
           <a:solidFill>
-            <a:srgbClr val="161616"/>
+            <a:srgbClr val="2A4A33"/>
           </a:solidFill>
           <a:ln w="12700">
             <a:solidFill>
-              <a:srgbClr val="2A2A2A"/>
+              <a:srgbClr val="142B1A"/>
             </a:solidFill>
             <a:prstDash val="solid"/>
           </a:ln>
@@ -7259,7 +7259,7 @@
             <a:r>
               <a:rPr lang="en-US" sz="1400" b="1" dirty="0">
                 <a:solidFill>
-                  <a:srgbClr val="FFFFFF"/>
+                  <a:srgbClr val="F0F5EA"/>
                 </a:solidFill>
                 <a:latin typeface="Arial Black" pitchFamily="34" charset="0"/>
                 <a:ea typeface="Arial Black" pitchFamily="34" charset="-122"/>
@@ -7298,7 +7298,7 @@
             <a:r>
               <a:rPr lang="en-US" sz="850" dirty="0">
                 <a:solidFill>
-                  <a:srgbClr val="B0B0B0"/>
+                  <a:srgbClr val="8FAE8B"/>
                 </a:solidFill>
                 <a:latin typeface="Arial" pitchFamily="34" charset="0"/>
                 <a:ea typeface="Arial" pitchFamily="34" charset="-122"/>
@@ -7325,11 +7325,11 @@
             <a:avLst/>
           </a:prstGeom>
           <a:solidFill>
-            <a:srgbClr val="2A2A2A"/>
+            <a:srgbClr val="142B1A"/>
           </a:solidFill>
           <a:ln w="12700">
             <a:solidFill>
-              <a:srgbClr val="2A2A2A"/>
+              <a:srgbClr val="142B1A"/>
             </a:solidFill>
             <a:prstDash val="solid"/>
           </a:ln>
@@ -7350,11 +7350,11 @@
             <a:avLst/>
           </a:prstGeom>
           <a:solidFill>
-            <a:srgbClr val="555555"/>
+            <a:srgbClr val="3E5C42"/>
           </a:solidFill>
           <a:ln w="12700">
             <a:solidFill>
-              <a:srgbClr val="555555"/>
+              <a:srgbClr val="3E5C42"/>
             </a:solidFill>
             <a:prstDash val="solid"/>
           </a:ln>
@@ -7377,11 +7377,11 @@
             </a:avLst>
           </a:prstGeom>
           <a:solidFill>
-            <a:srgbClr val="161616"/>
+            <a:srgbClr val="2A4A33"/>
           </a:solidFill>
           <a:ln w="12700">
             <a:solidFill>
-              <a:srgbClr val="2A2A2A"/>
+              <a:srgbClr val="142B1A"/>
             </a:solidFill>
             <a:prstDash val="solid"/>
           </a:ln>
@@ -7414,7 +7414,7 @@
             <a:r>
               <a:rPr lang="en-US" sz="1400" b="1" dirty="0">
                 <a:solidFill>
-                  <a:srgbClr val="FFFFFF"/>
+                  <a:srgbClr val="F0F5EA"/>
                 </a:solidFill>
                 <a:latin typeface="Arial Black" pitchFamily="34" charset="0"/>
                 <a:ea typeface="Arial Black" pitchFamily="34" charset="-122"/>
@@ -7453,7 +7453,7 @@
             <a:r>
               <a:rPr lang="en-US" sz="850" dirty="0">
                 <a:solidFill>
-                  <a:srgbClr val="B0B0B0"/>
+                  <a:srgbClr val="8FAE8B"/>
                 </a:solidFill>
                 <a:latin typeface="Arial" pitchFamily="34" charset="0"/>
                 <a:ea typeface="Arial" pitchFamily="34" charset="-122"/>
@@ -7480,11 +7480,11 @@
             <a:avLst/>
           </a:prstGeom>
           <a:solidFill>
-            <a:srgbClr val="2A2A2A"/>
+            <a:srgbClr val="142B1A"/>
           </a:solidFill>
           <a:ln w="12700">
             <a:solidFill>
-              <a:srgbClr val="2A2A2A"/>
+              <a:srgbClr val="142B1A"/>
             </a:solidFill>
             <a:prstDash val="solid"/>
           </a:ln>
@@ -7505,11 +7505,11 @@
             <a:avLst/>
           </a:prstGeom>
           <a:solidFill>
-            <a:srgbClr val="555555"/>
+            <a:srgbClr val="3E5C42"/>
           </a:solidFill>
           <a:ln w="12700">
             <a:solidFill>
-              <a:srgbClr val="555555"/>
+              <a:srgbClr val="3E5C42"/>
             </a:solidFill>
             <a:prstDash val="solid"/>
           </a:ln>
@@ -7532,11 +7532,11 @@
             </a:avLst>
           </a:prstGeom>
           <a:solidFill>
-            <a:srgbClr val="161616"/>
+            <a:srgbClr val="2A4A33"/>
           </a:solidFill>
           <a:ln w="12700">
             <a:solidFill>
-              <a:srgbClr val="2A2A2A"/>
+              <a:srgbClr val="142B1A"/>
             </a:solidFill>
             <a:prstDash val="solid"/>
           </a:ln>
@@ -7569,7 +7569,7 @@
             <a:r>
               <a:rPr lang="en-US" sz="1400" b="1" dirty="0">
                 <a:solidFill>
-                  <a:srgbClr val="FFFFFF"/>
+                  <a:srgbClr val="F0F5EA"/>
                 </a:solidFill>
                 <a:latin typeface="Arial Black" pitchFamily="34" charset="0"/>
                 <a:ea typeface="Arial Black" pitchFamily="34" charset="-122"/>
@@ -7608,7 +7608,7 @@
             <a:r>
               <a:rPr lang="en-US" sz="850" dirty="0">
                 <a:solidFill>
-                  <a:srgbClr val="B0B0B0"/>
+                  <a:srgbClr val="8FAE8B"/>
                 </a:solidFill>
                 <a:latin typeface="Arial" pitchFamily="34" charset="0"/>
                 <a:ea typeface="Arial" pitchFamily="34" charset="-122"/>
@@ -7647,7 +7647,7 @@
             <a:r>
               <a:rPr lang="en-US" sz="850" dirty="0">
                 <a:solidFill>
-                  <a:srgbClr val="B0B0B0"/>
+                  <a:srgbClr val="8FAE8B"/>
                 </a:solidFill>
                 <a:latin typeface="Arial" pitchFamily="34" charset="0"/>
                 <a:ea typeface="Arial" pitchFamily="34" charset="-122"/>
@@ -7676,7 +7676,7 @@
     <p:bg>
       <p:bgPr>
         <a:solidFill>
-          <a:srgbClr val="FFFFFF"/>
+          <a:srgbClr val="F0F5EA"/>
         </a:solidFill>
       </p:bgPr>
     </p:bg>
@@ -7721,7 +7721,7 @@
             <a:r>
               <a:rPr lang="en-US" sz="2800" b="1" dirty="0">
                 <a:solidFill>
-                  <a:srgbClr val="E0E0E0"/>
+                  <a:srgbClr val="D8E8C8"/>
                 </a:solidFill>
                 <a:latin typeface="Arial Black" pitchFamily="34" charset="0"/>
                 <a:ea typeface="Arial Black" pitchFamily="34" charset="-122"/>
@@ -7767,7 +7767,7 @@
             <a:r>
               <a:rPr lang="en-US" sz="2800" b="1" dirty="0">
                 <a:solidFill>
-                  <a:srgbClr val="0A0A0A"/>
+                  <a:srgbClr val="2C5F2D"/>
                 </a:solidFill>
                 <a:latin typeface="Arial Black" pitchFamily="34" charset="0"/>
                 <a:ea typeface="Arial Black" pitchFamily="34" charset="-122"/>
@@ -7794,11 +7794,11 @@
             <a:avLst/>
           </a:prstGeom>
           <a:solidFill>
-            <a:srgbClr val="0A0A0A"/>
+            <a:srgbClr val="2C5F2D"/>
           </a:solidFill>
           <a:ln w="12700">
             <a:solidFill>
-              <a:srgbClr val="0A0A0A"/>
+              <a:srgbClr val="2C5F2D"/>
             </a:solidFill>
             <a:prstDash val="solid"/>
           </a:ln>
@@ -7831,7 +7831,7 @@
             <a:r>
               <a:rPr lang="en-US" sz="1600" b="1" dirty="0">
                 <a:solidFill>
-                  <a:srgbClr val="0A0A0A"/>
+                  <a:srgbClr val="2C5F2D"/>
                 </a:solidFill>
                 <a:latin typeface="Arial" pitchFamily="34" charset="0"/>
                 <a:ea typeface="Arial" pitchFamily="34" charset="-122"/>
@@ -7858,11 +7858,11 @@
             <a:avLst/>
           </a:prstGeom>
           <a:solidFill>
-            <a:srgbClr val="E0E0E0"/>
+            <a:srgbClr val="D8E8C8"/>
           </a:solidFill>
           <a:ln w="12700">
             <a:solidFill>
-              <a:srgbClr val="E0E0E0"/>
+              <a:srgbClr val="D8E8C8"/>
             </a:solidFill>
             <a:prstDash val="solid"/>
           </a:ln>
@@ -7885,11 +7885,11 @@
             </a:avLst>
           </a:prstGeom>
           <a:solidFill>
-            <a:srgbClr val="FFFFFF"/>
+            <a:srgbClr val="F0F5EA"/>
           </a:solidFill>
           <a:ln w="19050">
             <a:solidFill>
-              <a:srgbClr val="0A0A0A"/>
+              <a:srgbClr val="2C5F2D"/>
             </a:solidFill>
             <a:prstDash val="solid"/>
           </a:ln>
@@ -7910,7 +7910,7 @@
             <a:avLst/>
           </a:prstGeom>
           <a:solidFill>
-            <a:srgbClr val="0A0A0A"/>
+            <a:srgbClr val="1F3D26"/>
           </a:solidFill>
           <a:ln/>
         </p:spPr>
@@ -7942,7 +7942,7 @@
             <a:r>
               <a:rPr lang="en-US" sz="1400" b="1" dirty="0">
                 <a:solidFill>
-                  <a:srgbClr val="FFFFFF"/>
+                  <a:srgbClr val="F0F5EA"/>
                 </a:solidFill>
                 <a:latin typeface="Arial" pitchFamily="34" charset="0"/>
                 <a:ea typeface="Arial" pitchFamily="34" charset="-122"/>
@@ -7981,7 +7981,7 @@
             <a:r>
               <a:rPr lang="en-US" sz="1500" b="1" dirty="0">
                 <a:solidFill>
-                  <a:srgbClr val="0A0A0A"/>
+                  <a:srgbClr val="2C5F2D"/>
                 </a:solidFill>
                 <a:latin typeface="Arial Black" pitchFamily="34" charset="0"/>
                 <a:ea typeface="Arial Black" pitchFamily="34" charset="-122"/>
@@ -8023,7 +8023,7 @@
             <a:r>
               <a:rPr lang="en-US" sz="1050" dirty="0">
                 <a:solidFill>
-                  <a:srgbClr val="0A0A0A"/>
+                  <a:srgbClr val="2C5F2D"/>
                 </a:solidFill>
                 <a:latin typeface="Arial" pitchFamily="34" charset="0"/>
                 <a:ea typeface="Arial" pitchFamily="34" charset="-122"/>
@@ -8043,7 +8043,7 @@
             <a:r>
               <a:rPr lang="en-US" sz="1050" dirty="0">
                 <a:solidFill>
-                  <a:srgbClr val="0A0A0A"/>
+                  <a:srgbClr val="2C5F2D"/>
                 </a:solidFill>
                 <a:latin typeface="Arial" pitchFamily="34" charset="0"/>
                 <a:ea typeface="Arial" pitchFamily="34" charset="-122"/>
@@ -8063,7 +8063,7 @@
             <a:r>
               <a:rPr lang="en-US" sz="1050" dirty="0">
                 <a:solidFill>
-                  <a:srgbClr val="0A0A0A"/>
+                  <a:srgbClr val="2C5F2D"/>
                 </a:solidFill>
                 <a:latin typeface="Arial" pitchFamily="34" charset="0"/>
                 <a:ea typeface="Arial" pitchFamily="34" charset="-122"/>
@@ -8083,7 +8083,7 @@
             <a:r>
               <a:rPr lang="en-US" sz="1050" dirty="0">
                 <a:solidFill>
-                  <a:srgbClr val="0A0A0A"/>
+                  <a:srgbClr val="2C5F2D"/>
                 </a:solidFill>
                 <a:latin typeface="Arial" pitchFamily="34" charset="0"/>
                 <a:ea typeface="Arial" pitchFamily="34" charset="-122"/>
@@ -8110,11 +8110,11 @@
             <a:avLst/>
           </a:prstGeom>
           <a:solidFill>
-            <a:srgbClr val="E0E0E0"/>
+            <a:srgbClr val="D8E8C8"/>
           </a:solidFill>
           <a:ln w="12700">
             <a:solidFill>
-              <a:srgbClr val="E0E0E0"/>
+              <a:srgbClr val="D8E8C8"/>
             </a:solidFill>
             <a:prstDash val="solid"/>
           </a:ln>
@@ -8137,11 +8137,11 @@
             </a:avLst>
           </a:prstGeom>
           <a:solidFill>
-            <a:srgbClr val="FFFFFF"/>
+            <a:srgbClr val="F0F5EA"/>
           </a:solidFill>
           <a:ln w="19050">
             <a:solidFill>
-              <a:srgbClr val="0A0A0A"/>
+              <a:srgbClr val="2C5F2D"/>
             </a:solidFill>
             <a:prstDash val="solid"/>
           </a:ln>
@@ -8162,7 +8162,7 @@
             <a:avLst/>
           </a:prstGeom>
           <a:solidFill>
-            <a:srgbClr val="0A0A0A"/>
+            <a:srgbClr val="1F3D26"/>
           </a:solidFill>
           <a:ln/>
         </p:spPr>
@@ -8194,7 +8194,7 @@
             <a:r>
               <a:rPr lang="en-US" sz="1400" b="1" dirty="0">
                 <a:solidFill>
-                  <a:srgbClr val="FFFFFF"/>
+                  <a:srgbClr val="F0F5EA"/>
                 </a:solidFill>
                 <a:latin typeface="Arial" pitchFamily="34" charset="0"/>
                 <a:ea typeface="Arial" pitchFamily="34" charset="-122"/>
@@ -8233,7 +8233,7 @@
             <a:r>
               <a:rPr lang="en-US" sz="1500" b="1" dirty="0">
                 <a:solidFill>
-                  <a:srgbClr val="0A0A0A"/>
+                  <a:srgbClr val="2C5F2D"/>
                 </a:solidFill>
                 <a:latin typeface="Arial Black" pitchFamily="34" charset="0"/>
                 <a:ea typeface="Arial Black" pitchFamily="34" charset="-122"/>
@@ -8275,7 +8275,7 @@
             <a:r>
               <a:rPr lang="en-US" sz="1050" dirty="0">
                 <a:solidFill>
-                  <a:srgbClr val="0A0A0A"/>
+                  <a:srgbClr val="2C5F2D"/>
                 </a:solidFill>
                 <a:latin typeface="Arial" pitchFamily="34" charset="0"/>
                 <a:ea typeface="Arial" pitchFamily="34" charset="-122"/>
@@ -8295,7 +8295,7 @@
             <a:r>
               <a:rPr lang="en-US" sz="1050" dirty="0">
                 <a:solidFill>
-                  <a:srgbClr val="0A0A0A"/>
+                  <a:srgbClr val="2C5F2D"/>
                 </a:solidFill>
                 <a:latin typeface="Arial" pitchFamily="34" charset="0"/>
                 <a:ea typeface="Arial" pitchFamily="34" charset="-122"/>
@@ -8315,7 +8315,7 @@
             <a:r>
               <a:rPr lang="en-US" sz="1050" dirty="0">
                 <a:solidFill>
-                  <a:srgbClr val="0A0A0A"/>
+                  <a:srgbClr val="2C5F2D"/>
                 </a:solidFill>
                 <a:latin typeface="Arial" pitchFamily="34" charset="0"/>
                 <a:ea typeface="Arial" pitchFamily="34" charset="-122"/>
@@ -8335,7 +8335,7 @@
             <a:r>
               <a:rPr lang="en-US" sz="1050" dirty="0">
                 <a:solidFill>
-                  <a:srgbClr val="0A0A0A"/>
+                  <a:srgbClr val="2C5F2D"/>
                 </a:solidFill>
                 <a:latin typeface="Arial" pitchFamily="34" charset="0"/>
                 <a:ea typeface="Arial" pitchFamily="34" charset="-122"/>
@@ -8362,11 +8362,11 @@
             <a:avLst/>
           </a:prstGeom>
           <a:solidFill>
-            <a:srgbClr val="E0E0E0"/>
+            <a:srgbClr val="D8E8C8"/>
           </a:solidFill>
           <a:ln w="12700">
             <a:solidFill>
-              <a:srgbClr val="E0E0E0"/>
+              <a:srgbClr val="D8E8C8"/>
             </a:solidFill>
             <a:prstDash val="solid"/>
           </a:ln>
@@ -8389,11 +8389,11 @@
             </a:avLst>
           </a:prstGeom>
           <a:solidFill>
-            <a:srgbClr val="FFFFFF"/>
+            <a:srgbClr val="F0F5EA"/>
           </a:solidFill>
           <a:ln w="19050">
             <a:solidFill>
-              <a:srgbClr val="0A0A0A"/>
+              <a:srgbClr val="2C5F2D"/>
             </a:solidFill>
             <a:prstDash val="solid"/>
           </a:ln>
@@ -8414,7 +8414,7 @@
             <a:avLst/>
           </a:prstGeom>
           <a:solidFill>
-            <a:srgbClr val="0A0A0A"/>
+            <a:srgbClr val="1F3D26"/>
           </a:solidFill>
           <a:ln/>
         </p:spPr>
@@ -8446,7 +8446,7 @@
             <a:r>
               <a:rPr lang="en-US" sz="1400" b="1" dirty="0">
                 <a:solidFill>
-                  <a:srgbClr val="FFFFFF"/>
+                  <a:srgbClr val="F0F5EA"/>
                 </a:solidFill>
                 <a:latin typeface="Arial" pitchFamily="34" charset="0"/>
                 <a:ea typeface="Arial" pitchFamily="34" charset="-122"/>
@@ -8485,7 +8485,7 @@
             <a:r>
               <a:rPr lang="en-US" sz="1500" b="1" dirty="0">
                 <a:solidFill>
-                  <a:srgbClr val="0A0A0A"/>
+                  <a:srgbClr val="2C5F2D"/>
                 </a:solidFill>
                 <a:latin typeface="Arial Black" pitchFamily="34" charset="0"/>
                 <a:ea typeface="Arial Black" pitchFamily="34" charset="-122"/>
@@ -8527,7 +8527,7 @@
             <a:r>
               <a:rPr lang="en-US" sz="1050" dirty="0">
                 <a:solidFill>
-                  <a:srgbClr val="0A0A0A"/>
+                  <a:srgbClr val="2C5F2D"/>
                 </a:solidFill>
                 <a:latin typeface="Arial" pitchFamily="34" charset="0"/>
                 <a:ea typeface="Arial" pitchFamily="34" charset="-122"/>
@@ -8547,7 +8547,7 @@
             <a:r>
               <a:rPr lang="en-US" sz="1050" dirty="0">
                 <a:solidFill>
-                  <a:srgbClr val="0A0A0A"/>
+                  <a:srgbClr val="2C5F2D"/>
                 </a:solidFill>
                 <a:latin typeface="Arial" pitchFamily="34" charset="0"/>
                 <a:ea typeface="Arial" pitchFamily="34" charset="-122"/>
@@ -8567,7 +8567,7 @@
             <a:r>
               <a:rPr lang="en-US" sz="1050" dirty="0">
                 <a:solidFill>
-                  <a:srgbClr val="0A0A0A"/>
+                  <a:srgbClr val="2C5F2D"/>
                 </a:solidFill>
                 <a:latin typeface="Arial" pitchFamily="34" charset="0"/>
                 <a:ea typeface="Arial" pitchFamily="34" charset="-122"/>
@@ -8587,7 +8587,7 @@
             <a:r>
               <a:rPr lang="en-US" sz="1050" dirty="0">
                 <a:solidFill>
-                  <a:srgbClr val="0A0A0A"/>
+                  <a:srgbClr val="2C5F2D"/>
                 </a:solidFill>
                 <a:latin typeface="Arial" pitchFamily="34" charset="0"/>
                 <a:ea typeface="Arial" pitchFamily="34" charset="-122"/>
@@ -8626,7 +8626,7 @@
             <a:r>
               <a:rPr lang="en-US" sz="1050" i="1" dirty="0">
                 <a:solidFill>
-                  <a:srgbClr val="6E6E6E"/>
+                  <a:srgbClr val="5A6B5A"/>
                 </a:solidFill>
                 <a:latin typeface="Arial" pitchFamily="34" charset="0"/>
                 <a:ea typeface="Arial" pitchFamily="34" charset="-122"/>
@@ -8665,7 +8665,7 @@
             <a:r>
               <a:rPr lang="en-US" sz="850" dirty="0">
                 <a:solidFill>
-                  <a:srgbClr val="6E6E6E"/>
+                  <a:srgbClr val="5A6B5A"/>
                 </a:solidFill>
                 <a:latin typeface="Arial" pitchFamily="34" charset="0"/>
                 <a:ea typeface="Arial" pitchFamily="34" charset="-122"/>
@@ -8694,7 +8694,7 @@
     <p:bg>
       <p:bgPr>
         <a:solidFill>
-          <a:srgbClr val="FFFFFF"/>
+          <a:srgbClr val="F0F5EA"/>
         </a:solidFill>
       </p:bgPr>
     </p:bg>
@@ -8739,7 +8739,7 @@
             <a:r>
               <a:rPr lang="en-US" sz="2800" b="1" dirty="0">
                 <a:solidFill>
-                  <a:srgbClr val="E0E0E0"/>
+                  <a:srgbClr val="D8E8C8"/>
                 </a:solidFill>
                 <a:latin typeface="Arial Black" pitchFamily="34" charset="0"/>
                 <a:ea typeface="Arial Black" pitchFamily="34" charset="-122"/>
@@ -8785,7 +8785,7 @@
             <a:r>
               <a:rPr lang="en-US" sz="2800" b="1" dirty="0">
                 <a:solidFill>
-                  <a:srgbClr val="0A0A0A"/>
+                  <a:srgbClr val="2C5F2D"/>
                 </a:solidFill>
                 <a:latin typeface="Arial Black" pitchFamily="34" charset="0"/>
                 <a:ea typeface="Arial Black" pitchFamily="34" charset="-122"/>
@@ -8812,11 +8812,11 @@
             <a:avLst/>
           </a:prstGeom>
           <a:solidFill>
-            <a:srgbClr val="0A0A0A"/>
+            <a:srgbClr val="2C5F2D"/>
           </a:solidFill>
           <a:ln w="12700">
             <a:solidFill>
-              <a:srgbClr val="0A0A0A"/>
+              <a:srgbClr val="2C5F2D"/>
             </a:solidFill>
             <a:prstDash val="solid"/>
           </a:ln>
@@ -8837,11 +8837,11 @@
             <a:avLst/>
           </a:prstGeom>
           <a:solidFill>
-            <a:srgbClr val="E0E0E0"/>
+            <a:srgbClr val="D8E8C8"/>
           </a:solidFill>
           <a:ln w="12700">
             <a:solidFill>
-              <a:srgbClr val="E0E0E0"/>
+              <a:srgbClr val="D8E8C8"/>
             </a:solidFill>
             <a:prstDash val="solid"/>
           </a:ln>
@@ -8864,11 +8864,11 @@
             </a:avLst>
           </a:prstGeom>
           <a:solidFill>
-            <a:srgbClr val="FFFFFF"/>
+            <a:srgbClr val="F0F5EA"/>
           </a:solidFill>
           <a:ln w="19050">
             <a:solidFill>
-              <a:srgbClr val="0A0A0A"/>
+              <a:srgbClr val="2C5F2D"/>
             </a:solidFill>
             <a:prstDash val="solid"/>
           </a:ln>
@@ -8889,7 +8889,7 @@
             <a:avLst/>
           </a:prstGeom>
           <a:solidFill>
-            <a:srgbClr val="0A0A0A"/>
+            <a:srgbClr val="1F3D26"/>
           </a:solidFill>
           <a:ln/>
         </p:spPr>
@@ -8921,7 +8921,7 @@
             <a:r>
               <a:rPr lang="en-US" sz="1800" b="1" dirty="0">
                 <a:solidFill>
-                  <a:srgbClr val="FFFFFF"/>
+                  <a:srgbClr val="F0F5EA"/>
                 </a:solidFill>
                 <a:latin typeface="Arial" pitchFamily="34" charset="0"/>
                 <a:ea typeface="Arial" pitchFamily="34" charset="-122"/>
@@ -8960,7 +8960,7 @@
             <a:r>
               <a:rPr lang="en-US" sz="1400" b="1" dirty="0">
                 <a:solidFill>
-                  <a:srgbClr val="0A0A0A"/>
+                  <a:srgbClr val="2C5F2D"/>
                 </a:solidFill>
                 <a:latin typeface="Arial Black" pitchFamily="34" charset="0"/>
                 <a:ea typeface="Arial Black" pitchFamily="34" charset="-122"/>
@@ -8999,7 +8999,7 @@
             <a:r>
               <a:rPr lang="en-US" sz="1050" dirty="0">
                 <a:solidFill>
-                  <a:srgbClr val="0A0A0A"/>
+                  <a:srgbClr val="2C5F2D"/>
                 </a:solidFill>
                 <a:latin typeface="Arial" pitchFamily="34" charset="0"/>
                 <a:ea typeface="Arial" pitchFamily="34" charset="-122"/>
@@ -9038,7 +9038,7 @@
             <a:r>
               <a:rPr lang="en-US" sz="950" i="1" dirty="0">
                 <a:solidFill>
-                  <a:srgbClr val="6E6E6E"/>
+                  <a:srgbClr val="5A6B5A"/>
                 </a:solidFill>
                 <a:latin typeface="Arial" pitchFamily="34" charset="0"/>
                 <a:ea typeface="Arial" pitchFamily="34" charset="-122"/>
@@ -9077,7 +9077,7 @@
             <a:r>
               <a:rPr lang="en-US" sz="2000" b="1" dirty="0">
                 <a:solidFill>
-                  <a:srgbClr val="B0B0B0"/>
+                  <a:srgbClr val="8FAE8B"/>
                 </a:solidFill>
                 <a:latin typeface="Arial" pitchFamily="34" charset="0"/>
                 <a:ea typeface="Arial" pitchFamily="34" charset="-122"/>
@@ -9104,11 +9104,11 @@
             <a:avLst/>
           </a:prstGeom>
           <a:solidFill>
-            <a:srgbClr val="E0E0E0"/>
+            <a:srgbClr val="D8E8C8"/>
           </a:solidFill>
           <a:ln w="12700">
             <a:solidFill>
-              <a:srgbClr val="E0E0E0"/>
+              <a:srgbClr val="D8E8C8"/>
             </a:solidFill>
             <a:prstDash val="solid"/>
           </a:ln>
@@ -9131,11 +9131,11 @@
             </a:avLst>
           </a:prstGeom>
           <a:solidFill>
-            <a:srgbClr val="FFFFFF"/>
+            <a:srgbClr val="F0F5EA"/>
           </a:solidFill>
           <a:ln w="19050">
             <a:solidFill>
-              <a:srgbClr val="0A0A0A"/>
+              <a:srgbClr val="2C5F2D"/>
             </a:solidFill>
             <a:prstDash val="solid"/>
           </a:ln>
@@ -9156,7 +9156,7 @@
             <a:avLst/>
           </a:prstGeom>
           <a:solidFill>
-            <a:srgbClr val="0A0A0A"/>
+            <a:srgbClr val="1F3D26"/>
           </a:solidFill>
           <a:ln/>
         </p:spPr>
@@ -9188,7 +9188,7 @@
             <a:r>
               <a:rPr lang="en-US" sz="1800" b="1" dirty="0">
                 <a:solidFill>
-                  <a:srgbClr val="FFFFFF"/>
+                  <a:srgbClr val="F0F5EA"/>
                 </a:solidFill>
                 <a:latin typeface="Arial" pitchFamily="34" charset="0"/>
                 <a:ea typeface="Arial" pitchFamily="34" charset="-122"/>
@@ -9227,7 +9227,7 @@
             <a:r>
               <a:rPr lang="en-US" sz="1400" b="1" dirty="0">
                 <a:solidFill>
-                  <a:srgbClr val="0A0A0A"/>
+                  <a:srgbClr val="2C5F2D"/>
                 </a:solidFill>
                 <a:latin typeface="Arial Black" pitchFamily="34" charset="0"/>
                 <a:ea typeface="Arial Black" pitchFamily="34" charset="-122"/>
@@ -9266,7 +9266,7 @@
             <a:r>
               <a:rPr lang="en-US" sz="1050" dirty="0">
                 <a:solidFill>
-                  <a:srgbClr val="0A0A0A"/>
+                  <a:srgbClr val="2C5F2D"/>
                 </a:solidFill>
                 <a:latin typeface="Arial" pitchFamily="34" charset="0"/>
                 <a:ea typeface="Arial" pitchFamily="34" charset="-122"/>
@@ -9305,7 +9305,7 @@
             <a:r>
               <a:rPr lang="en-US" sz="950" i="1" dirty="0">
                 <a:solidFill>
-                  <a:srgbClr val="6E6E6E"/>
+                  <a:srgbClr val="5A6B5A"/>
                 </a:solidFill>
                 <a:latin typeface="Arial" pitchFamily="34" charset="0"/>
                 <a:ea typeface="Arial" pitchFamily="34" charset="-122"/>
@@ -9344,7 +9344,7 @@
             <a:r>
               <a:rPr lang="en-US" sz="2000" b="1" dirty="0">
                 <a:solidFill>
-                  <a:srgbClr val="B0B0B0"/>
+                  <a:srgbClr val="8FAE8B"/>
                 </a:solidFill>
                 <a:latin typeface="Arial" pitchFamily="34" charset="0"/>
                 <a:ea typeface="Arial" pitchFamily="34" charset="-122"/>
@@ -9371,11 +9371,11 @@
             <a:avLst/>
           </a:prstGeom>
           <a:solidFill>
-            <a:srgbClr val="E0E0E0"/>
+            <a:srgbClr val="D8E8C8"/>
           </a:solidFill>
           <a:ln w="12700">
             <a:solidFill>
-              <a:srgbClr val="E0E0E0"/>
+              <a:srgbClr val="D8E8C8"/>
             </a:solidFill>
             <a:prstDash val="solid"/>
           </a:ln>
@@ -9398,11 +9398,11 @@
             </a:avLst>
           </a:prstGeom>
           <a:solidFill>
-            <a:srgbClr val="FFFFFF"/>
+            <a:srgbClr val="F0F5EA"/>
           </a:solidFill>
           <a:ln w="19050">
             <a:solidFill>
-              <a:srgbClr val="0A0A0A"/>
+              <a:srgbClr val="2C5F2D"/>
             </a:solidFill>
             <a:prstDash val="solid"/>
           </a:ln>
@@ -9423,7 +9423,7 @@
             <a:avLst/>
           </a:prstGeom>
           <a:solidFill>
-            <a:srgbClr val="0A0A0A"/>
+            <a:srgbClr val="1F3D26"/>
           </a:solidFill>
           <a:ln/>
         </p:spPr>
@@ -9455,7 +9455,7 @@
             <a:r>
               <a:rPr lang="en-US" sz="1800" b="1" dirty="0">
                 <a:solidFill>
-                  <a:srgbClr val="FFFFFF"/>
+                  <a:srgbClr val="F0F5EA"/>
                 </a:solidFill>
                 <a:latin typeface="Arial" pitchFamily="34" charset="0"/>
                 <a:ea typeface="Arial" pitchFamily="34" charset="-122"/>
@@ -9494,7 +9494,7 @@
             <a:r>
               <a:rPr lang="en-US" sz="1400" b="1" dirty="0">
                 <a:solidFill>
-                  <a:srgbClr val="0A0A0A"/>
+                  <a:srgbClr val="2C5F2D"/>
                 </a:solidFill>
                 <a:latin typeface="Arial Black" pitchFamily="34" charset="0"/>
                 <a:ea typeface="Arial Black" pitchFamily="34" charset="-122"/>
@@ -9533,7 +9533,7 @@
             <a:r>
               <a:rPr lang="en-US" sz="1050" dirty="0">
                 <a:solidFill>
-                  <a:srgbClr val="0A0A0A"/>
+                  <a:srgbClr val="2C5F2D"/>
                 </a:solidFill>
                 <a:latin typeface="Arial" pitchFamily="34" charset="0"/>
                 <a:ea typeface="Arial" pitchFamily="34" charset="-122"/>
@@ -9572,7 +9572,7 @@
             <a:r>
               <a:rPr lang="en-US" sz="950" i="1" dirty="0">
                 <a:solidFill>
-                  <a:srgbClr val="6E6E6E"/>
+                  <a:srgbClr val="5A6B5A"/>
                 </a:solidFill>
                 <a:latin typeface="Arial" pitchFamily="34" charset="0"/>
                 <a:ea typeface="Arial" pitchFamily="34" charset="-122"/>
@@ -9611,7 +9611,7 @@
             <a:r>
               <a:rPr lang="en-US" sz="2000" b="1" dirty="0">
                 <a:solidFill>
-                  <a:srgbClr val="B0B0B0"/>
+                  <a:srgbClr val="8FAE8B"/>
                 </a:solidFill>
                 <a:latin typeface="Arial" pitchFamily="34" charset="0"/>
                 <a:ea typeface="Arial" pitchFamily="34" charset="-122"/>
@@ -9638,11 +9638,11 @@
             <a:avLst/>
           </a:prstGeom>
           <a:solidFill>
-            <a:srgbClr val="E0E0E0"/>
+            <a:srgbClr val="D8E8C8"/>
           </a:solidFill>
           <a:ln w="12700">
             <a:solidFill>
-              <a:srgbClr val="E0E0E0"/>
+              <a:srgbClr val="D8E8C8"/>
             </a:solidFill>
             <a:prstDash val="solid"/>
           </a:ln>
@@ -9665,11 +9665,11 @@
             </a:avLst>
           </a:prstGeom>
           <a:solidFill>
-            <a:srgbClr val="FFFFFF"/>
+            <a:srgbClr val="F0F5EA"/>
           </a:solidFill>
           <a:ln w="19050">
             <a:solidFill>
-              <a:srgbClr val="0A0A0A"/>
+              <a:srgbClr val="2C5F2D"/>
             </a:solidFill>
             <a:prstDash val="solid"/>
           </a:ln>
@@ -9690,7 +9690,7 @@
             <a:avLst/>
           </a:prstGeom>
           <a:solidFill>
-            <a:srgbClr val="0A0A0A"/>
+            <a:srgbClr val="1F3D26"/>
           </a:solidFill>
           <a:ln/>
         </p:spPr>
@@ -9722,7 +9722,7 @@
             <a:r>
               <a:rPr lang="en-US" sz="1800" b="1" dirty="0">
                 <a:solidFill>
-                  <a:srgbClr val="FFFFFF"/>
+                  <a:srgbClr val="F0F5EA"/>
                 </a:solidFill>
                 <a:latin typeface="Arial" pitchFamily="34" charset="0"/>
                 <a:ea typeface="Arial" pitchFamily="34" charset="-122"/>
@@ -9761,7 +9761,7 @@
             <a:r>
               <a:rPr lang="en-US" sz="1400" b="1" dirty="0">
                 <a:solidFill>
-                  <a:srgbClr val="0A0A0A"/>
+                  <a:srgbClr val="2C5F2D"/>
                 </a:solidFill>
                 <a:latin typeface="Arial Black" pitchFamily="34" charset="0"/>
                 <a:ea typeface="Arial Black" pitchFamily="34" charset="-122"/>
@@ -9800,7 +9800,7 @@
             <a:r>
               <a:rPr lang="en-US" sz="1050" dirty="0">
                 <a:solidFill>
-                  <a:srgbClr val="0A0A0A"/>
+                  <a:srgbClr val="2C5F2D"/>
                 </a:solidFill>
                 <a:latin typeface="Arial" pitchFamily="34" charset="0"/>
                 <a:ea typeface="Arial" pitchFamily="34" charset="-122"/>
@@ -9839,7 +9839,7 @@
             <a:r>
               <a:rPr lang="en-US" sz="950" i="1" dirty="0">
                 <a:solidFill>
-                  <a:srgbClr val="6E6E6E"/>
+                  <a:srgbClr val="5A6B5A"/>
                 </a:solidFill>
                 <a:latin typeface="Arial" pitchFamily="34" charset="0"/>
                 <a:ea typeface="Arial" pitchFamily="34" charset="-122"/>
@@ -9878,7 +9878,7 @@
             <a:r>
               <a:rPr lang="en-US" sz="1350" b="1" dirty="0">
                 <a:solidFill>
-                  <a:srgbClr val="0A0A0A"/>
+                  <a:srgbClr val="2C5F2D"/>
                 </a:solidFill>
                 <a:latin typeface="Arial Black" pitchFamily="34" charset="0"/>
                 <a:ea typeface="Arial Black" pitchFamily="34" charset="-122"/>
@@ -9917,7 +9917,7 @@
             <a:r>
               <a:rPr lang="en-US" sz="850" dirty="0">
                 <a:solidFill>
-                  <a:srgbClr val="6E6E6E"/>
+                  <a:srgbClr val="5A6B5A"/>
                 </a:solidFill>
                 <a:latin typeface="Arial" pitchFamily="34" charset="0"/>
                 <a:ea typeface="Arial" pitchFamily="34" charset="-122"/>
@@ -9946,7 +9946,7 @@
     <p:bg>
       <p:bgPr>
         <a:solidFill>
-          <a:srgbClr val="FFFFFF"/>
+          <a:srgbClr val="F0F5EA"/>
         </a:solidFill>
       </p:bgPr>
     </p:bg>
@@ -9991,7 +9991,7 @@
             <a:r>
               <a:rPr lang="en-US" sz="2800" b="1" dirty="0">
                 <a:solidFill>
-                  <a:srgbClr val="E0E0E0"/>
+                  <a:srgbClr val="D8E8C8"/>
                 </a:solidFill>
                 <a:latin typeface="Arial Black" pitchFamily="34" charset="0"/>
                 <a:ea typeface="Arial Black" pitchFamily="34" charset="-122"/>
@@ -10037,7 +10037,7 @@
             <a:r>
               <a:rPr lang="en-US" sz="2800" b="1" dirty="0">
                 <a:solidFill>
-                  <a:srgbClr val="0A0A0A"/>
+                  <a:srgbClr val="2C5F2D"/>
                 </a:solidFill>
                 <a:latin typeface="Arial Black" pitchFamily="34" charset="0"/>
                 <a:ea typeface="Arial Black" pitchFamily="34" charset="-122"/>
@@ -10064,11 +10064,11 @@
             <a:avLst/>
           </a:prstGeom>
           <a:solidFill>
-            <a:srgbClr val="0A0A0A"/>
+            <a:srgbClr val="2C5F2D"/>
           </a:solidFill>
           <a:ln w="12700">
             <a:solidFill>
-              <a:srgbClr val="0A0A0A"/>
+              <a:srgbClr val="2C5F2D"/>
             </a:solidFill>
             <a:prstDash val="solid"/>
           </a:ln>
@@ -10089,11 +10089,11 @@
             <a:avLst/>
           </a:prstGeom>
           <a:solidFill>
-            <a:srgbClr val="E0E0E0"/>
+            <a:srgbClr val="D8E8C8"/>
           </a:solidFill>
           <a:ln w="12700">
             <a:solidFill>
-              <a:srgbClr val="E0E0E0"/>
+              <a:srgbClr val="D8E8C8"/>
             </a:solidFill>
             <a:prstDash val="solid"/>
           </a:ln>
@@ -10114,11 +10114,11 @@
             <a:avLst/>
           </a:prstGeom>
           <a:solidFill>
-            <a:srgbClr val="555555"/>
+            <a:srgbClr val="3E5C42"/>
           </a:solidFill>
           <a:ln w="12700">
             <a:solidFill>
-              <a:srgbClr val="555555"/>
+              <a:srgbClr val="3E5C42"/>
             </a:solidFill>
             <a:prstDash val="solid"/>
           </a:ln>
@@ -10141,7 +10141,7 @@
             </a:avLst>
           </a:prstGeom>
           <a:solidFill>
-            <a:srgbClr val="0A0A0A"/>
+            <a:srgbClr val="1F3D26"/>
           </a:solidFill>
           <a:ln w="12700">
             <a:solidFill>
@@ -10178,7 +10178,7 @@
             <a:r>
               <a:rPr lang="en-US" sz="1800" b="1" dirty="0">
                 <a:solidFill>
-                  <a:srgbClr val="FFFFFF"/>
+                  <a:srgbClr val="F0F5EA"/>
                 </a:solidFill>
                 <a:latin typeface="Arial Black" pitchFamily="34" charset="0"/>
                 <a:ea typeface="Arial Black" pitchFamily="34" charset="-122"/>
@@ -10217,7 +10217,7 @@
             <a:r>
               <a:rPr lang="en-US" sz="900" dirty="0">
                 <a:solidFill>
-                  <a:srgbClr val="B0B0B0"/>
+                  <a:srgbClr val="8FAE8B"/>
                 </a:solidFill>
                 <a:latin typeface="Arial" pitchFamily="34" charset="0"/>
                 <a:ea typeface="Arial" pitchFamily="34" charset="-122"/>
@@ -10244,11 +10244,11 @@
             <a:avLst/>
           </a:prstGeom>
           <a:solidFill>
-            <a:srgbClr val="E0E0E0"/>
+            <a:srgbClr val="D8E8C8"/>
           </a:solidFill>
           <a:ln w="12700">
             <a:solidFill>
-              <a:srgbClr val="E0E0E0"/>
+              <a:srgbClr val="D8E8C8"/>
             </a:solidFill>
             <a:prstDash val="solid"/>
           </a:ln>
@@ -10269,11 +10269,11 @@
             <a:avLst/>
           </a:prstGeom>
           <a:solidFill>
-            <a:srgbClr val="555555"/>
+            <a:srgbClr val="3E5C42"/>
           </a:solidFill>
           <a:ln w="12700">
             <a:solidFill>
-              <a:srgbClr val="555555"/>
+              <a:srgbClr val="3E5C42"/>
             </a:solidFill>
             <a:prstDash val="solid"/>
           </a:ln>
@@ -10296,7 +10296,7 @@
             </a:avLst>
           </a:prstGeom>
           <a:solidFill>
-            <a:srgbClr val="0A0A0A"/>
+            <a:srgbClr val="1F3D26"/>
           </a:solidFill>
           <a:ln w="12700">
             <a:solidFill>
@@ -10333,7 +10333,7 @@
             <a:r>
               <a:rPr lang="en-US" sz="1800" b="1" dirty="0">
                 <a:solidFill>
-                  <a:srgbClr val="FFFFFF"/>
+                  <a:srgbClr val="F0F5EA"/>
                 </a:solidFill>
                 <a:latin typeface="Arial Black" pitchFamily="34" charset="0"/>
                 <a:ea typeface="Arial Black" pitchFamily="34" charset="-122"/>
@@ -10372,7 +10372,7 @@
             <a:r>
               <a:rPr lang="en-US" sz="900" dirty="0">
                 <a:solidFill>
-                  <a:srgbClr val="B0B0B0"/>
+                  <a:srgbClr val="8FAE8B"/>
                 </a:solidFill>
                 <a:latin typeface="Arial" pitchFamily="34" charset="0"/>
                 <a:ea typeface="Arial" pitchFamily="34" charset="-122"/>
@@ -10399,11 +10399,11 @@
             <a:avLst/>
           </a:prstGeom>
           <a:solidFill>
-            <a:srgbClr val="E0E0E0"/>
+            <a:srgbClr val="D8E8C8"/>
           </a:solidFill>
           <a:ln w="12700">
             <a:solidFill>
-              <a:srgbClr val="E0E0E0"/>
+              <a:srgbClr val="D8E8C8"/>
             </a:solidFill>
             <a:prstDash val="solid"/>
           </a:ln>
@@ -10424,11 +10424,11 @@
             <a:avLst/>
           </a:prstGeom>
           <a:solidFill>
-            <a:srgbClr val="555555"/>
+            <a:srgbClr val="3E5C42"/>
           </a:solidFill>
           <a:ln w="12700">
             <a:solidFill>
-              <a:srgbClr val="555555"/>
+              <a:srgbClr val="3E5C42"/>
             </a:solidFill>
             <a:prstDash val="solid"/>
           </a:ln>
@@ -10451,7 +10451,7 @@
             </a:avLst>
           </a:prstGeom>
           <a:solidFill>
-            <a:srgbClr val="0A0A0A"/>
+            <a:srgbClr val="1F3D26"/>
           </a:solidFill>
           <a:ln w="12700">
             <a:solidFill>
@@ -10488,7 +10488,7 @@
             <a:r>
               <a:rPr lang="en-US" sz="1800" b="1" dirty="0">
                 <a:solidFill>
-                  <a:srgbClr val="FFFFFF"/>
+                  <a:srgbClr val="F0F5EA"/>
                 </a:solidFill>
                 <a:latin typeface="Arial Black" pitchFamily="34" charset="0"/>
                 <a:ea typeface="Arial Black" pitchFamily="34" charset="-122"/>
@@ -10527,7 +10527,7 @@
             <a:r>
               <a:rPr lang="en-US" sz="900" dirty="0">
                 <a:solidFill>
-                  <a:srgbClr val="B0B0B0"/>
+                  <a:srgbClr val="8FAE8B"/>
                 </a:solidFill>
                 <a:latin typeface="Arial" pitchFamily="34" charset="0"/>
                 <a:ea typeface="Arial" pitchFamily="34" charset="-122"/>
@@ -10554,11 +10554,11 @@
             <a:avLst/>
           </a:prstGeom>
           <a:solidFill>
-            <a:srgbClr val="E0E0E0"/>
+            <a:srgbClr val="D8E8C8"/>
           </a:solidFill>
           <a:ln w="12700">
             <a:solidFill>
-              <a:srgbClr val="E0E0E0"/>
+              <a:srgbClr val="D8E8C8"/>
             </a:solidFill>
             <a:prstDash val="solid"/>
           </a:ln>
@@ -10579,11 +10579,11 @@
             <a:avLst/>
           </a:prstGeom>
           <a:solidFill>
-            <a:srgbClr val="555555"/>
+            <a:srgbClr val="3E5C42"/>
           </a:solidFill>
           <a:ln w="12700">
             <a:solidFill>
-              <a:srgbClr val="555555"/>
+              <a:srgbClr val="3E5C42"/>
             </a:solidFill>
             <a:prstDash val="solid"/>
           </a:ln>
@@ -10606,7 +10606,7 @@
             </a:avLst>
           </a:prstGeom>
           <a:solidFill>
-            <a:srgbClr val="0A0A0A"/>
+            <a:srgbClr val="1F3D26"/>
           </a:solidFill>
           <a:ln w="12700">
             <a:solidFill>
@@ -10643,7 +10643,7 @@
             <a:r>
               <a:rPr lang="en-US" sz="1800" b="1" dirty="0">
                 <a:solidFill>
-                  <a:srgbClr val="FFFFFF"/>
+                  <a:srgbClr val="F0F5EA"/>
                 </a:solidFill>
                 <a:latin typeface="Arial Black" pitchFamily="34" charset="0"/>
                 <a:ea typeface="Arial Black" pitchFamily="34" charset="-122"/>
@@ -10682,7 +10682,7 @@
             <a:r>
               <a:rPr lang="en-US" sz="900" dirty="0">
                 <a:solidFill>
-                  <a:srgbClr val="B0B0B0"/>
+                  <a:srgbClr val="8FAE8B"/>
                 </a:solidFill>
                 <a:latin typeface="Arial" pitchFamily="34" charset="0"/>
                 <a:ea typeface="Arial" pitchFamily="34" charset="-122"/>
@@ -10709,11 +10709,11 @@
             <a:avLst/>
           </a:prstGeom>
           <a:solidFill>
-            <a:srgbClr val="E0E0E0"/>
+            <a:srgbClr val="D8E8C8"/>
           </a:solidFill>
           <a:ln w="12700">
             <a:solidFill>
-              <a:srgbClr val="E0E0E0"/>
+              <a:srgbClr val="D8E8C8"/>
             </a:solidFill>
             <a:prstDash val="solid"/>
           </a:ln>
@@ -10734,11 +10734,11 @@
             <a:avLst/>
           </a:prstGeom>
           <a:solidFill>
-            <a:srgbClr val="555555"/>
+            <a:srgbClr val="3E5C42"/>
           </a:solidFill>
           <a:ln w="12700">
             <a:solidFill>
-              <a:srgbClr val="555555"/>
+              <a:srgbClr val="3E5C42"/>
             </a:solidFill>
             <a:prstDash val="solid"/>
           </a:ln>
@@ -10761,7 +10761,7 @@
             </a:avLst>
           </a:prstGeom>
           <a:solidFill>
-            <a:srgbClr val="0A0A0A"/>
+            <a:srgbClr val="1F3D26"/>
           </a:solidFill>
           <a:ln w="12700">
             <a:solidFill>
@@ -10798,7 +10798,7 @@
             <a:r>
               <a:rPr lang="en-US" sz="1800" b="1" dirty="0">
                 <a:solidFill>
-                  <a:srgbClr val="FFFFFF"/>
+                  <a:srgbClr val="F0F5EA"/>
                 </a:solidFill>
                 <a:latin typeface="Arial Black" pitchFamily="34" charset="0"/>
                 <a:ea typeface="Arial Black" pitchFamily="34" charset="-122"/>
@@ -10837,7 +10837,7 @@
             <a:r>
               <a:rPr lang="en-US" sz="900" dirty="0">
                 <a:solidFill>
-                  <a:srgbClr val="B0B0B0"/>
+                  <a:srgbClr val="8FAE8B"/>
                 </a:solidFill>
                 <a:latin typeface="Arial" pitchFamily="34" charset="0"/>
                 <a:ea typeface="Arial" pitchFamily="34" charset="-122"/>
@@ -10864,11 +10864,11 @@
             <a:avLst/>
           </a:prstGeom>
           <a:solidFill>
-            <a:srgbClr val="E0E0E0"/>
+            <a:srgbClr val="D8E8C8"/>
           </a:solidFill>
           <a:ln w="12700">
             <a:solidFill>
-              <a:srgbClr val="E0E0E0"/>
+              <a:srgbClr val="D8E8C8"/>
             </a:solidFill>
             <a:prstDash val="solid"/>
           </a:ln>
@@ -10889,11 +10889,11 @@
             <a:avLst/>
           </a:prstGeom>
           <a:solidFill>
-            <a:srgbClr val="555555"/>
+            <a:srgbClr val="3E5C42"/>
           </a:solidFill>
           <a:ln w="12700">
             <a:solidFill>
-              <a:srgbClr val="555555"/>
+              <a:srgbClr val="3E5C42"/>
             </a:solidFill>
             <a:prstDash val="solid"/>
           </a:ln>
@@ -10916,7 +10916,7 @@
             </a:avLst>
           </a:prstGeom>
           <a:solidFill>
-            <a:srgbClr val="0A0A0A"/>
+            <a:srgbClr val="1F3D26"/>
           </a:solidFill>
           <a:ln w="12700">
             <a:solidFill>
@@ -10953,7 +10953,7 @@
             <a:r>
               <a:rPr lang="en-US" sz="1800" b="1" dirty="0">
                 <a:solidFill>
-                  <a:srgbClr val="FFFFFF"/>
+                  <a:srgbClr val="F0F5EA"/>
                 </a:solidFill>
                 <a:latin typeface="Arial Black" pitchFamily="34" charset="0"/>
                 <a:ea typeface="Arial Black" pitchFamily="34" charset="-122"/>
@@ -10992,7 +10992,7 @@
             <a:r>
               <a:rPr lang="en-US" sz="900" dirty="0">
                 <a:solidFill>
-                  <a:srgbClr val="B0B0B0"/>
+                  <a:srgbClr val="8FAE8B"/>
                 </a:solidFill>
                 <a:latin typeface="Arial" pitchFamily="34" charset="0"/>
                 <a:ea typeface="Arial" pitchFamily="34" charset="-122"/>
@@ -11031,7 +11031,7 @@
             <a:r>
               <a:rPr lang="en-US" sz="1150" dirty="0">
                 <a:solidFill>
-                  <a:srgbClr val="0A0A0A"/>
+                  <a:srgbClr val="2C5F2D"/>
                 </a:solidFill>
                 <a:latin typeface="Arial" pitchFamily="34" charset="0"/>
                 <a:ea typeface="Arial" pitchFamily="34" charset="-122"/>
@@ -11058,11 +11058,11 @@
             <a:avLst/>
           </a:prstGeom>
           <a:solidFill>
-            <a:srgbClr val="E0E0E0"/>
+            <a:srgbClr val="D8E8C8"/>
           </a:solidFill>
           <a:ln w="12700">
             <a:solidFill>
-              <a:srgbClr val="E0E0E0"/>
+              <a:srgbClr val="D8E8C8"/>
             </a:solidFill>
             <a:prstDash val="solid"/>
           </a:ln>
@@ -11085,7 +11085,7 @@
             </a:avLst>
           </a:prstGeom>
           <a:solidFill>
-            <a:srgbClr val="0A0A0A"/>
+            <a:srgbClr val="1F3D26"/>
           </a:solidFill>
           <a:ln w="12700">
             <a:solidFill>
@@ -11110,11 +11110,11 @@
             <a:avLst/>
           </a:prstGeom>
           <a:solidFill>
-            <a:srgbClr val="FF5A1F"/>
+            <a:srgbClr val="97BC62"/>
           </a:solidFill>
           <a:ln w="12700">
             <a:solidFill>
-              <a:srgbClr val="FF5A1F"/>
+              <a:srgbClr val="97BC62"/>
             </a:solidFill>
             <a:prstDash val="solid"/>
           </a:ln>
@@ -11147,7 +11147,7 @@
             <a:r>
               <a:rPr lang="en-US" sz="1050" dirty="0">
                 <a:solidFill>
-                  <a:srgbClr val="FFFFFF"/>
+                  <a:srgbClr val="F0F5EA"/>
                 </a:solidFill>
                 <a:latin typeface="Arial" pitchFamily="34" charset="0"/>
                 <a:ea typeface="Arial" pitchFamily="34" charset="-122"/>
@@ -11186,7 +11186,7 @@
             <a:r>
               <a:rPr lang="en-US" sz="850" dirty="0">
                 <a:solidFill>
-                  <a:srgbClr val="6E6E6E"/>
+                  <a:srgbClr val="5A6B5A"/>
                 </a:solidFill>
                 <a:latin typeface="Arial" pitchFamily="34" charset="0"/>
                 <a:ea typeface="Arial" pitchFamily="34" charset="-122"/>
@@ -11215,7 +11215,7 @@
     <p:bg>
       <p:bgPr>
         <a:solidFill>
-          <a:srgbClr val="FFFFFF"/>
+          <a:srgbClr val="F0F5EA"/>
         </a:solidFill>
       </p:bgPr>
     </p:bg>
@@ -11260,7 +11260,7 @@
             <a:r>
               <a:rPr lang="en-US" sz="2800" b="1" dirty="0">
                 <a:solidFill>
-                  <a:srgbClr val="E0E0E0"/>
+                  <a:srgbClr val="D8E8C8"/>
                 </a:solidFill>
                 <a:latin typeface="Arial Black" pitchFamily="34" charset="0"/>
                 <a:ea typeface="Arial Black" pitchFamily="34" charset="-122"/>
@@ -11306,7 +11306,7 @@
             <a:r>
               <a:rPr lang="en-US" sz="2800" b="1" dirty="0">
                 <a:solidFill>
-                  <a:srgbClr val="0A0A0A"/>
+                  <a:srgbClr val="2C5F2D"/>
                 </a:solidFill>
                 <a:latin typeface="Arial Black" pitchFamily="34" charset="0"/>
                 <a:ea typeface="Arial Black" pitchFamily="34" charset="-122"/>
@@ -11333,11 +11333,11 @@
             <a:avLst/>
           </a:prstGeom>
           <a:solidFill>
-            <a:srgbClr val="0A0A0A"/>
+            <a:srgbClr val="2C5F2D"/>
           </a:solidFill>
           <a:ln w="12700">
             <a:solidFill>
-              <a:srgbClr val="0A0A0A"/>
+              <a:srgbClr val="2C5F2D"/>
             </a:solidFill>
             <a:prstDash val="solid"/>
           </a:ln>
@@ -11358,11 +11358,11 @@
             <a:avLst/>
           </a:prstGeom>
           <a:solidFill>
-            <a:srgbClr val="E0E0E0"/>
+            <a:srgbClr val="D8E8C8"/>
           </a:solidFill>
           <a:ln w="12700">
             <a:solidFill>
-              <a:srgbClr val="E0E0E0"/>
+              <a:srgbClr val="D8E8C8"/>
             </a:solidFill>
             <a:prstDash val="solid"/>
           </a:ln>
@@ -11385,7 +11385,7 @@
             </a:avLst>
           </a:prstGeom>
           <a:solidFill>
-            <a:srgbClr val="F2F2F2"/>
+            <a:srgbClr val="EAF2E4"/>
           </a:solidFill>
           <a:ln w="12700">
             <a:solidFill>
@@ -11422,7 +11422,7 @@
             <a:r>
               <a:rPr lang="en-US" sz="1200" b="1" dirty="0">
                 <a:solidFill>
-                  <a:srgbClr val="6E6E6E"/>
+                  <a:srgbClr val="5A6B5A"/>
                 </a:solidFill>
                 <a:latin typeface="Arial" pitchFamily="34" charset="0"/>
                 <a:ea typeface="Arial" pitchFamily="34" charset="-122"/>
@@ -11461,7 +11461,7 @@
             <a:r>
               <a:rPr lang="en-US" sz="1700" i="1" dirty="0">
                 <a:solidFill>
-                  <a:srgbClr val="FF5A1F"/>
+                  <a:srgbClr val="97BC62"/>
                 </a:solidFill>
                 <a:latin typeface="Arial Black" pitchFamily="34" charset="0"/>
                 <a:ea typeface="Arial Black" pitchFamily="34" charset="-122"/>
@@ -11500,7 +11500,7 @@
             <a:r>
               <a:rPr lang="en-US" sz="1100" dirty="0">
                 <a:solidFill>
-                  <a:srgbClr val="6E6E6E"/>
+                  <a:srgbClr val="5A6B5A"/>
                 </a:solidFill>
                 <a:latin typeface="Arial" pitchFamily="34" charset="0"/>
                 <a:ea typeface="Arial" pitchFamily="34" charset="-122"/>
@@ -11527,11 +11527,11 @@
             <a:avLst/>
           </a:prstGeom>
           <a:solidFill>
-            <a:srgbClr val="E0E0E0"/>
+            <a:srgbClr val="D8E8C8"/>
           </a:solidFill>
           <a:ln w="12700">
             <a:solidFill>
-              <a:srgbClr val="E0E0E0"/>
+              <a:srgbClr val="D8E8C8"/>
             </a:solidFill>
             <a:prstDash val="solid"/>
           </a:ln>
@@ -11554,7 +11554,7 @@
             </a:avLst>
           </a:prstGeom>
           <a:solidFill>
-            <a:srgbClr val="0A0A0A"/>
+            <a:srgbClr val="1F3D26"/>
           </a:solidFill>
           <a:ln w="12700">
             <a:solidFill>
@@ -11591,7 +11591,7 @@
             <a:r>
               <a:rPr lang="en-US" sz="1200" b="1" dirty="0">
                 <a:solidFill>
-                  <a:srgbClr val="FFFFFF"/>
+                  <a:srgbClr val="F0F5EA"/>
                 </a:solidFill>
                 <a:latin typeface="Arial Black" pitchFamily="34" charset="0"/>
                 <a:ea typeface="Arial Black" pitchFamily="34" charset="-122"/>
@@ -11630,7 +11630,7 @@
             <a:r>
               <a:rPr lang="en-US" sz="1250" dirty="0">
                 <a:solidFill>
-                  <a:srgbClr val="FFFFFF"/>
+                  <a:srgbClr val="F0F5EA"/>
                 </a:solidFill>
                 <a:latin typeface="Arial" pitchFamily="34" charset="0"/>
                 <a:ea typeface="Arial" pitchFamily="34" charset="-122"/>
@@ -11681,7 +11681,7 @@
                       <a:r>
                         <a:rPr lang="en-US" sz="1200" b="1" dirty="0">
                           <a:solidFill>
-                            <a:srgbClr val="FFFFFF"/>
+                            <a:srgbClr val="F0F5EA"/>
                           </a:solidFill>
                           <a:latin typeface="Arial Black" pitchFamily="34" charset="0"/>
                           <a:ea typeface="Arial Black" pitchFamily="34" charset="-122"/>
@@ -11699,7 +11699,7 @@
                   <a:tcPr marL="54864" marR="54864" marT="54864" marB="54864" anchor="mid">
                     <a:lnL w="6350" cap="flat" cmpd="sng" algn="ctr">
                       <a:solidFill>
-                        <a:srgbClr val="D9D9D9"/>
+                        <a:srgbClr val="C8D9C0"/>
                       </a:solidFill>
                       <a:prstDash val="solid"/>
                       <a:round/>
@@ -11708,7 +11708,7 @@
                     </a:lnL>
                     <a:lnR w="6350" cap="flat" cmpd="sng" algn="ctr">
                       <a:solidFill>
-                        <a:srgbClr val="D9D9D9"/>
+                        <a:srgbClr val="C8D9C0"/>
                       </a:solidFill>
                       <a:prstDash val="solid"/>
                       <a:round/>
@@ -11717,7 +11717,7 @@
                     </a:lnR>
                     <a:lnT w="6350" cap="flat" cmpd="sng" algn="ctr">
                       <a:solidFill>
-                        <a:srgbClr val="D9D9D9"/>
+                        <a:srgbClr val="C8D9C0"/>
                       </a:solidFill>
                       <a:prstDash val="solid"/>
                       <a:round/>
@@ -11726,7 +11726,7 @@
                     </a:lnT>
                     <a:lnB w="6350" cap="flat" cmpd="sng" algn="ctr">
                       <a:solidFill>
-                        <a:srgbClr val="D9D9D9"/>
+                        <a:srgbClr val="C8D9C0"/>
                       </a:solidFill>
                       <a:prstDash val="solid"/>
                       <a:round/>
@@ -11734,7 +11734,7 @@
                       <a:tailEnd type="none" w="med" len="med"/>
                     </a:lnB>
                     <a:solidFill>
-                      <a:srgbClr val="0A0A0A"/>
+                      <a:srgbClr val="1F3D26"/>
                     </a:solidFill>
                   </a:tcPr>
                 </a:tc>
@@ -11757,7 +11757,7 @@
                       <a:r>
                         <a:rPr lang="en-US" sz="1050" b="1" dirty="0">
                           <a:solidFill>
-                            <a:srgbClr val="0A0A0A"/>
+                            <a:srgbClr val="2C5F2D"/>
                           </a:solidFill>
                           <a:latin typeface="Arial" pitchFamily="34" charset="0"/>
                           <a:ea typeface="Arial" pitchFamily="34" charset="-122"/>
@@ -11775,7 +11775,7 @@
                   <a:tcPr marL="54864" marR="54864" marT="54864" marB="54864" anchor="mid">
                     <a:lnL w="6350" cap="flat" cmpd="sng" algn="ctr">
                       <a:solidFill>
-                        <a:srgbClr val="D9D9D9"/>
+                        <a:srgbClr val="C8D9C0"/>
                       </a:solidFill>
                       <a:prstDash val="solid"/>
                       <a:round/>
@@ -11784,7 +11784,7 @@
                     </a:lnL>
                     <a:lnR w="6350" cap="flat" cmpd="sng" algn="ctr">
                       <a:solidFill>
-                        <a:srgbClr val="D9D9D9"/>
+                        <a:srgbClr val="C8D9C0"/>
                       </a:solidFill>
                       <a:prstDash val="solid"/>
                       <a:round/>
@@ -11793,7 +11793,7 @@
                     </a:lnR>
                     <a:lnT w="6350" cap="flat" cmpd="sng" algn="ctr">
                       <a:solidFill>
-                        <a:srgbClr val="D9D9D9"/>
+                        <a:srgbClr val="C8D9C0"/>
                       </a:solidFill>
                       <a:prstDash val="solid"/>
                       <a:round/>
@@ -11802,7 +11802,7 @@
                     </a:lnT>
                     <a:lnB w="6350" cap="flat" cmpd="sng" algn="ctr">
                       <a:solidFill>
-                        <a:srgbClr val="D9D9D9"/>
+                        <a:srgbClr val="C8D9C0"/>
                       </a:solidFill>
                       <a:prstDash val="solid"/>
                       <a:round/>
@@ -11810,7 +11810,7 @@
                       <a:tailEnd type="none" w="med" len="med"/>
                     </a:lnB>
                     <a:solidFill>
-                      <a:srgbClr val="F7F7F7"/>
+                      <a:srgbClr val="F4F9EF"/>
                     </a:solidFill>
                   </a:tcPr>
                 </a:tc>
@@ -11825,7 +11825,7 @@
                       <a:r>
                         <a:rPr lang="en-US" sz="1050" dirty="0">
                           <a:solidFill>
-                            <a:srgbClr val="6E6E6E"/>
+                            <a:srgbClr val="5A6B5A"/>
                           </a:solidFill>
                           <a:latin typeface="Arial" pitchFamily="34" charset="0"/>
                           <a:ea typeface="Arial" pitchFamily="34" charset="-122"/>
@@ -11843,7 +11843,7 @@
                   <a:tcPr marL="54864" marR="54864" marT="54864" marB="54864" anchor="mid">
                     <a:lnL w="6350" cap="flat" cmpd="sng" algn="ctr">
                       <a:solidFill>
-                        <a:srgbClr val="D9D9D9"/>
+                        <a:srgbClr val="C8D9C0"/>
                       </a:solidFill>
                       <a:prstDash val="solid"/>
                       <a:round/>
@@ -11852,7 +11852,7 @@
                     </a:lnL>
                     <a:lnR w="6350" cap="flat" cmpd="sng" algn="ctr">
                       <a:solidFill>
-                        <a:srgbClr val="D9D9D9"/>
+                        <a:srgbClr val="C8D9C0"/>
                       </a:solidFill>
                       <a:prstDash val="solid"/>
                       <a:round/>
@@ -11861,7 +11861,7 @@
                     </a:lnR>
                     <a:lnT w="6350" cap="flat" cmpd="sng" algn="ctr">
                       <a:solidFill>
-                        <a:srgbClr val="D9D9D9"/>
+                        <a:srgbClr val="C8D9C0"/>
                       </a:solidFill>
                       <a:prstDash val="solid"/>
                       <a:round/>
@@ -11870,7 +11870,7 @@
                     </a:lnT>
                     <a:lnB w="6350" cap="flat" cmpd="sng" algn="ctr">
                       <a:solidFill>
-                        <a:srgbClr val="D9D9D9"/>
+                        <a:srgbClr val="C8D9C0"/>
                       </a:solidFill>
                       <a:prstDash val="solid"/>
                       <a:round/>
@@ -11878,7 +11878,7 @@
                       <a:tailEnd type="none" w="med" len="med"/>
                     </a:lnB>
                     <a:solidFill>
-                      <a:srgbClr val="F7F7F7"/>
+                      <a:srgbClr val="F4F9EF"/>
                     </a:solidFill>
                   </a:tcPr>
                 </a:tc>
@@ -11893,7 +11893,7 @@
                       <a:r>
                         <a:rPr lang="en-US" sz="1050" dirty="0">
                           <a:solidFill>
-                            <a:srgbClr val="B0B0B0"/>
+                            <a:srgbClr val="8FAE8B"/>
                           </a:solidFill>
                           <a:latin typeface="Arial" pitchFamily="34" charset="0"/>
                           <a:ea typeface="Arial" pitchFamily="34" charset="-122"/>
@@ -11911,7 +11911,7 @@
                   <a:tcPr marL="54864" marR="54864" marT="54864" marB="54864" anchor="mid">
                     <a:lnL w="6350" cap="flat" cmpd="sng" algn="ctr">
                       <a:solidFill>
-                        <a:srgbClr val="D9D9D9"/>
+                        <a:srgbClr val="C8D9C0"/>
                       </a:solidFill>
                       <a:prstDash val="solid"/>
                       <a:round/>
@@ -11920,7 +11920,7 @@
                     </a:lnL>
                     <a:lnR w="6350" cap="flat" cmpd="sng" algn="ctr">
                       <a:solidFill>
-                        <a:srgbClr val="D9D9D9"/>
+                        <a:srgbClr val="C8D9C0"/>
                       </a:solidFill>
                       <a:prstDash val="solid"/>
                       <a:round/>
@@ -11929,7 +11929,7 @@
                     </a:lnR>
                     <a:lnT w="6350" cap="flat" cmpd="sng" algn="ctr">
                       <a:solidFill>
-                        <a:srgbClr val="D9D9D9"/>
+                        <a:srgbClr val="C8D9C0"/>
                       </a:solidFill>
                       <a:prstDash val="solid"/>
                       <a:round/>
@@ -11938,7 +11938,7 @@
                     </a:lnT>
                     <a:lnB w="6350" cap="flat" cmpd="sng" algn="ctr">
                       <a:solidFill>
-                        <a:srgbClr val="D9D9D9"/>
+                        <a:srgbClr val="C8D9C0"/>
                       </a:solidFill>
                       <a:prstDash val="solid"/>
                       <a:round/>
@@ -11946,7 +11946,7 @@
                       <a:tailEnd type="none" w="med" len="med"/>
                     </a:lnB>
                     <a:solidFill>
-                      <a:srgbClr val="F7F7F7"/>
+                      <a:srgbClr val="F4F9EF"/>
                     </a:solidFill>
                   </a:tcPr>
                 </a:tc>
@@ -11963,7 +11963,7 @@
                       <a:r>
                         <a:rPr lang="en-US" sz="1050" b="1" dirty="0">
                           <a:solidFill>
-                            <a:srgbClr val="0A0A0A"/>
+                            <a:srgbClr val="2C5F2D"/>
                           </a:solidFill>
                           <a:latin typeface="Arial" pitchFamily="34" charset="0"/>
                           <a:ea typeface="Arial" pitchFamily="34" charset="-122"/>
@@ -11981,7 +11981,7 @@
                   <a:tcPr marL="54864" marR="54864" marT="54864" marB="54864" anchor="mid">
                     <a:lnL w="6350" cap="flat" cmpd="sng" algn="ctr">
                       <a:solidFill>
-                        <a:srgbClr val="D9D9D9"/>
+                        <a:srgbClr val="C8D9C0"/>
                       </a:solidFill>
                       <a:prstDash val="solid"/>
                       <a:round/>
@@ -11990,7 +11990,7 @@
                     </a:lnL>
                     <a:lnR w="6350" cap="flat" cmpd="sng" algn="ctr">
                       <a:solidFill>
-                        <a:srgbClr val="D9D9D9"/>
+                        <a:srgbClr val="C8D9C0"/>
                       </a:solidFill>
                       <a:prstDash val="solid"/>
                       <a:round/>
@@ -11999,7 +11999,7 @@
                     </a:lnR>
                     <a:lnT w="6350" cap="flat" cmpd="sng" algn="ctr">
                       <a:solidFill>
-                        <a:srgbClr val="D9D9D9"/>
+                        <a:srgbClr val="C8D9C0"/>
                       </a:solidFill>
                       <a:prstDash val="solid"/>
                       <a:round/>
@@ -12008,7 +12008,7 @@
                     </a:lnT>
                     <a:lnB w="6350" cap="flat" cmpd="sng" algn="ctr">
                       <a:solidFill>
-                        <a:srgbClr val="D9D9D9"/>
+                        <a:srgbClr val="C8D9C0"/>
                       </a:solidFill>
                       <a:prstDash val="solid"/>
                       <a:round/>
@@ -12016,7 +12016,7 @@
                       <a:tailEnd type="none" w="med" len="med"/>
                     </a:lnB>
                     <a:solidFill>
-                      <a:srgbClr val="FFFFFF"/>
+                      <a:srgbClr val="F0F5EA"/>
                     </a:solidFill>
                   </a:tcPr>
                 </a:tc>
@@ -12031,7 +12031,7 @@
                       <a:r>
                         <a:rPr lang="en-US" sz="1050" dirty="0">
                           <a:solidFill>
-                            <a:srgbClr val="6E6E6E"/>
+                            <a:srgbClr val="5A6B5A"/>
                           </a:solidFill>
                           <a:latin typeface="Arial" pitchFamily="34" charset="0"/>
                           <a:ea typeface="Arial" pitchFamily="34" charset="-122"/>
@@ -12049,7 +12049,7 @@
                   <a:tcPr marL="54864" marR="54864" marT="54864" marB="54864" anchor="mid">
                     <a:lnL w="6350" cap="flat" cmpd="sng" algn="ctr">
                       <a:solidFill>
-                        <a:srgbClr val="D9D9D9"/>
+                        <a:srgbClr val="C8D9C0"/>
                       </a:solidFill>
                       <a:prstDash val="solid"/>
                       <a:round/>
@@ -12058,7 +12058,7 @@
                     </a:lnL>
                     <a:lnR w="6350" cap="flat" cmpd="sng" algn="ctr">
                       <a:solidFill>
-                        <a:srgbClr val="D9D9D9"/>
+                        <a:srgbClr val="C8D9C0"/>
                       </a:solidFill>
                       <a:prstDash val="solid"/>
                       <a:round/>
@@ -12067,7 +12067,7 @@
                     </a:lnR>
                     <a:lnT w="6350" cap="flat" cmpd="sng" algn="ctr">
                       <a:solidFill>
-                        <a:srgbClr val="D9D9D9"/>
+                        <a:srgbClr val="C8D9C0"/>
                       </a:solidFill>
                       <a:prstDash val="solid"/>
                       <a:round/>
@@ -12076,7 +12076,7 @@
                     </a:lnT>
                     <a:lnB w="6350" cap="flat" cmpd="sng" algn="ctr">
                       <a:solidFill>
-                        <a:srgbClr val="D9D9D9"/>
+                        <a:srgbClr val="C8D9C0"/>
                       </a:solidFill>
                       <a:prstDash val="solid"/>
                       <a:round/>
@@ -12084,7 +12084,7 @@
                       <a:tailEnd type="none" w="med" len="med"/>
                     </a:lnB>
                     <a:solidFill>
-                      <a:srgbClr val="FFFFFF"/>
+                      <a:srgbClr val="F0F5EA"/>
                     </a:solidFill>
                   </a:tcPr>
                 </a:tc>
@@ -12099,7 +12099,7 @@
                       <a:r>
                         <a:rPr lang="en-US" sz="1050" dirty="0">
                           <a:solidFill>
-                            <a:srgbClr val="B0B0B0"/>
+                            <a:srgbClr val="8FAE8B"/>
                           </a:solidFill>
                           <a:latin typeface="Arial" pitchFamily="34" charset="0"/>
                           <a:ea typeface="Arial" pitchFamily="34" charset="-122"/>
@@ -12117,7 +12117,7 @@
                   <a:tcPr marL="54864" marR="54864" marT="54864" marB="54864" anchor="mid">
                     <a:lnL w="6350" cap="flat" cmpd="sng" algn="ctr">
                       <a:solidFill>
-                        <a:srgbClr val="D9D9D9"/>
+                        <a:srgbClr val="C8D9C0"/>
                       </a:solidFill>
                       <a:prstDash val="solid"/>
                       <a:round/>
@@ -12126,7 +12126,7 @@
                     </a:lnL>
                     <a:lnR w="6350" cap="flat" cmpd="sng" algn="ctr">
                       <a:solidFill>
-                        <a:srgbClr val="D9D9D9"/>
+                        <a:srgbClr val="C8D9C0"/>
                       </a:solidFill>
                       <a:prstDash val="solid"/>
                       <a:round/>
@@ -12135,7 +12135,7 @@
                     </a:lnR>
                     <a:lnT w="6350" cap="flat" cmpd="sng" algn="ctr">
                       <a:solidFill>
-                        <a:srgbClr val="D9D9D9"/>
+                        <a:srgbClr val="C8D9C0"/>
                       </a:solidFill>
                       <a:prstDash val="solid"/>
                       <a:round/>
@@ -12144,7 +12144,7 @@
                     </a:lnT>
                     <a:lnB w="6350" cap="flat" cmpd="sng" algn="ctr">
                       <a:solidFill>
-                        <a:srgbClr val="D9D9D9"/>
+                        <a:srgbClr val="C8D9C0"/>
                       </a:solidFill>
                       <a:prstDash val="solid"/>
                       <a:round/>
@@ -12152,7 +12152,7 @@
                       <a:tailEnd type="none" w="med" len="med"/>
                     </a:lnB>
                     <a:solidFill>
-                      <a:srgbClr val="FFFFFF"/>
+                      <a:srgbClr val="F0F5EA"/>
                     </a:solidFill>
                   </a:tcPr>
                 </a:tc>
@@ -12169,7 +12169,7 @@
                       <a:r>
                         <a:rPr lang="en-US" sz="1050" b="1" dirty="0">
                           <a:solidFill>
-                            <a:srgbClr val="0A0A0A"/>
+                            <a:srgbClr val="2C5F2D"/>
                           </a:solidFill>
                           <a:latin typeface="Arial" pitchFamily="34" charset="0"/>
                           <a:ea typeface="Arial" pitchFamily="34" charset="-122"/>
@@ -12187,7 +12187,7 @@
                   <a:tcPr marL="54864" marR="54864" marT="54864" marB="54864" anchor="mid">
                     <a:lnL w="6350" cap="flat" cmpd="sng" algn="ctr">
                       <a:solidFill>
-                        <a:srgbClr val="D9D9D9"/>
+                        <a:srgbClr val="C8D9C0"/>
                       </a:solidFill>
                       <a:prstDash val="solid"/>
                       <a:round/>
@@ -12196,7 +12196,7 @@
                     </a:lnL>
                     <a:lnR w="6350" cap="flat" cmpd="sng" algn="ctr">
                       <a:solidFill>
-                        <a:srgbClr val="D9D9D9"/>
+                        <a:srgbClr val="C8D9C0"/>
                       </a:solidFill>
                       <a:prstDash val="solid"/>
                       <a:round/>
@@ -12205,7 +12205,7 @@
                     </a:lnR>
                     <a:lnT w="6350" cap="flat" cmpd="sng" algn="ctr">
                       <a:solidFill>
-                        <a:srgbClr val="D9D9D9"/>
+                        <a:srgbClr val="C8D9C0"/>
                       </a:solidFill>
                       <a:prstDash val="solid"/>
                       <a:round/>
@@ -12214,7 +12214,7 @@
                     </a:lnT>
                     <a:lnB w="6350" cap="flat" cmpd="sng" algn="ctr">
                       <a:solidFill>
-                        <a:srgbClr val="D9D9D9"/>
+                        <a:srgbClr val="C8D9C0"/>
                       </a:solidFill>
                       <a:prstDash val="solid"/>
                       <a:round/>
@@ -12222,7 +12222,7 @@
                       <a:tailEnd type="none" w="med" len="med"/>
                     </a:lnB>
                     <a:solidFill>
-                      <a:srgbClr val="F7F7F7"/>
+                      <a:srgbClr val="F4F9EF"/>
                     </a:solidFill>
                   </a:tcPr>
                 </a:tc>
@@ -12237,7 +12237,7 @@
                       <a:r>
                         <a:rPr lang="en-US" sz="1050" dirty="0">
                           <a:solidFill>
-                            <a:srgbClr val="6E6E6E"/>
+                            <a:srgbClr val="5A6B5A"/>
                           </a:solidFill>
                           <a:latin typeface="Arial" pitchFamily="34" charset="0"/>
                           <a:ea typeface="Arial" pitchFamily="34" charset="-122"/>
@@ -12255,7 +12255,7 @@
                   <a:tcPr marL="54864" marR="54864" marT="54864" marB="54864" anchor="mid">
                     <a:lnL w="6350" cap="flat" cmpd="sng" algn="ctr">
                       <a:solidFill>
-                        <a:srgbClr val="D9D9D9"/>
+                        <a:srgbClr val="C8D9C0"/>
                       </a:solidFill>
                       <a:prstDash val="solid"/>
                       <a:round/>
@@ -12264,7 +12264,7 @@
                     </a:lnL>
                     <a:lnR w="6350" cap="flat" cmpd="sng" algn="ctr">
                       <a:solidFill>
-                        <a:srgbClr val="D9D9D9"/>
+                        <a:srgbClr val="C8D9C0"/>
                       </a:solidFill>
                       <a:prstDash val="solid"/>
                       <a:round/>
@@ -12273,7 +12273,7 @@
                     </a:lnR>
                     <a:lnT w="6350" cap="flat" cmpd="sng" algn="ctr">
                       <a:solidFill>
-                        <a:srgbClr val="D9D9D9"/>
+                        <a:srgbClr val="C8D9C0"/>
                       </a:solidFill>
                       <a:prstDash val="solid"/>
                       <a:round/>
@@ -12282,7 +12282,7 @@
                     </a:lnT>
                     <a:lnB w="6350" cap="flat" cmpd="sng" algn="ctr">
                       <a:solidFill>
-                        <a:srgbClr val="D9D9D9"/>
+                        <a:srgbClr val="C8D9C0"/>
                       </a:solidFill>
                       <a:prstDash val="solid"/>
                       <a:round/>
@@ -12290,7 +12290,7 @@
                       <a:tailEnd type="none" w="med" len="med"/>
                     </a:lnB>
                     <a:solidFill>
-                      <a:srgbClr val="F7F7F7"/>
+                      <a:srgbClr val="F4F9EF"/>
                     </a:solidFill>
                   </a:tcPr>
                 </a:tc>
@@ -12305,7 +12305,7 @@
                       <a:r>
                         <a:rPr lang="en-US" sz="1050" dirty="0">
                           <a:solidFill>
-                            <a:srgbClr val="B0B0B0"/>
+                            <a:srgbClr val="8FAE8B"/>
                           </a:solidFill>
                           <a:latin typeface="Arial" pitchFamily="34" charset="0"/>
                           <a:ea typeface="Arial" pitchFamily="34" charset="-122"/>
@@ -12323,7 +12323,7 @@
                   <a:tcPr marL="54864" marR="54864" marT="54864" marB="54864" anchor="mid">
                     <a:lnL w="6350" cap="flat" cmpd="sng" algn="ctr">
                       <a:solidFill>
-                        <a:srgbClr val="D9D9D9"/>
+                        <a:srgbClr val="C8D9C0"/>
                       </a:solidFill>
                       <a:prstDash val="solid"/>
                       <a:round/>
@@ -12332,7 +12332,7 @@
                     </a:lnL>
                     <a:lnR w="6350" cap="flat" cmpd="sng" algn="ctr">
                       <a:solidFill>
-                        <a:srgbClr val="D9D9D9"/>
+                        <a:srgbClr val="C8D9C0"/>
                       </a:solidFill>
                       <a:prstDash val="solid"/>
                       <a:round/>
@@ -12341,7 +12341,7 @@
                     </a:lnR>
                     <a:lnT w="6350" cap="flat" cmpd="sng" algn="ctr">
                       <a:solidFill>
-                        <a:srgbClr val="D9D9D9"/>
+                        <a:srgbClr val="C8D9C0"/>
                       </a:solidFill>
                       <a:prstDash val="solid"/>
                       <a:round/>
@@ -12350,7 +12350,7 @@
                     </a:lnT>
                     <a:lnB w="6350" cap="flat" cmpd="sng" algn="ctr">
                       <a:solidFill>
-                        <a:srgbClr val="D9D9D9"/>
+                        <a:srgbClr val="C8D9C0"/>
                       </a:solidFill>
                       <a:prstDash val="solid"/>
                       <a:round/>
@@ -12358,7 +12358,7 @@
                       <a:tailEnd type="none" w="med" len="med"/>
                     </a:lnB>
                     <a:solidFill>
-                      <a:srgbClr val="F7F7F7"/>
+                      <a:srgbClr val="F4F9EF"/>
                     </a:solidFill>
                   </a:tcPr>
                 </a:tc>
@@ -12375,7 +12375,7 @@
                       <a:r>
                         <a:rPr lang="en-US" sz="1050" b="1" dirty="0">
                           <a:solidFill>
-                            <a:srgbClr val="0A0A0A"/>
+                            <a:srgbClr val="2C5F2D"/>
                           </a:solidFill>
                           <a:latin typeface="Arial" pitchFamily="34" charset="0"/>
                           <a:ea typeface="Arial" pitchFamily="34" charset="-122"/>
@@ -12393,7 +12393,7 @@
                   <a:tcPr marL="54864" marR="54864" marT="54864" marB="54864" anchor="mid">
                     <a:lnL w="6350" cap="flat" cmpd="sng" algn="ctr">
                       <a:solidFill>
-                        <a:srgbClr val="D9D9D9"/>
+                        <a:srgbClr val="C8D9C0"/>
                       </a:solidFill>
                       <a:prstDash val="solid"/>
                       <a:round/>
@@ -12402,7 +12402,7 @@
                     </a:lnL>
                     <a:lnR w="6350" cap="flat" cmpd="sng" algn="ctr">
                       <a:solidFill>
-                        <a:srgbClr val="D9D9D9"/>
+                        <a:srgbClr val="C8D9C0"/>
                       </a:solidFill>
                       <a:prstDash val="solid"/>
                       <a:round/>
@@ -12411,7 +12411,7 @@
                     </a:lnR>
                     <a:lnT w="6350" cap="flat" cmpd="sng" algn="ctr">
                       <a:solidFill>
-                        <a:srgbClr val="D9D9D9"/>
+                        <a:srgbClr val="C8D9C0"/>
                       </a:solidFill>
                       <a:prstDash val="solid"/>
                       <a:round/>
@@ -12420,7 +12420,7 @@
                     </a:lnT>
                     <a:lnB w="6350" cap="flat" cmpd="sng" algn="ctr">
                       <a:solidFill>
-                        <a:srgbClr val="D9D9D9"/>
+                        <a:srgbClr val="C8D9C0"/>
                       </a:solidFill>
                       <a:prstDash val="solid"/>
                       <a:round/>
@@ -12428,7 +12428,7 @@
                       <a:tailEnd type="none" w="med" len="med"/>
                     </a:lnB>
                     <a:solidFill>
-                      <a:srgbClr val="FFFFFF"/>
+                      <a:srgbClr val="F0F5EA"/>
                     </a:solidFill>
                   </a:tcPr>
                 </a:tc>
@@ -12443,7 +12443,7 @@
                       <a:r>
                         <a:rPr lang="en-US" sz="1050" dirty="0">
                           <a:solidFill>
-                            <a:srgbClr val="6E6E6E"/>
+                            <a:srgbClr val="5A6B5A"/>
                           </a:solidFill>
                           <a:latin typeface="Arial" pitchFamily="34" charset="0"/>
                           <a:ea typeface="Arial" pitchFamily="34" charset="-122"/>
@@ -12461,7 +12461,7 @@
                   <a:tcPr marL="54864" marR="54864" marT="54864" marB="54864" anchor="mid">
                     <a:lnL w="6350" cap="flat" cmpd="sng" algn="ctr">
                       <a:solidFill>
-                        <a:srgbClr val="D9D9D9"/>
+                        <a:srgbClr val="C8D9C0"/>
                       </a:solidFill>
                       <a:prstDash val="solid"/>
                       <a:round/>
@@ -12470,7 +12470,7 @@
                     </a:lnL>
                     <a:lnR w="6350" cap="flat" cmpd="sng" algn="ctr">
                       <a:solidFill>
-                        <a:srgbClr val="D9D9D9"/>
+                        <a:srgbClr val="C8D9C0"/>
                       </a:solidFill>
                       <a:prstDash val="solid"/>
                       <a:round/>
@@ -12479,7 +12479,7 @@
                     </a:lnR>
                     <a:lnT w="6350" cap="flat" cmpd="sng" algn="ctr">
                       <a:solidFill>
-                        <a:srgbClr val="D9D9D9"/>
+                        <a:srgbClr val="C8D9C0"/>
                       </a:solidFill>
                       <a:prstDash val="solid"/>
                       <a:round/>
@@ -12488,7 +12488,7 @@
                     </a:lnT>
                     <a:lnB w="6350" cap="flat" cmpd="sng" algn="ctr">
                       <a:solidFill>
-                        <a:srgbClr val="D9D9D9"/>
+                        <a:srgbClr val="C8D9C0"/>
                       </a:solidFill>
                       <a:prstDash val="solid"/>
                       <a:round/>
@@ -12496,7 +12496,7 @@
                       <a:tailEnd type="none" w="med" len="med"/>
                     </a:lnB>
                     <a:solidFill>
-                      <a:srgbClr val="FFFFFF"/>
+                      <a:srgbClr val="F0F5EA"/>
                     </a:solidFill>
                   </a:tcPr>
                 </a:tc>
@@ -12511,7 +12511,7 @@
                       <a:r>
                         <a:rPr lang="en-US" sz="1050" dirty="0">
                           <a:solidFill>
-                            <a:srgbClr val="B0B0B0"/>
+                            <a:srgbClr val="8FAE8B"/>
                           </a:solidFill>
                           <a:latin typeface="Arial" pitchFamily="34" charset="0"/>
                           <a:ea typeface="Arial" pitchFamily="34" charset="-122"/>
@@ -12529,7 +12529,7 @@
                   <a:tcPr marL="54864" marR="54864" marT="54864" marB="54864" anchor="mid">
                     <a:lnL w="6350" cap="flat" cmpd="sng" algn="ctr">
                       <a:solidFill>
-                        <a:srgbClr val="D9D9D9"/>
+                        <a:srgbClr val="C8D9C0"/>
                       </a:solidFill>
                       <a:prstDash val="solid"/>
                       <a:round/>
@@ -12538,7 +12538,7 @@
                     </a:lnL>
                     <a:lnR w="6350" cap="flat" cmpd="sng" algn="ctr">
                       <a:solidFill>
-                        <a:srgbClr val="D9D9D9"/>
+                        <a:srgbClr val="C8D9C0"/>
                       </a:solidFill>
                       <a:prstDash val="solid"/>
                       <a:round/>
@@ -12547,7 +12547,7 @@
                     </a:lnR>
                     <a:lnT w="6350" cap="flat" cmpd="sng" algn="ctr">
                       <a:solidFill>
-                        <a:srgbClr val="D9D9D9"/>
+                        <a:srgbClr val="C8D9C0"/>
                       </a:solidFill>
                       <a:prstDash val="solid"/>
                       <a:round/>
@@ -12556,7 +12556,7 @@
                     </a:lnT>
                     <a:lnB w="6350" cap="flat" cmpd="sng" algn="ctr">
                       <a:solidFill>
-                        <a:srgbClr val="D9D9D9"/>
+                        <a:srgbClr val="C8D9C0"/>
                       </a:solidFill>
                       <a:prstDash val="solid"/>
                       <a:round/>
@@ -12564,7 +12564,7 @@
                       <a:tailEnd type="none" w="med" len="med"/>
                     </a:lnB>
                     <a:solidFill>
-                      <a:srgbClr val="FFFFFF"/>
+                      <a:srgbClr val="F0F5EA"/>
                     </a:solidFill>
                   </a:tcPr>
                 </a:tc>
@@ -12600,7 +12600,7 @@
             <a:r>
               <a:rPr lang="en-US" sz="1500" b="1" dirty="0">
                 <a:solidFill>
-                  <a:srgbClr val="E0E0E0"/>
+                  <a:srgbClr val="D8E8C8"/>
                 </a:solidFill>
                 <a:latin typeface="Arial Black" pitchFamily="34" charset="0"/>
                 <a:ea typeface="Arial Black" pitchFamily="34" charset="-122"/>
@@ -12646,7 +12646,7 @@
             <a:r>
               <a:rPr lang="en-US" sz="1500" b="1" dirty="0">
                 <a:solidFill>
-                  <a:srgbClr val="0A0A0A"/>
+                  <a:srgbClr val="2C5F2D"/>
                 </a:solidFill>
                 <a:latin typeface="Arial Black" pitchFamily="34" charset="0"/>
                 <a:ea typeface="Arial Black" pitchFamily="34" charset="-122"/>
@@ -12685,7 +12685,7 @@
             <a:r>
               <a:rPr lang="en-US" sz="850" dirty="0">
                 <a:solidFill>
-                  <a:srgbClr val="6E6E6E"/>
+                  <a:srgbClr val="5A6B5A"/>
                 </a:solidFill>
                 <a:latin typeface="Arial" pitchFamily="34" charset="0"/>
                 <a:ea typeface="Arial" pitchFamily="34" charset="-122"/>
@@ -12714,7 +12714,7 @@
     <p:bg>
       <p:bgPr>
         <a:solidFill>
-          <a:srgbClr val="0A0A0A"/>
+          <a:srgbClr val="1F3D26"/>
         </a:solidFill>
       </p:bgPr>
     </p:bg>
@@ -12759,7 +12759,7 @@
             <a:r>
               <a:rPr lang="en-US" sz="2800" b="1" dirty="0">
                 <a:solidFill>
-                  <a:srgbClr val="2A2A2A"/>
+                  <a:srgbClr val="142B1A"/>
                 </a:solidFill>
                 <a:latin typeface="Arial Black" pitchFamily="34" charset="0"/>
                 <a:ea typeface="Arial Black" pitchFamily="34" charset="-122"/>
@@ -12798,7 +12798,7 @@
             <a:r>
               <a:rPr lang="en-US" sz="2800" b="1" dirty="0">
                 <a:solidFill>
-                  <a:srgbClr val="FFFFFF"/>
+                  <a:srgbClr val="F0F5EA"/>
                 </a:solidFill>
                 <a:latin typeface="Arial Black" pitchFamily="34" charset="0"/>
                 <a:ea typeface="Arial Black" pitchFamily="34" charset="-122"/>
@@ -12825,11 +12825,11 @@
             <a:avLst/>
           </a:prstGeom>
           <a:solidFill>
-            <a:srgbClr val="FF5A1F"/>
+            <a:srgbClr val="97BC62"/>
           </a:solidFill>
           <a:ln w="12700">
             <a:solidFill>
-              <a:srgbClr val="FF5A1F"/>
+              <a:srgbClr val="97BC62"/>
             </a:solidFill>
             <a:prstDash val="solid"/>
           </a:ln>
@@ -12862,7 +12862,7 @@
             <a:r>
               <a:rPr lang="en-US" sz="1150" dirty="0">
                 <a:solidFill>
-                  <a:srgbClr val="B0B0B0"/>
+                  <a:srgbClr val="8FAE8B"/>
                 </a:solidFill>
                 <a:latin typeface="Arial" pitchFamily="34" charset="0"/>
                 <a:ea typeface="Arial" pitchFamily="34" charset="-122"/>
@@ -12889,11 +12889,11 @@
             <a:avLst/>
           </a:prstGeom>
           <a:solidFill>
-            <a:srgbClr val="2A2A2A"/>
+            <a:srgbClr val="142B1A"/>
           </a:solidFill>
           <a:ln w="12700">
             <a:solidFill>
-              <a:srgbClr val="2A2A2A"/>
+              <a:srgbClr val="142B1A"/>
             </a:solidFill>
             <a:prstDash val="solid"/>
           </a:ln>
@@ -12914,11 +12914,11 @@
             <a:avLst/>
           </a:prstGeom>
           <a:solidFill>
-            <a:srgbClr val="555555"/>
+            <a:srgbClr val="3E5C42"/>
           </a:solidFill>
           <a:ln w="12700">
             <a:solidFill>
-              <a:srgbClr val="555555"/>
+              <a:srgbClr val="3E5C42"/>
             </a:solidFill>
             <a:prstDash val="solid"/>
           </a:ln>
@@ -12941,11 +12941,11 @@
             </a:avLst>
           </a:prstGeom>
           <a:solidFill>
-            <a:srgbClr val="161616"/>
+            <a:srgbClr val="2A4A33"/>
           </a:solidFill>
           <a:ln w="12700">
             <a:solidFill>
-              <a:srgbClr val="2A2A2A"/>
+              <a:srgbClr val="142B1A"/>
             </a:solidFill>
             <a:prstDash val="solid"/>
           </a:ln>
@@ -12978,7 +12978,7 @@
             <a:r>
               <a:rPr lang="en-US" sz="1500" b="1" dirty="0">
                 <a:solidFill>
-                  <a:srgbClr val="FFFFFF"/>
+                  <a:srgbClr val="F0F5EA"/>
                 </a:solidFill>
                 <a:latin typeface="Arial Black" pitchFamily="34" charset="0"/>
                 <a:ea typeface="Arial Black" pitchFamily="34" charset="-122"/>
@@ -13017,7 +13017,7 @@
             <a:r>
               <a:rPr lang="en-US" sz="800" dirty="0">
                 <a:solidFill>
-                  <a:srgbClr val="B0B0B0"/>
+                  <a:srgbClr val="8FAE8B"/>
                 </a:solidFill>
                 <a:latin typeface="Arial" pitchFamily="34" charset="0"/>
                 <a:ea typeface="Arial" pitchFamily="34" charset="-122"/>
@@ -13056,7 +13056,7 @@
             <a:r>
               <a:rPr lang="en-US" sz="650" dirty="0">
                 <a:solidFill>
-                  <a:srgbClr val="8A8A8A"/>
+                  <a:srgbClr val="8FAE8B"/>
                 </a:solidFill>
                 <a:latin typeface="Arial" pitchFamily="34" charset="0"/>
                 <a:ea typeface="Arial" pitchFamily="34" charset="-122"/>
@@ -13083,11 +13083,11 @@
             <a:avLst/>
           </a:prstGeom>
           <a:solidFill>
-            <a:srgbClr val="2A2A2A"/>
+            <a:srgbClr val="142B1A"/>
           </a:solidFill>
           <a:ln w="12700">
             <a:solidFill>
-              <a:srgbClr val="2A2A2A"/>
+              <a:srgbClr val="142B1A"/>
             </a:solidFill>
             <a:prstDash val="solid"/>
           </a:ln>
@@ -13108,11 +13108,11 @@
             <a:avLst/>
           </a:prstGeom>
           <a:solidFill>
-            <a:srgbClr val="555555"/>
+            <a:srgbClr val="3E5C42"/>
           </a:solidFill>
           <a:ln w="12700">
             <a:solidFill>
-              <a:srgbClr val="555555"/>
+              <a:srgbClr val="3E5C42"/>
             </a:solidFill>
             <a:prstDash val="solid"/>
           </a:ln>
@@ -13135,11 +13135,11 @@
             </a:avLst>
           </a:prstGeom>
           <a:solidFill>
-            <a:srgbClr val="161616"/>
+            <a:srgbClr val="2A4A33"/>
           </a:solidFill>
           <a:ln w="12700">
             <a:solidFill>
-              <a:srgbClr val="2A2A2A"/>
+              <a:srgbClr val="142B1A"/>
             </a:solidFill>
             <a:prstDash val="solid"/>
           </a:ln>
@@ -13172,7 +13172,7 @@
             <a:r>
               <a:rPr lang="en-US" sz="1500" b="1" dirty="0">
                 <a:solidFill>
-                  <a:srgbClr val="FFFFFF"/>
+                  <a:srgbClr val="F0F5EA"/>
                 </a:solidFill>
                 <a:latin typeface="Arial Black" pitchFamily="34" charset="0"/>
                 <a:ea typeface="Arial Black" pitchFamily="34" charset="-122"/>
@@ -13211,7 +13211,7 @@
             <a:r>
               <a:rPr lang="en-US" sz="800" dirty="0">
                 <a:solidFill>
-                  <a:srgbClr val="B0B0B0"/>
+                  <a:srgbClr val="8FAE8B"/>
                 </a:solidFill>
                 <a:latin typeface="Arial" pitchFamily="34" charset="0"/>
                 <a:ea typeface="Arial" pitchFamily="34" charset="-122"/>
@@ -13250,7 +13250,7 @@
             <a:r>
               <a:rPr lang="en-US" sz="650" dirty="0">
                 <a:solidFill>
-                  <a:srgbClr val="8A8A8A"/>
+                  <a:srgbClr val="8FAE8B"/>
                 </a:solidFill>
                 <a:latin typeface="Arial" pitchFamily="34" charset="0"/>
                 <a:ea typeface="Arial" pitchFamily="34" charset="-122"/>
@@ -13277,11 +13277,11 @@
             <a:avLst/>
           </a:prstGeom>
           <a:solidFill>
-            <a:srgbClr val="2A2A2A"/>
+            <a:srgbClr val="142B1A"/>
           </a:solidFill>
           <a:ln w="12700">
             <a:solidFill>
-              <a:srgbClr val="2A2A2A"/>
+              <a:srgbClr val="142B1A"/>
             </a:solidFill>
             <a:prstDash val="solid"/>
           </a:ln>
@@ -13302,11 +13302,11 @@
             <a:avLst/>
           </a:prstGeom>
           <a:solidFill>
-            <a:srgbClr val="555555"/>
+            <a:srgbClr val="3E5C42"/>
           </a:solidFill>
           <a:ln w="12700">
             <a:solidFill>
-              <a:srgbClr val="555555"/>
+              <a:srgbClr val="3E5C42"/>
             </a:solidFill>
             <a:prstDash val="solid"/>
           </a:ln>
@@ -13329,11 +13329,11 @@
             </a:avLst>
           </a:prstGeom>
           <a:solidFill>
-            <a:srgbClr val="161616"/>
+            <a:srgbClr val="2A4A33"/>
           </a:solidFill>
           <a:ln w="12700">
             <a:solidFill>
-              <a:srgbClr val="2A2A2A"/>
+              <a:srgbClr val="142B1A"/>
             </a:solidFill>
             <a:prstDash val="solid"/>
           </a:ln>
@@ -13366,7 +13366,7 @@
             <a:r>
               <a:rPr lang="en-US" sz="1500" b="1" dirty="0">
                 <a:solidFill>
-                  <a:srgbClr val="FFFFFF"/>
+                  <a:srgbClr val="F0F5EA"/>
                 </a:solidFill>
                 <a:latin typeface="Arial Black" pitchFamily="34" charset="0"/>
                 <a:ea typeface="Arial Black" pitchFamily="34" charset="-122"/>
@@ -13405,7 +13405,7 @@
             <a:r>
               <a:rPr lang="en-US" sz="800" dirty="0">
                 <a:solidFill>
-                  <a:srgbClr val="B0B0B0"/>
+                  <a:srgbClr val="8FAE8B"/>
                 </a:solidFill>
                 <a:latin typeface="Arial" pitchFamily="34" charset="0"/>
                 <a:ea typeface="Arial" pitchFamily="34" charset="-122"/>
@@ -13444,7 +13444,7 @@
             <a:r>
               <a:rPr lang="en-US" sz="650" dirty="0">
                 <a:solidFill>
-                  <a:srgbClr val="8A8A8A"/>
+                  <a:srgbClr val="8FAE8B"/>
                 </a:solidFill>
                 <a:latin typeface="Arial" pitchFamily="34" charset="0"/>
                 <a:ea typeface="Arial" pitchFamily="34" charset="-122"/>
@@ -13471,11 +13471,11 @@
             <a:avLst/>
           </a:prstGeom>
           <a:solidFill>
-            <a:srgbClr val="2A2A2A"/>
+            <a:srgbClr val="142B1A"/>
           </a:solidFill>
           <a:ln w="12700">
             <a:solidFill>
-              <a:srgbClr val="2A2A2A"/>
+              <a:srgbClr val="142B1A"/>
             </a:solidFill>
             <a:prstDash val="solid"/>
           </a:ln>
@@ -13496,11 +13496,11 @@
             <a:avLst/>
           </a:prstGeom>
           <a:solidFill>
-            <a:srgbClr val="555555"/>
+            <a:srgbClr val="3E5C42"/>
           </a:solidFill>
           <a:ln w="12700">
             <a:solidFill>
-              <a:srgbClr val="555555"/>
+              <a:srgbClr val="3E5C42"/>
             </a:solidFill>
             <a:prstDash val="solid"/>
           </a:ln>
@@ -13523,11 +13523,11 @@
             </a:avLst>
           </a:prstGeom>
           <a:solidFill>
-            <a:srgbClr val="161616"/>
+            <a:srgbClr val="2A4A33"/>
           </a:solidFill>
           <a:ln w="12700">
             <a:solidFill>
-              <a:srgbClr val="2A2A2A"/>
+              <a:srgbClr val="142B1A"/>
             </a:solidFill>
             <a:prstDash val="solid"/>
           </a:ln>
@@ -13560,7 +13560,7 @@
             <a:r>
               <a:rPr lang="en-US" sz="1500" b="1" dirty="0">
                 <a:solidFill>
-                  <a:srgbClr val="FFFFFF"/>
+                  <a:srgbClr val="F0F5EA"/>
                 </a:solidFill>
                 <a:latin typeface="Arial Black" pitchFamily="34" charset="0"/>
                 <a:ea typeface="Arial Black" pitchFamily="34" charset="-122"/>
@@ -13599,7 +13599,7 @@
             <a:r>
               <a:rPr lang="en-US" sz="800" dirty="0">
                 <a:solidFill>
-                  <a:srgbClr val="B0B0B0"/>
+                  <a:srgbClr val="8FAE8B"/>
                 </a:solidFill>
                 <a:latin typeface="Arial" pitchFamily="34" charset="0"/>
                 <a:ea typeface="Arial" pitchFamily="34" charset="-122"/>
@@ -13638,7 +13638,7 @@
             <a:r>
               <a:rPr lang="en-US" sz="650" dirty="0">
                 <a:solidFill>
-                  <a:srgbClr val="8A8A8A"/>
+                  <a:srgbClr val="8FAE8B"/>
                 </a:solidFill>
                 <a:latin typeface="Arial" pitchFamily="34" charset="0"/>
                 <a:ea typeface="Arial" pitchFamily="34" charset="-122"/>
@@ -13677,7 +13677,7 @@
             <a:r>
               <a:rPr lang="en-US" sz="850" dirty="0">
                 <a:solidFill>
-                  <a:srgbClr val="B0B0B0"/>
+                  <a:srgbClr val="8FAE8B"/>
                 </a:solidFill>
                 <a:latin typeface="Arial" pitchFamily="34" charset="0"/>
                 <a:ea typeface="Arial" pitchFamily="34" charset="-122"/>

</xml_diff>

<commit_message>
deck: green theme (forest & moss) on final 13-slide content
Recolor to green per user directive, on the merged main content (108,220 ha
Fani + 5,882 Yaas + 88.5 lakh PMFBY on S2, all 13 slides). Zero wording or
number changes: palette only.

- near-black -> forest green 1F3D26, orange -> moss green 97BC62
- grays -> sage greens, card fills -> pale greens, extrusion -> deep green
- check-deck.sh gate tokens updated to 97BC62 + 1F3D26
- inject_transitions.py (post-build fade transitions, 13 slides)

Verified: 13 slides, 0 em dash, tokens present, 13 fade transitions,
S2 renders clean (cards level, readable).
</commit_message>
<xml_diff>
--- a/scaffold/deck/KrishiSetu-Round0-20260816.pptx
+++ b/scaffold/deck/KrishiSetu-Round0-20260816.pptx
@@ -1925,7 +1925,7 @@
     <p:bg>
       <p:bgPr>
         <a:solidFill>
-          <a:srgbClr val="0A0A0A"/>
+          <a:srgbClr val="1F3D26"/>
         </a:solidFill>
       </p:bgPr>
     </p:bg>
@@ -1970,7 +1970,7 @@
             <a:r>
               <a:rPr lang="en-US" sz="5800" b="1" dirty="0">
                 <a:solidFill>
-                  <a:srgbClr val="2A2A2A"/>
+                  <a:srgbClr val="142B1A"/>
                 </a:solidFill>
                 <a:latin typeface="Arial Black" pitchFamily="34" charset="0"/>
                 <a:ea typeface="Arial Black" pitchFamily="34" charset="-122"/>
@@ -2009,7 +2009,7 @@
             <a:r>
               <a:rPr lang="en-US" sz="5800" b="1" dirty="0">
                 <a:solidFill>
-                  <a:srgbClr val="FFFFFF"/>
+                  <a:srgbClr val="F0F5EA"/>
                 </a:solidFill>
                 <a:latin typeface="Arial Black" pitchFamily="34" charset="0"/>
                 <a:ea typeface="Arial Black" pitchFamily="34" charset="-122"/>
@@ -2036,11 +2036,11 @@
             <a:avLst/>
           </a:prstGeom>
           <a:solidFill>
-            <a:srgbClr val="FFFFFF"/>
+            <a:srgbClr val="F0F5EA"/>
           </a:solidFill>
           <a:ln w="12700">
             <a:solidFill>
-              <a:srgbClr val="FFFFFF"/>
+              <a:srgbClr val="F0F5EA"/>
             </a:solidFill>
             <a:prstDash val="solid"/>
           </a:ln>
@@ -2073,7 +2073,7 @@
             <a:r>
               <a:rPr lang="en-US" sz="1800" b="1" dirty="0">
                 <a:solidFill>
-                  <a:srgbClr val="FFFFFF"/>
+                  <a:srgbClr val="F0F5EA"/>
                 </a:solidFill>
                 <a:latin typeface="Arial" pitchFamily="34" charset="0"/>
                 <a:ea typeface="Arial" pitchFamily="34" charset="-122"/>
@@ -2112,7 +2112,7 @@
             <a:r>
               <a:rPr lang="en-US" sz="1400" dirty="0">
                 <a:solidFill>
-                  <a:srgbClr val="B0B0B0"/>
+                  <a:srgbClr val="8FAE8B"/>
                 </a:solidFill>
                 <a:latin typeface="Arial" pitchFamily="34" charset="0"/>
                 <a:ea typeface="Arial" pitchFamily="34" charset="-122"/>
@@ -2151,7 +2151,7 @@
             <a:r>
               <a:rPr lang="en-US" sz="1200" dirty="0">
                 <a:solidFill>
-                  <a:srgbClr val="B0B0B0"/>
+                  <a:srgbClr val="8FAE8B"/>
                 </a:solidFill>
                 <a:latin typeface="Arial" pitchFamily="34" charset="0"/>
                 <a:ea typeface="Arial" pitchFamily="34" charset="-122"/>
@@ -2168,6 +2168,9 @@
   <p:clrMapOvr>
     <a:masterClrMapping/>
   </p:clrMapOvr>
+  <p:transition spd="med">
+    <p:fade/>
+  </p:transition>
 </p:sld>
 </file>
 
@@ -2177,7 +2180,7 @@
     <p:bg>
       <p:bgPr>
         <a:solidFill>
-          <a:srgbClr val="FFFFFF"/>
+          <a:srgbClr val="F0F5EA"/>
         </a:solidFill>
       </p:bgPr>
     </p:bg>
@@ -2222,7 +2225,7 @@
             <a:r>
               <a:rPr lang="en-US" sz="2800" b="1" dirty="0">
                 <a:solidFill>
-                  <a:srgbClr val="E0E0E0"/>
+                  <a:srgbClr val="D8E8C8"/>
                 </a:solidFill>
                 <a:latin typeface="Arial Black" pitchFamily="34" charset="0"/>
                 <a:ea typeface="Arial Black" pitchFamily="34" charset="-122"/>
@@ -2268,7 +2271,7 @@
             <a:r>
               <a:rPr lang="en-US" sz="2800" b="1" dirty="0">
                 <a:solidFill>
-                  <a:srgbClr val="0A0A0A"/>
+                  <a:srgbClr val="2C5F2D"/>
                 </a:solidFill>
                 <a:latin typeface="Arial Black" pitchFamily="34" charset="0"/>
                 <a:ea typeface="Arial Black" pitchFamily="34" charset="-122"/>
@@ -2295,11 +2298,11 @@
             <a:avLst/>
           </a:prstGeom>
           <a:solidFill>
-            <a:srgbClr val="0A0A0A"/>
+            <a:srgbClr val="2C5F2D"/>
           </a:solidFill>
           <a:ln w="12700">
             <a:solidFill>
-              <a:srgbClr val="0A0A0A"/>
+              <a:srgbClr val="2C5F2D"/>
             </a:solidFill>
             <a:prstDash val="solid"/>
           </a:ln>
@@ -2320,11 +2323,11 @@
             <a:avLst/>
           </a:prstGeom>
           <a:solidFill>
-            <a:srgbClr val="E0E0E0"/>
+            <a:srgbClr val="D8E8C8"/>
           </a:solidFill>
           <a:ln w="12700">
             <a:solidFill>
-              <a:srgbClr val="E0E0E0"/>
+              <a:srgbClr val="D8E8C8"/>
             </a:solidFill>
             <a:prstDash val="solid"/>
           </a:ln>
@@ -2345,11 +2348,11 @@
             <a:avLst/>
           </a:prstGeom>
           <a:solidFill>
-            <a:srgbClr val="555555"/>
+            <a:srgbClr val="3E5C42"/>
           </a:solidFill>
           <a:ln w="12700">
             <a:solidFill>
-              <a:srgbClr val="555555"/>
+              <a:srgbClr val="3E5C42"/>
             </a:solidFill>
             <a:prstDash val="solid"/>
           </a:ln>
@@ -2372,7 +2375,7 @@
             </a:avLst>
           </a:prstGeom>
           <a:solidFill>
-            <a:srgbClr val="0A0A0A"/>
+            <a:srgbClr val="1F3D26"/>
           </a:solidFill>
           <a:ln w="12700">
             <a:solidFill>
@@ -2409,7 +2412,7 @@
             <a:r>
               <a:rPr lang="en-US" sz="1600" b="1" dirty="0">
                 <a:solidFill>
-                  <a:srgbClr val="FFFFFF"/>
+                  <a:srgbClr val="F0F5EA"/>
                 </a:solidFill>
                 <a:latin typeface="Arial Black" pitchFamily="34" charset="0"/>
                 <a:ea typeface="Arial Black" pitchFamily="34" charset="-122"/>
@@ -2448,7 +2451,7 @@
             <a:r>
               <a:rPr lang="en-US" sz="1150" dirty="0">
                 <a:solidFill>
-                  <a:srgbClr val="B0B0B0"/>
+                  <a:srgbClr val="8FAE8B"/>
                 </a:solidFill>
                 <a:latin typeface="Arial" pitchFamily="34" charset="0"/>
                 <a:ea typeface="Arial" pitchFamily="34" charset="-122"/>
@@ -2487,7 +2490,7 @@
             <a:r>
               <a:rPr lang="en-US" sz="1000" i="1" dirty="0">
                 <a:solidFill>
-                  <a:srgbClr val="8A8A8A"/>
+                  <a:srgbClr val="8FAE8B"/>
                 </a:solidFill>
                 <a:latin typeface="Arial" pitchFamily="34" charset="0"/>
                 <a:ea typeface="Arial" pitchFamily="34" charset="-122"/>
@@ -2514,11 +2517,11 @@
             <a:avLst/>
           </a:prstGeom>
           <a:solidFill>
-            <a:srgbClr val="E0E0E0"/>
+            <a:srgbClr val="D8E8C8"/>
           </a:solidFill>
           <a:ln w="12700">
             <a:solidFill>
-              <a:srgbClr val="E0E0E0"/>
+              <a:srgbClr val="D8E8C8"/>
             </a:solidFill>
             <a:prstDash val="solid"/>
           </a:ln>
@@ -2539,11 +2542,11 @@
             <a:avLst/>
           </a:prstGeom>
           <a:solidFill>
-            <a:srgbClr val="555555"/>
+            <a:srgbClr val="3E5C42"/>
           </a:solidFill>
           <a:ln w="12700">
             <a:solidFill>
-              <a:srgbClr val="555555"/>
+              <a:srgbClr val="3E5C42"/>
             </a:solidFill>
             <a:prstDash val="solid"/>
           </a:ln>
@@ -2566,7 +2569,7 @@
             </a:avLst>
           </a:prstGeom>
           <a:solidFill>
-            <a:srgbClr val="0A0A0A"/>
+            <a:srgbClr val="1F3D26"/>
           </a:solidFill>
           <a:ln w="12700">
             <a:solidFill>
@@ -2603,7 +2606,7 @@
             <a:r>
               <a:rPr lang="en-US" sz="1600" b="1" dirty="0">
                 <a:solidFill>
-                  <a:srgbClr val="FFFFFF"/>
+                  <a:srgbClr val="F0F5EA"/>
                 </a:solidFill>
                 <a:latin typeface="Arial Black" pitchFamily="34" charset="0"/>
                 <a:ea typeface="Arial Black" pitchFamily="34" charset="-122"/>
@@ -2642,7 +2645,7 @@
             <a:r>
               <a:rPr lang="en-US" sz="1150" dirty="0">
                 <a:solidFill>
-                  <a:srgbClr val="B0B0B0"/>
+                  <a:srgbClr val="8FAE8B"/>
                 </a:solidFill>
                 <a:latin typeface="Arial" pitchFamily="34" charset="0"/>
                 <a:ea typeface="Arial" pitchFamily="34" charset="-122"/>
@@ -2681,7 +2684,7 @@
             <a:r>
               <a:rPr lang="en-US" sz="1000" i="1" dirty="0">
                 <a:solidFill>
-                  <a:srgbClr val="8A8A8A"/>
+                  <a:srgbClr val="8FAE8B"/>
                 </a:solidFill>
                 <a:latin typeface="Arial" pitchFamily="34" charset="0"/>
                 <a:ea typeface="Arial" pitchFamily="34" charset="-122"/>
@@ -2708,11 +2711,11 @@
             <a:avLst/>
           </a:prstGeom>
           <a:solidFill>
-            <a:srgbClr val="E0E0E0"/>
+            <a:srgbClr val="D8E8C8"/>
           </a:solidFill>
           <a:ln w="12700">
             <a:solidFill>
-              <a:srgbClr val="E0E0E0"/>
+              <a:srgbClr val="D8E8C8"/>
             </a:solidFill>
             <a:prstDash val="solid"/>
           </a:ln>
@@ -2733,11 +2736,11 @@
             <a:avLst/>
           </a:prstGeom>
           <a:solidFill>
-            <a:srgbClr val="555555"/>
+            <a:srgbClr val="3E5C42"/>
           </a:solidFill>
           <a:ln w="12700">
             <a:solidFill>
-              <a:srgbClr val="555555"/>
+              <a:srgbClr val="3E5C42"/>
             </a:solidFill>
             <a:prstDash val="solid"/>
           </a:ln>
@@ -2760,7 +2763,7 @@
             </a:avLst>
           </a:prstGeom>
           <a:solidFill>
-            <a:srgbClr val="0A0A0A"/>
+            <a:srgbClr val="1F3D26"/>
           </a:solidFill>
           <a:ln w="12700">
             <a:solidFill>
@@ -2797,7 +2800,7 @@
             <a:r>
               <a:rPr lang="en-US" sz="1600" b="1" dirty="0">
                 <a:solidFill>
-                  <a:srgbClr val="FFFFFF"/>
+                  <a:srgbClr val="F0F5EA"/>
                 </a:solidFill>
                 <a:latin typeface="Arial Black" pitchFamily="34" charset="0"/>
                 <a:ea typeface="Arial Black" pitchFamily="34" charset="-122"/>
@@ -2836,7 +2839,7 @@
             <a:r>
               <a:rPr lang="en-US" sz="1150" dirty="0">
                 <a:solidFill>
-                  <a:srgbClr val="B0B0B0"/>
+                  <a:srgbClr val="8FAE8B"/>
                 </a:solidFill>
                 <a:latin typeface="Arial" pitchFamily="34" charset="0"/>
                 <a:ea typeface="Arial" pitchFamily="34" charset="-122"/>
@@ -2875,7 +2878,7 @@
             <a:r>
               <a:rPr lang="en-US" sz="1000" i="1" dirty="0">
                 <a:solidFill>
-                  <a:srgbClr val="8A8A8A"/>
+                  <a:srgbClr val="8FAE8B"/>
                 </a:solidFill>
                 <a:latin typeface="Arial" pitchFamily="34" charset="0"/>
                 <a:ea typeface="Arial" pitchFamily="34" charset="-122"/>
@@ -2914,7 +2917,7 @@
             <a:r>
               <a:rPr lang="en-US" sz="1300" b="1" dirty="0">
                 <a:solidFill>
-                  <a:srgbClr val="0A0A0A"/>
+                  <a:srgbClr val="2C5F2D"/>
                 </a:solidFill>
                 <a:latin typeface="Arial Black" pitchFamily="34" charset="0"/>
                 <a:ea typeface="Arial Black" pitchFamily="34" charset="-122"/>
@@ -2953,7 +2956,7 @@
             <a:r>
               <a:rPr lang="en-US" sz="850" dirty="0">
                 <a:solidFill>
-                  <a:srgbClr val="6E6E6E"/>
+                  <a:srgbClr val="5A6B5A"/>
                 </a:solidFill>
                 <a:latin typeface="Arial" pitchFamily="34" charset="0"/>
                 <a:ea typeface="Arial" pitchFamily="34" charset="-122"/>
@@ -2970,6 +2973,9 @@
   <p:clrMapOvr>
     <a:masterClrMapping/>
   </p:clrMapOvr>
+  <p:transition spd="med">
+    <p:fade/>
+  </p:transition>
 </p:sld>
 </file>
 
@@ -2979,7 +2985,7 @@
     <p:bg>
       <p:bgPr>
         <a:solidFill>
-          <a:srgbClr val="FFFFFF"/>
+          <a:srgbClr val="F0F5EA"/>
         </a:solidFill>
       </p:bgPr>
     </p:bg>
@@ -3024,7 +3030,7 @@
             <a:r>
               <a:rPr lang="en-US" sz="2800" b="1" dirty="0">
                 <a:solidFill>
-                  <a:srgbClr val="E0E0E0"/>
+                  <a:srgbClr val="D8E8C8"/>
                 </a:solidFill>
                 <a:latin typeface="Arial Black" pitchFamily="34" charset="0"/>
                 <a:ea typeface="Arial Black" pitchFamily="34" charset="-122"/>
@@ -3070,7 +3076,7 @@
             <a:r>
               <a:rPr lang="en-US" sz="2800" b="1" dirty="0">
                 <a:solidFill>
-                  <a:srgbClr val="0A0A0A"/>
+                  <a:srgbClr val="2C5F2D"/>
                 </a:solidFill>
                 <a:latin typeface="Arial Black" pitchFamily="34" charset="0"/>
                 <a:ea typeface="Arial Black" pitchFamily="34" charset="-122"/>
@@ -3097,11 +3103,11 @@
             <a:avLst/>
           </a:prstGeom>
           <a:solidFill>
-            <a:srgbClr val="0A0A0A"/>
+            <a:srgbClr val="2C5F2D"/>
           </a:solidFill>
           <a:ln w="12700">
             <a:solidFill>
-              <a:srgbClr val="0A0A0A"/>
+              <a:srgbClr val="2C5F2D"/>
             </a:solidFill>
             <a:prstDash val="solid"/>
           </a:ln>
@@ -3122,11 +3128,11 @@
             <a:avLst/>
           </a:prstGeom>
           <a:solidFill>
-            <a:srgbClr val="E0E0E0"/>
+            <a:srgbClr val="D8E8C8"/>
           </a:solidFill>
           <a:ln w="12700">
             <a:solidFill>
-              <a:srgbClr val="E0E0E0"/>
+              <a:srgbClr val="D8E8C8"/>
             </a:solidFill>
             <a:prstDash val="solid"/>
           </a:ln>
@@ -3149,11 +3155,11 @@
             </a:avLst>
           </a:prstGeom>
           <a:solidFill>
-            <a:srgbClr val="FFFFFF"/>
+            <a:srgbClr val="F0F5EA"/>
           </a:solidFill>
           <a:ln w="25400">
             <a:solidFill>
-              <a:srgbClr val="0A0A0A"/>
+              <a:srgbClr val="2C5F2D"/>
             </a:solidFill>
             <a:prstDash val="solid"/>
           </a:ln>
@@ -3186,7 +3192,7 @@
             <a:r>
               <a:rPr lang="en-US" sz="1300" b="1" dirty="0">
                 <a:solidFill>
-                  <a:srgbClr val="0A0A0A"/>
+                  <a:srgbClr val="2C5F2D"/>
                 </a:solidFill>
                 <a:latin typeface="Arial Black" pitchFamily="34" charset="0"/>
                 <a:ea typeface="Arial Black" pitchFamily="34" charset="-122"/>
@@ -3225,7 +3231,7 @@
             <a:r>
               <a:rPr lang="en-US" sz="1600" b="1" dirty="0">
                 <a:solidFill>
-                  <a:srgbClr val="0A0A0A"/>
+                  <a:srgbClr val="2C5F2D"/>
                 </a:solidFill>
                 <a:latin typeface="Arial Black" pitchFamily="34" charset="0"/>
                 <a:ea typeface="Arial Black" pitchFamily="34" charset="-122"/>
@@ -3264,7 +3270,7 @@
             <a:r>
               <a:rPr lang="en-US" sz="1250" dirty="0">
                 <a:solidFill>
-                  <a:srgbClr val="0A0A0A"/>
+                  <a:srgbClr val="2C5F2D"/>
                 </a:solidFill>
                 <a:latin typeface="Arial" pitchFamily="34" charset="0"/>
                 <a:ea typeface="Arial" pitchFamily="34" charset="-122"/>
@@ -3303,7 +3309,7 @@
             <a:r>
               <a:rPr lang="en-US" sz="1200" dirty="0">
                 <a:solidFill>
-                  <a:srgbClr val="0A0A0A"/>
+                  <a:srgbClr val="2C5F2D"/>
                 </a:solidFill>
                 <a:latin typeface="Arial" pitchFamily="34" charset="0"/>
                 <a:ea typeface="Arial" pitchFamily="34" charset="-122"/>
@@ -3330,11 +3336,11 @@
             <a:avLst/>
           </a:prstGeom>
           <a:solidFill>
-            <a:srgbClr val="E0E0E0"/>
+            <a:srgbClr val="D8E8C8"/>
           </a:solidFill>
           <a:ln w="12700">
             <a:solidFill>
-              <a:srgbClr val="E0E0E0"/>
+              <a:srgbClr val="D8E8C8"/>
             </a:solidFill>
             <a:prstDash val="solid"/>
           </a:ln>
@@ -3357,11 +3363,11 @@
             </a:avLst>
           </a:prstGeom>
           <a:solidFill>
-            <a:srgbClr val="FFFFFF"/>
+            <a:srgbClr val="F0F5EA"/>
           </a:solidFill>
           <a:ln w="25400">
             <a:solidFill>
-              <a:srgbClr val="0A0A0A"/>
+              <a:srgbClr val="2C5F2D"/>
             </a:solidFill>
             <a:prstDash val="solid"/>
           </a:ln>
@@ -3394,7 +3400,7 @@
             <a:r>
               <a:rPr lang="en-US" sz="1300" b="1" dirty="0">
                 <a:solidFill>
-                  <a:srgbClr val="0A0A0A"/>
+                  <a:srgbClr val="2C5F2D"/>
                 </a:solidFill>
                 <a:latin typeface="Arial Black" pitchFamily="34" charset="0"/>
                 <a:ea typeface="Arial Black" pitchFamily="34" charset="-122"/>
@@ -3433,7 +3439,7 @@
             <a:r>
               <a:rPr lang="en-US" sz="1200" dirty="0">
                 <a:solidFill>
-                  <a:srgbClr val="0A0A0A"/>
+                  <a:srgbClr val="2C5F2D"/>
                 </a:solidFill>
                 <a:latin typeface="Arial" pitchFamily="34" charset="0"/>
                 <a:ea typeface="Arial" pitchFamily="34" charset="-122"/>
@@ -3472,7 +3478,7 @@
             <a:r>
               <a:rPr lang="en-US" sz="1200" dirty="0">
                 <a:solidFill>
-                  <a:srgbClr val="0A0A0A"/>
+                  <a:srgbClr val="2C5F2D"/>
                 </a:solidFill>
                 <a:latin typeface="Arial" pitchFamily="34" charset="0"/>
                 <a:ea typeface="Arial" pitchFamily="34" charset="-122"/>
@@ -3511,7 +3517,7 @@
             <a:r>
               <a:rPr lang="en-US" sz="1200" dirty="0">
                 <a:solidFill>
-                  <a:srgbClr val="0A0A0A"/>
+                  <a:srgbClr val="2C5F2D"/>
                 </a:solidFill>
                 <a:latin typeface="Arial" pitchFamily="34" charset="0"/>
                 <a:ea typeface="Arial" pitchFamily="34" charset="-122"/>
@@ -3550,7 +3556,7 @@
             <a:r>
               <a:rPr lang="en-US" sz="1450" b="1" dirty="0">
                 <a:solidFill>
-                  <a:srgbClr val="E0E0E0"/>
+                  <a:srgbClr val="D8E8C8"/>
                 </a:solidFill>
                 <a:latin typeface="Arial Black" pitchFamily="34" charset="0"/>
                 <a:ea typeface="Arial Black" pitchFamily="34" charset="-122"/>
@@ -3596,7 +3602,7 @@
             <a:r>
               <a:rPr lang="en-US" sz="1450" b="1" dirty="0">
                 <a:solidFill>
-                  <a:srgbClr val="0A0A0A"/>
+                  <a:srgbClr val="2C5F2D"/>
                 </a:solidFill>
                 <a:latin typeface="Arial Black" pitchFamily="34" charset="0"/>
                 <a:ea typeface="Arial Black" pitchFamily="34" charset="-122"/>
@@ -3635,7 +3641,7 @@
             <a:r>
               <a:rPr lang="en-US" sz="1000" i="1" dirty="0">
                 <a:solidFill>
-                  <a:srgbClr val="6E6E6E"/>
+                  <a:srgbClr val="5A6B5A"/>
                 </a:solidFill>
                 <a:latin typeface="Arial" pitchFamily="34" charset="0"/>
                 <a:ea typeface="Arial" pitchFamily="34" charset="-122"/>
@@ -3674,7 +3680,7 @@
             <a:r>
               <a:rPr lang="en-US" sz="850" dirty="0">
                 <a:solidFill>
-                  <a:srgbClr val="6E6E6E"/>
+                  <a:srgbClr val="5A6B5A"/>
                 </a:solidFill>
                 <a:latin typeface="Arial" pitchFamily="34" charset="0"/>
                 <a:ea typeface="Arial" pitchFamily="34" charset="-122"/>
@@ -3691,6 +3697,9 @@
   <p:clrMapOvr>
     <a:masterClrMapping/>
   </p:clrMapOvr>
+  <p:transition spd="med">
+    <p:fade/>
+  </p:transition>
 </p:sld>
 </file>
 
@@ -3700,7 +3709,7 @@
     <p:bg>
       <p:bgPr>
         <a:solidFill>
-          <a:srgbClr val="FFFFFF"/>
+          <a:srgbClr val="F0F5EA"/>
         </a:solidFill>
       </p:bgPr>
     </p:bg>
@@ -3745,7 +3754,7 @@
             <a:r>
               <a:rPr lang="en-US" sz="2800" b="1" dirty="0">
                 <a:solidFill>
-                  <a:srgbClr val="E0E0E0"/>
+                  <a:srgbClr val="D8E8C8"/>
                 </a:solidFill>
                 <a:latin typeface="Arial Black" pitchFamily="34" charset="0"/>
                 <a:ea typeface="Arial Black" pitchFamily="34" charset="-122"/>
@@ -3791,7 +3800,7 @@
             <a:r>
               <a:rPr lang="en-US" sz="2800" b="1" dirty="0">
                 <a:solidFill>
-                  <a:srgbClr val="0A0A0A"/>
+                  <a:srgbClr val="2C5F2D"/>
                 </a:solidFill>
                 <a:latin typeface="Arial Black" pitchFamily="34" charset="0"/>
                 <a:ea typeface="Arial Black" pitchFamily="34" charset="-122"/>
@@ -3818,11 +3827,11 @@
             <a:avLst/>
           </a:prstGeom>
           <a:solidFill>
-            <a:srgbClr val="0A0A0A"/>
+            <a:srgbClr val="2C5F2D"/>
           </a:solidFill>
           <a:ln w="12700">
             <a:solidFill>
-              <a:srgbClr val="0A0A0A"/>
+              <a:srgbClr val="2C5F2D"/>
             </a:solidFill>
             <a:prstDash val="solid"/>
           </a:ln>
@@ -3843,11 +3852,11 @@
             <a:avLst/>
           </a:prstGeom>
           <a:solidFill>
-            <a:srgbClr val="E0E0E0"/>
+            <a:srgbClr val="D8E8C8"/>
           </a:solidFill>
           <a:ln w="12700">
             <a:solidFill>
-              <a:srgbClr val="E0E0E0"/>
+              <a:srgbClr val="D8E8C8"/>
             </a:solidFill>
             <a:prstDash val="solid"/>
           </a:ln>
@@ -3870,11 +3879,11 @@
             </a:avLst>
           </a:prstGeom>
           <a:solidFill>
-            <a:srgbClr val="FFFFFF"/>
+            <a:srgbClr val="F0F5EA"/>
           </a:solidFill>
           <a:ln w="19050">
             <a:solidFill>
-              <a:srgbClr val="0A0A0A"/>
+              <a:srgbClr val="2C5F2D"/>
             </a:solidFill>
             <a:prstDash val="solid"/>
           </a:ln>
@@ -3895,7 +3904,7 @@
             <a:avLst/>
           </a:prstGeom>
           <a:solidFill>
-            <a:srgbClr val="0A0A0A"/>
+            <a:srgbClr val="1F3D26"/>
           </a:solidFill>
           <a:ln/>
         </p:spPr>
@@ -3927,7 +3936,7 @@
             <a:r>
               <a:rPr lang="en-US" sz="2000" b="1" dirty="0">
                 <a:solidFill>
-                  <a:srgbClr val="FFFFFF"/>
+                  <a:srgbClr val="F0F5EA"/>
                 </a:solidFill>
                 <a:latin typeface="Arial" pitchFamily="34" charset="0"/>
                 <a:ea typeface="Arial" pitchFamily="34" charset="-122"/>
@@ -3966,7 +3975,7 @@
             <a:r>
               <a:rPr lang="en-US" sz="1500" b="1" dirty="0">
                 <a:solidFill>
-                  <a:srgbClr val="0A0A0A"/>
+                  <a:srgbClr val="2C5F2D"/>
                 </a:solidFill>
                 <a:latin typeface="Arial Black" pitchFamily="34" charset="0"/>
                 <a:ea typeface="Arial Black" pitchFamily="34" charset="-122"/>
@@ -4005,7 +4014,7 @@
             <a:r>
               <a:rPr lang="en-US" sz="1150" dirty="0">
                 <a:solidFill>
-                  <a:srgbClr val="6E6E6E"/>
+                  <a:srgbClr val="5A6B5A"/>
                 </a:solidFill>
                 <a:latin typeface="Arial" pitchFamily="34" charset="0"/>
                 <a:ea typeface="Arial" pitchFamily="34" charset="-122"/>
@@ -4044,7 +4053,7 @@
             <a:r>
               <a:rPr lang="en-US" sz="950" i="1" dirty="0">
                 <a:solidFill>
-                  <a:srgbClr val="6E6E6E"/>
+                  <a:srgbClr val="5A6B5A"/>
                 </a:solidFill>
                 <a:latin typeface="Arial" pitchFamily="34" charset="0"/>
                 <a:ea typeface="Arial" pitchFamily="34" charset="-122"/>
@@ -4071,11 +4080,11 @@
             <a:avLst/>
           </a:prstGeom>
           <a:solidFill>
-            <a:srgbClr val="E0E0E0"/>
+            <a:srgbClr val="D8E8C8"/>
           </a:solidFill>
           <a:ln w="12700">
             <a:solidFill>
-              <a:srgbClr val="E0E0E0"/>
+              <a:srgbClr val="D8E8C8"/>
             </a:solidFill>
             <a:prstDash val="solid"/>
           </a:ln>
@@ -4098,11 +4107,11 @@
             </a:avLst>
           </a:prstGeom>
           <a:solidFill>
-            <a:srgbClr val="FFFFFF"/>
+            <a:srgbClr val="F0F5EA"/>
           </a:solidFill>
           <a:ln w="19050">
             <a:solidFill>
-              <a:srgbClr val="0A0A0A"/>
+              <a:srgbClr val="2C5F2D"/>
             </a:solidFill>
             <a:prstDash val="solid"/>
           </a:ln>
@@ -4123,7 +4132,7 @@
             <a:avLst/>
           </a:prstGeom>
           <a:solidFill>
-            <a:srgbClr val="0A0A0A"/>
+            <a:srgbClr val="1F3D26"/>
           </a:solidFill>
           <a:ln/>
         </p:spPr>
@@ -4155,7 +4164,7 @@
             <a:r>
               <a:rPr lang="en-US" sz="2000" b="1" dirty="0">
                 <a:solidFill>
-                  <a:srgbClr val="FFFFFF"/>
+                  <a:srgbClr val="F0F5EA"/>
                 </a:solidFill>
                 <a:latin typeface="Arial" pitchFamily="34" charset="0"/>
                 <a:ea typeface="Arial" pitchFamily="34" charset="-122"/>
@@ -4194,7 +4203,7 @@
             <a:r>
               <a:rPr lang="en-US" sz="1500" b="1" dirty="0">
                 <a:solidFill>
-                  <a:srgbClr val="0A0A0A"/>
+                  <a:srgbClr val="2C5F2D"/>
                 </a:solidFill>
                 <a:latin typeface="Arial Black" pitchFamily="34" charset="0"/>
                 <a:ea typeface="Arial Black" pitchFamily="34" charset="-122"/>
@@ -4233,7 +4242,7 @@
             <a:r>
               <a:rPr lang="en-US" sz="1150" dirty="0">
                 <a:solidFill>
-                  <a:srgbClr val="6E6E6E"/>
+                  <a:srgbClr val="5A6B5A"/>
                 </a:solidFill>
                 <a:latin typeface="Arial" pitchFamily="34" charset="0"/>
                 <a:ea typeface="Arial" pitchFamily="34" charset="-122"/>
@@ -4272,7 +4281,7 @@
             <a:r>
               <a:rPr lang="en-US" sz="950" i="1" dirty="0">
                 <a:solidFill>
-                  <a:srgbClr val="6E6E6E"/>
+                  <a:srgbClr val="5A6B5A"/>
                 </a:solidFill>
                 <a:latin typeface="Arial" pitchFamily="34" charset="0"/>
                 <a:ea typeface="Arial" pitchFamily="34" charset="-122"/>
@@ -4299,11 +4308,11 @@
             <a:avLst/>
           </a:prstGeom>
           <a:solidFill>
-            <a:srgbClr val="E0E0E0"/>
+            <a:srgbClr val="D8E8C8"/>
           </a:solidFill>
           <a:ln w="12700">
             <a:solidFill>
-              <a:srgbClr val="E0E0E0"/>
+              <a:srgbClr val="D8E8C8"/>
             </a:solidFill>
             <a:prstDash val="solid"/>
           </a:ln>
@@ -4326,11 +4335,11 @@
             </a:avLst>
           </a:prstGeom>
           <a:solidFill>
-            <a:srgbClr val="FFFFFF"/>
+            <a:srgbClr val="F0F5EA"/>
           </a:solidFill>
           <a:ln w="19050">
             <a:solidFill>
-              <a:srgbClr val="0A0A0A"/>
+              <a:srgbClr val="2C5F2D"/>
             </a:solidFill>
             <a:prstDash val="solid"/>
           </a:ln>
@@ -4351,7 +4360,7 @@
             <a:avLst/>
           </a:prstGeom>
           <a:solidFill>
-            <a:srgbClr val="0A0A0A"/>
+            <a:srgbClr val="1F3D26"/>
           </a:solidFill>
           <a:ln/>
         </p:spPr>
@@ -4383,7 +4392,7 @@
             <a:r>
               <a:rPr lang="en-US" sz="2000" b="1" dirty="0">
                 <a:solidFill>
-                  <a:srgbClr val="FFFFFF"/>
+                  <a:srgbClr val="F0F5EA"/>
                 </a:solidFill>
                 <a:latin typeface="Arial" pitchFamily="34" charset="0"/>
                 <a:ea typeface="Arial" pitchFamily="34" charset="-122"/>
@@ -4422,7 +4431,7 @@
             <a:r>
               <a:rPr lang="en-US" sz="1500" b="1" dirty="0">
                 <a:solidFill>
-                  <a:srgbClr val="0A0A0A"/>
+                  <a:srgbClr val="2C5F2D"/>
                 </a:solidFill>
                 <a:latin typeface="Arial Black" pitchFamily="34" charset="0"/>
                 <a:ea typeface="Arial Black" pitchFamily="34" charset="-122"/>
@@ -4461,7 +4470,7 @@
             <a:r>
               <a:rPr lang="en-US" sz="1150" dirty="0">
                 <a:solidFill>
-                  <a:srgbClr val="6E6E6E"/>
+                  <a:srgbClr val="5A6B5A"/>
                 </a:solidFill>
                 <a:latin typeface="Arial" pitchFamily="34" charset="0"/>
                 <a:ea typeface="Arial" pitchFamily="34" charset="-122"/>
@@ -4500,7 +4509,7 @@
             <a:r>
               <a:rPr lang="en-US" sz="950" i="1" dirty="0">
                 <a:solidFill>
-                  <a:srgbClr val="6E6E6E"/>
+                  <a:srgbClr val="5A6B5A"/>
                 </a:solidFill>
                 <a:latin typeface="Arial" pitchFamily="34" charset="0"/>
                 <a:ea typeface="Arial" pitchFamily="34" charset="-122"/>
@@ -4539,7 +4548,7 @@
             <a:r>
               <a:rPr lang="en-US" sz="1300" b="1" dirty="0">
                 <a:solidFill>
-                  <a:srgbClr val="0A0A0A"/>
+                  <a:srgbClr val="2C5F2D"/>
                 </a:solidFill>
                 <a:latin typeface="Arial Black" pitchFamily="34" charset="0"/>
                 <a:ea typeface="Arial Black" pitchFamily="34" charset="-122"/>
@@ -4578,7 +4587,7 @@
             <a:r>
               <a:rPr lang="en-US" sz="850" dirty="0">
                 <a:solidFill>
-                  <a:srgbClr val="6E6E6E"/>
+                  <a:srgbClr val="5A6B5A"/>
                 </a:solidFill>
                 <a:latin typeface="Arial" pitchFamily="34" charset="0"/>
                 <a:ea typeface="Arial" pitchFamily="34" charset="-122"/>
@@ -4595,6 +4604,9 @@
   <p:clrMapOvr>
     <a:masterClrMapping/>
   </p:clrMapOvr>
+  <p:transition spd="med">
+    <p:fade/>
+  </p:transition>
 </p:sld>
 </file>
 
@@ -4604,7 +4616,7 @@
     <p:bg>
       <p:bgPr>
         <a:solidFill>
-          <a:srgbClr val="0A0A0A"/>
+          <a:srgbClr val="1F3D26"/>
         </a:solidFill>
       </p:bgPr>
     </p:bg>
@@ -4649,7 +4661,7 @@
             <a:r>
               <a:rPr lang="en-US" sz="4000" b="1" dirty="0">
                 <a:solidFill>
-                  <a:srgbClr val="2A2A2A"/>
+                  <a:srgbClr val="142B1A"/>
                 </a:solidFill>
                 <a:latin typeface="Arial Black" pitchFamily="34" charset="0"/>
                 <a:ea typeface="Arial Black" pitchFamily="34" charset="-122"/>
@@ -4688,7 +4700,7 @@
             <a:r>
               <a:rPr lang="en-US" sz="4000" b="1" dirty="0">
                 <a:solidFill>
-                  <a:srgbClr val="FFFFFF"/>
+                  <a:srgbClr val="F0F5EA"/>
                 </a:solidFill>
                 <a:latin typeface="Arial Black" pitchFamily="34" charset="0"/>
                 <a:ea typeface="Arial Black" pitchFamily="34" charset="-122"/>
@@ -4727,7 +4739,7 @@
             <a:r>
               <a:rPr lang="en-US" sz="1500" dirty="0">
                 <a:solidFill>
-                  <a:srgbClr val="B0B0B0"/>
+                  <a:srgbClr val="8FAE8B"/>
                 </a:solidFill>
                 <a:latin typeface="Arial" pitchFamily="34" charset="0"/>
                 <a:ea typeface="Arial" pitchFamily="34" charset="-122"/>
@@ -4754,11 +4766,11 @@
             <a:avLst/>
           </a:prstGeom>
           <a:solidFill>
-            <a:srgbClr val="2A2A2A"/>
+            <a:srgbClr val="142B1A"/>
           </a:solidFill>
           <a:ln w="12700">
             <a:solidFill>
-              <a:srgbClr val="2A2A2A"/>
+              <a:srgbClr val="142B1A"/>
             </a:solidFill>
             <a:prstDash val="solid"/>
           </a:ln>
@@ -4781,11 +4793,11 @@
             </a:avLst>
           </a:prstGeom>
           <a:solidFill>
-            <a:srgbClr val="161616"/>
+            <a:srgbClr val="2A4A33"/>
           </a:solidFill>
           <a:ln w="12700">
             <a:solidFill>
-              <a:srgbClr val="2A2A2A"/>
+              <a:srgbClr val="142B1A"/>
             </a:solidFill>
             <a:prstDash val="solid"/>
           </a:ln>
@@ -4806,11 +4818,11 @@
             <a:avLst/>
           </a:prstGeom>
           <a:solidFill>
-            <a:srgbClr val="FF5A1F"/>
+            <a:srgbClr val="97BC62"/>
           </a:solidFill>
           <a:ln w="12700">
             <a:solidFill>
-              <a:srgbClr val="FF5A1F"/>
+              <a:srgbClr val="97BC62"/>
             </a:solidFill>
             <a:prstDash val="solid"/>
           </a:ln>
@@ -4843,7 +4855,7 @@
             <a:r>
               <a:rPr lang="en-US" sz="1200" dirty="0">
                 <a:solidFill>
-                  <a:srgbClr val="FFFFFF"/>
+                  <a:srgbClr val="F0F5EA"/>
                 </a:solidFill>
                 <a:latin typeface="Arial" pitchFamily="34" charset="0"/>
                 <a:ea typeface="Arial" pitchFamily="34" charset="-122"/>
@@ -4882,7 +4894,7 @@
             <a:r>
               <a:rPr lang="en-US" sz="1250" dirty="0">
                 <a:solidFill>
-                  <a:srgbClr val="B0B0B0"/>
+                  <a:srgbClr val="8FAE8B"/>
                 </a:solidFill>
                 <a:latin typeface="Arial" pitchFamily="34" charset="0"/>
                 <a:ea typeface="Arial" pitchFamily="34" charset="-122"/>
@@ -4899,6 +4911,9 @@
   <p:clrMapOvr>
     <a:masterClrMapping/>
   </p:clrMapOvr>
+  <p:transition spd="med">
+    <p:fade/>
+  </p:transition>
 </p:sld>
 </file>
 
@@ -4908,7 +4923,7 @@
     <p:bg>
       <p:bgPr>
         <a:solidFill>
-          <a:srgbClr val="FFFFFF"/>
+          <a:srgbClr val="F0F5EA"/>
         </a:solidFill>
       </p:bgPr>
     </p:bg>
@@ -4953,7 +4968,7 @@
             <a:r>
               <a:rPr lang="en-US" sz="2800" b="1" dirty="0">
                 <a:solidFill>
-                  <a:srgbClr val="E0E0E0"/>
+                  <a:srgbClr val="D8E8C8"/>
                 </a:solidFill>
                 <a:latin typeface="Arial Black" pitchFamily="34" charset="0"/>
                 <a:ea typeface="Arial Black" pitchFamily="34" charset="-122"/>
@@ -4999,7 +5014,7 @@
             <a:r>
               <a:rPr lang="en-US" sz="2800" b="1" dirty="0">
                 <a:solidFill>
-                  <a:srgbClr val="0A0A0A"/>
+                  <a:srgbClr val="2C5F2D"/>
                 </a:solidFill>
                 <a:latin typeface="Arial Black" pitchFamily="34" charset="0"/>
                 <a:ea typeface="Arial Black" pitchFamily="34" charset="-122"/>
@@ -5026,11 +5041,11 @@
             <a:avLst/>
           </a:prstGeom>
           <a:solidFill>
-            <a:srgbClr val="0A0A0A"/>
+            <a:srgbClr val="2C5F2D"/>
           </a:solidFill>
           <a:ln w="12700">
             <a:solidFill>
-              <a:srgbClr val="0A0A0A"/>
+              <a:srgbClr val="2C5F2D"/>
             </a:solidFill>
             <a:prstDash val="solid"/>
           </a:ln>
@@ -5051,11 +5066,11 @@
             <a:avLst/>
           </a:prstGeom>
           <a:solidFill>
-            <a:srgbClr val="E0E0E0"/>
+            <a:srgbClr val="D8E8C8"/>
           </a:solidFill>
           <a:ln w="12700">
             <a:solidFill>
-              <a:srgbClr val="E0E0E0"/>
+              <a:srgbClr val="D8E8C8"/>
             </a:solidFill>
             <a:prstDash val="solid"/>
           </a:ln>
@@ -5078,7 +5093,7 @@
             </a:avLst>
           </a:prstGeom>
           <a:solidFill>
-            <a:srgbClr val="0A0A0A"/>
+            <a:srgbClr val="1F3D26"/>
           </a:solidFill>
           <a:ln w="12700">
             <a:solidFill>
@@ -5103,11 +5118,11 @@
             <a:avLst/>
           </a:prstGeom>
           <a:solidFill>
-            <a:srgbClr val="FF5A1F"/>
+            <a:srgbClr val="97BC62"/>
           </a:solidFill>
           <a:ln w="12700">
             <a:solidFill>
-              <a:srgbClr val="FF5A1F"/>
+              <a:srgbClr val="97BC62"/>
             </a:solidFill>
             <a:prstDash val="solid"/>
           </a:ln>
@@ -5140,7 +5155,7 @@
             <a:r>
               <a:rPr lang="en-US" sz="1450" i="1" dirty="0">
                 <a:solidFill>
-                  <a:srgbClr val="FFFFFF"/>
+                  <a:srgbClr val="F0F5EA"/>
                 </a:solidFill>
                 <a:latin typeface="Arial" pitchFamily="34" charset="0"/>
                 <a:ea typeface="Arial" pitchFamily="34" charset="-122"/>
@@ -5167,11 +5182,11 @@
             <a:avLst/>
           </a:prstGeom>
           <a:solidFill>
-            <a:srgbClr val="E0E0E0"/>
+            <a:srgbClr val="D8E8C8"/>
           </a:solidFill>
           <a:ln w="12700">
             <a:solidFill>
-              <a:srgbClr val="E0E0E0"/>
+              <a:srgbClr val="D8E8C8"/>
             </a:solidFill>
             <a:prstDash val="solid"/>
           </a:ln>
@@ -5192,11 +5207,11 @@
             <a:avLst/>
           </a:prstGeom>
           <a:solidFill>
-            <a:srgbClr val="555555"/>
+            <a:srgbClr val="3E5C42"/>
           </a:solidFill>
           <a:ln w="12700">
             <a:solidFill>
-              <a:srgbClr val="555555"/>
+              <a:srgbClr val="3E5C42"/>
             </a:solidFill>
             <a:prstDash val="solid"/>
           </a:ln>
@@ -5219,7 +5234,7 @@
             </a:avLst>
           </a:prstGeom>
           <a:solidFill>
-            <a:srgbClr val="0A0A0A"/>
+            <a:srgbClr val="1F3D26"/>
           </a:solidFill>
           <a:ln w="12700">
             <a:solidFill>
@@ -5244,11 +5259,11 @@
             <a:avLst/>
           </a:prstGeom>
           <a:solidFill>
-            <a:srgbClr val="FF5A1F"/>
+            <a:srgbClr val="97BC62"/>
           </a:solidFill>
           <a:ln w="12700">
             <a:solidFill>
-              <a:srgbClr val="FF5A1F"/>
+              <a:srgbClr val="97BC62"/>
             </a:solidFill>
             <a:prstDash val="solid"/>
           </a:ln>
@@ -5281,7 +5296,7 @@
             <a:r>
               <a:rPr lang="en-US" sz="3200" b="1" dirty="0">
                 <a:solidFill>
-                  <a:srgbClr val="FFFFFF"/>
+                  <a:srgbClr val="F0F5EA"/>
                 </a:solidFill>
                 <a:latin typeface="Arial Black" pitchFamily="34" charset="0"/>
                 <a:ea typeface="Arial Black" pitchFamily="34" charset="-122"/>
@@ -5320,7 +5335,7 @@
             <a:r>
               <a:rPr lang="en-US" sz="1000" dirty="0">
                 <a:solidFill>
-                  <a:srgbClr val="B0B0B0"/>
+                  <a:srgbClr val="8FAE8B"/>
                 </a:solidFill>
                 <a:latin typeface="Arial" pitchFamily="34" charset="0"/>
                 <a:ea typeface="Arial" pitchFamily="34" charset="-122"/>
@@ -5347,11 +5362,11 @@
             <a:avLst/>
           </a:prstGeom>
           <a:solidFill>
-            <a:srgbClr val="E0E0E0"/>
+            <a:srgbClr val="D8E8C8"/>
           </a:solidFill>
           <a:ln w="12700">
             <a:solidFill>
-              <a:srgbClr val="E0E0E0"/>
+              <a:srgbClr val="D8E8C8"/>
             </a:solidFill>
             <a:prstDash val="solid"/>
           </a:ln>
@@ -5372,11 +5387,11 @@
             <a:avLst/>
           </a:prstGeom>
           <a:solidFill>
-            <a:srgbClr val="555555"/>
+            <a:srgbClr val="3E5C42"/>
           </a:solidFill>
           <a:ln w="12700">
             <a:solidFill>
-              <a:srgbClr val="555555"/>
+              <a:srgbClr val="3E5C42"/>
             </a:solidFill>
             <a:prstDash val="solid"/>
           </a:ln>
@@ -5399,7 +5414,7 @@
             </a:avLst>
           </a:prstGeom>
           <a:solidFill>
-            <a:srgbClr val="0A0A0A"/>
+            <a:srgbClr val="1F3D26"/>
           </a:solidFill>
           <a:ln w="12700">
             <a:solidFill>
@@ -5424,11 +5439,11 @@
             <a:avLst/>
           </a:prstGeom>
           <a:solidFill>
-            <a:srgbClr val="FF5A1F"/>
+            <a:srgbClr val="97BC62"/>
           </a:solidFill>
           <a:ln w="12700">
             <a:solidFill>
-              <a:srgbClr val="FF5A1F"/>
+              <a:srgbClr val="97BC62"/>
             </a:solidFill>
             <a:prstDash val="solid"/>
           </a:ln>
@@ -5461,7 +5476,7 @@
             <a:r>
               <a:rPr lang="en-US" sz="3200" b="1" dirty="0">
                 <a:solidFill>
-                  <a:srgbClr val="FFFFFF"/>
+                  <a:srgbClr val="F0F5EA"/>
                 </a:solidFill>
                 <a:latin typeface="Arial Black" pitchFamily="34" charset="0"/>
                 <a:ea typeface="Arial Black" pitchFamily="34" charset="-122"/>
@@ -5500,7 +5515,7 @@
             <a:r>
               <a:rPr lang="en-US" sz="1000" dirty="0">
                 <a:solidFill>
-                  <a:srgbClr val="B0B0B0"/>
+                  <a:srgbClr val="8FAE8B"/>
                 </a:solidFill>
                 <a:latin typeface="Arial" pitchFamily="34" charset="0"/>
                 <a:ea typeface="Arial" pitchFamily="34" charset="-122"/>
@@ -5527,11 +5542,11 @@
             <a:avLst/>
           </a:prstGeom>
           <a:solidFill>
-            <a:srgbClr val="E0E0E0"/>
+            <a:srgbClr val="D8E8C8"/>
           </a:solidFill>
           <a:ln w="12700">
             <a:solidFill>
-              <a:srgbClr val="E0E0E0"/>
+              <a:srgbClr val="D8E8C8"/>
             </a:solidFill>
             <a:prstDash val="solid"/>
           </a:ln>
@@ -5552,11 +5567,11 @@
             <a:avLst/>
           </a:prstGeom>
           <a:solidFill>
-            <a:srgbClr val="555555"/>
+            <a:srgbClr val="3E5C42"/>
           </a:solidFill>
           <a:ln w="12700">
             <a:solidFill>
-              <a:srgbClr val="555555"/>
+              <a:srgbClr val="3E5C42"/>
             </a:solidFill>
             <a:prstDash val="solid"/>
           </a:ln>
@@ -5579,7 +5594,7 @@
             </a:avLst>
           </a:prstGeom>
           <a:solidFill>
-            <a:srgbClr val="0A0A0A"/>
+            <a:srgbClr val="1F3D26"/>
           </a:solidFill>
           <a:ln w="12700">
             <a:solidFill>
@@ -5604,11 +5619,11 @@
             <a:avLst/>
           </a:prstGeom>
           <a:solidFill>
-            <a:srgbClr val="FF5A1F"/>
+            <a:srgbClr val="97BC62"/>
           </a:solidFill>
           <a:ln w="12700">
             <a:solidFill>
-              <a:srgbClr val="FF5A1F"/>
+              <a:srgbClr val="97BC62"/>
             </a:solidFill>
             <a:prstDash val="solid"/>
           </a:ln>
@@ -5641,7 +5656,7 @@
             <a:r>
               <a:rPr lang="en-US" sz="3200" b="1" dirty="0">
                 <a:solidFill>
-                  <a:srgbClr val="FFFFFF"/>
+                  <a:srgbClr val="F0F5EA"/>
                 </a:solidFill>
                 <a:latin typeface="Arial Black" pitchFamily="34" charset="0"/>
                 <a:ea typeface="Arial Black" pitchFamily="34" charset="-122"/>
@@ -5680,7 +5695,7 @@
             <a:r>
               <a:rPr lang="en-US" sz="1000" dirty="0">
                 <a:solidFill>
-                  <a:srgbClr val="B0B0B0"/>
+                  <a:srgbClr val="8FAE8B"/>
                 </a:solidFill>
                 <a:latin typeface="Arial" pitchFamily="34" charset="0"/>
                 <a:ea typeface="Arial" pitchFamily="34" charset="-122"/>
@@ -5719,7 +5734,7 @@
             <a:r>
               <a:rPr lang="en-US" sz="1700" b="1" dirty="0">
                 <a:solidFill>
-                  <a:srgbClr val="E0E0E0"/>
+                  <a:srgbClr val="D8E8C8"/>
                 </a:solidFill>
                 <a:latin typeface="Arial Black" pitchFamily="34" charset="0"/>
                 <a:ea typeface="Arial Black" pitchFamily="34" charset="-122"/>
@@ -5765,7 +5780,7 @@
             <a:r>
               <a:rPr lang="en-US" sz="1700" b="1" dirty="0">
                 <a:solidFill>
-                  <a:srgbClr val="0A0A0A"/>
+                  <a:srgbClr val="2C5F2D"/>
                 </a:solidFill>
                 <a:latin typeface="Arial Black" pitchFamily="34" charset="0"/>
                 <a:ea typeface="Arial Black" pitchFamily="34" charset="-122"/>
@@ -5804,7 +5819,7 @@
             <a:r>
               <a:rPr lang="en-US" sz="850" dirty="0">
                 <a:solidFill>
-                  <a:srgbClr val="6E6E6E"/>
+                  <a:srgbClr val="5A6B5A"/>
                 </a:solidFill>
                 <a:latin typeface="Arial" pitchFamily="34" charset="0"/>
                 <a:ea typeface="Arial" pitchFamily="34" charset="-122"/>
@@ -5821,6 +5836,9 @@
   <p:clrMapOvr>
     <a:masterClrMapping/>
   </p:clrMapOvr>
+  <p:transition spd="med">
+    <p:fade/>
+  </p:transition>
 </p:sld>
 </file>
 
@@ -5830,7 +5848,7 @@
     <p:bg>
       <p:bgPr>
         <a:solidFill>
-          <a:srgbClr val="0A0A0A"/>
+          <a:srgbClr val="1F3D26"/>
         </a:solidFill>
       </p:bgPr>
     </p:bg>
@@ -5875,7 +5893,7 @@
             <a:r>
               <a:rPr lang="en-US" sz="3200" b="1" dirty="0">
                 <a:solidFill>
-                  <a:srgbClr val="2A2A2A"/>
+                  <a:srgbClr val="142B1A"/>
                 </a:solidFill>
                 <a:latin typeface="Arial Black" pitchFamily="34" charset="0"/>
                 <a:ea typeface="Arial Black" pitchFamily="34" charset="-122"/>
@@ -5914,7 +5932,7 @@
             <a:r>
               <a:rPr lang="en-US" sz="3200" b="1" dirty="0">
                 <a:solidFill>
-                  <a:srgbClr val="FFFFFF"/>
+                  <a:srgbClr val="F0F5EA"/>
                 </a:solidFill>
                 <a:latin typeface="Arial Black" pitchFamily="34" charset="0"/>
                 <a:ea typeface="Arial Black" pitchFamily="34" charset="-122"/>
@@ -5941,11 +5959,11 @@
             <a:avLst/>
           </a:prstGeom>
           <a:solidFill>
-            <a:srgbClr val="B0B0B0"/>
+            <a:srgbClr val="8FAE8B"/>
           </a:solidFill>
           <a:ln w="12700">
             <a:solidFill>
-              <a:srgbClr val="B0B0B0"/>
+              <a:srgbClr val="8FAE8B"/>
             </a:solidFill>
             <a:prstDash val="solid"/>
           </a:ln>
@@ -5966,11 +5984,11 @@
             <a:avLst/>
           </a:prstGeom>
           <a:solidFill>
-            <a:srgbClr val="2A2A2A"/>
+            <a:srgbClr val="142B1A"/>
           </a:solidFill>
           <a:ln w="12700">
             <a:solidFill>
-              <a:srgbClr val="2A2A2A"/>
+              <a:srgbClr val="142B1A"/>
             </a:solidFill>
             <a:prstDash val="solid"/>
           </a:ln>
@@ -5991,11 +6009,11 @@
             <a:avLst/>
           </a:prstGeom>
           <a:solidFill>
-            <a:srgbClr val="555555"/>
+            <a:srgbClr val="3E5C42"/>
           </a:solidFill>
           <a:ln w="12700">
             <a:solidFill>
-              <a:srgbClr val="555555"/>
+              <a:srgbClr val="3E5C42"/>
             </a:solidFill>
             <a:prstDash val="solid"/>
           </a:ln>
@@ -6018,11 +6036,11 @@
             </a:avLst>
           </a:prstGeom>
           <a:solidFill>
-            <a:srgbClr val="161616"/>
+            <a:srgbClr val="2A4A33"/>
           </a:solidFill>
           <a:ln w="12700">
             <a:solidFill>
-              <a:srgbClr val="2A2A2A"/>
+              <a:srgbClr val="142B1A"/>
             </a:solidFill>
             <a:prstDash val="solid"/>
           </a:ln>
@@ -6055,7 +6073,7 @@
             <a:r>
               <a:rPr lang="en-US" sz="4400" b="1" dirty="0">
                 <a:solidFill>
-                  <a:srgbClr val="FFFFFF"/>
+                  <a:srgbClr val="F0F5EA"/>
                 </a:solidFill>
                 <a:latin typeface="Arial Black" pitchFamily="34" charset="0"/>
                 <a:ea typeface="Arial Black" pitchFamily="34" charset="-122"/>
@@ -6094,7 +6112,7 @@
             <a:r>
               <a:rPr lang="en-US" sz="950" dirty="0">
                 <a:solidFill>
-                  <a:srgbClr val="B0B0B0"/>
+                  <a:srgbClr val="8FAE8B"/>
                 </a:solidFill>
                 <a:latin typeface="Arial" pitchFamily="34" charset="0"/>
                 <a:ea typeface="Arial" pitchFamily="34" charset="-122"/>
@@ -6133,7 +6151,7 @@
             <a:r>
               <a:rPr lang="en-US" sz="750" dirty="0">
                 <a:solidFill>
-                  <a:srgbClr val="8A8A8A"/>
+                  <a:srgbClr val="8FAE8B"/>
                 </a:solidFill>
                 <a:latin typeface="Arial" pitchFamily="34" charset="0"/>
                 <a:ea typeface="Arial" pitchFamily="34" charset="-122"/>
@@ -6160,11 +6178,11 @@
             <a:avLst/>
           </a:prstGeom>
           <a:solidFill>
-            <a:srgbClr val="2A2A2A"/>
+            <a:srgbClr val="142B1A"/>
           </a:solidFill>
           <a:ln w="12700">
             <a:solidFill>
-              <a:srgbClr val="2A2A2A"/>
+              <a:srgbClr val="142B1A"/>
             </a:solidFill>
             <a:prstDash val="solid"/>
           </a:ln>
@@ -6185,11 +6203,11 @@
             <a:avLst/>
           </a:prstGeom>
           <a:solidFill>
-            <a:srgbClr val="555555"/>
+            <a:srgbClr val="3E5C42"/>
           </a:solidFill>
           <a:ln w="12700">
             <a:solidFill>
-              <a:srgbClr val="555555"/>
+              <a:srgbClr val="3E5C42"/>
             </a:solidFill>
             <a:prstDash val="solid"/>
           </a:ln>
@@ -6212,11 +6230,11 @@
             </a:avLst>
           </a:prstGeom>
           <a:solidFill>
-            <a:srgbClr val="161616"/>
+            <a:srgbClr val="2A4A33"/>
           </a:solidFill>
           <a:ln w="12700">
             <a:solidFill>
-              <a:srgbClr val="2A2A2A"/>
+              <a:srgbClr val="142B1A"/>
             </a:solidFill>
             <a:prstDash val="solid"/>
           </a:ln>
@@ -6249,7 +6267,7 @@
             <a:r>
               <a:rPr lang="en-US" sz="4400" b="1" dirty="0">
                 <a:solidFill>
-                  <a:srgbClr val="FFFFFF"/>
+                  <a:srgbClr val="F0F5EA"/>
                 </a:solidFill>
                 <a:latin typeface="Arial Black" pitchFamily="34" charset="0"/>
                 <a:ea typeface="Arial Black" pitchFamily="34" charset="-122"/>
@@ -6288,7 +6306,7 @@
             <a:r>
               <a:rPr lang="en-US" sz="950" dirty="0">
                 <a:solidFill>
-                  <a:srgbClr val="B0B0B0"/>
+                  <a:srgbClr val="8FAE8B"/>
                 </a:solidFill>
                 <a:latin typeface="Arial" pitchFamily="34" charset="0"/>
                 <a:ea typeface="Arial" pitchFamily="34" charset="-122"/>
@@ -6327,7 +6345,7 @@
             <a:r>
               <a:rPr lang="en-US" sz="750" dirty="0">
                 <a:solidFill>
-                  <a:srgbClr val="8A8A8A"/>
+                  <a:srgbClr val="8FAE8B"/>
                 </a:solidFill>
                 <a:latin typeface="Arial" pitchFamily="34" charset="0"/>
                 <a:ea typeface="Arial" pitchFamily="34" charset="-122"/>
@@ -6354,11 +6372,11 @@
             <a:avLst/>
           </a:prstGeom>
           <a:solidFill>
-            <a:srgbClr val="2A2A2A"/>
+            <a:srgbClr val="142B1A"/>
           </a:solidFill>
           <a:ln w="12700">
             <a:solidFill>
-              <a:srgbClr val="2A2A2A"/>
+              <a:srgbClr val="142B1A"/>
             </a:solidFill>
             <a:prstDash val="solid"/>
           </a:ln>
@@ -6379,11 +6397,11 @@
             <a:avLst/>
           </a:prstGeom>
           <a:solidFill>
-            <a:srgbClr val="555555"/>
+            <a:srgbClr val="3E5C42"/>
           </a:solidFill>
           <a:ln w="12700">
             <a:solidFill>
-              <a:srgbClr val="555555"/>
+              <a:srgbClr val="3E5C42"/>
             </a:solidFill>
             <a:prstDash val="solid"/>
           </a:ln>
@@ -6406,11 +6424,11 @@
             </a:avLst>
           </a:prstGeom>
           <a:solidFill>
-            <a:srgbClr val="161616"/>
+            <a:srgbClr val="2A4A33"/>
           </a:solidFill>
           <a:ln w="12700">
             <a:solidFill>
-              <a:srgbClr val="2A2A2A"/>
+              <a:srgbClr val="142B1A"/>
             </a:solidFill>
             <a:prstDash val="solid"/>
           </a:ln>
@@ -6443,7 +6461,7 @@
             <a:r>
               <a:rPr lang="en-US" sz="4400" b="1" dirty="0">
                 <a:solidFill>
-                  <a:srgbClr val="FFFFFF"/>
+                  <a:srgbClr val="F0F5EA"/>
                 </a:solidFill>
                 <a:latin typeface="Arial Black" pitchFamily="34" charset="0"/>
                 <a:ea typeface="Arial Black" pitchFamily="34" charset="-122"/>
@@ -6482,7 +6500,7 @@
             <a:r>
               <a:rPr lang="en-US" sz="950" dirty="0">
                 <a:solidFill>
-                  <a:srgbClr val="B0B0B0"/>
+                  <a:srgbClr val="8FAE8B"/>
                 </a:solidFill>
                 <a:latin typeface="Arial" pitchFamily="34" charset="0"/>
                 <a:ea typeface="Arial" pitchFamily="34" charset="-122"/>
@@ -6521,7 +6539,7 @@
             <a:r>
               <a:rPr lang="en-US" sz="750" dirty="0">
                 <a:solidFill>
-                  <a:srgbClr val="8A8A8A"/>
+                  <a:srgbClr val="8FAE8B"/>
                 </a:solidFill>
                 <a:latin typeface="Arial" pitchFamily="34" charset="0"/>
                 <a:ea typeface="Arial" pitchFamily="34" charset="-122"/>
@@ -6548,11 +6566,11 @@
             <a:avLst/>
           </a:prstGeom>
           <a:solidFill>
-            <a:srgbClr val="2A2A2A"/>
+            <a:srgbClr val="142B1A"/>
           </a:solidFill>
           <a:ln w="12700">
             <a:solidFill>
-              <a:srgbClr val="2A2A2A"/>
+              <a:srgbClr val="142B1A"/>
             </a:solidFill>
             <a:prstDash val="solid"/>
           </a:ln>
@@ -6573,11 +6591,11 @@
             <a:avLst/>
           </a:prstGeom>
           <a:solidFill>
-            <a:srgbClr val="555555"/>
+            <a:srgbClr val="3E5C42"/>
           </a:solidFill>
           <a:ln w="12700">
             <a:solidFill>
-              <a:srgbClr val="555555"/>
+              <a:srgbClr val="3E5C42"/>
             </a:solidFill>
             <a:prstDash val="solid"/>
           </a:ln>
@@ -6600,11 +6618,11 @@
             </a:avLst>
           </a:prstGeom>
           <a:solidFill>
-            <a:srgbClr val="161616"/>
+            <a:srgbClr val="2A4A33"/>
           </a:solidFill>
           <a:ln w="12700">
             <a:solidFill>
-              <a:srgbClr val="2A2A2A"/>
+              <a:srgbClr val="142B1A"/>
             </a:solidFill>
             <a:prstDash val="solid"/>
           </a:ln>
@@ -6637,7 +6655,7 @@
             <a:r>
               <a:rPr lang="en-US" sz="4400" b="1" dirty="0">
                 <a:solidFill>
-                  <a:srgbClr val="FFFFFF"/>
+                  <a:srgbClr val="F0F5EA"/>
                 </a:solidFill>
                 <a:latin typeface="Arial Black" pitchFamily="34" charset="0"/>
                 <a:ea typeface="Arial Black" pitchFamily="34" charset="-122"/>
@@ -6676,7 +6694,7 @@
             <a:r>
               <a:rPr lang="en-US" sz="950" dirty="0">
                 <a:solidFill>
-                  <a:srgbClr val="B0B0B0"/>
+                  <a:srgbClr val="8FAE8B"/>
                 </a:solidFill>
                 <a:latin typeface="Arial" pitchFamily="34" charset="0"/>
                 <a:ea typeface="Arial" pitchFamily="34" charset="-122"/>
@@ -6715,7 +6733,7 @@
             <a:r>
               <a:rPr lang="en-US" sz="750" dirty="0">
                 <a:solidFill>
-                  <a:srgbClr val="8A8A8A"/>
+                  <a:srgbClr val="8FAE8B"/>
                 </a:solidFill>
                 <a:latin typeface="Arial" pitchFamily="34" charset="0"/>
                 <a:ea typeface="Arial" pitchFamily="34" charset="-122"/>
@@ -6754,7 +6772,7 @@
             <a:r>
               <a:rPr lang="en-US" sz="1300" b="1" dirty="0">
                 <a:solidFill>
-                  <a:srgbClr val="FFFFFF"/>
+                  <a:srgbClr val="F0F5EA"/>
                 </a:solidFill>
                 <a:latin typeface="Arial Black" pitchFamily="34" charset="0"/>
                 <a:ea typeface="Arial Black" pitchFamily="34" charset="-122"/>
@@ -6793,7 +6811,7 @@
             <a:r>
               <a:rPr lang="en-US" sz="850" dirty="0">
                 <a:solidFill>
-                  <a:srgbClr val="B0B0B0"/>
+                  <a:srgbClr val="8FAE8B"/>
                 </a:solidFill>
                 <a:latin typeface="Arial" pitchFamily="34" charset="0"/>
                 <a:ea typeface="Arial" pitchFamily="34" charset="-122"/>
@@ -6810,6 +6828,9 @@
   <p:clrMapOvr>
     <a:masterClrMapping/>
   </p:clrMapOvr>
+  <p:transition spd="med">
+    <p:fade/>
+  </p:transition>
 </p:sld>
 </file>
 
@@ -6819,7 +6840,7 @@
     <p:bg>
       <p:bgPr>
         <a:solidFill>
-          <a:srgbClr val="0A0A0A"/>
+          <a:srgbClr val="1F3D26"/>
         </a:solidFill>
       </p:bgPr>
     </p:bg>
@@ -6864,7 +6885,7 @@
             <a:r>
               <a:rPr lang="en-US" sz="3000" b="1" dirty="0">
                 <a:solidFill>
-                  <a:srgbClr val="2A2A2A"/>
+                  <a:srgbClr val="142B1A"/>
                 </a:solidFill>
                 <a:latin typeface="Arial Black" pitchFamily="34" charset="0"/>
                 <a:ea typeface="Arial Black" pitchFamily="34" charset="-122"/>
@@ -6903,7 +6924,7 @@
             <a:r>
               <a:rPr lang="en-US" sz="3000" b="1" dirty="0">
                 <a:solidFill>
-                  <a:srgbClr val="FFFFFF"/>
+                  <a:srgbClr val="F0F5EA"/>
                 </a:solidFill>
                 <a:latin typeface="Arial Black" pitchFamily="34" charset="0"/>
                 <a:ea typeface="Arial Black" pitchFamily="34" charset="-122"/>
@@ -6930,11 +6951,11 @@
             <a:avLst/>
           </a:prstGeom>
           <a:solidFill>
-            <a:srgbClr val="FF5A1F"/>
+            <a:srgbClr val="97BC62"/>
           </a:solidFill>
           <a:ln w="12700">
             <a:solidFill>
-              <a:srgbClr val="FF5A1F"/>
+              <a:srgbClr val="97BC62"/>
             </a:solidFill>
             <a:prstDash val="solid"/>
           </a:ln>
@@ -6967,7 +6988,7 @@
             <a:r>
               <a:rPr lang="en-US" sz="1350" b="1" dirty="0">
                 <a:solidFill>
-                  <a:srgbClr val="FFFFFF"/>
+                  <a:srgbClr val="F0F5EA"/>
                 </a:solidFill>
                 <a:latin typeface="Arial" pitchFamily="34" charset="0"/>
                 <a:ea typeface="Arial" pitchFamily="34" charset="-122"/>
@@ -6994,11 +7015,11 @@
             <a:avLst/>
           </a:prstGeom>
           <a:solidFill>
-            <a:srgbClr val="2A2A2A"/>
+            <a:srgbClr val="142B1A"/>
           </a:solidFill>
           <a:ln w="12700">
             <a:solidFill>
-              <a:srgbClr val="2A2A2A"/>
+              <a:srgbClr val="142B1A"/>
             </a:solidFill>
             <a:prstDash val="solid"/>
           </a:ln>
@@ -7019,11 +7040,11 @@
             <a:avLst/>
           </a:prstGeom>
           <a:solidFill>
-            <a:srgbClr val="555555"/>
+            <a:srgbClr val="3E5C42"/>
           </a:solidFill>
           <a:ln w="12700">
             <a:solidFill>
-              <a:srgbClr val="555555"/>
+              <a:srgbClr val="3E5C42"/>
             </a:solidFill>
             <a:prstDash val="solid"/>
           </a:ln>
@@ -7046,11 +7067,11 @@
             </a:avLst>
           </a:prstGeom>
           <a:solidFill>
-            <a:srgbClr val="161616"/>
+            <a:srgbClr val="2A4A33"/>
           </a:solidFill>
           <a:ln w="12700">
             <a:solidFill>
-              <a:srgbClr val="2A2A2A"/>
+              <a:srgbClr val="142B1A"/>
             </a:solidFill>
             <a:prstDash val="solid"/>
           </a:ln>
@@ -7083,7 +7104,7 @@
             <a:r>
               <a:rPr lang="en-US" sz="1400" b="1" dirty="0">
                 <a:solidFill>
-                  <a:srgbClr val="FFFFFF"/>
+                  <a:srgbClr val="F0F5EA"/>
                 </a:solidFill>
                 <a:latin typeface="Arial Black" pitchFamily="34" charset="0"/>
                 <a:ea typeface="Arial Black" pitchFamily="34" charset="-122"/>
@@ -7122,7 +7143,7 @@
             <a:r>
               <a:rPr lang="en-US" sz="850" dirty="0">
                 <a:solidFill>
-                  <a:srgbClr val="B0B0B0"/>
+                  <a:srgbClr val="8FAE8B"/>
                 </a:solidFill>
                 <a:latin typeface="Arial" pitchFamily="34" charset="0"/>
                 <a:ea typeface="Arial" pitchFamily="34" charset="-122"/>
@@ -7149,11 +7170,11 @@
             <a:avLst/>
           </a:prstGeom>
           <a:solidFill>
-            <a:srgbClr val="2A2A2A"/>
+            <a:srgbClr val="142B1A"/>
           </a:solidFill>
           <a:ln w="12700">
             <a:solidFill>
-              <a:srgbClr val="2A2A2A"/>
+              <a:srgbClr val="142B1A"/>
             </a:solidFill>
             <a:prstDash val="solid"/>
           </a:ln>
@@ -7174,11 +7195,11 @@
             <a:avLst/>
           </a:prstGeom>
           <a:solidFill>
-            <a:srgbClr val="555555"/>
+            <a:srgbClr val="3E5C42"/>
           </a:solidFill>
           <a:ln w="12700">
             <a:solidFill>
-              <a:srgbClr val="555555"/>
+              <a:srgbClr val="3E5C42"/>
             </a:solidFill>
             <a:prstDash val="solid"/>
           </a:ln>
@@ -7201,11 +7222,11 @@
             </a:avLst>
           </a:prstGeom>
           <a:solidFill>
-            <a:srgbClr val="161616"/>
+            <a:srgbClr val="2A4A33"/>
           </a:solidFill>
           <a:ln w="12700">
             <a:solidFill>
-              <a:srgbClr val="2A2A2A"/>
+              <a:srgbClr val="142B1A"/>
             </a:solidFill>
             <a:prstDash val="solid"/>
           </a:ln>
@@ -7238,7 +7259,7 @@
             <a:r>
               <a:rPr lang="en-US" sz="1400" b="1" dirty="0">
                 <a:solidFill>
-                  <a:srgbClr val="FFFFFF"/>
+                  <a:srgbClr val="F0F5EA"/>
                 </a:solidFill>
                 <a:latin typeface="Arial Black" pitchFamily="34" charset="0"/>
                 <a:ea typeface="Arial Black" pitchFamily="34" charset="-122"/>
@@ -7277,7 +7298,7 @@
             <a:r>
               <a:rPr lang="en-US" sz="850" dirty="0">
                 <a:solidFill>
-                  <a:srgbClr val="B0B0B0"/>
+                  <a:srgbClr val="8FAE8B"/>
                 </a:solidFill>
                 <a:latin typeface="Arial" pitchFamily="34" charset="0"/>
                 <a:ea typeface="Arial" pitchFamily="34" charset="-122"/>
@@ -7304,11 +7325,11 @@
             <a:avLst/>
           </a:prstGeom>
           <a:solidFill>
-            <a:srgbClr val="2A2A2A"/>
+            <a:srgbClr val="142B1A"/>
           </a:solidFill>
           <a:ln w="12700">
             <a:solidFill>
-              <a:srgbClr val="2A2A2A"/>
+              <a:srgbClr val="142B1A"/>
             </a:solidFill>
             <a:prstDash val="solid"/>
           </a:ln>
@@ -7329,11 +7350,11 @@
             <a:avLst/>
           </a:prstGeom>
           <a:solidFill>
-            <a:srgbClr val="555555"/>
+            <a:srgbClr val="3E5C42"/>
           </a:solidFill>
           <a:ln w="12700">
             <a:solidFill>
-              <a:srgbClr val="555555"/>
+              <a:srgbClr val="3E5C42"/>
             </a:solidFill>
             <a:prstDash val="solid"/>
           </a:ln>
@@ -7356,11 +7377,11 @@
             </a:avLst>
           </a:prstGeom>
           <a:solidFill>
-            <a:srgbClr val="161616"/>
+            <a:srgbClr val="2A4A33"/>
           </a:solidFill>
           <a:ln w="12700">
             <a:solidFill>
-              <a:srgbClr val="2A2A2A"/>
+              <a:srgbClr val="142B1A"/>
             </a:solidFill>
             <a:prstDash val="solid"/>
           </a:ln>
@@ -7393,7 +7414,7 @@
             <a:r>
               <a:rPr lang="en-US" sz="1400" b="1" dirty="0">
                 <a:solidFill>
-                  <a:srgbClr val="FFFFFF"/>
+                  <a:srgbClr val="F0F5EA"/>
                 </a:solidFill>
                 <a:latin typeface="Arial Black" pitchFamily="34" charset="0"/>
                 <a:ea typeface="Arial Black" pitchFamily="34" charset="-122"/>
@@ -7432,7 +7453,7 @@
             <a:r>
               <a:rPr lang="en-US" sz="850" dirty="0">
                 <a:solidFill>
-                  <a:srgbClr val="B0B0B0"/>
+                  <a:srgbClr val="8FAE8B"/>
                 </a:solidFill>
                 <a:latin typeface="Arial" pitchFamily="34" charset="0"/>
                 <a:ea typeface="Arial" pitchFamily="34" charset="-122"/>
@@ -7459,11 +7480,11 @@
             <a:avLst/>
           </a:prstGeom>
           <a:solidFill>
-            <a:srgbClr val="2A2A2A"/>
+            <a:srgbClr val="142B1A"/>
           </a:solidFill>
           <a:ln w="12700">
             <a:solidFill>
-              <a:srgbClr val="2A2A2A"/>
+              <a:srgbClr val="142B1A"/>
             </a:solidFill>
             <a:prstDash val="solid"/>
           </a:ln>
@@ -7484,11 +7505,11 @@
             <a:avLst/>
           </a:prstGeom>
           <a:solidFill>
-            <a:srgbClr val="555555"/>
+            <a:srgbClr val="3E5C42"/>
           </a:solidFill>
           <a:ln w="12700">
             <a:solidFill>
-              <a:srgbClr val="555555"/>
+              <a:srgbClr val="3E5C42"/>
             </a:solidFill>
             <a:prstDash val="solid"/>
           </a:ln>
@@ -7511,11 +7532,11 @@
             </a:avLst>
           </a:prstGeom>
           <a:solidFill>
-            <a:srgbClr val="161616"/>
+            <a:srgbClr val="2A4A33"/>
           </a:solidFill>
           <a:ln w="12700">
             <a:solidFill>
-              <a:srgbClr val="2A2A2A"/>
+              <a:srgbClr val="142B1A"/>
             </a:solidFill>
             <a:prstDash val="solid"/>
           </a:ln>
@@ -7548,7 +7569,7 @@
             <a:r>
               <a:rPr lang="en-US" sz="1400" b="1" dirty="0">
                 <a:solidFill>
-                  <a:srgbClr val="FFFFFF"/>
+                  <a:srgbClr val="F0F5EA"/>
                 </a:solidFill>
                 <a:latin typeface="Arial Black" pitchFamily="34" charset="0"/>
                 <a:ea typeface="Arial Black" pitchFamily="34" charset="-122"/>
@@ -7587,7 +7608,7 @@
             <a:r>
               <a:rPr lang="en-US" sz="850" dirty="0">
                 <a:solidFill>
-                  <a:srgbClr val="B0B0B0"/>
+                  <a:srgbClr val="8FAE8B"/>
                 </a:solidFill>
                 <a:latin typeface="Arial" pitchFamily="34" charset="0"/>
                 <a:ea typeface="Arial" pitchFamily="34" charset="-122"/>
@@ -7626,7 +7647,7 @@
             <a:r>
               <a:rPr lang="en-US" sz="850" dirty="0">
                 <a:solidFill>
-                  <a:srgbClr val="B0B0B0"/>
+                  <a:srgbClr val="8FAE8B"/>
                 </a:solidFill>
                 <a:latin typeface="Arial" pitchFamily="34" charset="0"/>
                 <a:ea typeface="Arial" pitchFamily="34" charset="-122"/>
@@ -7643,6 +7664,9 @@
   <p:clrMapOvr>
     <a:masterClrMapping/>
   </p:clrMapOvr>
+  <p:transition spd="med">
+    <p:fade/>
+  </p:transition>
 </p:sld>
 </file>
 
@@ -7652,7 +7676,7 @@
     <p:bg>
       <p:bgPr>
         <a:solidFill>
-          <a:srgbClr val="FFFFFF"/>
+          <a:srgbClr val="F0F5EA"/>
         </a:solidFill>
       </p:bgPr>
     </p:bg>
@@ -7697,7 +7721,7 @@
             <a:r>
               <a:rPr lang="en-US" sz="2800" b="1" dirty="0">
                 <a:solidFill>
-                  <a:srgbClr val="E0E0E0"/>
+                  <a:srgbClr val="D8E8C8"/>
                 </a:solidFill>
                 <a:latin typeface="Arial Black" pitchFamily="34" charset="0"/>
                 <a:ea typeface="Arial Black" pitchFamily="34" charset="-122"/>
@@ -7743,7 +7767,7 @@
             <a:r>
               <a:rPr lang="en-US" sz="2800" b="1" dirty="0">
                 <a:solidFill>
-                  <a:srgbClr val="0A0A0A"/>
+                  <a:srgbClr val="2C5F2D"/>
                 </a:solidFill>
                 <a:latin typeface="Arial Black" pitchFamily="34" charset="0"/>
                 <a:ea typeface="Arial Black" pitchFamily="34" charset="-122"/>
@@ -7770,11 +7794,11 @@
             <a:avLst/>
           </a:prstGeom>
           <a:solidFill>
-            <a:srgbClr val="0A0A0A"/>
+            <a:srgbClr val="2C5F2D"/>
           </a:solidFill>
           <a:ln w="12700">
             <a:solidFill>
-              <a:srgbClr val="0A0A0A"/>
+              <a:srgbClr val="2C5F2D"/>
             </a:solidFill>
             <a:prstDash val="solid"/>
           </a:ln>
@@ -7807,7 +7831,7 @@
             <a:r>
               <a:rPr lang="en-US" sz="1600" b="1" dirty="0">
                 <a:solidFill>
-                  <a:srgbClr val="0A0A0A"/>
+                  <a:srgbClr val="2C5F2D"/>
                 </a:solidFill>
                 <a:latin typeface="Arial" pitchFamily="34" charset="0"/>
                 <a:ea typeface="Arial" pitchFamily="34" charset="-122"/>
@@ -7834,11 +7858,11 @@
             <a:avLst/>
           </a:prstGeom>
           <a:solidFill>
-            <a:srgbClr val="E0E0E0"/>
+            <a:srgbClr val="D8E8C8"/>
           </a:solidFill>
           <a:ln w="12700">
             <a:solidFill>
-              <a:srgbClr val="E0E0E0"/>
+              <a:srgbClr val="D8E8C8"/>
             </a:solidFill>
             <a:prstDash val="solid"/>
           </a:ln>
@@ -7861,11 +7885,11 @@
             </a:avLst>
           </a:prstGeom>
           <a:solidFill>
-            <a:srgbClr val="FFFFFF"/>
+            <a:srgbClr val="F0F5EA"/>
           </a:solidFill>
           <a:ln w="19050">
             <a:solidFill>
-              <a:srgbClr val="0A0A0A"/>
+              <a:srgbClr val="2C5F2D"/>
             </a:solidFill>
             <a:prstDash val="solid"/>
           </a:ln>
@@ -7886,7 +7910,7 @@
             <a:avLst/>
           </a:prstGeom>
           <a:solidFill>
-            <a:srgbClr val="0A0A0A"/>
+            <a:srgbClr val="1F3D26"/>
           </a:solidFill>
           <a:ln/>
         </p:spPr>
@@ -7918,7 +7942,7 @@
             <a:r>
               <a:rPr lang="en-US" sz="1400" b="1" dirty="0">
                 <a:solidFill>
-                  <a:srgbClr val="FFFFFF"/>
+                  <a:srgbClr val="F0F5EA"/>
                 </a:solidFill>
                 <a:latin typeface="Arial" pitchFamily="34" charset="0"/>
                 <a:ea typeface="Arial" pitchFamily="34" charset="-122"/>
@@ -7957,7 +7981,7 @@
             <a:r>
               <a:rPr lang="en-US" sz="1500" b="1" dirty="0">
                 <a:solidFill>
-                  <a:srgbClr val="0A0A0A"/>
+                  <a:srgbClr val="2C5F2D"/>
                 </a:solidFill>
                 <a:latin typeface="Arial Black" pitchFamily="34" charset="0"/>
                 <a:ea typeface="Arial Black" pitchFamily="34" charset="-122"/>
@@ -7999,7 +8023,7 @@
             <a:r>
               <a:rPr lang="en-US" sz="1100" dirty="0">
                 <a:solidFill>
-                  <a:srgbClr val="0A0A0A"/>
+                  <a:srgbClr val="2C5F2D"/>
                 </a:solidFill>
                 <a:latin typeface="Arial" pitchFamily="34" charset="0"/>
                 <a:ea typeface="Arial" pitchFamily="34" charset="-122"/>
@@ -8019,7 +8043,7 @@
             <a:r>
               <a:rPr lang="en-US" sz="1100" dirty="0">
                 <a:solidFill>
-                  <a:srgbClr val="0A0A0A"/>
+                  <a:srgbClr val="2C5F2D"/>
                 </a:solidFill>
                 <a:latin typeface="Arial" pitchFamily="34" charset="0"/>
                 <a:ea typeface="Arial" pitchFamily="34" charset="-122"/>
@@ -8039,7 +8063,7 @@
             <a:r>
               <a:rPr lang="en-US" sz="1100" dirty="0">
                 <a:solidFill>
-                  <a:srgbClr val="0A0A0A"/>
+                  <a:srgbClr val="2C5F2D"/>
                 </a:solidFill>
                 <a:latin typeface="Arial" pitchFamily="34" charset="0"/>
                 <a:ea typeface="Arial" pitchFamily="34" charset="-122"/>
@@ -8059,7 +8083,7 @@
             <a:r>
               <a:rPr lang="en-US" sz="1100" dirty="0">
                 <a:solidFill>
-                  <a:srgbClr val="0A0A0A"/>
+                  <a:srgbClr val="2C5F2D"/>
                 </a:solidFill>
                 <a:latin typeface="Arial" pitchFamily="34" charset="0"/>
                 <a:ea typeface="Arial" pitchFamily="34" charset="-122"/>
@@ -8086,11 +8110,11 @@
             <a:avLst/>
           </a:prstGeom>
           <a:solidFill>
-            <a:srgbClr val="E0E0E0"/>
+            <a:srgbClr val="D8E8C8"/>
           </a:solidFill>
           <a:ln w="12700">
             <a:solidFill>
-              <a:srgbClr val="E0E0E0"/>
+              <a:srgbClr val="D8E8C8"/>
             </a:solidFill>
             <a:prstDash val="solid"/>
           </a:ln>
@@ -8113,11 +8137,11 @@
             </a:avLst>
           </a:prstGeom>
           <a:solidFill>
-            <a:srgbClr val="FFFFFF"/>
+            <a:srgbClr val="F0F5EA"/>
           </a:solidFill>
           <a:ln w="19050">
             <a:solidFill>
-              <a:srgbClr val="0A0A0A"/>
+              <a:srgbClr val="2C5F2D"/>
             </a:solidFill>
             <a:prstDash val="solid"/>
           </a:ln>
@@ -8138,7 +8162,7 @@
             <a:avLst/>
           </a:prstGeom>
           <a:solidFill>
-            <a:srgbClr val="0A0A0A"/>
+            <a:srgbClr val="1F3D26"/>
           </a:solidFill>
           <a:ln/>
         </p:spPr>
@@ -8170,7 +8194,7 @@
             <a:r>
               <a:rPr lang="en-US" sz="1400" b="1" dirty="0">
                 <a:solidFill>
-                  <a:srgbClr val="FFFFFF"/>
+                  <a:srgbClr val="F0F5EA"/>
                 </a:solidFill>
                 <a:latin typeface="Arial" pitchFamily="34" charset="0"/>
                 <a:ea typeface="Arial" pitchFamily="34" charset="-122"/>
@@ -8209,7 +8233,7 @@
             <a:r>
               <a:rPr lang="en-US" sz="1500" b="1" dirty="0">
                 <a:solidFill>
-                  <a:srgbClr val="0A0A0A"/>
+                  <a:srgbClr val="2C5F2D"/>
                 </a:solidFill>
                 <a:latin typeface="Arial Black" pitchFamily="34" charset="0"/>
                 <a:ea typeface="Arial Black" pitchFamily="34" charset="-122"/>
@@ -8251,7 +8275,7 @@
             <a:r>
               <a:rPr lang="en-US" sz="1100" dirty="0">
                 <a:solidFill>
-                  <a:srgbClr val="0A0A0A"/>
+                  <a:srgbClr val="2C5F2D"/>
                 </a:solidFill>
                 <a:latin typeface="Arial" pitchFamily="34" charset="0"/>
                 <a:ea typeface="Arial" pitchFamily="34" charset="-122"/>
@@ -8271,7 +8295,7 @@
             <a:r>
               <a:rPr lang="en-US" sz="1100" dirty="0">
                 <a:solidFill>
-                  <a:srgbClr val="0A0A0A"/>
+                  <a:srgbClr val="2C5F2D"/>
                 </a:solidFill>
                 <a:latin typeface="Arial" pitchFamily="34" charset="0"/>
                 <a:ea typeface="Arial" pitchFamily="34" charset="-122"/>
@@ -8291,7 +8315,7 @@
             <a:r>
               <a:rPr lang="en-US" sz="1100" dirty="0">
                 <a:solidFill>
-                  <a:srgbClr val="0A0A0A"/>
+                  <a:srgbClr val="2C5F2D"/>
                 </a:solidFill>
                 <a:latin typeface="Arial" pitchFamily="34" charset="0"/>
                 <a:ea typeface="Arial" pitchFamily="34" charset="-122"/>
@@ -8311,7 +8335,7 @@
             <a:r>
               <a:rPr lang="en-US" sz="1100" dirty="0">
                 <a:solidFill>
-                  <a:srgbClr val="0A0A0A"/>
+                  <a:srgbClr val="2C5F2D"/>
                 </a:solidFill>
                 <a:latin typeface="Arial" pitchFamily="34" charset="0"/>
                 <a:ea typeface="Arial" pitchFamily="34" charset="-122"/>
@@ -8338,11 +8362,11 @@
             <a:avLst/>
           </a:prstGeom>
           <a:solidFill>
-            <a:srgbClr val="E0E0E0"/>
+            <a:srgbClr val="D8E8C8"/>
           </a:solidFill>
           <a:ln w="12700">
             <a:solidFill>
-              <a:srgbClr val="E0E0E0"/>
+              <a:srgbClr val="D8E8C8"/>
             </a:solidFill>
             <a:prstDash val="solid"/>
           </a:ln>
@@ -8365,11 +8389,11 @@
             </a:avLst>
           </a:prstGeom>
           <a:solidFill>
-            <a:srgbClr val="FFFFFF"/>
+            <a:srgbClr val="F0F5EA"/>
           </a:solidFill>
           <a:ln w="19050">
             <a:solidFill>
-              <a:srgbClr val="0A0A0A"/>
+              <a:srgbClr val="2C5F2D"/>
             </a:solidFill>
             <a:prstDash val="solid"/>
           </a:ln>
@@ -8390,7 +8414,7 @@
             <a:avLst/>
           </a:prstGeom>
           <a:solidFill>
-            <a:srgbClr val="0A0A0A"/>
+            <a:srgbClr val="1F3D26"/>
           </a:solidFill>
           <a:ln/>
         </p:spPr>
@@ -8422,7 +8446,7 @@
             <a:r>
               <a:rPr lang="en-US" sz="1400" b="1" dirty="0">
                 <a:solidFill>
-                  <a:srgbClr val="FFFFFF"/>
+                  <a:srgbClr val="F0F5EA"/>
                 </a:solidFill>
                 <a:latin typeface="Arial" pitchFamily="34" charset="0"/>
                 <a:ea typeface="Arial" pitchFamily="34" charset="-122"/>
@@ -8461,7 +8485,7 @@
             <a:r>
               <a:rPr lang="en-US" sz="1500" b="1" dirty="0">
                 <a:solidFill>
-                  <a:srgbClr val="0A0A0A"/>
+                  <a:srgbClr val="2C5F2D"/>
                 </a:solidFill>
                 <a:latin typeface="Arial Black" pitchFamily="34" charset="0"/>
                 <a:ea typeface="Arial Black" pitchFamily="34" charset="-122"/>
@@ -8503,7 +8527,7 @@
             <a:r>
               <a:rPr lang="en-US" sz="1100" dirty="0">
                 <a:solidFill>
-                  <a:srgbClr val="0A0A0A"/>
+                  <a:srgbClr val="2C5F2D"/>
                 </a:solidFill>
                 <a:latin typeface="Arial" pitchFamily="34" charset="0"/>
                 <a:ea typeface="Arial" pitchFamily="34" charset="-122"/>
@@ -8523,7 +8547,7 @@
             <a:r>
               <a:rPr lang="en-US" sz="1100" dirty="0">
                 <a:solidFill>
-                  <a:srgbClr val="0A0A0A"/>
+                  <a:srgbClr val="2C5F2D"/>
                 </a:solidFill>
                 <a:latin typeface="Arial" pitchFamily="34" charset="0"/>
                 <a:ea typeface="Arial" pitchFamily="34" charset="-122"/>
@@ -8543,7 +8567,7 @@
             <a:r>
               <a:rPr lang="en-US" sz="1100" dirty="0">
                 <a:solidFill>
-                  <a:srgbClr val="0A0A0A"/>
+                  <a:srgbClr val="2C5F2D"/>
                 </a:solidFill>
                 <a:latin typeface="Arial" pitchFamily="34" charset="0"/>
                 <a:ea typeface="Arial" pitchFamily="34" charset="-122"/>
@@ -8563,7 +8587,7 @@
             <a:r>
               <a:rPr lang="en-US" sz="1100" dirty="0">
                 <a:solidFill>
-                  <a:srgbClr val="0A0A0A"/>
+                  <a:srgbClr val="2C5F2D"/>
                 </a:solidFill>
                 <a:latin typeface="Arial" pitchFamily="34" charset="0"/>
                 <a:ea typeface="Arial" pitchFamily="34" charset="-122"/>
@@ -8602,7 +8626,7 @@
             <a:r>
               <a:rPr lang="en-US" sz="1050" i="1" dirty="0">
                 <a:solidFill>
-                  <a:srgbClr val="6E6E6E"/>
+                  <a:srgbClr val="5A6B5A"/>
                 </a:solidFill>
                 <a:latin typeface="Arial" pitchFamily="34" charset="0"/>
                 <a:ea typeface="Arial" pitchFamily="34" charset="-122"/>
@@ -8641,7 +8665,7 @@
             <a:r>
               <a:rPr lang="en-US" sz="850" dirty="0">
                 <a:solidFill>
-                  <a:srgbClr val="6E6E6E"/>
+                  <a:srgbClr val="5A6B5A"/>
                 </a:solidFill>
                 <a:latin typeface="Arial" pitchFamily="34" charset="0"/>
                 <a:ea typeface="Arial" pitchFamily="34" charset="-122"/>
@@ -8658,6 +8682,9 @@
   <p:clrMapOvr>
     <a:masterClrMapping/>
   </p:clrMapOvr>
+  <p:transition spd="med">
+    <p:fade/>
+  </p:transition>
 </p:sld>
 </file>
 
@@ -8667,7 +8694,7 @@
     <p:bg>
       <p:bgPr>
         <a:solidFill>
-          <a:srgbClr val="FFFFFF"/>
+          <a:srgbClr val="F0F5EA"/>
         </a:solidFill>
       </p:bgPr>
     </p:bg>
@@ -8712,7 +8739,7 @@
             <a:r>
               <a:rPr lang="en-US" sz="2800" b="1" dirty="0">
                 <a:solidFill>
-                  <a:srgbClr val="E0E0E0"/>
+                  <a:srgbClr val="D8E8C8"/>
                 </a:solidFill>
                 <a:latin typeface="Arial Black" pitchFamily="34" charset="0"/>
                 <a:ea typeface="Arial Black" pitchFamily="34" charset="-122"/>
@@ -8758,7 +8785,7 @@
             <a:r>
               <a:rPr lang="en-US" sz="2800" b="1" dirty="0">
                 <a:solidFill>
-                  <a:srgbClr val="0A0A0A"/>
+                  <a:srgbClr val="2C5F2D"/>
                 </a:solidFill>
                 <a:latin typeface="Arial Black" pitchFamily="34" charset="0"/>
                 <a:ea typeface="Arial Black" pitchFamily="34" charset="-122"/>
@@ -8785,11 +8812,11 @@
             <a:avLst/>
           </a:prstGeom>
           <a:solidFill>
-            <a:srgbClr val="0A0A0A"/>
+            <a:srgbClr val="2C5F2D"/>
           </a:solidFill>
           <a:ln w="12700">
             <a:solidFill>
-              <a:srgbClr val="0A0A0A"/>
+              <a:srgbClr val="2C5F2D"/>
             </a:solidFill>
             <a:prstDash val="solid"/>
           </a:ln>
@@ -8810,11 +8837,11 @@
             <a:avLst/>
           </a:prstGeom>
           <a:solidFill>
-            <a:srgbClr val="E0E0E0"/>
+            <a:srgbClr val="D8E8C8"/>
           </a:solidFill>
           <a:ln w="12700">
             <a:solidFill>
-              <a:srgbClr val="E0E0E0"/>
+              <a:srgbClr val="D8E8C8"/>
             </a:solidFill>
             <a:prstDash val="solid"/>
           </a:ln>
@@ -8837,11 +8864,11 @@
             </a:avLst>
           </a:prstGeom>
           <a:solidFill>
-            <a:srgbClr val="FFFFFF"/>
+            <a:srgbClr val="F0F5EA"/>
           </a:solidFill>
           <a:ln w="19050">
             <a:solidFill>
-              <a:srgbClr val="0A0A0A"/>
+              <a:srgbClr val="2C5F2D"/>
             </a:solidFill>
             <a:prstDash val="solid"/>
           </a:ln>
@@ -8862,7 +8889,7 @@
             <a:avLst/>
           </a:prstGeom>
           <a:solidFill>
-            <a:srgbClr val="0A0A0A"/>
+            <a:srgbClr val="1F3D26"/>
           </a:solidFill>
           <a:ln/>
         </p:spPr>
@@ -8894,7 +8921,7 @@
             <a:r>
               <a:rPr lang="en-US" sz="1800" b="1" dirty="0">
                 <a:solidFill>
-                  <a:srgbClr val="FFFFFF"/>
+                  <a:srgbClr val="F0F5EA"/>
                 </a:solidFill>
                 <a:latin typeface="Arial" pitchFamily="34" charset="0"/>
                 <a:ea typeface="Arial" pitchFamily="34" charset="-122"/>
@@ -8933,7 +8960,7 @@
             <a:r>
               <a:rPr lang="en-US" sz="1400" b="1" dirty="0">
                 <a:solidFill>
-                  <a:srgbClr val="0A0A0A"/>
+                  <a:srgbClr val="2C5F2D"/>
                 </a:solidFill>
                 <a:latin typeface="Arial Black" pitchFamily="34" charset="0"/>
                 <a:ea typeface="Arial Black" pitchFamily="34" charset="-122"/>
@@ -8972,7 +8999,7 @@
             <a:r>
               <a:rPr lang="en-US" sz="1050" dirty="0">
                 <a:solidFill>
-                  <a:srgbClr val="0A0A0A"/>
+                  <a:srgbClr val="2C5F2D"/>
                 </a:solidFill>
                 <a:latin typeface="Arial" pitchFamily="34" charset="0"/>
                 <a:ea typeface="Arial" pitchFamily="34" charset="-122"/>
@@ -9011,7 +9038,7 @@
             <a:r>
               <a:rPr lang="en-US" sz="950" i="1" dirty="0">
                 <a:solidFill>
-                  <a:srgbClr val="6E6E6E"/>
+                  <a:srgbClr val="5A6B5A"/>
                 </a:solidFill>
                 <a:latin typeface="Arial" pitchFamily="34" charset="0"/>
                 <a:ea typeface="Arial" pitchFamily="34" charset="-122"/>
@@ -9050,7 +9077,7 @@
             <a:r>
               <a:rPr lang="en-US" sz="2000" b="1" dirty="0">
                 <a:solidFill>
-                  <a:srgbClr val="B0B0B0"/>
+                  <a:srgbClr val="8FAE8B"/>
                 </a:solidFill>
                 <a:latin typeface="Arial" pitchFamily="34" charset="0"/>
                 <a:ea typeface="Arial" pitchFamily="34" charset="-122"/>
@@ -9077,11 +9104,11 @@
             <a:avLst/>
           </a:prstGeom>
           <a:solidFill>
-            <a:srgbClr val="E0E0E0"/>
+            <a:srgbClr val="D8E8C8"/>
           </a:solidFill>
           <a:ln w="12700">
             <a:solidFill>
-              <a:srgbClr val="E0E0E0"/>
+              <a:srgbClr val="D8E8C8"/>
             </a:solidFill>
             <a:prstDash val="solid"/>
           </a:ln>
@@ -9104,11 +9131,11 @@
             </a:avLst>
           </a:prstGeom>
           <a:solidFill>
-            <a:srgbClr val="FFFFFF"/>
+            <a:srgbClr val="F0F5EA"/>
           </a:solidFill>
           <a:ln w="19050">
             <a:solidFill>
-              <a:srgbClr val="0A0A0A"/>
+              <a:srgbClr val="2C5F2D"/>
             </a:solidFill>
             <a:prstDash val="solid"/>
           </a:ln>
@@ -9129,7 +9156,7 @@
             <a:avLst/>
           </a:prstGeom>
           <a:solidFill>
-            <a:srgbClr val="0A0A0A"/>
+            <a:srgbClr val="1F3D26"/>
           </a:solidFill>
           <a:ln/>
         </p:spPr>
@@ -9161,7 +9188,7 @@
             <a:r>
               <a:rPr lang="en-US" sz="1800" b="1" dirty="0">
                 <a:solidFill>
-                  <a:srgbClr val="FFFFFF"/>
+                  <a:srgbClr val="F0F5EA"/>
                 </a:solidFill>
                 <a:latin typeface="Arial" pitchFamily="34" charset="0"/>
                 <a:ea typeface="Arial" pitchFamily="34" charset="-122"/>
@@ -9200,7 +9227,7 @@
             <a:r>
               <a:rPr lang="en-US" sz="1400" b="1" dirty="0">
                 <a:solidFill>
-                  <a:srgbClr val="0A0A0A"/>
+                  <a:srgbClr val="2C5F2D"/>
                 </a:solidFill>
                 <a:latin typeface="Arial Black" pitchFamily="34" charset="0"/>
                 <a:ea typeface="Arial Black" pitchFamily="34" charset="-122"/>
@@ -9239,7 +9266,7 @@
             <a:r>
               <a:rPr lang="en-US" sz="1050" dirty="0">
                 <a:solidFill>
-                  <a:srgbClr val="0A0A0A"/>
+                  <a:srgbClr val="2C5F2D"/>
                 </a:solidFill>
                 <a:latin typeface="Arial" pitchFamily="34" charset="0"/>
                 <a:ea typeface="Arial" pitchFamily="34" charset="-122"/>
@@ -9278,7 +9305,7 @@
             <a:r>
               <a:rPr lang="en-US" sz="950" i="1" dirty="0">
                 <a:solidFill>
-                  <a:srgbClr val="6E6E6E"/>
+                  <a:srgbClr val="5A6B5A"/>
                 </a:solidFill>
                 <a:latin typeface="Arial" pitchFamily="34" charset="0"/>
                 <a:ea typeface="Arial" pitchFamily="34" charset="-122"/>
@@ -9317,7 +9344,7 @@
             <a:r>
               <a:rPr lang="en-US" sz="2000" b="1" dirty="0">
                 <a:solidFill>
-                  <a:srgbClr val="B0B0B0"/>
+                  <a:srgbClr val="8FAE8B"/>
                 </a:solidFill>
                 <a:latin typeface="Arial" pitchFamily="34" charset="0"/>
                 <a:ea typeface="Arial" pitchFamily="34" charset="-122"/>
@@ -9344,11 +9371,11 @@
             <a:avLst/>
           </a:prstGeom>
           <a:solidFill>
-            <a:srgbClr val="E0E0E0"/>
+            <a:srgbClr val="D8E8C8"/>
           </a:solidFill>
           <a:ln w="12700">
             <a:solidFill>
-              <a:srgbClr val="E0E0E0"/>
+              <a:srgbClr val="D8E8C8"/>
             </a:solidFill>
             <a:prstDash val="solid"/>
           </a:ln>
@@ -9371,11 +9398,11 @@
             </a:avLst>
           </a:prstGeom>
           <a:solidFill>
-            <a:srgbClr val="FFFFFF"/>
+            <a:srgbClr val="F0F5EA"/>
           </a:solidFill>
           <a:ln w="19050">
             <a:solidFill>
-              <a:srgbClr val="0A0A0A"/>
+              <a:srgbClr val="2C5F2D"/>
             </a:solidFill>
             <a:prstDash val="solid"/>
           </a:ln>
@@ -9396,7 +9423,7 @@
             <a:avLst/>
           </a:prstGeom>
           <a:solidFill>
-            <a:srgbClr val="0A0A0A"/>
+            <a:srgbClr val="1F3D26"/>
           </a:solidFill>
           <a:ln/>
         </p:spPr>
@@ -9428,7 +9455,7 @@
             <a:r>
               <a:rPr lang="en-US" sz="1800" b="1" dirty="0">
                 <a:solidFill>
-                  <a:srgbClr val="FFFFFF"/>
+                  <a:srgbClr val="F0F5EA"/>
                 </a:solidFill>
                 <a:latin typeface="Arial" pitchFamily="34" charset="0"/>
                 <a:ea typeface="Arial" pitchFamily="34" charset="-122"/>
@@ -9467,7 +9494,7 @@
             <a:r>
               <a:rPr lang="en-US" sz="1400" b="1" dirty="0">
                 <a:solidFill>
-                  <a:srgbClr val="0A0A0A"/>
+                  <a:srgbClr val="2C5F2D"/>
                 </a:solidFill>
                 <a:latin typeface="Arial Black" pitchFamily="34" charset="0"/>
                 <a:ea typeface="Arial Black" pitchFamily="34" charset="-122"/>
@@ -9506,7 +9533,7 @@
             <a:r>
               <a:rPr lang="en-US" sz="1050" dirty="0">
                 <a:solidFill>
-                  <a:srgbClr val="0A0A0A"/>
+                  <a:srgbClr val="2C5F2D"/>
                 </a:solidFill>
                 <a:latin typeface="Arial" pitchFamily="34" charset="0"/>
                 <a:ea typeface="Arial" pitchFamily="34" charset="-122"/>
@@ -9545,7 +9572,7 @@
             <a:r>
               <a:rPr lang="en-US" sz="950" i="1" dirty="0">
                 <a:solidFill>
-                  <a:srgbClr val="6E6E6E"/>
+                  <a:srgbClr val="5A6B5A"/>
                 </a:solidFill>
                 <a:latin typeface="Arial" pitchFamily="34" charset="0"/>
                 <a:ea typeface="Arial" pitchFamily="34" charset="-122"/>
@@ -9584,7 +9611,7 @@
             <a:r>
               <a:rPr lang="en-US" sz="2000" b="1" dirty="0">
                 <a:solidFill>
-                  <a:srgbClr val="B0B0B0"/>
+                  <a:srgbClr val="8FAE8B"/>
                 </a:solidFill>
                 <a:latin typeface="Arial" pitchFamily="34" charset="0"/>
                 <a:ea typeface="Arial" pitchFamily="34" charset="-122"/>
@@ -9611,11 +9638,11 @@
             <a:avLst/>
           </a:prstGeom>
           <a:solidFill>
-            <a:srgbClr val="E0E0E0"/>
+            <a:srgbClr val="D8E8C8"/>
           </a:solidFill>
           <a:ln w="12700">
             <a:solidFill>
-              <a:srgbClr val="E0E0E0"/>
+              <a:srgbClr val="D8E8C8"/>
             </a:solidFill>
             <a:prstDash val="solid"/>
           </a:ln>
@@ -9638,11 +9665,11 @@
             </a:avLst>
           </a:prstGeom>
           <a:solidFill>
-            <a:srgbClr val="FFFFFF"/>
+            <a:srgbClr val="F0F5EA"/>
           </a:solidFill>
           <a:ln w="19050">
             <a:solidFill>
-              <a:srgbClr val="0A0A0A"/>
+              <a:srgbClr val="2C5F2D"/>
             </a:solidFill>
             <a:prstDash val="solid"/>
           </a:ln>
@@ -9663,7 +9690,7 @@
             <a:avLst/>
           </a:prstGeom>
           <a:solidFill>
-            <a:srgbClr val="0A0A0A"/>
+            <a:srgbClr val="1F3D26"/>
           </a:solidFill>
           <a:ln/>
         </p:spPr>
@@ -9695,7 +9722,7 @@
             <a:r>
               <a:rPr lang="en-US" sz="1800" b="1" dirty="0">
                 <a:solidFill>
-                  <a:srgbClr val="FFFFFF"/>
+                  <a:srgbClr val="F0F5EA"/>
                 </a:solidFill>
                 <a:latin typeface="Arial" pitchFamily="34" charset="0"/>
                 <a:ea typeface="Arial" pitchFamily="34" charset="-122"/>
@@ -9734,7 +9761,7 @@
             <a:r>
               <a:rPr lang="en-US" sz="1400" b="1" dirty="0">
                 <a:solidFill>
-                  <a:srgbClr val="0A0A0A"/>
+                  <a:srgbClr val="2C5F2D"/>
                 </a:solidFill>
                 <a:latin typeface="Arial Black" pitchFamily="34" charset="0"/>
                 <a:ea typeface="Arial Black" pitchFamily="34" charset="-122"/>
@@ -9773,7 +9800,7 @@
             <a:r>
               <a:rPr lang="en-US" sz="1050" dirty="0">
                 <a:solidFill>
-                  <a:srgbClr val="0A0A0A"/>
+                  <a:srgbClr val="2C5F2D"/>
                 </a:solidFill>
                 <a:latin typeface="Arial" pitchFamily="34" charset="0"/>
                 <a:ea typeface="Arial" pitchFamily="34" charset="-122"/>
@@ -9812,7 +9839,7 @@
             <a:r>
               <a:rPr lang="en-US" sz="950" i="1" dirty="0">
                 <a:solidFill>
-                  <a:srgbClr val="6E6E6E"/>
+                  <a:srgbClr val="5A6B5A"/>
                 </a:solidFill>
                 <a:latin typeface="Arial" pitchFamily="34" charset="0"/>
                 <a:ea typeface="Arial" pitchFamily="34" charset="-122"/>
@@ -9851,7 +9878,7 @@
             <a:r>
               <a:rPr lang="en-US" sz="1350" b="1" dirty="0">
                 <a:solidFill>
-                  <a:srgbClr val="0A0A0A"/>
+                  <a:srgbClr val="2C5F2D"/>
                 </a:solidFill>
                 <a:latin typeface="Arial Black" pitchFamily="34" charset="0"/>
                 <a:ea typeface="Arial Black" pitchFamily="34" charset="-122"/>
@@ -9890,7 +9917,7 @@
             <a:r>
               <a:rPr lang="en-US" sz="850" dirty="0">
                 <a:solidFill>
-                  <a:srgbClr val="6E6E6E"/>
+                  <a:srgbClr val="5A6B5A"/>
                 </a:solidFill>
                 <a:latin typeface="Arial" pitchFamily="34" charset="0"/>
                 <a:ea typeface="Arial" pitchFamily="34" charset="-122"/>
@@ -9907,6 +9934,9 @@
   <p:clrMapOvr>
     <a:masterClrMapping/>
   </p:clrMapOvr>
+  <p:transition spd="med">
+    <p:fade/>
+  </p:transition>
 </p:sld>
 </file>
 
@@ -9916,7 +9946,7 @@
     <p:bg>
       <p:bgPr>
         <a:solidFill>
-          <a:srgbClr val="FFFFFF"/>
+          <a:srgbClr val="F0F5EA"/>
         </a:solidFill>
       </p:bgPr>
     </p:bg>
@@ -9961,7 +9991,7 @@
             <a:r>
               <a:rPr lang="en-US" sz="2800" b="1" dirty="0">
                 <a:solidFill>
-                  <a:srgbClr val="E0E0E0"/>
+                  <a:srgbClr val="D8E8C8"/>
                 </a:solidFill>
                 <a:latin typeface="Arial Black" pitchFamily="34" charset="0"/>
                 <a:ea typeface="Arial Black" pitchFamily="34" charset="-122"/>
@@ -10007,7 +10037,7 @@
             <a:r>
               <a:rPr lang="en-US" sz="2800" b="1" dirty="0">
                 <a:solidFill>
-                  <a:srgbClr val="0A0A0A"/>
+                  <a:srgbClr val="2C5F2D"/>
                 </a:solidFill>
                 <a:latin typeface="Arial Black" pitchFamily="34" charset="0"/>
                 <a:ea typeface="Arial Black" pitchFamily="34" charset="-122"/>
@@ -10034,11 +10064,11 @@
             <a:avLst/>
           </a:prstGeom>
           <a:solidFill>
-            <a:srgbClr val="0A0A0A"/>
+            <a:srgbClr val="2C5F2D"/>
           </a:solidFill>
           <a:ln w="12700">
             <a:solidFill>
-              <a:srgbClr val="0A0A0A"/>
+              <a:srgbClr val="2C5F2D"/>
             </a:solidFill>
             <a:prstDash val="solid"/>
           </a:ln>
@@ -10059,11 +10089,11 @@
             <a:avLst/>
           </a:prstGeom>
           <a:solidFill>
-            <a:srgbClr val="E0E0E0"/>
+            <a:srgbClr val="D8E8C8"/>
           </a:solidFill>
           <a:ln w="12700">
             <a:solidFill>
-              <a:srgbClr val="E0E0E0"/>
+              <a:srgbClr val="D8E8C8"/>
             </a:solidFill>
             <a:prstDash val="solid"/>
           </a:ln>
@@ -10084,11 +10114,11 @@
             <a:avLst/>
           </a:prstGeom>
           <a:solidFill>
-            <a:srgbClr val="555555"/>
+            <a:srgbClr val="3E5C42"/>
           </a:solidFill>
           <a:ln w="12700">
             <a:solidFill>
-              <a:srgbClr val="555555"/>
+              <a:srgbClr val="3E5C42"/>
             </a:solidFill>
             <a:prstDash val="solid"/>
           </a:ln>
@@ -10111,7 +10141,7 @@
             </a:avLst>
           </a:prstGeom>
           <a:solidFill>
-            <a:srgbClr val="0A0A0A"/>
+            <a:srgbClr val="1F3D26"/>
           </a:solidFill>
           <a:ln w="12700">
             <a:solidFill>
@@ -10148,7 +10178,7 @@
             <a:r>
               <a:rPr lang="en-US" sz="1800" b="1" dirty="0">
                 <a:solidFill>
-                  <a:srgbClr val="FFFFFF"/>
+                  <a:srgbClr val="F0F5EA"/>
                 </a:solidFill>
                 <a:latin typeface="Arial Black" pitchFamily="34" charset="0"/>
                 <a:ea typeface="Arial Black" pitchFamily="34" charset="-122"/>
@@ -10187,7 +10217,7 @@
             <a:r>
               <a:rPr lang="en-US" sz="900" dirty="0">
                 <a:solidFill>
-                  <a:srgbClr val="B0B0B0"/>
+                  <a:srgbClr val="8FAE8B"/>
                 </a:solidFill>
                 <a:latin typeface="Arial" pitchFamily="34" charset="0"/>
                 <a:ea typeface="Arial" pitchFamily="34" charset="-122"/>
@@ -10214,11 +10244,11 @@
             <a:avLst/>
           </a:prstGeom>
           <a:solidFill>
-            <a:srgbClr val="E0E0E0"/>
+            <a:srgbClr val="D8E8C8"/>
           </a:solidFill>
           <a:ln w="12700">
             <a:solidFill>
-              <a:srgbClr val="E0E0E0"/>
+              <a:srgbClr val="D8E8C8"/>
             </a:solidFill>
             <a:prstDash val="solid"/>
           </a:ln>
@@ -10239,11 +10269,11 @@
             <a:avLst/>
           </a:prstGeom>
           <a:solidFill>
-            <a:srgbClr val="555555"/>
+            <a:srgbClr val="3E5C42"/>
           </a:solidFill>
           <a:ln w="12700">
             <a:solidFill>
-              <a:srgbClr val="555555"/>
+              <a:srgbClr val="3E5C42"/>
             </a:solidFill>
             <a:prstDash val="solid"/>
           </a:ln>
@@ -10266,7 +10296,7 @@
             </a:avLst>
           </a:prstGeom>
           <a:solidFill>
-            <a:srgbClr val="0A0A0A"/>
+            <a:srgbClr val="1F3D26"/>
           </a:solidFill>
           <a:ln w="12700">
             <a:solidFill>
@@ -10303,7 +10333,7 @@
             <a:r>
               <a:rPr lang="en-US" sz="1800" b="1" dirty="0">
                 <a:solidFill>
-                  <a:srgbClr val="FFFFFF"/>
+                  <a:srgbClr val="F0F5EA"/>
                 </a:solidFill>
                 <a:latin typeface="Arial Black" pitchFamily="34" charset="0"/>
                 <a:ea typeface="Arial Black" pitchFamily="34" charset="-122"/>
@@ -10342,7 +10372,7 @@
             <a:r>
               <a:rPr lang="en-US" sz="900" dirty="0">
                 <a:solidFill>
-                  <a:srgbClr val="B0B0B0"/>
+                  <a:srgbClr val="8FAE8B"/>
                 </a:solidFill>
                 <a:latin typeface="Arial" pitchFamily="34" charset="0"/>
                 <a:ea typeface="Arial" pitchFamily="34" charset="-122"/>
@@ -10369,11 +10399,11 @@
             <a:avLst/>
           </a:prstGeom>
           <a:solidFill>
-            <a:srgbClr val="E0E0E0"/>
+            <a:srgbClr val="D8E8C8"/>
           </a:solidFill>
           <a:ln w="12700">
             <a:solidFill>
-              <a:srgbClr val="E0E0E0"/>
+              <a:srgbClr val="D8E8C8"/>
             </a:solidFill>
             <a:prstDash val="solid"/>
           </a:ln>
@@ -10394,11 +10424,11 @@
             <a:avLst/>
           </a:prstGeom>
           <a:solidFill>
-            <a:srgbClr val="555555"/>
+            <a:srgbClr val="3E5C42"/>
           </a:solidFill>
           <a:ln w="12700">
             <a:solidFill>
-              <a:srgbClr val="555555"/>
+              <a:srgbClr val="3E5C42"/>
             </a:solidFill>
             <a:prstDash val="solid"/>
           </a:ln>
@@ -10421,7 +10451,7 @@
             </a:avLst>
           </a:prstGeom>
           <a:solidFill>
-            <a:srgbClr val="0A0A0A"/>
+            <a:srgbClr val="1F3D26"/>
           </a:solidFill>
           <a:ln w="12700">
             <a:solidFill>
@@ -10458,7 +10488,7 @@
             <a:r>
               <a:rPr lang="en-US" sz="1800" b="1" dirty="0">
                 <a:solidFill>
-                  <a:srgbClr val="FFFFFF"/>
+                  <a:srgbClr val="F0F5EA"/>
                 </a:solidFill>
                 <a:latin typeface="Arial Black" pitchFamily="34" charset="0"/>
                 <a:ea typeface="Arial Black" pitchFamily="34" charset="-122"/>
@@ -10497,7 +10527,7 @@
             <a:r>
               <a:rPr lang="en-US" sz="900" dirty="0">
                 <a:solidFill>
-                  <a:srgbClr val="B0B0B0"/>
+                  <a:srgbClr val="8FAE8B"/>
                 </a:solidFill>
                 <a:latin typeface="Arial" pitchFamily="34" charset="0"/>
                 <a:ea typeface="Arial" pitchFamily="34" charset="-122"/>
@@ -10524,11 +10554,11 @@
             <a:avLst/>
           </a:prstGeom>
           <a:solidFill>
-            <a:srgbClr val="E0E0E0"/>
+            <a:srgbClr val="D8E8C8"/>
           </a:solidFill>
           <a:ln w="12700">
             <a:solidFill>
-              <a:srgbClr val="E0E0E0"/>
+              <a:srgbClr val="D8E8C8"/>
             </a:solidFill>
             <a:prstDash val="solid"/>
           </a:ln>
@@ -10549,11 +10579,11 @@
             <a:avLst/>
           </a:prstGeom>
           <a:solidFill>
-            <a:srgbClr val="555555"/>
+            <a:srgbClr val="3E5C42"/>
           </a:solidFill>
           <a:ln w="12700">
             <a:solidFill>
-              <a:srgbClr val="555555"/>
+              <a:srgbClr val="3E5C42"/>
             </a:solidFill>
             <a:prstDash val="solid"/>
           </a:ln>
@@ -10576,7 +10606,7 @@
             </a:avLst>
           </a:prstGeom>
           <a:solidFill>
-            <a:srgbClr val="0A0A0A"/>
+            <a:srgbClr val="1F3D26"/>
           </a:solidFill>
           <a:ln w="12700">
             <a:solidFill>
@@ -10613,7 +10643,7 @@
             <a:r>
               <a:rPr lang="en-US" sz="1800" b="1" dirty="0">
                 <a:solidFill>
-                  <a:srgbClr val="FFFFFF"/>
+                  <a:srgbClr val="F0F5EA"/>
                 </a:solidFill>
                 <a:latin typeface="Arial Black" pitchFamily="34" charset="0"/>
                 <a:ea typeface="Arial Black" pitchFamily="34" charset="-122"/>
@@ -10652,7 +10682,7 @@
             <a:r>
               <a:rPr lang="en-US" sz="900" dirty="0">
                 <a:solidFill>
-                  <a:srgbClr val="B0B0B0"/>
+                  <a:srgbClr val="8FAE8B"/>
                 </a:solidFill>
                 <a:latin typeface="Arial" pitchFamily="34" charset="0"/>
                 <a:ea typeface="Arial" pitchFamily="34" charset="-122"/>
@@ -10679,11 +10709,11 @@
             <a:avLst/>
           </a:prstGeom>
           <a:solidFill>
-            <a:srgbClr val="E0E0E0"/>
+            <a:srgbClr val="D8E8C8"/>
           </a:solidFill>
           <a:ln w="12700">
             <a:solidFill>
-              <a:srgbClr val="E0E0E0"/>
+              <a:srgbClr val="D8E8C8"/>
             </a:solidFill>
             <a:prstDash val="solid"/>
           </a:ln>
@@ -10704,11 +10734,11 @@
             <a:avLst/>
           </a:prstGeom>
           <a:solidFill>
-            <a:srgbClr val="555555"/>
+            <a:srgbClr val="3E5C42"/>
           </a:solidFill>
           <a:ln w="12700">
             <a:solidFill>
-              <a:srgbClr val="555555"/>
+              <a:srgbClr val="3E5C42"/>
             </a:solidFill>
             <a:prstDash val="solid"/>
           </a:ln>
@@ -10731,7 +10761,7 @@
             </a:avLst>
           </a:prstGeom>
           <a:solidFill>
-            <a:srgbClr val="0A0A0A"/>
+            <a:srgbClr val="1F3D26"/>
           </a:solidFill>
           <a:ln w="12700">
             <a:solidFill>
@@ -10768,7 +10798,7 @@
             <a:r>
               <a:rPr lang="en-US" sz="1800" b="1" dirty="0">
                 <a:solidFill>
-                  <a:srgbClr val="FFFFFF"/>
+                  <a:srgbClr val="F0F5EA"/>
                 </a:solidFill>
                 <a:latin typeface="Arial Black" pitchFamily="34" charset="0"/>
                 <a:ea typeface="Arial Black" pitchFamily="34" charset="-122"/>
@@ -10807,7 +10837,7 @@
             <a:r>
               <a:rPr lang="en-US" sz="900" dirty="0">
                 <a:solidFill>
-                  <a:srgbClr val="B0B0B0"/>
+                  <a:srgbClr val="8FAE8B"/>
                 </a:solidFill>
                 <a:latin typeface="Arial" pitchFamily="34" charset="0"/>
                 <a:ea typeface="Arial" pitchFamily="34" charset="-122"/>
@@ -10834,11 +10864,11 @@
             <a:avLst/>
           </a:prstGeom>
           <a:solidFill>
-            <a:srgbClr val="E0E0E0"/>
+            <a:srgbClr val="D8E8C8"/>
           </a:solidFill>
           <a:ln w="12700">
             <a:solidFill>
-              <a:srgbClr val="E0E0E0"/>
+              <a:srgbClr val="D8E8C8"/>
             </a:solidFill>
             <a:prstDash val="solid"/>
           </a:ln>
@@ -10859,11 +10889,11 @@
             <a:avLst/>
           </a:prstGeom>
           <a:solidFill>
-            <a:srgbClr val="555555"/>
+            <a:srgbClr val="3E5C42"/>
           </a:solidFill>
           <a:ln w="12700">
             <a:solidFill>
-              <a:srgbClr val="555555"/>
+              <a:srgbClr val="3E5C42"/>
             </a:solidFill>
             <a:prstDash val="solid"/>
           </a:ln>
@@ -10886,7 +10916,7 @@
             </a:avLst>
           </a:prstGeom>
           <a:solidFill>
-            <a:srgbClr val="0A0A0A"/>
+            <a:srgbClr val="1F3D26"/>
           </a:solidFill>
           <a:ln w="12700">
             <a:solidFill>
@@ -10923,7 +10953,7 @@
             <a:r>
               <a:rPr lang="en-US" sz="1800" b="1" dirty="0">
                 <a:solidFill>
-                  <a:srgbClr val="FFFFFF"/>
+                  <a:srgbClr val="F0F5EA"/>
                 </a:solidFill>
                 <a:latin typeface="Arial Black" pitchFamily="34" charset="0"/>
                 <a:ea typeface="Arial Black" pitchFamily="34" charset="-122"/>
@@ -10962,7 +10992,7 @@
             <a:r>
               <a:rPr lang="en-US" sz="900" dirty="0">
                 <a:solidFill>
-                  <a:srgbClr val="B0B0B0"/>
+                  <a:srgbClr val="8FAE8B"/>
                 </a:solidFill>
                 <a:latin typeface="Arial" pitchFamily="34" charset="0"/>
                 <a:ea typeface="Arial" pitchFamily="34" charset="-122"/>
@@ -11001,7 +11031,7 @@
             <a:r>
               <a:rPr lang="en-US" sz="1150" dirty="0">
                 <a:solidFill>
-                  <a:srgbClr val="0A0A0A"/>
+                  <a:srgbClr val="2C5F2D"/>
                 </a:solidFill>
                 <a:latin typeface="Arial" pitchFamily="34" charset="0"/>
                 <a:ea typeface="Arial" pitchFamily="34" charset="-122"/>
@@ -11028,11 +11058,11 @@
             <a:avLst/>
           </a:prstGeom>
           <a:solidFill>
-            <a:srgbClr val="E0E0E0"/>
+            <a:srgbClr val="D8E8C8"/>
           </a:solidFill>
           <a:ln w="12700">
             <a:solidFill>
-              <a:srgbClr val="E0E0E0"/>
+              <a:srgbClr val="D8E8C8"/>
             </a:solidFill>
             <a:prstDash val="solid"/>
           </a:ln>
@@ -11055,7 +11085,7 @@
             </a:avLst>
           </a:prstGeom>
           <a:solidFill>
-            <a:srgbClr val="0A0A0A"/>
+            <a:srgbClr val="1F3D26"/>
           </a:solidFill>
           <a:ln w="12700">
             <a:solidFill>
@@ -11080,11 +11110,11 @@
             <a:avLst/>
           </a:prstGeom>
           <a:solidFill>
-            <a:srgbClr val="FF5A1F"/>
+            <a:srgbClr val="97BC62"/>
           </a:solidFill>
           <a:ln w="12700">
             <a:solidFill>
-              <a:srgbClr val="FF5A1F"/>
+              <a:srgbClr val="97BC62"/>
             </a:solidFill>
             <a:prstDash val="solid"/>
           </a:ln>
@@ -11117,7 +11147,7 @@
             <a:r>
               <a:rPr lang="en-US" sz="1050" dirty="0">
                 <a:solidFill>
-                  <a:srgbClr val="FFFFFF"/>
+                  <a:srgbClr val="F0F5EA"/>
                 </a:solidFill>
                 <a:latin typeface="Arial" pitchFamily="34" charset="0"/>
                 <a:ea typeface="Arial" pitchFamily="34" charset="-122"/>
@@ -11156,7 +11186,7 @@
             <a:r>
               <a:rPr lang="en-US" sz="850" dirty="0">
                 <a:solidFill>
-                  <a:srgbClr val="6E6E6E"/>
+                  <a:srgbClr val="5A6B5A"/>
                 </a:solidFill>
                 <a:latin typeface="Arial" pitchFamily="34" charset="0"/>
                 <a:ea typeface="Arial" pitchFamily="34" charset="-122"/>
@@ -11173,6 +11203,9 @@
   <p:clrMapOvr>
     <a:masterClrMapping/>
   </p:clrMapOvr>
+  <p:transition spd="med">
+    <p:fade/>
+  </p:transition>
 </p:sld>
 </file>
 
@@ -11182,7 +11215,7 @@
     <p:bg>
       <p:bgPr>
         <a:solidFill>
-          <a:srgbClr val="FFFFFF"/>
+          <a:srgbClr val="F0F5EA"/>
         </a:solidFill>
       </p:bgPr>
     </p:bg>
@@ -11227,7 +11260,7 @@
             <a:r>
               <a:rPr lang="en-US" sz="2800" b="1" dirty="0">
                 <a:solidFill>
-                  <a:srgbClr val="E0E0E0"/>
+                  <a:srgbClr val="D8E8C8"/>
                 </a:solidFill>
                 <a:latin typeface="Arial Black" pitchFamily="34" charset="0"/>
                 <a:ea typeface="Arial Black" pitchFamily="34" charset="-122"/>
@@ -11273,7 +11306,7 @@
             <a:r>
               <a:rPr lang="en-US" sz="2800" b="1" dirty="0">
                 <a:solidFill>
-                  <a:srgbClr val="0A0A0A"/>
+                  <a:srgbClr val="2C5F2D"/>
                 </a:solidFill>
                 <a:latin typeface="Arial Black" pitchFamily="34" charset="0"/>
                 <a:ea typeface="Arial Black" pitchFamily="34" charset="-122"/>
@@ -11300,11 +11333,11 @@
             <a:avLst/>
           </a:prstGeom>
           <a:solidFill>
-            <a:srgbClr val="0A0A0A"/>
+            <a:srgbClr val="2C5F2D"/>
           </a:solidFill>
           <a:ln w="12700">
             <a:solidFill>
-              <a:srgbClr val="0A0A0A"/>
+              <a:srgbClr val="2C5F2D"/>
             </a:solidFill>
             <a:prstDash val="solid"/>
           </a:ln>
@@ -11325,11 +11358,11 @@
             <a:avLst/>
           </a:prstGeom>
           <a:solidFill>
-            <a:srgbClr val="E0E0E0"/>
+            <a:srgbClr val="D8E8C8"/>
           </a:solidFill>
           <a:ln w="12700">
             <a:solidFill>
-              <a:srgbClr val="E0E0E0"/>
+              <a:srgbClr val="D8E8C8"/>
             </a:solidFill>
             <a:prstDash val="solid"/>
           </a:ln>
@@ -11352,7 +11385,7 @@
             </a:avLst>
           </a:prstGeom>
           <a:solidFill>
-            <a:srgbClr val="F2F2F2"/>
+            <a:srgbClr val="EAF2E4"/>
           </a:solidFill>
           <a:ln w="12700">
             <a:solidFill>
@@ -11389,7 +11422,7 @@
             <a:r>
               <a:rPr lang="en-US" sz="1200" b="1" dirty="0">
                 <a:solidFill>
-                  <a:srgbClr val="6E6E6E"/>
+                  <a:srgbClr val="5A6B5A"/>
                 </a:solidFill>
                 <a:latin typeface="Arial" pitchFamily="34" charset="0"/>
                 <a:ea typeface="Arial" pitchFamily="34" charset="-122"/>
@@ -11428,7 +11461,7 @@
             <a:r>
               <a:rPr lang="en-US" sz="1700" i="1" dirty="0">
                 <a:solidFill>
-                  <a:srgbClr val="FF5A1F"/>
+                  <a:srgbClr val="97BC62"/>
                 </a:solidFill>
                 <a:latin typeface="Arial Black" pitchFamily="34" charset="0"/>
                 <a:ea typeface="Arial Black" pitchFamily="34" charset="-122"/>
@@ -11467,7 +11500,7 @@
             <a:r>
               <a:rPr lang="en-US" sz="1100" dirty="0">
                 <a:solidFill>
-                  <a:srgbClr val="6E6E6E"/>
+                  <a:srgbClr val="5A6B5A"/>
                 </a:solidFill>
                 <a:latin typeface="Arial" pitchFamily="34" charset="0"/>
                 <a:ea typeface="Arial" pitchFamily="34" charset="-122"/>
@@ -11494,11 +11527,11 @@
             <a:avLst/>
           </a:prstGeom>
           <a:solidFill>
-            <a:srgbClr val="E0E0E0"/>
+            <a:srgbClr val="D8E8C8"/>
           </a:solidFill>
           <a:ln w="12700">
             <a:solidFill>
-              <a:srgbClr val="E0E0E0"/>
+              <a:srgbClr val="D8E8C8"/>
             </a:solidFill>
             <a:prstDash val="solid"/>
           </a:ln>
@@ -11521,7 +11554,7 @@
             </a:avLst>
           </a:prstGeom>
           <a:solidFill>
-            <a:srgbClr val="0A0A0A"/>
+            <a:srgbClr val="1F3D26"/>
           </a:solidFill>
           <a:ln w="12700">
             <a:solidFill>
@@ -11558,7 +11591,7 @@
             <a:r>
               <a:rPr lang="en-US" sz="1200" b="1" dirty="0">
                 <a:solidFill>
-                  <a:srgbClr val="FFFFFF"/>
+                  <a:srgbClr val="F0F5EA"/>
                 </a:solidFill>
                 <a:latin typeface="Arial Black" pitchFamily="34" charset="0"/>
                 <a:ea typeface="Arial Black" pitchFamily="34" charset="-122"/>
@@ -11597,7 +11630,7 @@
             <a:r>
               <a:rPr lang="en-US" sz="1350" dirty="0">
                 <a:solidFill>
-                  <a:srgbClr val="FFFFFF"/>
+                  <a:srgbClr val="F0F5EA"/>
                 </a:solidFill>
                 <a:latin typeface="Arial" pitchFamily="34" charset="0"/>
                 <a:ea typeface="Arial" pitchFamily="34" charset="-122"/>
@@ -11648,7 +11681,7 @@
                       <a:r>
                         <a:rPr lang="en-US" sz="1200" b="1" dirty="0">
                           <a:solidFill>
-                            <a:srgbClr val="FFFFFF"/>
+                            <a:srgbClr val="F0F5EA"/>
                           </a:solidFill>
                           <a:latin typeface="Arial Black" pitchFamily="34" charset="0"/>
                           <a:ea typeface="Arial Black" pitchFamily="34" charset="-122"/>
@@ -11666,7 +11699,7 @@
                   <a:tcPr marL="54864" marR="54864" marT="54864" marB="54864" anchor="mid">
                     <a:lnL w="6350" cap="flat" cmpd="sng" algn="ctr">
                       <a:solidFill>
-                        <a:srgbClr val="D9D9D9"/>
+                        <a:srgbClr val="C8D9C0"/>
                       </a:solidFill>
                       <a:prstDash val="solid"/>
                       <a:round/>
@@ -11675,7 +11708,7 @@
                     </a:lnL>
                     <a:lnR w="6350" cap="flat" cmpd="sng" algn="ctr">
                       <a:solidFill>
-                        <a:srgbClr val="D9D9D9"/>
+                        <a:srgbClr val="C8D9C0"/>
                       </a:solidFill>
                       <a:prstDash val="solid"/>
                       <a:round/>
@@ -11684,7 +11717,7 @@
                     </a:lnR>
                     <a:lnT w="6350" cap="flat" cmpd="sng" algn="ctr">
                       <a:solidFill>
-                        <a:srgbClr val="D9D9D9"/>
+                        <a:srgbClr val="C8D9C0"/>
                       </a:solidFill>
                       <a:prstDash val="solid"/>
                       <a:round/>
@@ -11693,7 +11726,7 @@
                     </a:lnT>
                     <a:lnB w="6350" cap="flat" cmpd="sng" algn="ctr">
                       <a:solidFill>
-                        <a:srgbClr val="D9D9D9"/>
+                        <a:srgbClr val="C8D9C0"/>
                       </a:solidFill>
                       <a:prstDash val="solid"/>
                       <a:round/>
@@ -11701,7 +11734,7 @@
                       <a:tailEnd type="none" w="med" len="med"/>
                     </a:lnB>
                     <a:solidFill>
-                      <a:srgbClr val="0A0A0A"/>
+                      <a:srgbClr val="1F3D26"/>
                     </a:solidFill>
                   </a:tcPr>
                 </a:tc>
@@ -11724,7 +11757,7 @@
                       <a:r>
                         <a:rPr lang="en-US" sz="1050" b="1" dirty="0">
                           <a:solidFill>
-                            <a:srgbClr val="0A0A0A"/>
+                            <a:srgbClr val="2C5F2D"/>
                           </a:solidFill>
                           <a:latin typeface="Arial" pitchFamily="34" charset="0"/>
                           <a:ea typeface="Arial" pitchFamily="34" charset="-122"/>
@@ -11742,7 +11775,7 @@
                   <a:tcPr marL="54864" marR="54864" marT="54864" marB="54864" anchor="mid">
                     <a:lnL w="6350" cap="flat" cmpd="sng" algn="ctr">
                       <a:solidFill>
-                        <a:srgbClr val="D9D9D9"/>
+                        <a:srgbClr val="C8D9C0"/>
                       </a:solidFill>
                       <a:prstDash val="solid"/>
                       <a:round/>
@@ -11751,7 +11784,7 @@
                     </a:lnL>
                     <a:lnR w="6350" cap="flat" cmpd="sng" algn="ctr">
                       <a:solidFill>
-                        <a:srgbClr val="D9D9D9"/>
+                        <a:srgbClr val="C8D9C0"/>
                       </a:solidFill>
                       <a:prstDash val="solid"/>
                       <a:round/>
@@ -11760,7 +11793,7 @@
                     </a:lnR>
                     <a:lnT w="6350" cap="flat" cmpd="sng" algn="ctr">
                       <a:solidFill>
-                        <a:srgbClr val="D9D9D9"/>
+                        <a:srgbClr val="C8D9C0"/>
                       </a:solidFill>
                       <a:prstDash val="solid"/>
                       <a:round/>
@@ -11769,7 +11802,7 @@
                     </a:lnT>
                     <a:lnB w="6350" cap="flat" cmpd="sng" algn="ctr">
                       <a:solidFill>
-                        <a:srgbClr val="D9D9D9"/>
+                        <a:srgbClr val="C8D9C0"/>
                       </a:solidFill>
                       <a:prstDash val="solid"/>
                       <a:round/>
@@ -11777,7 +11810,7 @@
                       <a:tailEnd type="none" w="med" len="med"/>
                     </a:lnB>
                     <a:solidFill>
-                      <a:srgbClr val="F7F7F7"/>
+                      <a:srgbClr val="F4F9EF"/>
                     </a:solidFill>
                   </a:tcPr>
                 </a:tc>
@@ -11792,7 +11825,7 @@
                       <a:r>
                         <a:rPr lang="en-US" sz="1050" dirty="0">
                           <a:solidFill>
-                            <a:srgbClr val="6E6E6E"/>
+                            <a:srgbClr val="5A6B5A"/>
                           </a:solidFill>
                           <a:latin typeface="Arial" pitchFamily="34" charset="0"/>
                           <a:ea typeface="Arial" pitchFamily="34" charset="-122"/>
@@ -11810,7 +11843,7 @@
                   <a:tcPr marL="54864" marR="54864" marT="54864" marB="54864" anchor="mid">
                     <a:lnL w="6350" cap="flat" cmpd="sng" algn="ctr">
                       <a:solidFill>
-                        <a:srgbClr val="D9D9D9"/>
+                        <a:srgbClr val="C8D9C0"/>
                       </a:solidFill>
                       <a:prstDash val="solid"/>
                       <a:round/>
@@ -11819,7 +11852,7 @@
                     </a:lnL>
                     <a:lnR w="6350" cap="flat" cmpd="sng" algn="ctr">
                       <a:solidFill>
-                        <a:srgbClr val="D9D9D9"/>
+                        <a:srgbClr val="C8D9C0"/>
                       </a:solidFill>
                       <a:prstDash val="solid"/>
                       <a:round/>
@@ -11828,7 +11861,7 @@
                     </a:lnR>
                     <a:lnT w="6350" cap="flat" cmpd="sng" algn="ctr">
                       <a:solidFill>
-                        <a:srgbClr val="D9D9D9"/>
+                        <a:srgbClr val="C8D9C0"/>
                       </a:solidFill>
                       <a:prstDash val="solid"/>
                       <a:round/>
@@ -11837,7 +11870,7 @@
                     </a:lnT>
                     <a:lnB w="6350" cap="flat" cmpd="sng" algn="ctr">
                       <a:solidFill>
-                        <a:srgbClr val="D9D9D9"/>
+                        <a:srgbClr val="C8D9C0"/>
                       </a:solidFill>
                       <a:prstDash val="solid"/>
                       <a:round/>
@@ -11845,7 +11878,7 @@
                       <a:tailEnd type="none" w="med" len="med"/>
                     </a:lnB>
                     <a:solidFill>
-                      <a:srgbClr val="F7F7F7"/>
+                      <a:srgbClr val="F4F9EF"/>
                     </a:solidFill>
                   </a:tcPr>
                 </a:tc>
@@ -11860,7 +11893,7 @@
                       <a:r>
                         <a:rPr lang="en-US" sz="1050" dirty="0">
                           <a:solidFill>
-                            <a:srgbClr val="B0B0B0"/>
+                            <a:srgbClr val="8FAE8B"/>
                           </a:solidFill>
                           <a:latin typeface="Arial" pitchFamily="34" charset="0"/>
                           <a:ea typeface="Arial" pitchFamily="34" charset="-122"/>
@@ -11878,7 +11911,7 @@
                   <a:tcPr marL="54864" marR="54864" marT="54864" marB="54864" anchor="mid">
                     <a:lnL w="6350" cap="flat" cmpd="sng" algn="ctr">
                       <a:solidFill>
-                        <a:srgbClr val="D9D9D9"/>
+                        <a:srgbClr val="C8D9C0"/>
                       </a:solidFill>
                       <a:prstDash val="solid"/>
                       <a:round/>
@@ -11887,7 +11920,7 @@
                     </a:lnL>
                     <a:lnR w="6350" cap="flat" cmpd="sng" algn="ctr">
                       <a:solidFill>
-                        <a:srgbClr val="D9D9D9"/>
+                        <a:srgbClr val="C8D9C0"/>
                       </a:solidFill>
                       <a:prstDash val="solid"/>
                       <a:round/>
@@ -11896,7 +11929,7 @@
                     </a:lnR>
                     <a:lnT w="6350" cap="flat" cmpd="sng" algn="ctr">
                       <a:solidFill>
-                        <a:srgbClr val="D9D9D9"/>
+                        <a:srgbClr val="C8D9C0"/>
                       </a:solidFill>
                       <a:prstDash val="solid"/>
                       <a:round/>
@@ -11905,7 +11938,7 @@
                     </a:lnT>
                     <a:lnB w="6350" cap="flat" cmpd="sng" algn="ctr">
                       <a:solidFill>
-                        <a:srgbClr val="D9D9D9"/>
+                        <a:srgbClr val="C8D9C0"/>
                       </a:solidFill>
                       <a:prstDash val="solid"/>
                       <a:round/>
@@ -11913,7 +11946,7 @@
                       <a:tailEnd type="none" w="med" len="med"/>
                     </a:lnB>
                     <a:solidFill>
-                      <a:srgbClr val="F7F7F7"/>
+                      <a:srgbClr val="F4F9EF"/>
                     </a:solidFill>
                   </a:tcPr>
                 </a:tc>
@@ -11930,7 +11963,7 @@
                       <a:r>
                         <a:rPr lang="en-US" sz="1050" b="1" dirty="0">
                           <a:solidFill>
-                            <a:srgbClr val="0A0A0A"/>
+                            <a:srgbClr val="2C5F2D"/>
                           </a:solidFill>
                           <a:latin typeface="Arial" pitchFamily="34" charset="0"/>
                           <a:ea typeface="Arial" pitchFamily="34" charset="-122"/>
@@ -11948,7 +11981,7 @@
                   <a:tcPr marL="54864" marR="54864" marT="54864" marB="54864" anchor="mid">
                     <a:lnL w="6350" cap="flat" cmpd="sng" algn="ctr">
                       <a:solidFill>
-                        <a:srgbClr val="D9D9D9"/>
+                        <a:srgbClr val="C8D9C0"/>
                       </a:solidFill>
                       <a:prstDash val="solid"/>
                       <a:round/>
@@ -11957,7 +11990,7 @@
                     </a:lnL>
                     <a:lnR w="6350" cap="flat" cmpd="sng" algn="ctr">
                       <a:solidFill>
-                        <a:srgbClr val="D9D9D9"/>
+                        <a:srgbClr val="C8D9C0"/>
                       </a:solidFill>
                       <a:prstDash val="solid"/>
                       <a:round/>
@@ -11966,7 +11999,7 @@
                     </a:lnR>
                     <a:lnT w="6350" cap="flat" cmpd="sng" algn="ctr">
                       <a:solidFill>
-                        <a:srgbClr val="D9D9D9"/>
+                        <a:srgbClr val="C8D9C0"/>
                       </a:solidFill>
                       <a:prstDash val="solid"/>
                       <a:round/>
@@ -11975,7 +12008,7 @@
                     </a:lnT>
                     <a:lnB w="6350" cap="flat" cmpd="sng" algn="ctr">
                       <a:solidFill>
-                        <a:srgbClr val="D9D9D9"/>
+                        <a:srgbClr val="C8D9C0"/>
                       </a:solidFill>
                       <a:prstDash val="solid"/>
                       <a:round/>
@@ -11983,7 +12016,7 @@
                       <a:tailEnd type="none" w="med" len="med"/>
                     </a:lnB>
                     <a:solidFill>
-                      <a:srgbClr val="FFFFFF"/>
+                      <a:srgbClr val="F0F5EA"/>
                     </a:solidFill>
                   </a:tcPr>
                 </a:tc>
@@ -11998,7 +12031,7 @@
                       <a:r>
                         <a:rPr lang="en-US" sz="1050" dirty="0">
                           <a:solidFill>
-                            <a:srgbClr val="6E6E6E"/>
+                            <a:srgbClr val="5A6B5A"/>
                           </a:solidFill>
                           <a:latin typeface="Arial" pitchFamily="34" charset="0"/>
                           <a:ea typeface="Arial" pitchFamily="34" charset="-122"/>
@@ -12016,7 +12049,7 @@
                   <a:tcPr marL="54864" marR="54864" marT="54864" marB="54864" anchor="mid">
                     <a:lnL w="6350" cap="flat" cmpd="sng" algn="ctr">
                       <a:solidFill>
-                        <a:srgbClr val="D9D9D9"/>
+                        <a:srgbClr val="C8D9C0"/>
                       </a:solidFill>
                       <a:prstDash val="solid"/>
                       <a:round/>
@@ -12025,7 +12058,7 @@
                     </a:lnL>
                     <a:lnR w="6350" cap="flat" cmpd="sng" algn="ctr">
                       <a:solidFill>
-                        <a:srgbClr val="D9D9D9"/>
+                        <a:srgbClr val="C8D9C0"/>
                       </a:solidFill>
                       <a:prstDash val="solid"/>
                       <a:round/>
@@ -12034,7 +12067,7 @@
                     </a:lnR>
                     <a:lnT w="6350" cap="flat" cmpd="sng" algn="ctr">
                       <a:solidFill>
-                        <a:srgbClr val="D9D9D9"/>
+                        <a:srgbClr val="C8D9C0"/>
                       </a:solidFill>
                       <a:prstDash val="solid"/>
                       <a:round/>
@@ -12043,7 +12076,7 @@
                     </a:lnT>
                     <a:lnB w="6350" cap="flat" cmpd="sng" algn="ctr">
                       <a:solidFill>
-                        <a:srgbClr val="D9D9D9"/>
+                        <a:srgbClr val="C8D9C0"/>
                       </a:solidFill>
                       <a:prstDash val="solid"/>
                       <a:round/>
@@ -12051,7 +12084,7 @@
                       <a:tailEnd type="none" w="med" len="med"/>
                     </a:lnB>
                     <a:solidFill>
-                      <a:srgbClr val="FFFFFF"/>
+                      <a:srgbClr val="F0F5EA"/>
                     </a:solidFill>
                   </a:tcPr>
                 </a:tc>
@@ -12066,7 +12099,7 @@
                       <a:r>
                         <a:rPr lang="en-US" sz="1050" dirty="0">
                           <a:solidFill>
-                            <a:srgbClr val="B0B0B0"/>
+                            <a:srgbClr val="8FAE8B"/>
                           </a:solidFill>
                           <a:latin typeface="Arial" pitchFamily="34" charset="0"/>
                           <a:ea typeface="Arial" pitchFamily="34" charset="-122"/>
@@ -12084,7 +12117,7 @@
                   <a:tcPr marL="54864" marR="54864" marT="54864" marB="54864" anchor="mid">
                     <a:lnL w="6350" cap="flat" cmpd="sng" algn="ctr">
                       <a:solidFill>
-                        <a:srgbClr val="D9D9D9"/>
+                        <a:srgbClr val="C8D9C0"/>
                       </a:solidFill>
                       <a:prstDash val="solid"/>
                       <a:round/>
@@ -12093,7 +12126,7 @@
                     </a:lnL>
                     <a:lnR w="6350" cap="flat" cmpd="sng" algn="ctr">
                       <a:solidFill>
-                        <a:srgbClr val="D9D9D9"/>
+                        <a:srgbClr val="C8D9C0"/>
                       </a:solidFill>
                       <a:prstDash val="solid"/>
                       <a:round/>
@@ -12102,7 +12135,7 @@
                     </a:lnR>
                     <a:lnT w="6350" cap="flat" cmpd="sng" algn="ctr">
                       <a:solidFill>
-                        <a:srgbClr val="D9D9D9"/>
+                        <a:srgbClr val="C8D9C0"/>
                       </a:solidFill>
                       <a:prstDash val="solid"/>
                       <a:round/>
@@ -12111,7 +12144,7 @@
                     </a:lnT>
                     <a:lnB w="6350" cap="flat" cmpd="sng" algn="ctr">
                       <a:solidFill>
-                        <a:srgbClr val="D9D9D9"/>
+                        <a:srgbClr val="C8D9C0"/>
                       </a:solidFill>
                       <a:prstDash val="solid"/>
                       <a:round/>
@@ -12119,7 +12152,7 @@
                       <a:tailEnd type="none" w="med" len="med"/>
                     </a:lnB>
                     <a:solidFill>
-                      <a:srgbClr val="FFFFFF"/>
+                      <a:srgbClr val="F0F5EA"/>
                     </a:solidFill>
                   </a:tcPr>
                 </a:tc>
@@ -12136,7 +12169,7 @@
                       <a:r>
                         <a:rPr lang="en-US" sz="1050" b="1" dirty="0">
                           <a:solidFill>
-                            <a:srgbClr val="0A0A0A"/>
+                            <a:srgbClr val="2C5F2D"/>
                           </a:solidFill>
                           <a:latin typeface="Arial" pitchFamily="34" charset="0"/>
                           <a:ea typeface="Arial" pitchFamily="34" charset="-122"/>
@@ -12154,7 +12187,7 @@
                   <a:tcPr marL="54864" marR="54864" marT="54864" marB="54864" anchor="mid">
                     <a:lnL w="6350" cap="flat" cmpd="sng" algn="ctr">
                       <a:solidFill>
-                        <a:srgbClr val="D9D9D9"/>
+                        <a:srgbClr val="C8D9C0"/>
                       </a:solidFill>
                       <a:prstDash val="solid"/>
                       <a:round/>
@@ -12163,7 +12196,7 @@
                     </a:lnL>
                     <a:lnR w="6350" cap="flat" cmpd="sng" algn="ctr">
                       <a:solidFill>
-                        <a:srgbClr val="D9D9D9"/>
+                        <a:srgbClr val="C8D9C0"/>
                       </a:solidFill>
                       <a:prstDash val="solid"/>
                       <a:round/>
@@ -12172,7 +12205,7 @@
                     </a:lnR>
                     <a:lnT w="6350" cap="flat" cmpd="sng" algn="ctr">
                       <a:solidFill>
-                        <a:srgbClr val="D9D9D9"/>
+                        <a:srgbClr val="C8D9C0"/>
                       </a:solidFill>
                       <a:prstDash val="solid"/>
                       <a:round/>
@@ -12181,7 +12214,7 @@
                     </a:lnT>
                     <a:lnB w="6350" cap="flat" cmpd="sng" algn="ctr">
                       <a:solidFill>
-                        <a:srgbClr val="D9D9D9"/>
+                        <a:srgbClr val="C8D9C0"/>
                       </a:solidFill>
                       <a:prstDash val="solid"/>
                       <a:round/>
@@ -12189,7 +12222,7 @@
                       <a:tailEnd type="none" w="med" len="med"/>
                     </a:lnB>
                     <a:solidFill>
-                      <a:srgbClr val="F7F7F7"/>
+                      <a:srgbClr val="F4F9EF"/>
                     </a:solidFill>
                   </a:tcPr>
                 </a:tc>
@@ -12204,7 +12237,7 @@
                       <a:r>
                         <a:rPr lang="en-US" sz="1050" dirty="0">
                           <a:solidFill>
-                            <a:srgbClr val="6E6E6E"/>
+                            <a:srgbClr val="5A6B5A"/>
                           </a:solidFill>
                           <a:latin typeface="Arial" pitchFamily="34" charset="0"/>
                           <a:ea typeface="Arial" pitchFamily="34" charset="-122"/>
@@ -12222,7 +12255,7 @@
                   <a:tcPr marL="54864" marR="54864" marT="54864" marB="54864" anchor="mid">
                     <a:lnL w="6350" cap="flat" cmpd="sng" algn="ctr">
                       <a:solidFill>
-                        <a:srgbClr val="D9D9D9"/>
+                        <a:srgbClr val="C8D9C0"/>
                       </a:solidFill>
                       <a:prstDash val="solid"/>
                       <a:round/>
@@ -12231,7 +12264,7 @@
                     </a:lnL>
                     <a:lnR w="6350" cap="flat" cmpd="sng" algn="ctr">
                       <a:solidFill>
-                        <a:srgbClr val="D9D9D9"/>
+                        <a:srgbClr val="C8D9C0"/>
                       </a:solidFill>
                       <a:prstDash val="solid"/>
                       <a:round/>
@@ -12240,7 +12273,7 @@
                     </a:lnR>
                     <a:lnT w="6350" cap="flat" cmpd="sng" algn="ctr">
                       <a:solidFill>
-                        <a:srgbClr val="D9D9D9"/>
+                        <a:srgbClr val="C8D9C0"/>
                       </a:solidFill>
                       <a:prstDash val="solid"/>
                       <a:round/>
@@ -12249,7 +12282,7 @@
                     </a:lnT>
                     <a:lnB w="6350" cap="flat" cmpd="sng" algn="ctr">
                       <a:solidFill>
-                        <a:srgbClr val="D9D9D9"/>
+                        <a:srgbClr val="C8D9C0"/>
                       </a:solidFill>
                       <a:prstDash val="solid"/>
                       <a:round/>
@@ -12257,7 +12290,7 @@
                       <a:tailEnd type="none" w="med" len="med"/>
                     </a:lnB>
                     <a:solidFill>
-                      <a:srgbClr val="F7F7F7"/>
+                      <a:srgbClr val="F4F9EF"/>
                     </a:solidFill>
                   </a:tcPr>
                 </a:tc>
@@ -12272,7 +12305,7 @@
                       <a:r>
                         <a:rPr lang="en-US" sz="1050" dirty="0">
                           <a:solidFill>
-                            <a:srgbClr val="B0B0B0"/>
+                            <a:srgbClr val="8FAE8B"/>
                           </a:solidFill>
                           <a:latin typeface="Arial" pitchFamily="34" charset="0"/>
                           <a:ea typeface="Arial" pitchFamily="34" charset="-122"/>
@@ -12290,7 +12323,7 @@
                   <a:tcPr marL="54864" marR="54864" marT="54864" marB="54864" anchor="mid">
                     <a:lnL w="6350" cap="flat" cmpd="sng" algn="ctr">
                       <a:solidFill>
-                        <a:srgbClr val="D9D9D9"/>
+                        <a:srgbClr val="C8D9C0"/>
                       </a:solidFill>
                       <a:prstDash val="solid"/>
                       <a:round/>
@@ -12299,7 +12332,7 @@
                     </a:lnL>
                     <a:lnR w="6350" cap="flat" cmpd="sng" algn="ctr">
                       <a:solidFill>
-                        <a:srgbClr val="D9D9D9"/>
+                        <a:srgbClr val="C8D9C0"/>
                       </a:solidFill>
                       <a:prstDash val="solid"/>
                       <a:round/>
@@ -12308,7 +12341,7 @@
                     </a:lnR>
                     <a:lnT w="6350" cap="flat" cmpd="sng" algn="ctr">
                       <a:solidFill>
-                        <a:srgbClr val="D9D9D9"/>
+                        <a:srgbClr val="C8D9C0"/>
                       </a:solidFill>
                       <a:prstDash val="solid"/>
                       <a:round/>
@@ -12317,7 +12350,7 @@
                     </a:lnT>
                     <a:lnB w="6350" cap="flat" cmpd="sng" algn="ctr">
                       <a:solidFill>
-                        <a:srgbClr val="D9D9D9"/>
+                        <a:srgbClr val="C8D9C0"/>
                       </a:solidFill>
                       <a:prstDash val="solid"/>
                       <a:round/>
@@ -12325,7 +12358,7 @@
                       <a:tailEnd type="none" w="med" len="med"/>
                     </a:lnB>
                     <a:solidFill>
-                      <a:srgbClr val="F7F7F7"/>
+                      <a:srgbClr val="F4F9EF"/>
                     </a:solidFill>
                   </a:tcPr>
                 </a:tc>
@@ -12342,7 +12375,7 @@
                       <a:r>
                         <a:rPr lang="en-US" sz="1050" b="1" dirty="0">
                           <a:solidFill>
-                            <a:srgbClr val="0A0A0A"/>
+                            <a:srgbClr val="2C5F2D"/>
                           </a:solidFill>
                           <a:latin typeface="Arial" pitchFamily="34" charset="0"/>
                           <a:ea typeface="Arial" pitchFamily="34" charset="-122"/>
@@ -12360,7 +12393,7 @@
                   <a:tcPr marL="54864" marR="54864" marT="54864" marB="54864" anchor="mid">
                     <a:lnL w="6350" cap="flat" cmpd="sng" algn="ctr">
                       <a:solidFill>
-                        <a:srgbClr val="D9D9D9"/>
+                        <a:srgbClr val="C8D9C0"/>
                       </a:solidFill>
                       <a:prstDash val="solid"/>
                       <a:round/>
@@ -12369,7 +12402,7 @@
                     </a:lnL>
                     <a:lnR w="6350" cap="flat" cmpd="sng" algn="ctr">
                       <a:solidFill>
-                        <a:srgbClr val="D9D9D9"/>
+                        <a:srgbClr val="C8D9C0"/>
                       </a:solidFill>
                       <a:prstDash val="solid"/>
                       <a:round/>
@@ -12378,7 +12411,7 @@
                     </a:lnR>
                     <a:lnT w="6350" cap="flat" cmpd="sng" algn="ctr">
                       <a:solidFill>
-                        <a:srgbClr val="D9D9D9"/>
+                        <a:srgbClr val="C8D9C0"/>
                       </a:solidFill>
                       <a:prstDash val="solid"/>
                       <a:round/>
@@ -12387,7 +12420,7 @@
                     </a:lnT>
                     <a:lnB w="6350" cap="flat" cmpd="sng" algn="ctr">
                       <a:solidFill>
-                        <a:srgbClr val="D9D9D9"/>
+                        <a:srgbClr val="C8D9C0"/>
                       </a:solidFill>
                       <a:prstDash val="solid"/>
                       <a:round/>
@@ -12395,7 +12428,7 @@
                       <a:tailEnd type="none" w="med" len="med"/>
                     </a:lnB>
                     <a:solidFill>
-                      <a:srgbClr val="FFFFFF"/>
+                      <a:srgbClr val="F0F5EA"/>
                     </a:solidFill>
                   </a:tcPr>
                 </a:tc>
@@ -12410,7 +12443,7 @@
                       <a:r>
                         <a:rPr lang="en-US" sz="1050" dirty="0">
                           <a:solidFill>
-                            <a:srgbClr val="6E6E6E"/>
+                            <a:srgbClr val="5A6B5A"/>
                           </a:solidFill>
                           <a:latin typeface="Arial" pitchFamily="34" charset="0"/>
                           <a:ea typeface="Arial" pitchFamily="34" charset="-122"/>
@@ -12428,7 +12461,7 @@
                   <a:tcPr marL="54864" marR="54864" marT="54864" marB="54864" anchor="mid">
                     <a:lnL w="6350" cap="flat" cmpd="sng" algn="ctr">
                       <a:solidFill>
-                        <a:srgbClr val="D9D9D9"/>
+                        <a:srgbClr val="C8D9C0"/>
                       </a:solidFill>
                       <a:prstDash val="solid"/>
                       <a:round/>
@@ -12437,7 +12470,7 @@
                     </a:lnL>
                     <a:lnR w="6350" cap="flat" cmpd="sng" algn="ctr">
                       <a:solidFill>
-                        <a:srgbClr val="D9D9D9"/>
+                        <a:srgbClr val="C8D9C0"/>
                       </a:solidFill>
                       <a:prstDash val="solid"/>
                       <a:round/>
@@ -12446,7 +12479,7 @@
                     </a:lnR>
                     <a:lnT w="6350" cap="flat" cmpd="sng" algn="ctr">
                       <a:solidFill>
-                        <a:srgbClr val="D9D9D9"/>
+                        <a:srgbClr val="C8D9C0"/>
                       </a:solidFill>
                       <a:prstDash val="solid"/>
                       <a:round/>
@@ -12455,7 +12488,7 @@
                     </a:lnT>
                     <a:lnB w="6350" cap="flat" cmpd="sng" algn="ctr">
                       <a:solidFill>
-                        <a:srgbClr val="D9D9D9"/>
+                        <a:srgbClr val="C8D9C0"/>
                       </a:solidFill>
                       <a:prstDash val="solid"/>
                       <a:round/>
@@ -12463,7 +12496,7 @@
                       <a:tailEnd type="none" w="med" len="med"/>
                     </a:lnB>
                     <a:solidFill>
-                      <a:srgbClr val="FFFFFF"/>
+                      <a:srgbClr val="F0F5EA"/>
                     </a:solidFill>
                   </a:tcPr>
                 </a:tc>
@@ -12478,7 +12511,7 @@
                       <a:r>
                         <a:rPr lang="en-US" sz="1050" dirty="0">
                           <a:solidFill>
-                            <a:srgbClr val="B0B0B0"/>
+                            <a:srgbClr val="8FAE8B"/>
                           </a:solidFill>
                           <a:latin typeface="Arial" pitchFamily="34" charset="0"/>
                           <a:ea typeface="Arial" pitchFamily="34" charset="-122"/>
@@ -12496,7 +12529,7 @@
                   <a:tcPr marL="54864" marR="54864" marT="54864" marB="54864" anchor="mid">
                     <a:lnL w="6350" cap="flat" cmpd="sng" algn="ctr">
                       <a:solidFill>
-                        <a:srgbClr val="D9D9D9"/>
+                        <a:srgbClr val="C8D9C0"/>
                       </a:solidFill>
                       <a:prstDash val="solid"/>
                       <a:round/>
@@ -12505,7 +12538,7 @@
                     </a:lnL>
                     <a:lnR w="6350" cap="flat" cmpd="sng" algn="ctr">
                       <a:solidFill>
-                        <a:srgbClr val="D9D9D9"/>
+                        <a:srgbClr val="C8D9C0"/>
                       </a:solidFill>
                       <a:prstDash val="solid"/>
                       <a:round/>
@@ -12514,7 +12547,7 @@
                     </a:lnR>
                     <a:lnT w="6350" cap="flat" cmpd="sng" algn="ctr">
                       <a:solidFill>
-                        <a:srgbClr val="D9D9D9"/>
+                        <a:srgbClr val="C8D9C0"/>
                       </a:solidFill>
                       <a:prstDash val="solid"/>
                       <a:round/>
@@ -12523,7 +12556,7 @@
                     </a:lnT>
                     <a:lnB w="6350" cap="flat" cmpd="sng" algn="ctr">
                       <a:solidFill>
-                        <a:srgbClr val="D9D9D9"/>
+                        <a:srgbClr val="C8D9C0"/>
                       </a:solidFill>
                       <a:prstDash val="solid"/>
                       <a:round/>
@@ -12531,7 +12564,7 @@
                       <a:tailEnd type="none" w="med" len="med"/>
                     </a:lnB>
                     <a:solidFill>
-                      <a:srgbClr val="FFFFFF"/>
+                      <a:srgbClr val="F0F5EA"/>
                     </a:solidFill>
                   </a:tcPr>
                 </a:tc>
@@ -12567,7 +12600,7 @@
             <a:r>
               <a:rPr lang="en-US" sz="1500" b="1" dirty="0">
                 <a:solidFill>
-                  <a:srgbClr val="E0E0E0"/>
+                  <a:srgbClr val="D8E8C8"/>
                 </a:solidFill>
                 <a:latin typeface="Arial Black" pitchFamily="34" charset="0"/>
                 <a:ea typeface="Arial Black" pitchFamily="34" charset="-122"/>
@@ -12613,7 +12646,7 @@
             <a:r>
               <a:rPr lang="en-US" sz="1500" b="1" dirty="0">
                 <a:solidFill>
-                  <a:srgbClr val="0A0A0A"/>
+                  <a:srgbClr val="2C5F2D"/>
                 </a:solidFill>
                 <a:latin typeface="Arial Black" pitchFamily="34" charset="0"/>
                 <a:ea typeface="Arial Black" pitchFamily="34" charset="-122"/>
@@ -12652,7 +12685,7 @@
             <a:r>
               <a:rPr lang="en-US" sz="850" dirty="0">
                 <a:solidFill>
-                  <a:srgbClr val="6E6E6E"/>
+                  <a:srgbClr val="5A6B5A"/>
                 </a:solidFill>
                 <a:latin typeface="Arial" pitchFamily="34" charset="0"/>
                 <a:ea typeface="Arial" pitchFamily="34" charset="-122"/>
@@ -12669,6 +12702,9 @@
   <p:clrMapOvr>
     <a:masterClrMapping/>
   </p:clrMapOvr>
+  <p:transition spd="med">
+    <p:fade/>
+  </p:transition>
 </p:sld>
 </file>
 
@@ -12678,7 +12714,7 @@
     <p:bg>
       <p:bgPr>
         <a:solidFill>
-          <a:srgbClr val="0A0A0A"/>
+          <a:srgbClr val="1F3D26"/>
         </a:solidFill>
       </p:bgPr>
     </p:bg>
@@ -12723,7 +12759,7 @@
             <a:r>
               <a:rPr lang="en-US" sz="2800" b="1" dirty="0">
                 <a:solidFill>
-                  <a:srgbClr val="2A2A2A"/>
+                  <a:srgbClr val="142B1A"/>
                 </a:solidFill>
                 <a:latin typeface="Arial Black" pitchFamily="34" charset="0"/>
                 <a:ea typeface="Arial Black" pitchFamily="34" charset="-122"/>
@@ -12762,7 +12798,7 @@
             <a:r>
               <a:rPr lang="en-US" sz="2800" b="1" dirty="0">
                 <a:solidFill>
-                  <a:srgbClr val="FFFFFF"/>
+                  <a:srgbClr val="F0F5EA"/>
                 </a:solidFill>
                 <a:latin typeface="Arial Black" pitchFamily="34" charset="0"/>
                 <a:ea typeface="Arial Black" pitchFamily="34" charset="-122"/>
@@ -12789,11 +12825,11 @@
             <a:avLst/>
           </a:prstGeom>
           <a:solidFill>
-            <a:srgbClr val="FF5A1F"/>
+            <a:srgbClr val="97BC62"/>
           </a:solidFill>
           <a:ln w="12700">
             <a:solidFill>
-              <a:srgbClr val="FF5A1F"/>
+              <a:srgbClr val="97BC62"/>
             </a:solidFill>
             <a:prstDash val="solid"/>
           </a:ln>
@@ -12826,7 +12862,7 @@
             <a:r>
               <a:rPr lang="en-US" sz="1150" dirty="0">
                 <a:solidFill>
-                  <a:srgbClr val="B0B0B0"/>
+                  <a:srgbClr val="8FAE8B"/>
                 </a:solidFill>
                 <a:latin typeface="Arial" pitchFamily="34" charset="0"/>
                 <a:ea typeface="Arial" pitchFamily="34" charset="-122"/>
@@ -12853,11 +12889,11 @@
             <a:avLst/>
           </a:prstGeom>
           <a:solidFill>
-            <a:srgbClr val="2A2A2A"/>
+            <a:srgbClr val="142B1A"/>
           </a:solidFill>
           <a:ln w="12700">
             <a:solidFill>
-              <a:srgbClr val="2A2A2A"/>
+              <a:srgbClr val="142B1A"/>
             </a:solidFill>
             <a:prstDash val="solid"/>
           </a:ln>
@@ -12878,11 +12914,11 @@
             <a:avLst/>
           </a:prstGeom>
           <a:solidFill>
-            <a:srgbClr val="555555"/>
+            <a:srgbClr val="3E5C42"/>
           </a:solidFill>
           <a:ln w="12700">
             <a:solidFill>
-              <a:srgbClr val="555555"/>
+              <a:srgbClr val="3E5C42"/>
             </a:solidFill>
             <a:prstDash val="solid"/>
           </a:ln>
@@ -12905,11 +12941,11 @@
             </a:avLst>
           </a:prstGeom>
           <a:solidFill>
-            <a:srgbClr val="161616"/>
+            <a:srgbClr val="2A4A33"/>
           </a:solidFill>
           <a:ln w="12700">
             <a:solidFill>
-              <a:srgbClr val="2A2A2A"/>
+              <a:srgbClr val="142B1A"/>
             </a:solidFill>
             <a:prstDash val="solid"/>
           </a:ln>
@@ -12942,7 +12978,7 @@
             <a:r>
               <a:rPr lang="en-US" sz="1500" b="1" dirty="0">
                 <a:solidFill>
-                  <a:srgbClr val="FFFFFF"/>
+                  <a:srgbClr val="F0F5EA"/>
                 </a:solidFill>
                 <a:latin typeface="Arial Black" pitchFamily="34" charset="0"/>
                 <a:ea typeface="Arial Black" pitchFamily="34" charset="-122"/>
@@ -12981,7 +13017,7 @@
             <a:r>
               <a:rPr lang="en-US" sz="800" dirty="0">
                 <a:solidFill>
-                  <a:srgbClr val="B0B0B0"/>
+                  <a:srgbClr val="8FAE8B"/>
                 </a:solidFill>
                 <a:latin typeface="Arial" pitchFamily="34" charset="0"/>
                 <a:ea typeface="Arial" pitchFamily="34" charset="-122"/>
@@ -13020,7 +13056,7 @@
             <a:r>
               <a:rPr lang="en-US" sz="650" dirty="0">
                 <a:solidFill>
-                  <a:srgbClr val="8A8A8A"/>
+                  <a:srgbClr val="8FAE8B"/>
                 </a:solidFill>
                 <a:latin typeface="Arial" pitchFamily="34" charset="0"/>
                 <a:ea typeface="Arial" pitchFamily="34" charset="-122"/>
@@ -13047,11 +13083,11 @@
             <a:avLst/>
           </a:prstGeom>
           <a:solidFill>
-            <a:srgbClr val="2A2A2A"/>
+            <a:srgbClr val="142B1A"/>
           </a:solidFill>
           <a:ln w="12700">
             <a:solidFill>
-              <a:srgbClr val="2A2A2A"/>
+              <a:srgbClr val="142B1A"/>
             </a:solidFill>
             <a:prstDash val="solid"/>
           </a:ln>
@@ -13072,11 +13108,11 @@
             <a:avLst/>
           </a:prstGeom>
           <a:solidFill>
-            <a:srgbClr val="555555"/>
+            <a:srgbClr val="3E5C42"/>
           </a:solidFill>
           <a:ln w="12700">
             <a:solidFill>
-              <a:srgbClr val="555555"/>
+              <a:srgbClr val="3E5C42"/>
             </a:solidFill>
             <a:prstDash val="solid"/>
           </a:ln>
@@ -13099,11 +13135,11 @@
             </a:avLst>
           </a:prstGeom>
           <a:solidFill>
-            <a:srgbClr val="161616"/>
+            <a:srgbClr val="2A4A33"/>
           </a:solidFill>
           <a:ln w="12700">
             <a:solidFill>
-              <a:srgbClr val="2A2A2A"/>
+              <a:srgbClr val="142B1A"/>
             </a:solidFill>
             <a:prstDash val="solid"/>
           </a:ln>
@@ -13136,7 +13172,7 @@
             <a:r>
               <a:rPr lang="en-US" sz="1500" b="1" dirty="0">
                 <a:solidFill>
-                  <a:srgbClr val="FFFFFF"/>
+                  <a:srgbClr val="F0F5EA"/>
                 </a:solidFill>
                 <a:latin typeface="Arial Black" pitchFamily="34" charset="0"/>
                 <a:ea typeface="Arial Black" pitchFamily="34" charset="-122"/>
@@ -13175,7 +13211,7 @@
             <a:r>
               <a:rPr lang="en-US" sz="800" dirty="0">
                 <a:solidFill>
-                  <a:srgbClr val="B0B0B0"/>
+                  <a:srgbClr val="8FAE8B"/>
                 </a:solidFill>
                 <a:latin typeface="Arial" pitchFamily="34" charset="0"/>
                 <a:ea typeface="Arial" pitchFamily="34" charset="-122"/>
@@ -13214,7 +13250,7 @@
             <a:r>
               <a:rPr lang="en-US" sz="650" dirty="0">
                 <a:solidFill>
-                  <a:srgbClr val="8A8A8A"/>
+                  <a:srgbClr val="8FAE8B"/>
                 </a:solidFill>
                 <a:latin typeface="Arial" pitchFamily="34" charset="0"/>
                 <a:ea typeface="Arial" pitchFamily="34" charset="-122"/>
@@ -13241,11 +13277,11 @@
             <a:avLst/>
           </a:prstGeom>
           <a:solidFill>
-            <a:srgbClr val="2A2A2A"/>
+            <a:srgbClr val="142B1A"/>
           </a:solidFill>
           <a:ln w="12700">
             <a:solidFill>
-              <a:srgbClr val="2A2A2A"/>
+              <a:srgbClr val="142B1A"/>
             </a:solidFill>
             <a:prstDash val="solid"/>
           </a:ln>
@@ -13266,11 +13302,11 @@
             <a:avLst/>
           </a:prstGeom>
           <a:solidFill>
-            <a:srgbClr val="555555"/>
+            <a:srgbClr val="3E5C42"/>
           </a:solidFill>
           <a:ln w="12700">
             <a:solidFill>
-              <a:srgbClr val="555555"/>
+              <a:srgbClr val="3E5C42"/>
             </a:solidFill>
             <a:prstDash val="solid"/>
           </a:ln>
@@ -13293,11 +13329,11 @@
             </a:avLst>
           </a:prstGeom>
           <a:solidFill>
-            <a:srgbClr val="161616"/>
+            <a:srgbClr val="2A4A33"/>
           </a:solidFill>
           <a:ln w="12700">
             <a:solidFill>
-              <a:srgbClr val="2A2A2A"/>
+              <a:srgbClr val="142B1A"/>
             </a:solidFill>
             <a:prstDash val="solid"/>
           </a:ln>
@@ -13330,7 +13366,7 @@
             <a:r>
               <a:rPr lang="en-US" sz="1500" b="1" dirty="0">
                 <a:solidFill>
-                  <a:srgbClr val="FFFFFF"/>
+                  <a:srgbClr val="F0F5EA"/>
                 </a:solidFill>
                 <a:latin typeface="Arial Black" pitchFamily="34" charset="0"/>
                 <a:ea typeface="Arial Black" pitchFamily="34" charset="-122"/>
@@ -13369,7 +13405,7 @@
             <a:r>
               <a:rPr lang="en-US" sz="800" dirty="0">
                 <a:solidFill>
-                  <a:srgbClr val="B0B0B0"/>
+                  <a:srgbClr val="8FAE8B"/>
                 </a:solidFill>
                 <a:latin typeface="Arial" pitchFamily="34" charset="0"/>
                 <a:ea typeface="Arial" pitchFamily="34" charset="-122"/>
@@ -13408,7 +13444,7 @@
             <a:r>
               <a:rPr lang="en-US" sz="650" dirty="0">
                 <a:solidFill>
-                  <a:srgbClr val="8A8A8A"/>
+                  <a:srgbClr val="8FAE8B"/>
                 </a:solidFill>
                 <a:latin typeface="Arial" pitchFamily="34" charset="0"/>
                 <a:ea typeface="Arial" pitchFamily="34" charset="-122"/>
@@ -13435,11 +13471,11 @@
             <a:avLst/>
           </a:prstGeom>
           <a:solidFill>
-            <a:srgbClr val="2A2A2A"/>
+            <a:srgbClr val="142B1A"/>
           </a:solidFill>
           <a:ln w="12700">
             <a:solidFill>
-              <a:srgbClr val="2A2A2A"/>
+              <a:srgbClr val="142B1A"/>
             </a:solidFill>
             <a:prstDash val="solid"/>
           </a:ln>
@@ -13460,11 +13496,11 @@
             <a:avLst/>
           </a:prstGeom>
           <a:solidFill>
-            <a:srgbClr val="555555"/>
+            <a:srgbClr val="3E5C42"/>
           </a:solidFill>
           <a:ln w="12700">
             <a:solidFill>
-              <a:srgbClr val="555555"/>
+              <a:srgbClr val="3E5C42"/>
             </a:solidFill>
             <a:prstDash val="solid"/>
           </a:ln>
@@ -13487,11 +13523,11 @@
             </a:avLst>
           </a:prstGeom>
           <a:solidFill>
-            <a:srgbClr val="161616"/>
+            <a:srgbClr val="2A4A33"/>
           </a:solidFill>
           <a:ln w="12700">
             <a:solidFill>
-              <a:srgbClr val="2A2A2A"/>
+              <a:srgbClr val="142B1A"/>
             </a:solidFill>
             <a:prstDash val="solid"/>
           </a:ln>
@@ -13524,7 +13560,7 @@
             <a:r>
               <a:rPr lang="en-US" sz="1500" b="1" dirty="0">
                 <a:solidFill>
-                  <a:srgbClr val="FFFFFF"/>
+                  <a:srgbClr val="F0F5EA"/>
                 </a:solidFill>
                 <a:latin typeface="Arial Black" pitchFamily="34" charset="0"/>
                 <a:ea typeface="Arial Black" pitchFamily="34" charset="-122"/>
@@ -13563,7 +13599,7 @@
             <a:r>
               <a:rPr lang="en-US" sz="800" dirty="0">
                 <a:solidFill>
-                  <a:srgbClr val="B0B0B0"/>
+                  <a:srgbClr val="8FAE8B"/>
                 </a:solidFill>
                 <a:latin typeface="Arial" pitchFamily="34" charset="0"/>
                 <a:ea typeface="Arial" pitchFamily="34" charset="-122"/>
@@ -13602,7 +13638,7 @@
             <a:r>
               <a:rPr lang="en-US" sz="650" dirty="0">
                 <a:solidFill>
-                  <a:srgbClr val="8A8A8A"/>
+                  <a:srgbClr val="8FAE8B"/>
                 </a:solidFill>
                 <a:latin typeface="Arial" pitchFamily="34" charset="0"/>
                 <a:ea typeface="Arial" pitchFamily="34" charset="-122"/>
@@ -13641,7 +13677,7 @@
             <a:r>
               <a:rPr lang="en-US" sz="850" dirty="0">
                 <a:solidFill>
-                  <a:srgbClr val="B0B0B0"/>
+                  <a:srgbClr val="8FAE8B"/>
                 </a:solidFill>
                 <a:latin typeface="Arial" pitchFamily="34" charset="0"/>
                 <a:ea typeface="Arial" pitchFamily="34" charset="-122"/>
@@ -13658,6 +13694,9 @@
   <p:clrMapOvr>
     <a:masterClrMapping/>
   </p:clrMapOvr>
+  <p:transition spd="med">
+    <p:fade/>
+  </p:transition>
 </p:sld>
 </file>
 

</xml_diff>

<commit_message>
deck pptx: green theme rebuild (13 slides, gate pass, viewer-compat)
</commit_message>
<xml_diff>
--- a/scaffold/deck/KrishiSetu-Round0-20260816.pptx
+++ b/scaffold/deck/KrishiSetu-Round0-20260816.pptx
@@ -2168,9 +2168,6 @@
   <p:clrMapOvr>
     <a:masterClrMapping/>
   </p:clrMapOvr>
-  <p:transition spd="med">
-    <p:fade/>
-  </p:transition>
 </p:sld>
 </file>
 
@@ -2973,9 +2970,6 @@
   <p:clrMapOvr>
     <a:masterClrMapping/>
   </p:clrMapOvr>
-  <p:transition spd="med">
-    <p:fade/>
-  </p:transition>
 </p:sld>
 </file>
 
@@ -3697,9 +3691,6 @@
   <p:clrMapOvr>
     <a:masterClrMapping/>
   </p:clrMapOvr>
-  <p:transition spd="med">
-    <p:fade/>
-  </p:transition>
 </p:sld>
 </file>
 
@@ -4604,9 +4595,6 @@
   <p:clrMapOvr>
     <a:masterClrMapping/>
   </p:clrMapOvr>
-  <p:transition spd="med">
-    <p:fade/>
-  </p:transition>
 </p:sld>
 </file>
 
@@ -4911,9 +4899,6 @@
   <p:clrMapOvr>
     <a:masterClrMapping/>
   </p:clrMapOvr>
-  <p:transition spd="med">
-    <p:fade/>
-  </p:transition>
 </p:sld>
 </file>
 
@@ -5836,9 +5821,6 @@
   <p:clrMapOvr>
     <a:masterClrMapping/>
   </p:clrMapOvr>
-  <p:transition spd="med">
-    <p:fade/>
-  </p:transition>
 </p:sld>
 </file>
 
@@ -6828,9 +6810,6 @@
   <p:clrMapOvr>
     <a:masterClrMapping/>
   </p:clrMapOvr>
-  <p:transition spd="med">
-    <p:fade/>
-  </p:transition>
 </p:sld>
 </file>
 
@@ -7664,9 +7643,6 @@
   <p:clrMapOvr>
     <a:masterClrMapping/>
   </p:clrMapOvr>
-  <p:transition spd="med">
-    <p:fade/>
-  </p:transition>
 </p:sld>
 </file>
 
@@ -8682,9 +8658,6 @@
   <p:clrMapOvr>
     <a:masterClrMapping/>
   </p:clrMapOvr>
-  <p:transition spd="med">
-    <p:fade/>
-  </p:transition>
 </p:sld>
 </file>
 
@@ -9934,9 +9907,6 @@
   <p:clrMapOvr>
     <a:masterClrMapping/>
   </p:clrMapOvr>
-  <p:transition spd="med">
-    <p:fade/>
-  </p:transition>
 </p:sld>
 </file>
 
@@ -11203,9 +11173,6 @@
   <p:clrMapOvr>
     <a:masterClrMapping/>
   </p:clrMapOvr>
-  <p:transition spd="med">
-    <p:fade/>
-  </p:transition>
 </p:sld>
 </file>
 
@@ -12702,9 +12669,6 @@
   <p:clrMapOvr>
     <a:masterClrMapping/>
   </p:clrMapOvr>
-  <p:transition spd="med">
-    <p:fade/>
-  </p:transition>
 </p:sld>
 </file>
 
@@ -13694,9 +13658,6 @@
   <p:clrMapOvr>
     <a:masterClrMapping/>
   </p:clrMapOvr>
-  <p:transition spd="med">
-    <p:fade/>
-  </p:transition>
 </p:sld>
 </file>
 

</xml_diff>